<commit_message>
Report the measured 500-feature ablation and update notebook and slides
</commit_message>
<xml_diff>
--- a/submission/Assignment.pptx
+++ b/submission/Assignment.pptx
@@ -2,17 +2,17 @@
 <file path=ppt/presentation.xml><?xml version="1.0" encoding="utf-8"?>
 <p:presentation xmlns:p="http://schemas.openxmlformats.org/presentationml/2006/main">
   <p:sldMasterIdLst>
-    <p:sldMasterId xmlns:r="http://schemas.openxmlformats.org/officeDocument/2006/relationships" id="2147483648" r:id="Rc92bc92c842a4fd2"/>
+    <p:sldMasterId xmlns:r="http://schemas.openxmlformats.org/officeDocument/2006/relationships" id="2147483648" r:id="R147245d4e7244151"/>
   </p:sldMasterIdLst>
   <p:notesMasterIdLst>
-    <p:notesMasterId xmlns:r="http://schemas.openxmlformats.org/officeDocument/2006/relationships" r:id="Rcfcb227eb6b74b6a"/>
+    <p:notesMasterId xmlns:r="http://schemas.openxmlformats.org/officeDocument/2006/relationships" r:id="R151822d007ed4d44"/>
   </p:notesMasterIdLst>
   <p:sldIdLst>
-    <p:sldId xmlns:r="http://schemas.openxmlformats.org/officeDocument/2006/relationships" id="256" r:id="R78644bb3ff0e4368"/>
-    <p:sldId xmlns:r="http://schemas.openxmlformats.org/officeDocument/2006/relationships" id="257" r:id="Re243dbb6ef9c47f6"/>
-    <p:sldId xmlns:r="http://schemas.openxmlformats.org/officeDocument/2006/relationships" id="258" r:id="Rf4ac539fe7434a48"/>
-    <p:sldId xmlns:r="http://schemas.openxmlformats.org/officeDocument/2006/relationships" id="259" r:id="Raa2b3dc05a2b4295"/>
-    <p:sldId xmlns:r="http://schemas.openxmlformats.org/officeDocument/2006/relationships" id="260" r:id="R8ef7044fd7d44919"/>
+    <p:sldId xmlns:r="http://schemas.openxmlformats.org/officeDocument/2006/relationships" id="256" r:id="Rc6cb655fdb92407e"/>
+    <p:sldId xmlns:r="http://schemas.openxmlformats.org/officeDocument/2006/relationships" id="257" r:id="Rd2711ebb707b4853"/>
+    <p:sldId xmlns:r="http://schemas.openxmlformats.org/officeDocument/2006/relationships" id="258" r:id="R0d67ed93676d44ce"/>
+    <p:sldId xmlns:r="http://schemas.openxmlformats.org/officeDocument/2006/relationships" id="259" r:id="Rebeb006bcc6847b9"/>
+    <p:sldId xmlns:r="http://schemas.openxmlformats.org/officeDocument/2006/relationships" id="260" r:id="Rb4368a08eb3543bf"/>
   </p:sldIdLst>
   <p:sldSz cx="12192000" cy="6858000"/>
   <p:notesSz cx="6858000" cy="9144000"/>
@@ -726,7 +726,7 @@
           <a:lstStyle xmlns:a="http://schemas.openxmlformats.org/drawingml/2006/main"/>
           <a:p xmlns:a="http://schemas.openxmlformats.org/drawingml/2006/main">
             <a:r>
-              <a:t>Sources: PLAN.md and results/comment_comparison.csv. Sparse character fragments, including comments, carry class cues. That data-based hypothesis motivates this ablation. Validation SVM-LR gaps: (0.8062140806-0.7913448450)*100=1.4869 and (0.6882900557-0.6580203866)*100=3.0270. The directional prediction failed. All validation and test ranks remain SVM, LR, RF, NB. SVM test Macro-F1 falls by 19.3861 percentage points. This is an exploratory follow-up because earlier eight-class outcomes were known. Do not claim the unique winner explanation was established.</a:t>
+              <a:t>Sources: PLAN.md, results/feature_comparison.csv and results/feature_interpretation.md. Hypothesis: distributed character patterns partly explain the SVM advantage. One limit of 500 was chosen and committed before execution in 5cdab0d, with no sweep. Original code and comments retained. Validation SVM-LR gap falls from 1.48692356 to 1.38818655 percentage points: a change of only 0.09873701 points. All validation and test ranks remain SVM, LR, RF, NB. Test SVM F1 falls from 0.7970261 to 0.7169088. This exploratory single-split result is weak directional support, not a ranking reversal or a statistically established causal explanation. Restricting vocabulary also changes normalization and the forest sqrt candidate-feature count. The prior comment-removal prediction failed: validation gap widened from 1.49 to 3.03 points. Both outcomes are retained and reported.</a:t>
             </a:r>
           </a:p>
         </p:txBody>
@@ -794,7 +794,7 @@
   </p:cSld>
   <p:clrMap bg1="lt1" tx1="dk1" bg2="lt2" tx2="dk2" accent1="accent1" accent2="accent2" accent3="accent3" accent4="accent4" accent5="accent5" accent6="accent6" hlink="hlink" folHlink="folHlink"/>
   <p:sldLayoutIdLst>
-    <p:sldLayoutId xmlns:r="http://schemas.openxmlformats.org/officeDocument/2006/relationships" id="2147483649" r:id="R7929973334d54711"/>
+    <p:sldLayoutId xmlns:r="http://schemas.openxmlformats.org/officeDocument/2006/relationships" id="2147483649" r:id="R937ea570cae24c6c"/>
   </p:sldLayoutIdLst>
   <p:txStyles>
     <p:titleStyle>
@@ -1345,7 +1345,7 @@
           <p:cNvPr id="7" name="">
             <a:extLst xmlns:a="http://schemas.openxmlformats.org/drawingml/2006/main">
               <a:ext uri="{FF2B5EF4-FFF2-40B4-BE49-F238E27FC236}">
-                <a16:creationId xmlns:a16="http://schemas.microsoft.com/office/drawing/2014/main" id="{DED4B5F9-CABD-470B-87AF-51CEACFE3178}"/>
+                <a16:creationId xmlns:a16="http://schemas.microsoft.com/office/drawing/2014/main" id="{5F6A74C2-4F95-419D-9DBD-CCFB1E3E5257}"/>
               </a:ext>
             </a:extLst>
           </p:cNvPr>
@@ -1402,7 +1402,7 @@
           <p:cNvPr id="2" name="">
             <a:extLst xmlns:a="http://schemas.openxmlformats.org/drawingml/2006/main">
               <a:ext uri="{FF2B5EF4-FFF2-40B4-BE49-F238E27FC236}">
-                <a16:creationId xmlns:a16="http://schemas.microsoft.com/office/drawing/2014/main" id="{A16C2B94-FE61-493F-8EC3-25487B5E2ED5}"/>
+                <a16:creationId xmlns:a16="http://schemas.microsoft.com/office/drawing/2014/main" id="{8E4BB4D5-534A-44C7-A5C3-59666DA26E91}"/>
               </a:ext>
             </a:extLst>
           </p:cNvPr>
@@ -1459,7 +1459,7 @@
           <p:cNvPr id="3" name="">
             <a:extLst xmlns:a="http://schemas.openxmlformats.org/drawingml/2006/main">
               <a:ext uri="{FF2B5EF4-FFF2-40B4-BE49-F238E27FC236}">
-                <a16:creationId xmlns:a16="http://schemas.microsoft.com/office/drawing/2014/main" id="{413CC072-5E24-4134-B0D6-B72B58A11F03}"/>
+                <a16:creationId xmlns:a16="http://schemas.microsoft.com/office/drawing/2014/main" id="{D971DD85-EF1D-489C-85A2-D5F492BEE8A6}"/>
               </a:ext>
             </a:extLst>
           </p:cNvPr>
@@ -1539,7 +1539,7 @@
           <p:cNvPr id="4" name="">
             <a:extLst xmlns:a="http://schemas.openxmlformats.org/drawingml/2006/main">
               <a:ext uri="{FF2B5EF4-FFF2-40B4-BE49-F238E27FC236}">
-                <a16:creationId xmlns:a16="http://schemas.microsoft.com/office/drawing/2014/main" id="{1EEA52E8-CB08-4680-AED1-6C1092364C41}"/>
+                <a16:creationId xmlns:a16="http://schemas.microsoft.com/office/drawing/2014/main" id="{0080827F-6AEA-4AED-A29B-1A0884EDE0F3}"/>
               </a:ext>
             </a:extLst>
           </p:cNvPr>
@@ -1619,7 +1619,7 @@
           <p:cNvPr id="5" name="">
             <a:extLst xmlns:a="http://schemas.openxmlformats.org/drawingml/2006/main">
               <a:ext uri="{FF2B5EF4-FFF2-40B4-BE49-F238E27FC236}">
-                <a16:creationId xmlns:a16="http://schemas.microsoft.com/office/drawing/2014/main" id="{A3ADA2A6-6891-49B3-A3A2-9543AEAA86DA}"/>
+                <a16:creationId xmlns:a16="http://schemas.microsoft.com/office/drawing/2014/main" id="{653B837F-B21A-4585-92AC-1F9B37305BE4}"/>
               </a:ext>
             </a:extLst>
           </p:cNvPr>
@@ -1676,7 +1676,7 @@
           <p:cNvPr id="6" name="">
             <a:extLst xmlns:a="http://schemas.openxmlformats.org/drawingml/2006/main">
               <a:ext uri="{FF2B5EF4-FFF2-40B4-BE49-F238E27FC236}">
-                <a16:creationId xmlns:a16="http://schemas.microsoft.com/office/drawing/2014/main" id="{A05F94D3-671E-4152-B90F-66B84FAFAD12}"/>
+                <a16:creationId xmlns:a16="http://schemas.microsoft.com/office/drawing/2014/main" id="{15D3F4E7-6178-4263-95A2-80B5BA4BDD1B}"/>
               </a:ext>
             </a:extLst>
           </p:cNvPr>
@@ -1731,7 +1731,7 @@
     </p:spTree>
     <p:extLst>
       <p:ext uri="{BB962C8B-B14F-4D97-AF65-F5344CB8AC3E}">
-        <p14:creationId xmlns:p14="http://schemas.microsoft.com/office/powerpoint/2010/main" val="261691003"/>
+        <p14:creationId xmlns:p14="http://schemas.microsoft.com/office/powerpoint/2010/main" val="1489348571"/>
       </p:ext>
     </p:extLst>
   </p:cSld>
@@ -1762,7 +1762,7 @@
           <p:cNvPr id="7" name="">
             <a:extLst xmlns:a="http://schemas.openxmlformats.org/drawingml/2006/main">
               <a:ext uri="{FF2B5EF4-FFF2-40B4-BE49-F238E27FC236}">
-                <a16:creationId xmlns:a16="http://schemas.microsoft.com/office/drawing/2014/main" id="{A91D4839-C300-4FC0-87CE-A5A652C8B449}"/>
+                <a16:creationId xmlns:a16="http://schemas.microsoft.com/office/drawing/2014/main" id="{77304140-8A41-4C17-BDB0-7E8DD0DE3B9C}"/>
               </a:ext>
             </a:extLst>
           </p:cNvPr>
@@ -2174,7 +2174,7 @@
           <p:cNvPr id="3" name="">
             <a:extLst xmlns:a="http://schemas.openxmlformats.org/drawingml/2006/main">
               <a:ext uri="{FF2B5EF4-FFF2-40B4-BE49-F238E27FC236}">
-                <a16:creationId xmlns:a16="http://schemas.microsoft.com/office/drawing/2014/main" id="{4E31430A-6884-44A4-94F1-8B4E6B6FBF2F}"/>
+                <a16:creationId xmlns:a16="http://schemas.microsoft.com/office/drawing/2014/main" id="{5CCAF138-6D34-4ED9-AC8B-8E80B7603FB5}"/>
               </a:ext>
             </a:extLst>
           </p:cNvPr>
@@ -2277,7 +2277,7 @@
           <p:cNvPr id="4" name="">
             <a:extLst xmlns:a="http://schemas.openxmlformats.org/drawingml/2006/main">
               <a:ext uri="{FF2B5EF4-FFF2-40B4-BE49-F238E27FC236}">
-                <a16:creationId xmlns:a16="http://schemas.microsoft.com/office/drawing/2014/main" id="{CFD1288F-E3BC-4450-8AE6-019AD8AC2A3B}"/>
+                <a16:creationId xmlns:a16="http://schemas.microsoft.com/office/drawing/2014/main" id="{53FDAA8F-E2BD-4A3C-A996-60C9CA866B24}"/>
               </a:ext>
             </a:extLst>
           </p:cNvPr>
@@ -2380,7 +2380,7 @@
           <p:cNvPr id="5" name="">
             <a:extLst xmlns:a="http://schemas.openxmlformats.org/drawingml/2006/main">
               <a:ext uri="{FF2B5EF4-FFF2-40B4-BE49-F238E27FC236}">
-                <a16:creationId xmlns:a16="http://schemas.microsoft.com/office/drawing/2014/main" id="{B75AA978-4EA3-43BE-9BB5-20F8F84C32CC}"/>
+                <a16:creationId xmlns:a16="http://schemas.microsoft.com/office/drawing/2014/main" id="{DE15496B-94E5-41AF-9A4A-C19CD292DF82}"/>
               </a:ext>
             </a:extLst>
           </p:cNvPr>
@@ -2460,7 +2460,7 @@
           <p:cNvPr id="6" name="">
             <a:extLst xmlns:a="http://schemas.openxmlformats.org/drawingml/2006/main">
               <a:ext uri="{FF2B5EF4-FFF2-40B4-BE49-F238E27FC236}">
-                <a16:creationId xmlns:a16="http://schemas.microsoft.com/office/drawing/2014/main" id="{F3C8E690-5541-4551-9E7F-DF2C41F4772D}"/>
+                <a16:creationId xmlns:a16="http://schemas.microsoft.com/office/drawing/2014/main" id="{9127EC34-23E1-45B1-AFD1-7D8A0EA64A7D}"/>
               </a:ext>
             </a:extLst>
           </p:cNvPr>
@@ -2515,7 +2515,7 @@
     </p:spTree>
     <p:extLst>
       <p:ext uri="{BB962C8B-B14F-4D97-AF65-F5344CB8AC3E}">
-        <p14:creationId xmlns:p14="http://schemas.microsoft.com/office/powerpoint/2010/main" val="966741975"/>
+        <p14:creationId xmlns:p14="http://schemas.microsoft.com/office/powerpoint/2010/main" val="1001095405"/>
       </p:ext>
     </p:extLst>
   </p:cSld>
@@ -2546,7 +2546,7 @@
           <p:cNvPr id="12" name="">
             <a:extLst xmlns:a="http://schemas.openxmlformats.org/drawingml/2006/main">
               <a:ext uri="{FF2B5EF4-FFF2-40B4-BE49-F238E27FC236}">
-                <a16:creationId xmlns:a16="http://schemas.microsoft.com/office/drawing/2014/main" id="{6B78EFA3-99A5-43B2-91DD-9F0F730274F0}"/>
+                <a16:creationId xmlns:a16="http://schemas.microsoft.com/office/drawing/2014/main" id="{E7E73206-36CF-4B56-91F7-60DC37BFE0A1}"/>
               </a:ext>
             </a:extLst>
           </p:cNvPr>
@@ -2603,7 +2603,7 @@
           <p:cNvPr id="2" name="">
             <a:extLst xmlns:a="http://schemas.openxmlformats.org/drawingml/2006/main">
               <a:ext uri="{FF2B5EF4-FFF2-40B4-BE49-F238E27FC236}">
-                <a16:creationId xmlns:a16="http://schemas.microsoft.com/office/drawing/2014/main" id="{0E7415B0-65BC-4F52-A03F-B9DEB50FFA6F}"/>
+                <a16:creationId xmlns:a16="http://schemas.microsoft.com/office/drawing/2014/main" id="{1E2D2320-DAC0-4C9F-9AB1-66B51F4057CD}"/>
               </a:ext>
             </a:extLst>
           </p:cNvPr>
@@ -2660,7 +2660,7 @@
           <p:cNvPr id="3" name="">
             <a:extLst xmlns:a="http://schemas.openxmlformats.org/drawingml/2006/main">
               <a:ext uri="{FF2B5EF4-FFF2-40B4-BE49-F238E27FC236}">
-                <a16:creationId xmlns:a16="http://schemas.microsoft.com/office/drawing/2014/main" id="{776FDAC4-8700-4F74-B3AE-D1034E897F91}"/>
+                <a16:creationId xmlns:a16="http://schemas.microsoft.com/office/drawing/2014/main" id="{5301E6EE-6D30-4634-9652-C788ABEFB15B}"/>
               </a:ext>
             </a:extLst>
           </p:cNvPr>
@@ -2717,7 +2717,7 @@
           <p:cNvPr id="4" name="">
             <a:extLst xmlns:a="http://schemas.openxmlformats.org/drawingml/2006/main">
               <a:ext uri="{FF2B5EF4-FFF2-40B4-BE49-F238E27FC236}">
-                <a16:creationId xmlns:a16="http://schemas.microsoft.com/office/drawing/2014/main" id="{2FD95940-6778-4ECF-A17D-5C5F2C42246D}"/>
+                <a16:creationId xmlns:a16="http://schemas.microsoft.com/office/drawing/2014/main" id="{2A472845-4AAF-4D80-94DA-CACEF8D7700D}"/>
               </a:ext>
             </a:extLst>
           </p:cNvPr>
@@ -2774,7 +2774,7 @@
           <p:cNvPr id="5" name="">
             <a:extLst xmlns:a="http://schemas.openxmlformats.org/drawingml/2006/main">
               <a:ext uri="{FF2B5EF4-FFF2-40B4-BE49-F238E27FC236}">
-                <a16:creationId xmlns:a16="http://schemas.microsoft.com/office/drawing/2014/main" id="{A9554DBF-AF6D-4F29-B86C-607744E609E3}"/>
+                <a16:creationId xmlns:a16="http://schemas.microsoft.com/office/drawing/2014/main" id="{528F8AD2-568E-4ED5-9AAA-16916BC46390}"/>
               </a:ext>
             </a:extLst>
           </p:cNvPr>
@@ -2831,7 +2831,7 @@
           <p:cNvPr id="6" name="">
             <a:extLst xmlns:a="http://schemas.openxmlformats.org/drawingml/2006/main">
               <a:ext uri="{FF2B5EF4-FFF2-40B4-BE49-F238E27FC236}">
-                <a16:creationId xmlns:a16="http://schemas.microsoft.com/office/drawing/2014/main" id="{FDF99ABF-8BB1-405C-8325-C91CAB0AE1F4}"/>
+                <a16:creationId xmlns:a16="http://schemas.microsoft.com/office/drawing/2014/main" id="{7320F779-83C5-415C-BE4E-03BB0A262BCC}"/>
               </a:ext>
             </a:extLst>
           </p:cNvPr>
@@ -2888,7 +2888,7 @@
           <p:cNvPr id="7" name="">
             <a:extLst xmlns:a="http://schemas.openxmlformats.org/drawingml/2006/main">
               <a:ext uri="{FF2B5EF4-FFF2-40B4-BE49-F238E27FC236}">
-                <a16:creationId xmlns:a16="http://schemas.microsoft.com/office/drawing/2014/main" id="{E34066BC-9D35-48E6-A46C-192617D0B553}"/>
+                <a16:creationId xmlns:a16="http://schemas.microsoft.com/office/drawing/2014/main" id="{379F312B-630E-48D0-B6F7-C318E06A146A}"/>
               </a:ext>
             </a:extLst>
           </p:cNvPr>
@@ -2945,7 +2945,7 @@
           <p:cNvPr id="8" name="">
             <a:extLst xmlns:a="http://schemas.openxmlformats.org/drawingml/2006/main">
               <a:ext uri="{FF2B5EF4-FFF2-40B4-BE49-F238E27FC236}">
-                <a16:creationId xmlns:a16="http://schemas.microsoft.com/office/drawing/2014/main" id="{D502F80C-6F16-4F94-8096-3F162D62A73B}"/>
+                <a16:creationId xmlns:a16="http://schemas.microsoft.com/office/drawing/2014/main" id="{923FB148-AD29-4A15-A131-50A08ABA6891}"/>
               </a:ext>
             </a:extLst>
           </p:cNvPr>
@@ -3002,7 +3002,7 @@
           <p:cNvPr id="9" name="">
             <a:extLst xmlns:a="http://schemas.openxmlformats.org/drawingml/2006/main">
               <a:ext uri="{FF2B5EF4-FFF2-40B4-BE49-F238E27FC236}">
-                <a16:creationId xmlns:a16="http://schemas.microsoft.com/office/drawing/2014/main" id="{540D0862-D477-4A3F-9C1A-7E23ED356637}"/>
+                <a16:creationId xmlns:a16="http://schemas.microsoft.com/office/drawing/2014/main" id="{9721E28D-0796-400D-9D43-93A60C4F5DF1}"/>
               </a:ext>
             </a:extLst>
           </p:cNvPr>
@@ -3059,7 +3059,7 @@
           <p:cNvPr id="10" name="">
             <a:extLst xmlns:a="http://schemas.openxmlformats.org/drawingml/2006/main">
               <a:ext uri="{FF2B5EF4-FFF2-40B4-BE49-F238E27FC236}">
-                <a16:creationId xmlns:a16="http://schemas.microsoft.com/office/drawing/2014/main" id="{B46295B3-B47C-4442-B86E-EFCA0F58E495}"/>
+                <a16:creationId xmlns:a16="http://schemas.microsoft.com/office/drawing/2014/main" id="{4C8CD0DD-8103-456D-BB5D-CC8B994657B6}"/>
               </a:ext>
             </a:extLst>
           </p:cNvPr>
@@ -3116,7 +3116,7 @@
           <p:cNvPr id="11" name="">
             <a:extLst xmlns:a="http://schemas.openxmlformats.org/drawingml/2006/main">
               <a:ext uri="{FF2B5EF4-FFF2-40B4-BE49-F238E27FC236}">
-                <a16:creationId xmlns:a16="http://schemas.microsoft.com/office/drawing/2014/main" id="{3D7B5CD4-1BD1-4A71-A971-7320EC09CCED}"/>
+                <a16:creationId xmlns:a16="http://schemas.microsoft.com/office/drawing/2014/main" id="{F05DAA05-4D90-48DF-83E6-65B7C266A0FF}"/>
               </a:ext>
             </a:extLst>
           </p:cNvPr>
@@ -3194,7 +3194,7 @@
     </p:spTree>
     <p:extLst>
       <p:ext uri="{BB962C8B-B14F-4D97-AF65-F5344CB8AC3E}">
-        <p14:creationId xmlns:p14="http://schemas.microsoft.com/office/powerpoint/2010/main" val="2098475925"/>
+        <p14:creationId xmlns:p14="http://schemas.microsoft.com/office/powerpoint/2010/main" val="2030792755"/>
       </p:ext>
     </p:extLst>
   </p:cSld>
@@ -3225,7 +3225,7 @@
           <p:cNvPr id="5" name="">
             <a:extLst xmlns:a="http://schemas.openxmlformats.org/drawingml/2006/main">
               <a:ext uri="{FF2B5EF4-FFF2-40B4-BE49-F238E27FC236}">
-                <a16:creationId xmlns:a16="http://schemas.microsoft.com/office/drawing/2014/main" id="{4673AD92-8990-4E92-B4E5-C4539C7B164E}"/>
+                <a16:creationId xmlns:a16="http://schemas.microsoft.com/office/drawing/2014/main" id="{843FBC93-EBA2-44A4-9258-B4B7151068F6}"/>
               </a:ext>
             </a:extLst>
           </p:cNvPr>
@@ -3992,7 +3992,7 @@
           <p:cNvPr id="3" name="">
             <a:extLst xmlns:a="http://schemas.openxmlformats.org/drawingml/2006/main">
               <a:ext uri="{FF2B5EF4-FFF2-40B4-BE49-F238E27FC236}">
-                <a16:creationId xmlns:a16="http://schemas.microsoft.com/office/drawing/2014/main" id="{B1CF8E93-30A1-4A4D-824F-D6AE8D478E0C}"/>
+                <a16:creationId xmlns:a16="http://schemas.microsoft.com/office/drawing/2014/main" id="{3BFA7B34-CBA0-4E8F-B412-A3340810BE42}"/>
               </a:ext>
             </a:extLst>
           </p:cNvPr>
@@ -4072,7 +4072,7 @@
           <p:cNvPr id="4" name="">
             <a:extLst xmlns:a="http://schemas.openxmlformats.org/drawingml/2006/main">
               <a:ext uri="{FF2B5EF4-FFF2-40B4-BE49-F238E27FC236}">
-                <a16:creationId xmlns:a16="http://schemas.microsoft.com/office/drawing/2014/main" id="{DD47A220-EFF2-4C78-AE86-59CC0D4C55EF}"/>
+                <a16:creationId xmlns:a16="http://schemas.microsoft.com/office/drawing/2014/main" id="{BFF30153-121D-4671-9917-8702C53F1156}"/>
               </a:ext>
             </a:extLst>
           </p:cNvPr>
@@ -4127,7 +4127,7 @@
     </p:spTree>
     <p:extLst>
       <p:ext uri="{BB962C8B-B14F-4D97-AF65-F5344CB8AC3E}">
-        <p14:creationId xmlns:p14="http://schemas.microsoft.com/office/powerpoint/2010/main" val="652522180"/>
+        <p14:creationId xmlns:p14="http://schemas.microsoft.com/office/powerpoint/2010/main" val="2058895215"/>
       </p:ext>
     </p:extLst>
   </p:cSld>
@@ -4158,7 +4158,7 @@
           <p:cNvPr id="5" name="">
             <a:extLst xmlns:a="http://schemas.openxmlformats.org/drawingml/2006/main">
               <a:ext uri="{FF2B5EF4-FFF2-40B4-BE49-F238E27FC236}">
-                <a16:creationId xmlns:a16="http://schemas.microsoft.com/office/drawing/2014/main" id="{9642B19D-08AC-4868-9559-E3AC65789305}"/>
+                <a16:creationId xmlns:a16="http://schemas.microsoft.com/office/drawing/2014/main" id="{585BE1B7-F06B-4464-B74C-EB3FF529C004}"/>
               </a:ext>
             </a:extLst>
           </p:cNvPr>
@@ -4205,7 +4205,7 @@
                 <a:ea typeface="Arial"/>
                 <a:cs typeface="Arial"/>
               </a:rPr>
-              <a:t>Experiment 2: remove comments</a:t>
+              <a:t>Ablation: restrict the code-pattern vocabulary</a:t>
             </a:r>
           </a:p>
         </p:txBody>
@@ -4225,10 +4225,10 @@
             <a:tbl>
               <a:tblPr/>
               <a:tblGrid>
-                <a:gridCol w="3905250"/>
-                <a:gridCol w="2381250"/>
-                <a:gridCol w="2762250"/>
-                <a:gridCol w="2000250"/>
+                <a:gridCol w="3810000"/>
+                <a:gridCol w="2571750"/>
+                <a:gridCol w="2476500"/>
+                <a:gridCol w="2190750"/>
               </a:tblGrid>
               <a:tr h="542925">
                 <a:tc>
@@ -4275,7 +4275,7 @@
                           <a:ea typeface="Arial"/>
                           <a:cs typeface="Arial"/>
                         </a:rPr>
-                        <a:t>Original</a:t>
+                        <a:t>50,000 features</a:t>
                       </a:r>
                     </a:p>
                   </a:txBody>
@@ -4302,7 +4302,7 @@
                           <a:ea typeface="Arial"/>
                           <a:cs typeface="Arial"/>
                         </a:rPr>
-                        <a:t>No comments</a:t>
+                        <a:t>500 features</a:t>
                       </a:r>
                     </a:p>
                   </a:txBody>
@@ -4412,7 +4412,7 @@
                           <a:ea typeface="Arial"/>
                           <a:cs typeface="Arial"/>
                         </a:rPr>
-                        <a:t>0.6883</a:t>
+                        <a:t>0.7336</a:t>
                       </a:r>
                     </a:p>
                   </a:txBody>
@@ -4522,7 +4522,7 @@
                           <a:ea typeface="Arial"/>
                           <a:cs typeface="Arial"/>
                         </a:rPr>
-                        <a:t>0.6580</a:t>
+                        <a:t>0.7197</a:t>
                       </a:r>
                     </a:p>
                   </a:txBody>
@@ -4632,7 +4632,7 @@
                           <a:ea typeface="Arial"/>
                           <a:cs typeface="Arial"/>
                         </a:rPr>
-                        <a:t>0.6453</a:t>
+                        <a:t>0.6614</a:t>
                       </a:r>
                     </a:p>
                   </a:txBody>
@@ -4742,7 +4742,7 @@
                           <a:ea typeface="Arial"/>
                           <a:cs typeface="Arial"/>
                         </a:rPr>
-                        <a:t>0.5287</a:t>
+                        <a:t>0.5214</a:t>
                       </a:r>
                     </a:p>
                   </a:txBody>
@@ -4789,7 +4789,7 @@
           <p:cNvPr id="3" name="">
             <a:extLst xmlns:a="http://schemas.openxmlformats.org/drawingml/2006/main">
               <a:ext uri="{FF2B5EF4-FFF2-40B4-BE49-F238E27FC236}">
-                <a16:creationId xmlns:a16="http://schemas.microsoft.com/office/drawing/2014/main" id="{6A18D446-33B9-42B9-B75A-830DB9B0C79F}"/>
+                <a16:creationId xmlns:a16="http://schemas.microsoft.com/office/drawing/2014/main" id="{5F08BF02-F422-4D2E-9D67-BEC93E9DB899}"/>
               </a:ext>
             </a:extLst>
           </p:cNvPr>
@@ -4836,7 +4836,7 @@
                 <a:ea typeface="Arial"/>
                 <a:cs typeface="Arial"/>
               </a:rPr>
-              <a:t>Prediction: removing comment cues would narrow SVM's lead over LR.</a:t>
+              <a:t>Prediction: fewer patterns would narrow SVM’s lead over LR.</a:t>
             </a:r>
           </a:p>
           <a:p xmlns:a="http://schemas.openxmlformats.org/drawingml/2006/main">
@@ -4859,7 +4859,7 @@
                 <a:ea typeface="Arial"/>
                 <a:cs typeface="Arial"/>
               </a:rPr>
-              <a:t>Observed validation gap: 1.49 to 3.03 percentage points.</a:t>
+              <a:t>Observed: 1.49 to 1.39 percentage points. Rankings did not change.</a:t>
             </a:r>
           </a:p>
         </p:txBody>
@@ -4869,7 +4869,7 @@
           <p:cNvPr id="4" name="">
             <a:extLst xmlns:a="http://schemas.openxmlformats.org/drawingml/2006/main">
               <a:ext uri="{FF2B5EF4-FFF2-40B4-BE49-F238E27FC236}">
-                <a16:creationId xmlns:a16="http://schemas.microsoft.com/office/drawing/2014/main" id="{85EB0D7D-6C2A-49E1-B6CE-350B53E15710}"/>
+                <a16:creationId xmlns:a16="http://schemas.microsoft.com/office/drawing/2014/main" id="{108BEF3B-75C1-4C25-A102-B6ADC1AB733E}"/>
               </a:ext>
             </a:extLst>
           </p:cNvPr>
@@ -4898,7 +4898,7 @@
           <a:lstStyle xmlns:a="http://schemas.openxmlformats.org/drawingml/2006/main"/>
           <a:p xmlns:a="http://schemas.openxmlformats.org/drawingml/2006/main">
             <a:pPr>
-              <a:defRPr sz="2100" b="1">
+              <a:defRPr sz="2025" b="1">
                 <a:solidFill>
                   <a:srgbClr val="117C83"/>
                 </a:solidFill>
@@ -4908,7 +4908,7 @@
               </a:defRPr>
             </a:pPr>
             <a:r>
-              <a:rPr sz="2100" b="1">
+              <a:rPr sz="2025" b="1">
                 <a:solidFill>
                   <a:srgbClr val="117C83"/>
                 </a:solidFill>
@@ -4916,12 +4916,12 @@
                 <a:ea typeface="Arial"/>
                 <a:cs typeface="Arial"/>
               </a:rPr>
-              <a:t>All models lose F1. Rankings stay the same.</a:t>
+              <a:t>Weak support for the gap prediction, not a full explanation.</a:t>
             </a:r>
           </a:p>
           <a:p xmlns:a="http://schemas.openxmlformats.org/drawingml/2006/main">
             <a:pPr>
-              <a:defRPr sz="2100" b="1">
+              <a:defRPr sz="2025" b="1">
                 <a:solidFill>
                   <a:srgbClr val="117C83"/>
                 </a:solidFill>
@@ -4931,7 +4931,7 @@
               </a:defRPr>
             </a:pPr>
             <a:r>
-              <a:rPr sz="2100" b="1">
+              <a:rPr sz="2025" b="1">
                 <a:solidFill>
                   <a:srgbClr val="117C83"/>
                 </a:solidFill>
@@ -4939,7 +4939,7 @@
                 <a:ea typeface="Arial"/>
                 <a:cs typeface="Arial"/>
               </a:rPr>
-              <a:t>Comments help attribution, but do not explain why SVM wins.</a:t>
+              <a:t>Removing comments also hurt all models without changing ranks.</a:t>
             </a:r>
           </a:p>
         </p:txBody>
@@ -4947,7 +4947,7 @@
     </p:spTree>
     <p:extLst>
       <p:ext uri="{BB962C8B-B14F-4D97-AF65-F5344CB8AC3E}">
-        <p14:creationId xmlns:p14="http://schemas.microsoft.com/office/powerpoint/2010/main" val="819662805"/>
+        <p14:creationId xmlns:p14="http://schemas.microsoft.com/office/powerpoint/2010/main" val="1724817866"/>
       </p:ext>
     </p:extLst>
   </p:cSld>

</xml_diff>

<commit_message>
Add result figures and metric formulas; remove Colab notebook
</commit_message>
<xml_diff>
--- a/submission/Assignment.pptx
+++ b/submission/Assignment.pptx
@@ -2,17 +2,17 @@
 <file path=ppt/presentation.xml><?xml version="1.0" encoding="utf-8"?>
 <p:presentation xmlns:p="http://schemas.openxmlformats.org/presentationml/2006/main">
   <p:sldMasterIdLst>
-    <p:sldMasterId xmlns:r="http://schemas.openxmlformats.org/officeDocument/2006/relationships" id="2147483648" r:id="R147245d4e7244151"/>
+    <p:sldMasterId xmlns:r="http://schemas.openxmlformats.org/officeDocument/2006/relationships" id="2147483648" r:id="R63a29f5e7f25410c"/>
   </p:sldMasterIdLst>
   <p:notesMasterIdLst>
-    <p:notesMasterId xmlns:r="http://schemas.openxmlformats.org/officeDocument/2006/relationships" r:id="R151822d007ed4d44"/>
+    <p:notesMasterId xmlns:r="http://schemas.openxmlformats.org/officeDocument/2006/relationships" r:id="R73d731f2d13c4f17"/>
   </p:notesMasterIdLst>
   <p:sldIdLst>
-    <p:sldId xmlns:r="http://schemas.openxmlformats.org/officeDocument/2006/relationships" id="256" r:id="Rc6cb655fdb92407e"/>
-    <p:sldId xmlns:r="http://schemas.openxmlformats.org/officeDocument/2006/relationships" id="257" r:id="Rd2711ebb707b4853"/>
-    <p:sldId xmlns:r="http://schemas.openxmlformats.org/officeDocument/2006/relationships" id="258" r:id="R0d67ed93676d44ce"/>
-    <p:sldId xmlns:r="http://schemas.openxmlformats.org/officeDocument/2006/relationships" id="259" r:id="Rebeb006bcc6847b9"/>
-    <p:sldId xmlns:r="http://schemas.openxmlformats.org/officeDocument/2006/relationships" id="260" r:id="Rb4368a08eb3543bf"/>
+    <p:sldId xmlns:r="http://schemas.openxmlformats.org/officeDocument/2006/relationships" id="256" r:id="R783fb77b17f94040"/>
+    <p:sldId xmlns:r="http://schemas.openxmlformats.org/officeDocument/2006/relationships" id="257" r:id="R9e3de1344307478d"/>
+    <p:sldId xmlns:r="http://schemas.openxmlformats.org/officeDocument/2006/relationships" id="258" r:id="R5f46e31709024883"/>
+    <p:sldId xmlns:r="http://schemas.openxmlformats.org/officeDocument/2006/relationships" id="259" r:id="Rcf1d0d5c8d504f5f"/>
+    <p:sldId xmlns:r="http://schemas.openxmlformats.org/officeDocument/2006/relationships" id="260" r:id="R645a7e4cb6394c49"/>
   </p:sldIdLst>
   <p:sldSz cx="12192000" cy="6858000"/>
   <p:notesSz cx="6858000" cy="9144000"/>
@@ -656,7 +656,7 @@
           <a:lstStyle xmlns:a="http://schemas.openxmlformats.org/drawingml/2006/main"/>
           <a:p xmlns:a="http://schemas.openxmlformats.org/drawingml/2006/main">
             <a:r>
-              <a:t>Source: results/metrics.csv. Test scores use 3,872 programs. Training timings depend on hardware; vectorizer extraction time and size are stored separately in each experiment features.json. Five labels match the paper, but the split and feature setup differ. These scores do not reproduce the published benchmark. No confidence interval or statistical significance is claimed.</a:t>
+              <a:t>Sources: results/metrics.csv and results/experiment_1_original/Linear SVM_test_confusion.csv. Matrix shows raw counts for 3,872 test programs. Labels abbreviated: Claude is claude-3.5-haiku, DeepSeek is deepseek-chat, Gemini is gemini-2.5-flash-preview-05-20, GPT-4.1 is gpt-4.1 and Llama is llama-3.3-70b-instruct. Rows are actual labels, columns predictions. SVM selected using validation Macro-F1 0.8062. Timings and compressed classifier sizes exclude shared TF-IDF. Single split, no significance claim.</a:t>
             </a:r>
           </a:p>
         </p:txBody>
@@ -794,7 +794,7 @@
   </p:cSld>
   <p:clrMap bg1="lt1" tx1="dk1" bg2="lt2" tx2="dk2" accent1="accent1" accent2="accent2" accent3="accent3" accent4="accent4" accent5="accent5" accent6="accent6" hlink="hlink" folHlink="folHlink"/>
   <p:sldLayoutIdLst>
-    <p:sldLayoutId xmlns:r="http://schemas.openxmlformats.org/officeDocument/2006/relationships" id="2147483649" r:id="R937ea570cae24c6c"/>
+    <p:sldLayoutId xmlns:r="http://schemas.openxmlformats.org/officeDocument/2006/relationships" id="2147483649" r:id="Rcbf0d320b4a44ce5"/>
   </p:sldLayoutIdLst>
   <p:txStyles>
     <p:titleStyle>
@@ -1345,7 +1345,7 @@
           <p:cNvPr id="7" name="">
             <a:extLst xmlns:a="http://schemas.openxmlformats.org/drawingml/2006/main">
               <a:ext uri="{FF2B5EF4-FFF2-40B4-BE49-F238E27FC236}">
-                <a16:creationId xmlns:a16="http://schemas.microsoft.com/office/drawing/2014/main" id="{5F6A74C2-4F95-419D-9DBD-CCFB1E3E5257}"/>
+                <a16:creationId xmlns:a16="http://schemas.microsoft.com/office/drawing/2014/main" id="{77AE8B64-FC45-4AD2-B7A4-8E78D8BFD4BE}"/>
               </a:ext>
             </a:extLst>
           </p:cNvPr>
@@ -1402,7 +1402,7 @@
           <p:cNvPr id="2" name="">
             <a:extLst xmlns:a="http://schemas.openxmlformats.org/drawingml/2006/main">
               <a:ext uri="{FF2B5EF4-FFF2-40B4-BE49-F238E27FC236}">
-                <a16:creationId xmlns:a16="http://schemas.microsoft.com/office/drawing/2014/main" id="{8E4BB4D5-534A-44C7-A5C3-59666DA26E91}"/>
+                <a16:creationId xmlns:a16="http://schemas.microsoft.com/office/drawing/2014/main" id="{FB6B09E2-372C-4250-B3C4-263C192ACD1A}"/>
               </a:ext>
             </a:extLst>
           </p:cNvPr>
@@ -1459,7 +1459,7 @@
           <p:cNvPr id="3" name="">
             <a:extLst xmlns:a="http://schemas.openxmlformats.org/drawingml/2006/main">
               <a:ext uri="{FF2B5EF4-FFF2-40B4-BE49-F238E27FC236}">
-                <a16:creationId xmlns:a16="http://schemas.microsoft.com/office/drawing/2014/main" id="{D971DD85-EF1D-489C-85A2-D5F492BEE8A6}"/>
+                <a16:creationId xmlns:a16="http://schemas.microsoft.com/office/drawing/2014/main" id="{37608EE4-F721-4AB6-BE4E-750D7CD898BB}"/>
               </a:ext>
             </a:extLst>
           </p:cNvPr>
@@ -1539,7 +1539,7 @@
           <p:cNvPr id="4" name="">
             <a:extLst xmlns:a="http://schemas.openxmlformats.org/drawingml/2006/main">
               <a:ext uri="{FF2B5EF4-FFF2-40B4-BE49-F238E27FC236}">
-                <a16:creationId xmlns:a16="http://schemas.microsoft.com/office/drawing/2014/main" id="{0080827F-6AEA-4AED-A29B-1A0884EDE0F3}"/>
+                <a16:creationId xmlns:a16="http://schemas.microsoft.com/office/drawing/2014/main" id="{8FCE3108-4B7B-468E-BAAF-DBF573DAE9F1}"/>
               </a:ext>
             </a:extLst>
           </p:cNvPr>
@@ -1619,7 +1619,7 @@
           <p:cNvPr id="5" name="">
             <a:extLst xmlns:a="http://schemas.openxmlformats.org/drawingml/2006/main">
               <a:ext uri="{FF2B5EF4-FFF2-40B4-BE49-F238E27FC236}">
-                <a16:creationId xmlns:a16="http://schemas.microsoft.com/office/drawing/2014/main" id="{653B837F-B21A-4585-92AC-1F9B37305BE4}"/>
+                <a16:creationId xmlns:a16="http://schemas.microsoft.com/office/drawing/2014/main" id="{9D5EA350-EE39-4251-9701-5E4953DAD2BF}"/>
               </a:ext>
             </a:extLst>
           </p:cNvPr>
@@ -1676,7 +1676,7 @@
           <p:cNvPr id="6" name="">
             <a:extLst xmlns:a="http://schemas.openxmlformats.org/drawingml/2006/main">
               <a:ext uri="{FF2B5EF4-FFF2-40B4-BE49-F238E27FC236}">
-                <a16:creationId xmlns:a16="http://schemas.microsoft.com/office/drawing/2014/main" id="{15D3F4E7-6178-4263-95A2-80B5BA4BDD1B}"/>
+                <a16:creationId xmlns:a16="http://schemas.microsoft.com/office/drawing/2014/main" id="{8BA9ED1C-55F0-4C81-B40C-A23E44C66ED6}"/>
               </a:ext>
             </a:extLst>
           </p:cNvPr>
@@ -1731,7 +1731,7 @@
     </p:spTree>
     <p:extLst>
       <p:ext uri="{BB962C8B-B14F-4D97-AF65-F5344CB8AC3E}">
-        <p14:creationId xmlns:p14="http://schemas.microsoft.com/office/powerpoint/2010/main" val="1489348571"/>
+        <p14:creationId xmlns:p14="http://schemas.microsoft.com/office/powerpoint/2010/main" val="1431277627"/>
       </p:ext>
     </p:extLst>
   </p:cSld>
@@ -1762,7 +1762,7 @@
           <p:cNvPr id="7" name="">
             <a:extLst xmlns:a="http://schemas.openxmlformats.org/drawingml/2006/main">
               <a:ext uri="{FF2B5EF4-FFF2-40B4-BE49-F238E27FC236}">
-                <a16:creationId xmlns:a16="http://schemas.microsoft.com/office/drawing/2014/main" id="{77304140-8A41-4C17-BDB0-7E8DD0DE3B9C}"/>
+                <a16:creationId xmlns:a16="http://schemas.microsoft.com/office/drawing/2014/main" id="{83FA1A6F-7C27-4DE6-AD42-16DE75E5A448}"/>
               </a:ext>
             </a:extLst>
           </p:cNvPr>
@@ -2174,7 +2174,7 @@
           <p:cNvPr id="3" name="">
             <a:extLst xmlns:a="http://schemas.openxmlformats.org/drawingml/2006/main">
               <a:ext uri="{FF2B5EF4-FFF2-40B4-BE49-F238E27FC236}">
-                <a16:creationId xmlns:a16="http://schemas.microsoft.com/office/drawing/2014/main" id="{5CCAF138-6D34-4ED9-AC8B-8E80B7603FB5}"/>
+                <a16:creationId xmlns:a16="http://schemas.microsoft.com/office/drawing/2014/main" id="{E2153699-B6D9-45DC-90DA-2B8C93F9448D}"/>
               </a:ext>
             </a:extLst>
           </p:cNvPr>
@@ -2277,7 +2277,7 @@
           <p:cNvPr id="4" name="">
             <a:extLst xmlns:a="http://schemas.openxmlformats.org/drawingml/2006/main">
               <a:ext uri="{FF2B5EF4-FFF2-40B4-BE49-F238E27FC236}">
-                <a16:creationId xmlns:a16="http://schemas.microsoft.com/office/drawing/2014/main" id="{53FDAA8F-E2BD-4A3C-A996-60C9CA866B24}"/>
+                <a16:creationId xmlns:a16="http://schemas.microsoft.com/office/drawing/2014/main" id="{CB28F9F6-BE66-4C1A-8BAE-49EBCBBA8A71}"/>
               </a:ext>
             </a:extLst>
           </p:cNvPr>
@@ -2380,7 +2380,7 @@
           <p:cNvPr id="5" name="">
             <a:extLst xmlns:a="http://schemas.openxmlformats.org/drawingml/2006/main">
               <a:ext uri="{FF2B5EF4-FFF2-40B4-BE49-F238E27FC236}">
-                <a16:creationId xmlns:a16="http://schemas.microsoft.com/office/drawing/2014/main" id="{DE15496B-94E5-41AF-9A4A-C19CD292DF82}"/>
+                <a16:creationId xmlns:a16="http://schemas.microsoft.com/office/drawing/2014/main" id="{4082A76E-FD6A-4C21-ABA0-B45746873ADF}"/>
               </a:ext>
             </a:extLst>
           </p:cNvPr>
@@ -2460,7 +2460,7 @@
           <p:cNvPr id="6" name="">
             <a:extLst xmlns:a="http://schemas.openxmlformats.org/drawingml/2006/main">
               <a:ext uri="{FF2B5EF4-FFF2-40B4-BE49-F238E27FC236}">
-                <a16:creationId xmlns:a16="http://schemas.microsoft.com/office/drawing/2014/main" id="{9127EC34-23E1-45B1-AFD1-7D8A0EA64A7D}"/>
+                <a16:creationId xmlns:a16="http://schemas.microsoft.com/office/drawing/2014/main" id="{5581F71B-51D3-4047-B0E2-A7137D765F15}"/>
               </a:ext>
             </a:extLst>
           </p:cNvPr>
@@ -2515,7 +2515,7 @@
     </p:spTree>
     <p:extLst>
       <p:ext uri="{BB962C8B-B14F-4D97-AF65-F5344CB8AC3E}">
-        <p14:creationId xmlns:p14="http://schemas.microsoft.com/office/powerpoint/2010/main" val="1001095405"/>
+        <p14:creationId xmlns:p14="http://schemas.microsoft.com/office/powerpoint/2010/main" val="1427523030"/>
       </p:ext>
     </p:extLst>
   </p:cSld>
@@ -2543,10 +2543,10 @@
       </p:grpSpPr>
       <p:sp>
         <p:nvSpPr>
-          <p:cNvPr id="12" name="">
+          <p:cNvPr id="13" name="">
             <a:extLst xmlns:a="http://schemas.openxmlformats.org/drawingml/2006/main">
               <a:ext uri="{FF2B5EF4-FFF2-40B4-BE49-F238E27FC236}">
-                <a16:creationId xmlns:a16="http://schemas.microsoft.com/office/drawing/2014/main" id="{E7E73206-36CF-4B56-91F7-60DC37BFE0A1}"/>
+                <a16:creationId xmlns:a16="http://schemas.microsoft.com/office/drawing/2014/main" id="{FF616124-4688-498C-9AC9-B7AAC83B2E46}"/>
               </a:ext>
             </a:extLst>
           </p:cNvPr>
@@ -2603,7 +2603,7 @@
           <p:cNvPr id="2" name="">
             <a:extLst xmlns:a="http://schemas.openxmlformats.org/drawingml/2006/main">
               <a:ext uri="{FF2B5EF4-FFF2-40B4-BE49-F238E27FC236}">
-                <a16:creationId xmlns:a16="http://schemas.microsoft.com/office/drawing/2014/main" id="{1E2D2320-DAC0-4C9F-9AB1-66B51F4057CD}"/>
+                <a16:creationId xmlns:a16="http://schemas.microsoft.com/office/drawing/2014/main" id="{9EAF72D8-56E3-4DE4-B1DE-16BE5F6FAE0E}"/>
               </a:ext>
             </a:extLst>
           </p:cNvPr>
@@ -2660,7 +2660,7 @@
           <p:cNvPr id="3" name="">
             <a:extLst xmlns:a="http://schemas.openxmlformats.org/drawingml/2006/main">
               <a:ext uri="{FF2B5EF4-FFF2-40B4-BE49-F238E27FC236}">
-                <a16:creationId xmlns:a16="http://schemas.microsoft.com/office/drawing/2014/main" id="{5301E6EE-6D30-4634-9652-C788ABEFB15B}"/>
+                <a16:creationId xmlns:a16="http://schemas.microsoft.com/office/drawing/2014/main" id="{E73E074A-F0E1-493C-8B5E-6695927D410C}"/>
               </a:ext>
             </a:extLst>
           </p:cNvPr>
@@ -2671,7 +2671,7 @@
         </p:nvSpPr>
         <p:spPr>
           <a:xfrm xmlns:a="http://schemas.openxmlformats.org/drawingml/2006/main">
-            <a:off x="571500" y="2428875"/>
+            <a:off x="571500" y="2114550"/>
             <a:ext cx="4143375" cy="457200"/>
           </a:xfrm>
           <a:prstGeom xmlns:a="http://schemas.openxmlformats.org/drawingml/2006/main" prst="rect">
@@ -2717,7 +2717,7 @@
           <p:cNvPr id="4" name="">
             <a:extLst xmlns:a="http://schemas.openxmlformats.org/drawingml/2006/main">
               <a:ext uri="{FF2B5EF4-FFF2-40B4-BE49-F238E27FC236}">
-                <a16:creationId xmlns:a16="http://schemas.microsoft.com/office/drawing/2014/main" id="{2A472845-4AAF-4D80-94DA-CACEF8D7700D}"/>
+                <a16:creationId xmlns:a16="http://schemas.microsoft.com/office/drawing/2014/main" id="{8746A9B1-C976-408C-9E3B-CA4FC05E9479}"/>
               </a:ext>
             </a:extLst>
           </p:cNvPr>
@@ -2728,7 +2728,7 @@
         </p:nvSpPr>
         <p:spPr>
           <a:xfrm xmlns:a="http://schemas.openxmlformats.org/drawingml/2006/main">
-            <a:off x="5238750" y="2428875"/>
+            <a:off x="5238750" y="2114550"/>
             <a:ext cx="6096000" cy="457200"/>
           </a:xfrm>
           <a:prstGeom xmlns:a="http://schemas.openxmlformats.org/drawingml/2006/main" prst="rect">
@@ -2774,7 +2774,7 @@
           <p:cNvPr id="5" name="">
             <a:extLst xmlns:a="http://schemas.openxmlformats.org/drawingml/2006/main">
               <a:ext uri="{FF2B5EF4-FFF2-40B4-BE49-F238E27FC236}">
-                <a16:creationId xmlns:a16="http://schemas.microsoft.com/office/drawing/2014/main" id="{528F8AD2-568E-4ED5-9AAA-16916BC46390}"/>
+                <a16:creationId xmlns:a16="http://schemas.microsoft.com/office/drawing/2014/main" id="{49B8534D-1BF7-4013-B66A-04D0E41CE69C}"/>
               </a:ext>
             </a:extLst>
           </p:cNvPr>
@@ -2785,7 +2785,7 @@
         </p:nvSpPr>
         <p:spPr>
           <a:xfrm xmlns:a="http://schemas.openxmlformats.org/drawingml/2006/main">
-            <a:off x="571500" y="3076575"/>
+            <a:off x="571500" y="2647950"/>
             <a:ext cx="4143375" cy="457200"/>
           </a:xfrm>
           <a:prstGeom xmlns:a="http://schemas.openxmlformats.org/drawingml/2006/main" prst="rect">
@@ -2831,7 +2831,7 @@
           <p:cNvPr id="6" name="">
             <a:extLst xmlns:a="http://schemas.openxmlformats.org/drawingml/2006/main">
               <a:ext uri="{FF2B5EF4-FFF2-40B4-BE49-F238E27FC236}">
-                <a16:creationId xmlns:a16="http://schemas.microsoft.com/office/drawing/2014/main" id="{7320F779-83C5-415C-BE4E-03BB0A262BCC}"/>
+                <a16:creationId xmlns:a16="http://schemas.microsoft.com/office/drawing/2014/main" id="{1D3B7919-BF73-42C8-811D-421410BDBB80}"/>
               </a:ext>
             </a:extLst>
           </p:cNvPr>
@@ -2842,7 +2842,7 @@
         </p:nvSpPr>
         <p:spPr>
           <a:xfrm xmlns:a="http://schemas.openxmlformats.org/drawingml/2006/main">
-            <a:off x="5238750" y="3076575"/>
+            <a:off x="5238750" y="2647950"/>
             <a:ext cx="6096000" cy="457200"/>
           </a:xfrm>
           <a:prstGeom xmlns:a="http://schemas.openxmlformats.org/drawingml/2006/main" prst="rect">
@@ -2888,7 +2888,7 @@
           <p:cNvPr id="7" name="">
             <a:extLst xmlns:a="http://schemas.openxmlformats.org/drawingml/2006/main">
               <a:ext uri="{FF2B5EF4-FFF2-40B4-BE49-F238E27FC236}">
-                <a16:creationId xmlns:a16="http://schemas.microsoft.com/office/drawing/2014/main" id="{379F312B-630E-48D0-B6F7-C318E06A146A}"/>
+                <a16:creationId xmlns:a16="http://schemas.microsoft.com/office/drawing/2014/main" id="{D148FDBB-540C-45F7-9AB4-443CC6AE94A3}"/>
               </a:ext>
             </a:extLst>
           </p:cNvPr>
@@ -2899,7 +2899,7 @@
         </p:nvSpPr>
         <p:spPr>
           <a:xfrm xmlns:a="http://schemas.openxmlformats.org/drawingml/2006/main">
-            <a:off x="571500" y="3724275"/>
+            <a:off x="571500" y="3181350"/>
             <a:ext cx="4143375" cy="457200"/>
           </a:xfrm>
           <a:prstGeom xmlns:a="http://schemas.openxmlformats.org/drawingml/2006/main" prst="rect">
@@ -2945,7 +2945,7 @@
           <p:cNvPr id="8" name="">
             <a:extLst xmlns:a="http://schemas.openxmlformats.org/drawingml/2006/main">
               <a:ext uri="{FF2B5EF4-FFF2-40B4-BE49-F238E27FC236}">
-                <a16:creationId xmlns:a16="http://schemas.microsoft.com/office/drawing/2014/main" id="{923FB148-AD29-4A15-A131-50A08ABA6891}"/>
+                <a16:creationId xmlns:a16="http://schemas.microsoft.com/office/drawing/2014/main" id="{3DFA98A6-C246-4649-9D9E-04654E80F4EA}"/>
               </a:ext>
             </a:extLst>
           </p:cNvPr>
@@ -2956,7 +2956,7 @@
         </p:nvSpPr>
         <p:spPr>
           <a:xfrm xmlns:a="http://schemas.openxmlformats.org/drawingml/2006/main">
-            <a:off x="5238750" y="3724275"/>
+            <a:off x="5238750" y="3181350"/>
             <a:ext cx="6096000" cy="457200"/>
           </a:xfrm>
           <a:prstGeom xmlns:a="http://schemas.openxmlformats.org/drawingml/2006/main" prst="rect">
@@ -3002,7 +3002,7 @@
           <p:cNvPr id="9" name="">
             <a:extLst xmlns:a="http://schemas.openxmlformats.org/drawingml/2006/main">
               <a:ext uri="{FF2B5EF4-FFF2-40B4-BE49-F238E27FC236}">
-                <a16:creationId xmlns:a16="http://schemas.microsoft.com/office/drawing/2014/main" id="{9721E28D-0796-400D-9D43-93A60C4F5DF1}"/>
+                <a16:creationId xmlns:a16="http://schemas.microsoft.com/office/drawing/2014/main" id="{E82C7E5E-A0E6-4879-B422-29D651CCC07E}"/>
               </a:ext>
             </a:extLst>
           </p:cNvPr>
@@ -3013,7 +3013,7 @@
         </p:nvSpPr>
         <p:spPr>
           <a:xfrm xmlns:a="http://schemas.openxmlformats.org/drawingml/2006/main">
-            <a:off x="571500" y="4371975"/>
+            <a:off x="571500" y="3714750"/>
             <a:ext cx="4143375" cy="457200"/>
           </a:xfrm>
           <a:prstGeom xmlns:a="http://schemas.openxmlformats.org/drawingml/2006/main" prst="rect">
@@ -3059,7 +3059,7 @@
           <p:cNvPr id="10" name="">
             <a:extLst xmlns:a="http://schemas.openxmlformats.org/drawingml/2006/main">
               <a:ext uri="{FF2B5EF4-FFF2-40B4-BE49-F238E27FC236}">
-                <a16:creationId xmlns:a16="http://schemas.microsoft.com/office/drawing/2014/main" id="{4C8CD0DD-8103-456D-BB5D-CC8B994657B6}"/>
+                <a16:creationId xmlns:a16="http://schemas.microsoft.com/office/drawing/2014/main" id="{2F73650F-7524-4FEE-9893-968C4109109D}"/>
               </a:ext>
             </a:extLst>
           </p:cNvPr>
@@ -3070,7 +3070,7 @@
         </p:nvSpPr>
         <p:spPr>
           <a:xfrm xmlns:a="http://schemas.openxmlformats.org/drawingml/2006/main">
-            <a:off x="5238750" y="4371975"/>
+            <a:off x="5238750" y="3714750"/>
             <a:ext cx="6096000" cy="457200"/>
           </a:xfrm>
           <a:prstGeom xmlns:a="http://schemas.openxmlformats.org/drawingml/2006/main" prst="rect">
@@ -3116,7 +3116,7 @@
           <p:cNvPr id="11" name="">
             <a:extLst xmlns:a="http://schemas.openxmlformats.org/drawingml/2006/main">
               <a:ext uri="{FF2B5EF4-FFF2-40B4-BE49-F238E27FC236}">
-                <a16:creationId xmlns:a16="http://schemas.microsoft.com/office/drawing/2014/main" id="{F05DAA05-4D90-48DF-83E6-65B7C266A0FF}"/>
+                <a16:creationId xmlns:a16="http://schemas.microsoft.com/office/drawing/2014/main" id="{3144B875-D7ED-464F-8B97-96A54E1284E3}"/>
               </a:ext>
             </a:extLst>
           </p:cNvPr>
@@ -3127,8 +3127,8 @@
         </p:nvSpPr>
         <p:spPr>
           <a:xfrm xmlns:a="http://schemas.openxmlformats.org/drawingml/2006/main">
-            <a:off x="571500" y="5429250"/>
-            <a:ext cx="10953750" cy="838200"/>
+            <a:off x="571500" y="4591050"/>
+            <a:ext cx="11049000" cy="895350"/>
           </a:xfrm>
           <a:prstGeom xmlns:a="http://schemas.openxmlformats.org/drawingml/2006/main" prst="rect">
             <a:avLst/>
@@ -3145,9 +3145,9 @@
           <a:lstStyle xmlns:a="http://schemas.openxmlformats.org/drawingml/2006/main"/>
           <a:p xmlns:a="http://schemas.openxmlformats.org/drawingml/2006/main">
             <a:pPr>
-              <a:defRPr sz="2100" b="0">
-                <a:solidFill>
-                  <a:srgbClr val="152E38"/>
+              <a:defRPr sz="2175" b="1">
+                <a:solidFill>
+                  <a:srgbClr val="117C83"/>
                 </a:solidFill>
                 <a:latin typeface="Arial"/>
                 <a:ea typeface="Arial"/>
@@ -3155,22 +3155,22 @@
               </a:defRPr>
             </a:pPr>
             <a:r>
-              <a:rPr sz="2100" b="0">
-                <a:solidFill>
-                  <a:srgbClr val="152E38"/>
+              <a:rPr sz="2175" b="1">
+                <a:solidFill>
+                  <a:srgbClr val="117C83"/>
                 </a:solidFill>
                 <a:latin typeface="Arial"/>
                 <a:ea typeface="Arial"/>
                 <a:cs typeface="Arial"/>
               </a:rPr>
-              <a:t>Keep comments and identifiers. Seed 42 where supported.</a:t>
+              <a:t>F1 = 2 × precision × recall / (precision + recall)</a:t>
             </a:r>
           </a:p>
           <a:p xmlns:a="http://schemas.openxmlformats.org/drawingml/2006/main">
             <a:pPr>
-              <a:defRPr sz="2100" b="0">
-                <a:solidFill>
-                  <a:srgbClr val="152E38"/>
+              <a:defRPr sz="2175" b="1">
+                <a:solidFill>
+                  <a:srgbClr val="117C83"/>
                 </a:solidFill>
                 <a:latin typeface="Arial"/>
                 <a:ea typeface="Arial"/>
@@ -3178,23 +3178,80 @@
               </a:defRPr>
             </a:pPr>
             <a:r>
-              <a:rPr sz="2100" b="0">
-                <a:solidFill>
-                  <a:srgbClr val="152E38"/>
+              <a:rPr sz="2175" b="1">
+                <a:solidFill>
+                  <a:srgbClr val="117C83"/>
                 </a:solidFill>
                 <a:latin typeface="Arial"/>
                 <a:ea typeface="Arial"/>
                 <a:cs typeface="Arial"/>
               </a:rPr>
-              <a:t>Select the model with the highest validation Macro-F1.</a:t>
+              <a:t>Macro-F1 = average of the five class F1 scores</a:t>
             </a:r>
           </a:p>
         </p:txBody>
       </p:sp>
+      <p:sp>
+        <p:nvSpPr>
+          <p:cNvPr id="12" name="">
+            <a:extLst xmlns:a="http://schemas.openxmlformats.org/drawingml/2006/main">
+              <a:ext uri="{FF2B5EF4-FFF2-40B4-BE49-F238E27FC236}">
+                <a16:creationId xmlns:a16="http://schemas.microsoft.com/office/drawing/2014/main" id="{1BDD8B95-C3F1-4216-A438-1893F67CBE2A}"/>
+              </a:ext>
+            </a:extLst>
+          </p:cNvPr>
+          <p:cNvSpPr>
+            <a:spLocks xmlns:a="http://schemas.openxmlformats.org/drawingml/2006/main" noGrp="1"/>
+          </p:cNvSpPr>
+          <p:nvPr/>
+        </p:nvSpPr>
+        <p:spPr>
+          <a:xfrm xmlns:a="http://schemas.openxmlformats.org/drawingml/2006/main">
+            <a:off x="571500" y="5876925"/>
+            <a:ext cx="11049000" cy="409575"/>
+          </a:xfrm>
+          <a:prstGeom xmlns:a="http://schemas.openxmlformats.org/drawingml/2006/main" prst="rect">
+            <a:avLst/>
+          </a:prstGeom>
+          <a:noFill xmlns:a="http://schemas.openxmlformats.org/drawingml/2006/main"/>
+          <a:ln xmlns:a="http://schemas.openxmlformats.org/drawingml/2006/main" w="0">
+            <a:noFill/>
+          </a:ln>
+        </p:spPr>
+        <p:txBody>
+          <a:bodyPr xmlns:a="http://schemas.openxmlformats.org/drawingml/2006/main" lIns="0" tIns="0" rIns="0" bIns="0">
+            <a:noAutofit/>
+          </a:bodyPr>
+          <a:lstStyle xmlns:a="http://schemas.openxmlformats.org/drawingml/2006/main"/>
+          <a:p xmlns:a="http://schemas.openxmlformats.org/drawingml/2006/main">
+            <a:pPr>
+              <a:defRPr sz="1950" b="0">
+                <a:solidFill>
+                  <a:srgbClr val="152E38"/>
+                </a:solidFill>
+                <a:latin typeface="Arial"/>
+                <a:ea typeface="Arial"/>
+                <a:cs typeface="Arial"/>
+              </a:defRPr>
+            </a:pPr>
+            <a:r>
+              <a:rPr sz="1950" b="0">
+                <a:solidFill>
+                  <a:srgbClr val="152E38"/>
+                </a:solidFill>
+                <a:latin typeface="Arial"/>
+                <a:ea typeface="Arial"/>
+                <a:cs typeface="Arial"/>
+              </a:rPr>
+              <a:t>Select using validation Macro-F1. Each LLM class has equal weight.</a:t>
+            </a:r>
+          </a:p>
+        </p:txBody>
+      </p:sp>
     </p:spTree>
     <p:extLst>
       <p:ext uri="{BB962C8B-B14F-4D97-AF65-F5344CB8AC3E}">
-        <p14:creationId xmlns:p14="http://schemas.microsoft.com/office/powerpoint/2010/main" val="2030792755"/>
+        <p14:creationId xmlns:p14="http://schemas.microsoft.com/office/powerpoint/2010/main" val="1952846311"/>
       </p:ext>
     </p:extLst>
   </p:cSld>
@@ -3222,10 +3279,10 @@
       </p:grpSpPr>
       <p:sp>
         <p:nvSpPr>
-          <p:cNvPr id="5" name="">
+          <p:cNvPr id="6" name="">
             <a:extLst xmlns:a="http://schemas.openxmlformats.org/drawingml/2006/main">
               <a:ext uri="{FF2B5EF4-FFF2-40B4-BE49-F238E27FC236}">
-                <a16:creationId xmlns:a16="http://schemas.microsoft.com/office/drawing/2014/main" id="{843FBC93-EBA2-44A4-9258-B4B7151068F6}"/>
+                <a16:creationId xmlns:a16="http://schemas.microsoft.com/office/drawing/2014/main" id="{0E07F51B-90B7-4763-8523-BDF78EEE1AF9}"/>
               </a:ext>
             </a:extLst>
           </p:cNvPr>
@@ -3272,31 +3329,31 @@
                 <a:ea typeface="Arial"/>
                 <a:cs typeface="Arial"/>
               </a:rPr>
-              <a:t>Experiment 1: results</a:t>
+              <a:t>Results and SVM classification errors</a:t>
             </a:r>
           </a:p>
         </p:txBody>
       </p:sp>
       <p:graphicFrame>
         <p:nvGraphicFramePr>
-          <p:cNvPr id="6" name=""/>
+          <p:cNvPr id="7" name=""/>
           <p:cNvGraphicFramePr/>
           <p:nvPr/>
         </p:nvGraphicFramePr>
         <p:xfrm>
-          <a:off xmlns:a="http://schemas.openxmlformats.org/drawingml/2006/main" x="571500" y="1657350"/>
-          <a:ext xmlns:a="http://schemas.openxmlformats.org/drawingml/2006/main" cx="11049000" cy="2905125"/>
+          <a:off xmlns:a="http://schemas.openxmlformats.org/drawingml/2006/main" x="476250" y="1657350"/>
+          <a:ext xmlns:a="http://schemas.openxmlformats.org/drawingml/2006/main" cx="6762750" cy="2905125"/>
         </p:xfrm>
         <a:graphic xmlns:a="http://schemas.openxmlformats.org/drawingml/2006/main">
           <a:graphicData uri="http://schemas.openxmlformats.org/drawingml/2006/table">
             <a:tbl>
               <a:tblPr/>
               <a:tblGrid>
-                <a:gridCol w="3619500"/>
-                <a:gridCol w="1809750"/>
-                <a:gridCol w="1809750"/>
-                <a:gridCol w="1809750"/>
-                <a:gridCol w="2000250"/>
+                <a:gridCol w="2476500"/>
+                <a:gridCol w="1143000"/>
+                <a:gridCol w="1238250"/>
+                <a:gridCol w="952500"/>
+                <a:gridCol w="952500"/>
               </a:tblGrid>
               <a:tr h="581025">
                 <a:tc>
@@ -3308,7 +3365,7 @@
                     <a:p>
                       <a:pPr algn="l"/>
                       <a:r>
-                        <a:rPr sz="1875" b="1">
+                        <a:rPr sz="1650" b="1">
                           <a:solidFill>
                             <a:srgbClr val="FFFFFF"/>
                           </a:solidFill>
@@ -3335,7 +3392,7 @@
                     <a:p>
                       <a:pPr algn="ctr"/>
                       <a:r>
-                        <a:rPr sz="1875" b="1">
+                        <a:rPr sz="1650" b="1">
                           <a:solidFill>
                             <a:srgbClr val="FFFFFF"/>
                           </a:solidFill>
@@ -3362,7 +3419,7 @@
                     <a:p>
                       <a:pPr algn="ctr"/>
                       <a:r>
-                        <a:rPr sz="1875" b="1">
+                        <a:rPr sz="1650" b="1">
                           <a:solidFill>
                             <a:srgbClr val="FFFFFF"/>
                           </a:solidFill>
@@ -3389,7 +3446,7 @@
                     <a:p>
                       <a:pPr algn="ctr"/>
                       <a:r>
-                        <a:rPr sz="1875" b="1">
+                        <a:rPr sz="1650" b="1">
                           <a:solidFill>
                             <a:srgbClr val="FFFFFF"/>
                           </a:solidFill>
@@ -3416,7 +3473,7 @@
                     <a:p>
                       <a:pPr algn="ctr"/>
                       <a:r>
-                        <a:rPr sz="1875" b="1">
+                        <a:rPr sz="1650" b="1">
                           <a:solidFill>
                             <a:srgbClr val="FFFFFF"/>
                           </a:solidFill>
@@ -3424,7 +3481,7 @@
                           <a:ea typeface="Arial"/>
                           <a:cs typeface="Arial"/>
                         </a:rPr>
-                        <a:t>Size (MB)</a:t>
+                        <a:t>MB</a:t>
                       </a:r>
                     </a:p>
                   </a:txBody>
@@ -3445,7 +3502,7 @@
                     <a:p>
                       <a:pPr algn="l"/>
                       <a:r>
-                        <a:rPr sz="1950" b="0">
+                        <a:rPr sz="1725" b="0">
                           <a:solidFill>
                             <a:srgbClr val="152E38"/>
                           </a:solidFill>
@@ -3472,7 +3529,7 @@
                     <a:p>
                       <a:pPr algn="ctr"/>
                       <a:r>
-                        <a:rPr sz="1950" b="0">
+                        <a:rPr sz="1725" b="0">
                           <a:solidFill>
                             <a:srgbClr val="152E38"/>
                           </a:solidFill>
@@ -3499,7 +3556,7 @@
                     <a:p>
                       <a:pPr algn="ctr"/>
                       <a:r>
-                        <a:rPr sz="1950" b="0">
+                        <a:rPr sz="1725" b="0">
                           <a:solidFill>
                             <a:srgbClr val="152E38"/>
                           </a:solidFill>
@@ -3526,7 +3583,7 @@
                     <a:p>
                       <a:pPr algn="ctr"/>
                       <a:r>
-                        <a:rPr sz="1950" b="0">
+                        <a:rPr sz="1725" b="0">
                           <a:solidFill>
                             <a:srgbClr val="152E38"/>
                           </a:solidFill>
@@ -3553,7 +3610,7 @@
                     <a:p>
                       <a:pPr algn="ctr"/>
                       <a:r>
-                        <a:rPr sz="1950" b="0">
+                        <a:rPr sz="1725" b="0">
                           <a:solidFill>
                             <a:srgbClr val="152E38"/>
                           </a:solidFill>
@@ -3582,7 +3639,7 @@
                     <a:p>
                       <a:pPr algn="l"/>
                       <a:r>
-                        <a:rPr sz="1950" b="0">
+                        <a:rPr sz="1725" b="0">
                           <a:solidFill>
                             <a:srgbClr val="152E38"/>
                           </a:solidFill>
@@ -3609,7 +3666,7 @@
                     <a:p>
                       <a:pPr algn="ctr"/>
                       <a:r>
-                        <a:rPr sz="1950" b="0">
+                        <a:rPr sz="1725" b="0">
                           <a:solidFill>
                             <a:srgbClr val="152E38"/>
                           </a:solidFill>
@@ -3636,7 +3693,7 @@
                     <a:p>
                       <a:pPr algn="ctr"/>
                       <a:r>
-                        <a:rPr sz="1950" b="0">
+                        <a:rPr sz="1725" b="0">
                           <a:solidFill>
                             <a:srgbClr val="152E38"/>
                           </a:solidFill>
@@ -3663,7 +3720,7 @@
                     <a:p>
                       <a:pPr algn="ctr"/>
                       <a:r>
-                        <a:rPr sz="1950" b="0">
+                        <a:rPr sz="1725" b="0">
                           <a:solidFill>
                             <a:srgbClr val="152E38"/>
                           </a:solidFill>
@@ -3690,7 +3747,7 @@
                     <a:p>
                       <a:pPr algn="ctr"/>
                       <a:r>
-                        <a:rPr sz="1950" b="0">
+                        <a:rPr sz="1725" b="0">
                           <a:solidFill>
                             <a:srgbClr val="152E38"/>
                           </a:solidFill>
@@ -3719,7 +3776,7 @@
                     <a:p>
                       <a:pPr algn="l"/>
                       <a:r>
-                        <a:rPr sz="1950" b="1">
+                        <a:rPr sz="1725" b="1">
                           <a:solidFill>
                             <a:srgbClr val="152E38"/>
                           </a:solidFill>
@@ -3746,7 +3803,7 @@
                     <a:p>
                       <a:pPr algn="ctr"/>
                       <a:r>
-                        <a:rPr sz="1950" b="1">
+                        <a:rPr sz="1725" b="1">
                           <a:solidFill>
                             <a:srgbClr val="152E38"/>
                           </a:solidFill>
@@ -3773,7 +3830,7 @@
                     <a:p>
                       <a:pPr algn="ctr"/>
                       <a:r>
-                        <a:rPr sz="1950" b="1">
+                        <a:rPr sz="1725" b="1">
                           <a:solidFill>
                             <a:srgbClr val="152E38"/>
                           </a:solidFill>
@@ -3800,7 +3857,7 @@
                     <a:p>
                       <a:pPr algn="ctr"/>
                       <a:r>
-                        <a:rPr sz="1950" b="1">
+                        <a:rPr sz="1725" b="1">
                           <a:solidFill>
                             <a:srgbClr val="152E38"/>
                           </a:solidFill>
@@ -3827,7 +3884,7 @@
                     <a:p>
                       <a:pPr algn="ctr"/>
                       <a:r>
-                        <a:rPr sz="1950" b="1">
+                        <a:rPr sz="1725" b="1">
                           <a:solidFill>
                             <a:srgbClr val="152E38"/>
                           </a:solidFill>
@@ -3856,7 +3913,7 @@
                     <a:p>
                       <a:pPr algn="l"/>
                       <a:r>
-                        <a:rPr sz="1950" b="0">
+                        <a:rPr sz="1725" b="0">
                           <a:solidFill>
                             <a:srgbClr val="152E38"/>
                           </a:solidFill>
@@ -3883,7 +3940,7 @@
                     <a:p>
                       <a:pPr algn="ctr"/>
                       <a:r>
-                        <a:rPr sz="1950" b="0">
+                        <a:rPr sz="1725" b="0">
                           <a:solidFill>
                             <a:srgbClr val="152E38"/>
                           </a:solidFill>
@@ -3910,7 +3967,7 @@
                     <a:p>
                       <a:pPr algn="ctr"/>
                       <a:r>
-                        <a:rPr sz="1950" b="0">
+                        <a:rPr sz="1725" b="0">
                           <a:solidFill>
                             <a:srgbClr val="152E38"/>
                           </a:solidFill>
@@ -3937,7 +3994,7 @@
                     <a:p>
                       <a:pPr algn="ctr"/>
                       <a:r>
-                        <a:rPr sz="1950" b="0">
+                        <a:rPr sz="1725" b="0">
                           <a:solidFill>
                             <a:srgbClr val="152E38"/>
                           </a:solidFill>
@@ -3964,7 +4021,7 @@
                     <a:p>
                       <a:pPr algn="ctr"/>
                       <a:r>
-                        <a:rPr sz="1950" b="0">
+                        <a:rPr sz="1725" b="0">
                           <a:solidFill>
                             <a:srgbClr val="152E38"/>
                           </a:solidFill>
@@ -3987,12 +4044,34 @@
           </a:graphicData>
         </a:graphic>
       </p:graphicFrame>
-      <p:sp>
-        <p:nvSpPr>
-          <p:cNvPr id="3" name="">
+      <p:pic>
+        <p:nvPicPr>
+          <p:cNvPr id="8" name=""/>
+          <p:cNvPicPr>
+            <a:picLocks xmlns:a="http://schemas.openxmlformats.org/drawingml/2006/main" noChangeAspect="1"/>
+          </p:cNvPicPr>
+          <p:nvPr/>
+        </p:nvPicPr>
+        <p:blipFill>
+          <a:blip xmlns:r="http://schemas.openxmlformats.org/officeDocument/2006/relationships" xmlns:a="http://schemas.openxmlformats.org/drawingml/2006/main" r:embed="R3c4ecda0ac844eb6"/>
+          <a:stretch xmlns:a="http://schemas.openxmlformats.org/drawingml/2006/main"/>
+        </p:blipFill>
+        <p:spPr>
+          <a:xfrm xmlns:a="http://schemas.openxmlformats.org/drawingml/2006/main">
+            <a:off x="7410450" y="1333500"/>
+            <a:ext cx="4667250" cy="4667250"/>
+          </a:xfrm>
+          <a:prstGeom xmlns:a="http://schemas.openxmlformats.org/drawingml/2006/main" prst="rect">
+            <a:avLst/>
+          </a:prstGeom>
+        </p:spPr>
+      </p:pic>
+      <p:sp>
+        <p:nvSpPr>
+          <p:cNvPr id="4" name="">
             <a:extLst xmlns:a="http://schemas.openxmlformats.org/drawingml/2006/main">
               <a:ext uri="{FF2B5EF4-FFF2-40B4-BE49-F238E27FC236}">
-                <a16:creationId xmlns:a16="http://schemas.microsoft.com/office/drawing/2014/main" id="{3BFA7B34-CBA0-4E8F-B412-A3340810BE42}"/>
+                <a16:creationId xmlns:a16="http://schemas.microsoft.com/office/drawing/2014/main" id="{AA49DD9B-055A-415C-961C-21548E98591D}"/>
               </a:ext>
             </a:extLst>
           </p:cNvPr>
@@ -4003,8 +4082,8 @@
         </p:nvSpPr>
         <p:spPr>
           <a:xfrm xmlns:a="http://schemas.openxmlformats.org/drawingml/2006/main">
-            <a:off x="571500" y="5010150"/>
-            <a:ext cx="10858500" cy="857250"/>
+            <a:off x="571500" y="5095875"/>
+            <a:ext cx="6667500" cy="876300"/>
           </a:xfrm>
           <a:prstGeom xmlns:a="http://schemas.openxmlformats.org/drawingml/2006/main" prst="rect">
             <a:avLst/>
@@ -4021,7 +4100,7 @@
           <a:lstStyle xmlns:a="http://schemas.openxmlformats.org/drawingml/2006/main"/>
           <a:p xmlns:a="http://schemas.openxmlformats.org/drawingml/2006/main">
             <a:pPr>
-              <a:defRPr sz="2250" b="1">
+              <a:defRPr sz="2025" b="1">
                 <a:solidFill>
                   <a:srgbClr val="117C83"/>
                 </a:solidFill>
@@ -4031,7 +4110,7 @@
               </a:defRPr>
             </a:pPr>
             <a:r>
-              <a:rPr sz="2250" b="1">
+              <a:rPr sz="2025" b="1">
                 <a:solidFill>
                   <a:srgbClr val="117C83"/>
                 </a:solidFill>
@@ -4039,12 +4118,12 @@
                 <a:ea typeface="Arial"/>
                 <a:cs typeface="Arial"/>
               </a:rPr>
-              <a:t>Linear SVM leads on validation and test.</a:t>
+              <a:t>SVM test accuracy: 79.75%</a:t>
             </a:r>
           </a:p>
           <a:p xmlns:a="http://schemas.openxmlformats.org/drawingml/2006/main">
             <a:pPr>
-              <a:defRPr sz="2250" b="1">
+              <a:defRPr sz="2025" b="1">
                 <a:solidFill>
                   <a:srgbClr val="117C83"/>
                 </a:solidFill>
@@ -4054,7 +4133,7 @@
               </a:defRPr>
             </a:pPr>
             <a:r>
-              <a:rPr sz="2250" b="1">
+              <a:rPr sz="2025" b="1">
                 <a:solidFill>
                   <a:srgbClr val="117C83"/>
                 </a:solidFill>
@@ -4062,17 +4141,17 @@
                 <a:ea typeface="Arial"/>
                 <a:cs typeface="Arial"/>
               </a:rPr>
-              <a:t>Validation Macro-F1: 0.8062</a:t>
+              <a:t>Correct predictions lie on the matrix diagonal.</a:t>
             </a:r>
           </a:p>
         </p:txBody>
       </p:sp>
       <p:sp>
         <p:nvSpPr>
-          <p:cNvPr id="4" name="">
+          <p:cNvPr id="5" name="">
             <a:extLst xmlns:a="http://schemas.openxmlformats.org/drawingml/2006/main">
               <a:ext uri="{FF2B5EF4-FFF2-40B4-BE49-F238E27FC236}">
-                <a16:creationId xmlns:a16="http://schemas.microsoft.com/office/drawing/2014/main" id="{BFF30153-121D-4671-9917-8702C53F1156}"/>
+                <a16:creationId xmlns:a16="http://schemas.microsoft.com/office/drawing/2014/main" id="{8ECC7E48-2CF4-40BF-9753-907875B43ED4}"/>
               </a:ext>
             </a:extLst>
           </p:cNvPr>
@@ -4083,8 +4162,8 @@
         </p:nvSpPr>
         <p:spPr>
           <a:xfrm xmlns:a="http://schemas.openxmlformats.org/drawingml/2006/main">
-            <a:off x="571500" y="6124575"/>
-            <a:ext cx="11049000" cy="333375"/>
+            <a:off x="571500" y="6257925"/>
+            <a:ext cx="11049000" cy="323850"/>
           </a:xfrm>
           <a:prstGeom xmlns:a="http://schemas.openxmlformats.org/drawingml/2006/main" prst="rect">
             <a:avLst/>
@@ -4101,7 +4180,7 @@
           <a:lstStyle xmlns:a="http://schemas.openxmlformats.org/drawingml/2006/main"/>
           <a:p xmlns:a="http://schemas.openxmlformats.org/drawingml/2006/main">
             <a:pPr>
-              <a:defRPr sz="1800" b="0">
+              <a:defRPr sz="1725" b="0">
                 <a:solidFill>
                   <a:srgbClr val="50636B"/>
                 </a:solidFill>
@@ -4111,7 +4190,7 @@
               </a:defRPr>
             </a:pPr>
             <a:r>
-              <a:rPr sz="1800" b="0">
+              <a:rPr sz="1725" b="0">
                 <a:solidFill>
                   <a:srgbClr val="50636B"/>
                 </a:solidFill>
@@ -4119,7 +4198,7 @@
                 <a:ea typeface="Arial"/>
                 <a:cs typeface="Arial"/>
               </a:rPr>
-              <a:t>Single-run times exclude TF-IDF. Size is the compressed classifier.</a:t>
+              <a:t>Fit time excludes TF-IDF. MB measures the compressed classifier.</a:t>
             </a:r>
           </a:p>
         </p:txBody>
@@ -4127,7 +4206,7 @@
     </p:spTree>
     <p:extLst>
       <p:ext uri="{BB962C8B-B14F-4D97-AF65-F5344CB8AC3E}">
-        <p14:creationId xmlns:p14="http://schemas.microsoft.com/office/powerpoint/2010/main" val="2058895215"/>
+        <p14:creationId xmlns:p14="http://schemas.microsoft.com/office/powerpoint/2010/main" val="1863823771"/>
       </p:ext>
     </p:extLst>
   </p:cSld>
@@ -4158,7 +4237,7 @@
           <p:cNvPr id="5" name="">
             <a:extLst xmlns:a="http://schemas.openxmlformats.org/drawingml/2006/main">
               <a:ext uri="{FF2B5EF4-FFF2-40B4-BE49-F238E27FC236}">
-                <a16:creationId xmlns:a16="http://schemas.microsoft.com/office/drawing/2014/main" id="{585BE1B7-F06B-4464-B74C-EB3FF529C004}"/>
+                <a16:creationId xmlns:a16="http://schemas.microsoft.com/office/drawing/2014/main" id="{53890294-D55C-47C7-A498-6BB4BE0A19A0}"/>
               </a:ext>
             </a:extLst>
           </p:cNvPr>
@@ -4210,586 +4289,34 @@
           </a:p>
         </p:txBody>
       </p:sp>
-      <p:graphicFrame>
-        <p:nvGraphicFramePr>
+      <p:pic>
+        <p:nvPicPr>
           <p:cNvPr id="6" name=""/>
-          <p:cNvGraphicFramePr/>
+          <p:cNvPicPr>
+            <a:picLocks xmlns:a="http://schemas.openxmlformats.org/drawingml/2006/main" noChangeAspect="1"/>
+          </p:cNvPicPr>
           <p:nvPr/>
-        </p:nvGraphicFramePr>
-        <p:xfrm>
-          <a:off xmlns:a="http://schemas.openxmlformats.org/drawingml/2006/main" x="571500" y="1476375"/>
-          <a:ext xmlns:a="http://schemas.openxmlformats.org/drawingml/2006/main" cx="11049000" cy="2714625"/>
-        </p:xfrm>
-        <a:graphic xmlns:a="http://schemas.openxmlformats.org/drawingml/2006/main">
-          <a:graphicData uri="http://schemas.openxmlformats.org/drawingml/2006/table">
-            <a:tbl>
-              <a:tblPr/>
-              <a:tblGrid>
-                <a:gridCol w="3810000"/>
-                <a:gridCol w="2571750"/>
-                <a:gridCol w="2476500"/>
-                <a:gridCol w="2190750"/>
-              </a:tblGrid>
-              <a:tr h="542925">
-                <a:tc>
-                  <a:txBody>
-                    <a:bodyPr>
-                      <a:noAutofit/>
-                    </a:bodyPr>
-                    <a:lstStyle/>
-                    <a:p>
-                      <a:pPr algn="l"/>
-                      <a:r>
-                        <a:rPr sz="1875" b="1">
-                          <a:solidFill>
-                            <a:srgbClr val="FFFFFF"/>
-                          </a:solidFill>
-                          <a:latin typeface="Arial"/>
-                          <a:ea typeface="Arial"/>
-                          <a:cs typeface="Arial"/>
-                        </a:rPr>
-                        <a:t>Validation F1</a:t>
-                      </a:r>
-                    </a:p>
-                  </a:txBody>
-                  <a:tcPr marL="91440" marR="91440" marT="45720" marB="45720">
-                    <a:solidFill>
-                      <a:srgbClr val="152E38"/>
-                    </a:solidFill>
-                  </a:tcPr>
-                </a:tc>
-                <a:tc>
-                  <a:txBody>
-                    <a:bodyPr>
-                      <a:noAutofit/>
-                    </a:bodyPr>
-                    <a:lstStyle/>
-                    <a:p>
-                      <a:pPr algn="ctr"/>
-                      <a:r>
-                        <a:rPr sz="1875" b="1">
-                          <a:solidFill>
-                            <a:srgbClr val="FFFFFF"/>
-                          </a:solidFill>
-                          <a:latin typeface="Arial"/>
-                          <a:ea typeface="Arial"/>
-                          <a:cs typeface="Arial"/>
-                        </a:rPr>
-                        <a:t>50,000 features</a:t>
-                      </a:r>
-                    </a:p>
-                  </a:txBody>
-                  <a:tcPr marL="91440" marR="91440" marT="45720" marB="45720">
-                    <a:solidFill>
-                      <a:srgbClr val="152E38"/>
-                    </a:solidFill>
-                  </a:tcPr>
-                </a:tc>
-                <a:tc>
-                  <a:txBody>
-                    <a:bodyPr>
-                      <a:noAutofit/>
-                    </a:bodyPr>
-                    <a:lstStyle/>
-                    <a:p>
-                      <a:pPr algn="ctr"/>
-                      <a:r>
-                        <a:rPr sz="1875" b="1">
-                          <a:solidFill>
-                            <a:srgbClr val="FFFFFF"/>
-                          </a:solidFill>
-                          <a:latin typeface="Arial"/>
-                          <a:ea typeface="Arial"/>
-                          <a:cs typeface="Arial"/>
-                        </a:rPr>
-                        <a:t>500 features</a:t>
-                      </a:r>
-                    </a:p>
-                  </a:txBody>
-                  <a:tcPr marL="91440" marR="91440" marT="45720" marB="45720">
-                    <a:solidFill>
-                      <a:srgbClr val="152E38"/>
-                    </a:solidFill>
-                  </a:tcPr>
-                </a:tc>
-                <a:tc>
-                  <a:txBody>
-                    <a:bodyPr>
-                      <a:noAutofit/>
-                    </a:bodyPr>
-                    <a:lstStyle/>
-                    <a:p>
-                      <a:pPr algn="ctr"/>
-                      <a:r>
-                        <a:rPr sz="1875" b="1">
-                          <a:solidFill>
-                            <a:srgbClr val="FFFFFF"/>
-                          </a:solidFill>
-                          <a:latin typeface="Arial"/>
-                          <a:ea typeface="Arial"/>
-                          <a:cs typeface="Arial"/>
-                        </a:rPr>
-                        <a:t>Rank</a:t>
-                      </a:r>
-                    </a:p>
-                  </a:txBody>
-                  <a:tcPr marL="91440" marR="91440" marT="45720" marB="45720">
-                    <a:solidFill>
-                      <a:srgbClr val="152E38"/>
-                    </a:solidFill>
-                  </a:tcPr>
-                </a:tc>
-              </a:tr>
-              <a:tr h="542925">
-                <a:tc>
-                  <a:txBody>
-                    <a:bodyPr>
-                      <a:noAutofit/>
-                    </a:bodyPr>
-                    <a:lstStyle/>
-                    <a:p>
-                      <a:pPr algn="l"/>
-                      <a:r>
-                        <a:rPr sz="1950" b="1">
-                          <a:solidFill>
-                            <a:srgbClr val="152E38"/>
-                          </a:solidFill>
-                          <a:latin typeface="Arial"/>
-                          <a:ea typeface="Arial"/>
-                          <a:cs typeface="Arial"/>
-                        </a:rPr>
-                        <a:t>Linear SVM</a:t>
-                      </a:r>
-                    </a:p>
-                  </a:txBody>
-                  <a:tcPr marL="91440" marR="91440" marT="45720" marB="45720">
-                    <a:solidFill>
-                      <a:srgbClr val="E0F0ED"/>
-                    </a:solidFill>
-                  </a:tcPr>
-                </a:tc>
-                <a:tc>
-                  <a:txBody>
-                    <a:bodyPr>
-                      <a:noAutofit/>
-                    </a:bodyPr>
-                    <a:lstStyle/>
-                    <a:p>
-                      <a:pPr algn="ctr"/>
-                      <a:r>
-                        <a:rPr sz="1950" b="1">
-                          <a:solidFill>
-                            <a:srgbClr val="152E38"/>
-                          </a:solidFill>
-                          <a:latin typeface="Arial"/>
-                          <a:ea typeface="Arial"/>
-                          <a:cs typeface="Arial"/>
-                        </a:rPr>
-                        <a:t>0.8062</a:t>
-                      </a:r>
-                    </a:p>
-                  </a:txBody>
-                  <a:tcPr marL="91440" marR="91440" marT="45720" marB="45720">
-                    <a:solidFill>
-                      <a:srgbClr val="E0F0ED"/>
-                    </a:solidFill>
-                  </a:tcPr>
-                </a:tc>
-                <a:tc>
-                  <a:txBody>
-                    <a:bodyPr>
-                      <a:noAutofit/>
-                    </a:bodyPr>
-                    <a:lstStyle/>
-                    <a:p>
-                      <a:pPr algn="ctr"/>
-                      <a:r>
-                        <a:rPr sz="1950" b="1">
-                          <a:solidFill>
-                            <a:srgbClr val="152E38"/>
-                          </a:solidFill>
-                          <a:latin typeface="Arial"/>
-                          <a:ea typeface="Arial"/>
-                          <a:cs typeface="Arial"/>
-                        </a:rPr>
-                        <a:t>0.7336</a:t>
-                      </a:r>
-                    </a:p>
-                  </a:txBody>
-                  <a:tcPr marL="91440" marR="91440" marT="45720" marB="45720">
-                    <a:solidFill>
-                      <a:srgbClr val="E0F0ED"/>
-                    </a:solidFill>
-                  </a:tcPr>
-                </a:tc>
-                <a:tc>
-                  <a:txBody>
-                    <a:bodyPr>
-                      <a:noAutofit/>
-                    </a:bodyPr>
-                    <a:lstStyle/>
-                    <a:p>
-                      <a:pPr algn="ctr"/>
-                      <a:r>
-                        <a:rPr sz="1950" b="1">
-                          <a:solidFill>
-                            <a:srgbClr val="152E38"/>
-                          </a:solidFill>
-                          <a:latin typeface="Arial"/>
-                          <a:ea typeface="Arial"/>
-                          <a:cs typeface="Arial"/>
-                        </a:rPr>
-                        <a:t>1 to 1</a:t>
-                      </a:r>
-                    </a:p>
-                  </a:txBody>
-                  <a:tcPr marL="91440" marR="91440" marT="45720" marB="45720">
-                    <a:solidFill>
-                      <a:srgbClr val="E0F0ED"/>
-                    </a:solidFill>
-                  </a:tcPr>
-                </a:tc>
-              </a:tr>
-              <a:tr h="542925">
-                <a:tc>
-                  <a:txBody>
-                    <a:bodyPr>
-                      <a:noAutofit/>
-                    </a:bodyPr>
-                    <a:lstStyle/>
-                    <a:p>
-                      <a:pPr algn="l"/>
-                      <a:r>
-                        <a:rPr sz="1950" b="0">
-                          <a:solidFill>
-                            <a:srgbClr val="152E38"/>
-                          </a:solidFill>
-                          <a:latin typeface="Arial"/>
-                          <a:ea typeface="Arial"/>
-                          <a:cs typeface="Arial"/>
-                        </a:rPr>
-                        <a:t>Logistic Regression</a:t>
-                      </a:r>
-                    </a:p>
-                  </a:txBody>
-                  <a:tcPr marL="91440" marR="91440" marT="45720" marB="45720">
-                    <a:solidFill>
-                      <a:srgbClr val="FFFFFF"/>
-                    </a:solidFill>
-                  </a:tcPr>
-                </a:tc>
-                <a:tc>
-                  <a:txBody>
-                    <a:bodyPr>
-                      <a:noAutofit/>
-                    </a:bodyPr>
-                    <a:lstStyle/>
-                    <a:p>
-                      <a:pPr algn="ctr"/>
-                      <a:r>
-                        <a:rPr sz="1950" b="0">
-                          <a:solidFill>
-                            <a:srgbClr val="152E38"/>
-                          </a:solidFill>
-                          <a:latin typeface="Arial"/>
-                          <a:ea typeface="Arial"/>
-                          <a:cs typeface="Arial"/>
-                        </a:rPr>
-                        <a:t>0.7913</a:t>
-                      </a:r>
-                    </a:p>
-                  </a:txBody>
-                  <a:tcPr marL="91440" marR="91440" marT="45720" marB="45720">
-                    <a:solidFill>
-                      <a:srgbClr val="FFFFFF"/>
-                    </a:solidFill>
-                  </a:tcPr>
-                </a:tc>
-                <a:tc>
-                  <a:txBody>
-                    <a:bodyPr>
-                      <a:noAutofit/>
-                    </a:bodyPr>
-                    <a:lstStyle/>
-                    <a:p>
-                      <a:pPr algn="ctr"/>
-                      <a:r>
-                        <a:rPr sz="1950" b="0">
-                          <a:solidFill>
-                            <a:srgbClr val="152E38"/>
-                          </a:solidFill>
-                          <a:latin typeface="Arial"/>
-                          <a:ea typeface="Arial"/>
-                          <a:cs typeface="Arial"/>
-                        </a:rPr>
-                        <a:t>0.7197</a:t>
-                      </a:r>
-                    </a:p>
-                  </a:txBody>
-                  <a:tcPr marL="91440" marR="91440" marT="45720" marB="45720">
-                    <a:solidFill>
-                      <a:srgbClr val="FFFFFF"/>
-                    </a:solidFill>
-                  </a:tcPr>
-                </a:tc>
-                <a:tc>
-                  <a:txBody>
-                    <a:bodyPr>
-                      <a:noAutofit/>
-                    </a:bodyPr>
-                    <a:lstStyle/>
-                    <a:p>
-                      <a:pPr algn="ctr"/>
-                      <a:r>
-                        <a:rPr sz="1950" b="0">
-                          <a:solidFill>
-                            <a:srgbClr val="152E38"/>
-                          </a:solidFill>
-                          <a:latin typeface="Arial"/>
-                          <a:ea typeface="Arial"/>
-                          <a:cs typeface="Arial"/>
-                        </a:rPr>
-                        <a:t>2 to 2</a:t>
-                      </a:r>
-                    </a:p>
-                  </a:txBody>
-                  <a:tcPr marL="91440" marR="91440" marT="45720" marB="45720">
-                    <a:solidFill>
-                      <a:srgbClr val="FFFFFF"/>
-                    </a:solidFill>
-                  </a:tcPr>
-                </a:tc>
-              </a:tr>
-              <a:tr h="542925">
-                <a:tc>
-                  <a:txBody>
-                    <a:bodyPr>
-                      <a:noAutofit/>
-                    </a:bodyPr>
-                    <a:lstStyle/>
-                    <a:p>
-                      <a:pPr algn="l"/>
-                      <a:r>
-                        <a:rPr sz="1950" b="0">
-                          <a:solidFill>
-                            <a:srgbClr val="152E38"/>
-                          </a:solidFill>
-                          <a:latin typeface="Arial"/>
-                          <a:ea typeface="Arial"/>
-                          <a:cs typeface="Arial"/>
-                        </a:rPr>
-                        <a:t>Random Forest</a:t>
-                      </a:r>
-                    </a:p>
-                  </a:txBody>
-                  <a:tcPr marL="91440" marR="91440" marT="45720" marB="45720">
-                    <a:solidFill>
-                      <a:srgbClr val="FFFFFF"/>
-                    </a:solidFill>
-                  </a:tcPr>
-                </a:tc>
-                <a:tc>
-                  <a:txBody>
-                    <a:bodyPr>
-                      <a:noAutofit/>
-                    </a:bodyPr>
-                    <a:lstStyle/>
-                    <a:p>
-                      <a:pPr algn="ctr"/>
-                      <a:r>
-                        <a:rPr sz="1950" b="0">
-                          <a:solidFill>
-                            <a:srgbClr val="152E38"/>
-                          </a:solidFill>
-                          <a:latin typeface="Arial"/>
-                          <a:ea typeface="Arial"/>
-                          <a:cs typeface="Arial"/>
-                        </a:rPr>
-                        <a:t>0.7609</a:t>
-                      </a:r>
-                    </a:p>
-                  </a:txBody>
-                  <a:tcPr marL="91440" marR="91440" marT="45720" marB="45720">
-                    <a:solidFill>
-                      <a:srgbClr val="FFFFFF"/>
-                    </a:solidFill>
-                  </a:tcPr>
-                </a:tc>
-                <a:tc>
-                  <a:txBody>
-                    <a:bodyPr>
-                      <a:noAutofit/>
-                    </a:bodyPr>
-                    <a:lstStyle/>
-                    <a:p>
-                      <a:pPr algn="ctr"/>
-                      <a:r>
-                        <a:rPr sz="1950" b="0">
-                          <a:solidFill>
-                            <a:srgbClr val="152E38"/>
-                          </a:solidFill>
-                          <a:latin typeface="Arial"/>
-                          <a:ea typeface="Arial"/>
-                          <a:cs typeface="Arial"/>
-                        </a:rPr>
-                        <a:t>0.6614</a:t>
-                      </a:r>
-                    </a:p>
-                  </a:txBody>
-                  <a:tcPr marL="91440" marR="91440" marT="45720" marB="45720">
-                    <a:solidFill>
-                      <a:srgbClr val="FFFFFF"/>
-                    </a:solidFill>
-                  </a:tcPr>
-                </a:tc>
-                <a:tc>
-                  <a:txBody>
-                    <a:bodyPr>
-                      <a:noAutofit/>
-                    </a:bodyPr>
-                    <a:lstStyle/>
-                    <a:p>
-                      <a:pPr algn="ctr"/>
-                      <a:r>
-                        <a:rPr sz="1950" b="0">
-                          <a:solidFill>
-                            <a:srgbClr val="152E38"/>
-                          </a:solidFill>
-                          <a:latin typeface="Arial"/>
-                          <a:ea typeface="Arial"/>
-                          <a:cs typeface="Arial"/>
-                        </a:rPr>
-                        <a:t>3 to 3</a:t>
-                      </a:r>
-                    </a:p>
-                  </a:txBody>
-                  <a:tcPr marL="91440" marR="91440" marT="45720" marB="45720">
-                    <a:solidFill>
-                      <a:srgbClr val="FFFFFF"/>
-                    </a:solidFill>
-                  </a:tcPr>
-                </a:tc>
-              </a:tr>
-              <a:tr h="542925">
-                <a:tc>
-                  <a:txBody>
-                    <a:bodyPr>
-                      <a:noAutofit/>
-                    </a:bodyPr>
-                    <a:lstStyle/>
-                    <a:p>
-                      <a:pPr algn="l"/>
-                      <a:r>
-                        <a:rPr sz="1950" b="0">
-                          <a:solidFill>
-                            <a:srgbClr val="152E38"/>
-                          </a:solidFill>
-                          <a:latin typeface="Arial"/>
-                          <a:ea typeface="Arial"/>
-                          <a:cs typeface="Arial"/>
-                        </a:rPr>
-                        <a:t>Naive Bayes</a:t>
-                      </a:r>
-                    </a:p>
-                  </a:txBody>
-                  <a:tcPr marL="91440" marR="91440" marT="45720" marB="45720">
-                    <a:solidFill>
-                      <a:srgbClr val="FFFFFF"/>
-                    </a:solidFill>
-                  </a:tcPr>
-                </a:tc>
-                <a:tc>
-                  <a:txBody>
-                    <a:bodyPr>
-                      <a:noAutofit/>
-                    </a:bodyPr>
-                    <a:lstStyle/>
-                    <a:p>
-                      <a:pPr algn="ctr"/>
-                      <a:r>
-                        <a:rPr sz="1950" b="0">
-                          <a:solidFill>
-                            <a:srgbClr val="152E38"/>
-                          </a:solidFill>
-                          <a:latin typeface="Arial"/>
-                          <a:ea typeface="Arial"/>
-                          <a:cs typeface="Arial"/>
-                        </a:rPr>
-                        <a:t>0.6903</a:t>
-                      </a:r>
-                    </a:p>
-                  </a:txBody>
-                  <a:tcPr marL="91440" marR="91440" marT="45720" marB="45720">
-                    <a:solidFill>
-                      <a:srgbClr val="FFFFFF"/>
-                    </a:solidFill>
-                  </a:tcPr>
-                </a:tc>
-                <a:tc>
-                  <a:txBody>
-                    <a:bodyPr>
-                      <a:noAutofit/>
-                    </a:bodyPr>
-                    <a:lstStyle/>
-                    <a:p>
-                      <a:pPr algn="ctr"/>
-                      <a:r>
-                        <a:rPr sz="1950" b="0">
-                          <a:solidFill>
-                            <a:srgbClr val="152E38"/>
-                          </a:solidFill>
-                          <a:latin typeface="Arial"/>
-                          <a:ea typeface="Arial"/>
-                          <a:cs typeface="Arial"/>
-                        </a:rPr>
-                        <a:t>0.5214</a:t>
-                      </a:r>
-                    </a:p>
-                  </a:txBody>
-                  <a:tcPr marL="91440" marR="91440" marT="45720" marB="45720">
-                    <a:solidFill>
-                      <a:srgbClr val="FFFFFF"/>
-                    </a:solidFill>
-                  </a:tcPr>
-                </a:tc>
-                <a:tc>
-                  <a:txBody>
-                    <a:bodyPr>
-                      <a:noAutofit/>
-                    </a:bodyPr>
-                    <a:lstStyle/>
-                    <a:p>
-                      <a:pPr algn="ctr"/>
-                      <a:r>
-                        <a:rPr sz="1950" b="0">
-                          <a:solidFill>
-                            <a:srgbClr val="152E38"/>
-                          </a:solidFill>
-                          <a:latin typeface="Arial"/>
-                          <a:ea typeface="Arial"/>
-                          <a:cs typeface="Arial"/>
-                        </a:rPr>
-                        <a:t>4 to 4</a:t>
-                      </a:r>
-                    </a:p>
-                  </a:txBody>
-                  <a:tcPr marL="91440" marR="91440" marT="45720" marB="45720">
-                    <a:solidFill>
-                      <a:srgbClr val="FFFFFF"/>
-                    </a:solidFill>
-                  </a:tcPr>
-                </a:tc>
-              </a:tr>
-            </a:tbl>
-          </a:graphicData>
-        </a:graphic>
-      </p:graphicFrame>
+        </p:nvPicPr>
+        <p:blipFill>
+          <a:blip xmlns:r="http://schemas.openxmlformats.org/officeDocument/2006/relationships" xmlns:a="http://schemas.openxmlformats.org/drawingml/2006/main" r:embed="R28b6fe4ff8a646d5"/>
+          <a:stretch xmlns:a="http://schemas.openxmlformats.org/drawingml/2006/main"/>
+        </p:blipFill>
+        <p:spPr>
+          <a:xfrm xmlns:a="http://schemas.openxmlformats.org/drawingml/2006/main">
+            <a:off x="633132" y="1333500"/>
+            <a:ext cx="10925735" cy="3095625"/>
+          </a:xfrm>
+          <a:prstGeom xmlns:a="http://schemas.openxmlformats.org/drawingml/2006/main" prst="rect">
+            <a:avLst/>
+          </a:prstGeom>
+        </p:spPr>
+      </p:pic>
       <p:sp>
         <p:nvSpPr>
           <p:cNvPr id="3" name="">
             <a:extLst xmlns:a="http://schemas.openxmlformats.org/drawingml/2006/main">
               <a:ext uri="{FF2B5EF4-FFF2-40B4-BE49-F238E27FC236}">
-                <a16:creationId xmlns:a16="http://schemas.microsoft.com/office/drawing/2014/main" id="{5F08BF02-F422-4D2E-9D67-BEC93E9DB899}"/>
+                <a16:creationId xmlns:a16="http://schemas.microsoft.com/office/drawing/2014/main" id="{B52D6927-C7B6-48B7-A846-68F39FCFDCEA}"/>
               </a:ext>
             </a:extLst>
           </p:cNvPr>
@@ -4869,7 +4396,7 @@
           <p:cNvPr id="4" name="">
             <a:extLst xmlns:a="http://schemas.openxmlformats.org/drawingml/2006/main">
               <a:ext uri="{FF2B5EF4-FFF2-40B4-BE49-F238E27FC236}">
-                <a16:creationId xmlns:a16="http://schemas.microsoft.com/office/drawing/2014/main" id="{108BEF3B-75C1-4C25-A102-B6ADC1AB733E}"/>
+                <a16:creationId xmlns:a16="http://schemas.microsoft.com/office/drawing/2014/main" id="{557A80C0-68C2-49EB-920B-23EB0C756E51}"/>
               </a:ext>
             </a:extLst>
           </p:cNvPr>
@@ -4947,7 +4474,7 @@
     </p:spTree>
     <p:extLst>
       <p:ext uri="{BB962C8B-B14F-4D97-AF65-F5344CB8AC3E}">
-        <p14:creationId xmlns:p14="http://schemas.microsoft.com/office/powerpoint/2010/main" val="1724817866"/>
+        <p14:creationId xmlns:p14="http://schemas.microsoft.com/office/powerpoint/2010/main" val="56885040"/>
       </p:ext>
     </p:extLst>
   </p:cSld>

</xml_diff>

<commit_message>
Explain SVM mathematics and clarify results navigation
</commit_message>
<xml_diff>
--- a/submission/Assignment.pptx
+++ b/submission/Assignment.pptx
@@ -2,17 +2,17 @@
 <file path=ppt/presentation.xml><?xml version="1.0" encoding="utf-8"?>
 <p:presentation xmlns:p="http://schemas.openxmlformats.org/presentationml/2006/main">
   <p:sldMasterIdLst>
-    <p:sldMasterId xmlns:r="http://schemas.openxmlformats.org/officeDocument/2006/relationships" id="2147483648" r:id="R63a29f5e7f25410c"/>
+    <p:sldMasterId xmlns:r="http://schemas.openxmlformats.org/officeDocument/2006/relationships" id="2147483648" r:id="R034efcd4b1414613"/>
   </p:sldMasterIdLst>
   <p:notesMasterIdLst>
-    <p:notesMasterId xmlns:r="http://schemas.openxmlformats.org/officeDocument/2006/relationships" r:id="R73d731f2d13c4f17"/>
+    <p:notesMasterId xmlns:r="http://schemas.openxmlformats.org/officeDocument/2006/relationships" r:id="R231da35ed40348b2"/>
   </p:notesMasterIdLst>
   <p:sldIdLst>
-    <p:sldId xmlns:r="http://schemas.openxmlformats.org/officeDocument/2006/relationships" id="256" r:id="R783fb77b17f94040"/>
-    <p:sldId xmlns:r="http://schemas.openxmlformats.org/officeDocument/2006/relationships" id="257" r:id="R9e3de1344307478d"/>
-    <p:sldId xmlns:r="http://schemas.openxmlformats.org/officeDocument/2006/relationships" id="258" r:id="R5f46e31709024883"/>
-    <p:sldId xmlns:r="http://schemas.openxmlformats.org/officeDocument/2006/relationships" id="259" r:id="Rcf1d0d5c8d504f5f"/>
-    <p:sldId xmlns:r="http://schemas.openxmlformats.org/officeDocument/2006/relationships" id="260" r:id="R645a7e4cb6394c49"/>
+    <p:sldId xmlns:r="http://schemas.openxmlformats.org/officeDocument/2006/relationships" id="256" r:id="R2edb8b2c9b7f4fb9"/>
+    <p:sldId xmlns:r="http://schemas.openxmlformats.org/officeDocument/2006/relationships" id="257" r:id="Rcb5dbcb3feaf4f1f"/>
+    <p:sldId xmlns:r="http://schemas.openxmlformats.org/officeDocument/2006/relationships" id="258" r:id="R5cec3d1956794dbf"/>
+    <p:sldId xmlns:r="http://schemas.openxmlformats.org/officeDocument/2006/relationships" id="259" r:id="R20c34acd1cbc41a6"/>
+    <p:sldId xmlns:r="http://schemas.openxmlformats.org/officeDocument/2006/relationships" id="260" r:id="R831267d18b184c01"/>
   </p:sldIdLst>
   <p:sldSz cx="12192000" cy="6858000"/>
   <p:notesSz cx="6858000" cy="9144000"/>
@@ -586,7 +586,7 @@
           <a:lstStyle xmlns:a="http://schemas.openxmlformats.org/drawingml/2006/main"/>
           <a:p xmlns:a="http://schemas.openxmlformats.org/drawingml/2006/main">
             <a:r>
-              <a:t>Source: assignment.py. Same TF-IDF matrices for all four models. Macro-F1 gives each class equal importance. NB alpha=1. LR C=1, lbfgs, max_iter=3000. SVM C=1, dual=auto, max_iter=10000. RF 150 trees, max_depth=40, min_samples_leaf=2, max_features=sqrt, n_jobs=4. No hyperparameter search. Uniform-chance expected accuracy is 20%. Code uses numpy, pandas, scikit-learn and joblib.</a:t>
+              <a:t>Sources: assignment.py and https://scikit-learn.org/stable/modules/generated/sklearn.svm.LinearSVC.html . Explain aloud: each code sample becomes a vector x of TF-IDF weights. For a chosen author, multiply each feature by its learned weight, add the contributions, then add b. The superscript T means transpose and w-transpose-x is a dot product. k indexes authors; i indexes training programs. For each author y is +1 for that author and -1 for the other four. The training algorithm minimizes J over w and b. Norm squared means sum of squared weights; sigma means sum over training examples. Our defaults use L2 penalty, squared-hinge loss, one-vs-rest, fit_intercept=True and intercept_scaling=1, so b squared is part of the regularization term. C=1 controls the relative cost of margin violations. If signed score y*f is at least 1, loss is zero. At 0.6 loss is 0.16; at -0.5 loss is 2.25. These are invented teaching examples, not measured model outputs. Five class scores are compared by argmax; scores are not calibrated probabilities. NB alpha=1; LR C=1 max_iter=3000; RF 150 trees max_depth=40 min_samples_leaf=2 max_features=sqrt. Shared splits and feature matrix keep the comparison fair. The equation explains the mechanism, not proof of why SVM wins on this dataset.</a:t>
             </a:r>
           </a:p>
         </p:txBody>
@@ -794,7 +794,7 @@
   </p:cSld>
   <p:clrMap bg1="lt1" tx1="dk1" bg2="lt2" tx2="dk2" accent1="accent1" accent2="accent2" accent3="accent3" accent4="accent4" accent5="accent5" accent6="accent6" hlink="hlink" folHlink="folHlink"/>
   <p:sldLayoutIdLst>
-    <p:sldLayoutId xmlns:r="http://schemas.openxmlformats.org/officeDocument/2006/relationships" id="2147483649" r:id="Rcbf0d320b4a44ce5"/>
+    <p:sldLayoutId xmlns:r="http://schemas.openxmlformats.org/officeDocument/2006/relationships" id="2147483649" r:id="R3a140da35ba548f7"/>
   </p:sldLayoutIdLst>
   <p:txStyles>
     <p:titleStyle>
@@ -1345,7 +1345,7 @@
           <p:cNvPr id="7" name="">
             <a:extLst xmlns:a="http://schemas.openxmlformats.org/drawingml/2006/main">
               <a:ext uri="{FF2B5EF4-FFF2-40B4-BE49-F238E27FC236}">
-                <a16:creationId xmlns:a16="http://schemas.microsoft.com/office/drawing/2014/main" id="{77AE8B64-FC45-4AD2-B7A4-8E78D8BFD4BE}"/>
+                <a16:creationId xmlns:a16="http://schemas.microsoft.com/office/drawing/2014/main" id="{56AC8825-FCAD-442E-8CBD-A18A46741BBF}"/>
               </a:ext>
             </a:extLst>
           </p:cNvPr>
@@ -1402,7 +1402,7 @@
           <p:cNvPr id="2" name="">
             <a:extLst xmlns:a="http://schemas.openxmlformats.org/drawingml/2006/main">
               <a:ext uri="{FF2B5EF4-FFF2-40B4-BE49-F238E27FC236}">
-                <a16:creationId xmlns:a16="http://schemas.microsoft.com/office/drawing/2014/main" id="{FB6B09E2-372C-4250-B3C4-263C192ACD1A}"/>
+                <a16:creationId xmlns:a16="http://schemas.microsoft.com/office/drawing/2014/main" id="{A2FE5CA1-4B04-4F65-A91C-005CBBDB25E9}"/>
               </a:ext>
             </a:extLst>
           </p:cNvPr>
@@ -1459,7 +1459,7 @@
           <p:cNvPr id="3" name="">
             <a:extLst xmlns:a="http://schemas.openxmlformats.org/drawingml/2006/main">
               <a:ext uri="{FF2B5EF4-FFF2-40B4-BE49-F238E27FC236}">
-                <a16:creationId xmlns:a16="http://schemas.microsoft.com/office/drawing/2014/main" id="{37608EE4-F721-4AB6-BE4E-750D7CD898BB}"/>
+                <a16:creationId xmlns:a16="http://schemas.microsoft.com/office/drawing/2014/main" id="{607AFCD3-D4B3-4324-95CB-B8C6C131BE73}"/>
               </a:ext>
             </a:extLst>
           </p:cNvPr>
@@ -1539,7 +1539,7 @@
           <p:cNvPr id="4" name="">
             <a:extLst xmlns:a="http://schemas.openxmlformats.org/drawingml/2006/main">
               <a:ext uri="{FF2B5EF4-FFF2-40B4-BE49-F238E27FC236}">
-                <a16:creationId xmlns:a16="http://schemas.microsoft.com/office/drawing/2014/main" id="{8FCE3108-4B7B-468E-BAAF-DBF573DAE9F1}"/>
+                <a16:creationId xmlns:a16="http://schemas.microsoft.com/office/drawing/2014/main" id="{AE8BCC15-88B6-48F7-9C33-F475B6AB0BE7}"/>
               </a:ext>
             </a:extLst>
           </p:cNvPr>
@@ -1619,7 +1619,7 @@
           <p:cNvPr id="5" name="">
             <a:extLst xmlns:a="http://schemas.openxmlformats.org/drawingml/2006/main">
               <a:ext uri="{FF2B5EF4-FFF2-40B4-BE49-F238E27FC236}">
-                <a16:creationId xmlns:a16="http://schemas.microsoft.com/office/drawing/2014/main" id="{9D5EA350-EE39-4251-9701-5E4953DAD2BF}"/>
+                <a16:creationId xmlns:a16="http://schemas.microsoft.com/office/drawing/2014/main" id="{8170F0D1-366C-488F-8971-A099B188867E}"/>
               </a:ext>
             </a:extLst>
           </p:cNvPr>
@@ -1676,7 +1676,7 @@
           <p:cNvPr id="6" name="">
             <a:extLst xmlns:a="http://schemas.openxmlformats.org/drawingml/2006/main">
               <a:ext uri="{FF2B5EF4-FFF2-40B4-BE49-F238E27FC236}">
-                <a16:creationId xmlns:a16="http://schemas.microsoft.com/office/drawing/2014/main" id="{8BA9ED1C-55F0-4C81-B40C-A23E44C66ED6}"/>
+                <a16:creationId xmlns:a16="http://schemas.microsoft.com/office/drawing/2014/main" id="{D9E259FF-2AC6-4300-9E9F-2DA5870D6934}"/>
               </a:ext>
             </a:extLst>
           </p:cNvPr>
@@ -1731,7 +1731,7 @@
     </p:spTree>
     <p:extLst>
       <p:ext uri="{BB962C8B-B14F-4D97-AF65-F5344CB8AC3E}">
-        <p14:creationId xmlns:p14="http://schemas.microsoft.com/office/powerpoint/2010/main" val="1431277627"/>
+        <p14:creationId xmlns:p14="http://schemas.microsoft.com/office/powerpoint/2010/main" val="1348411800"/>
       </p:ext>
     </p:extLst>
   </p:cSld>
@@ -1762,7 +1762,7 @@
           <p:cNvPr id="7" name="">
             <a:extLst xmlns:a="http://schemas.openxmlformats.org/drawingml/2006/main">
               <a:ext uri="{FF2B5EF4-FFF2-40B4-BE49-F238E27FC236}">
-                <a16:creationId xmlns:a16="http://schemas.microsoft.com/office/drawing/2014/main" id="{83FA1A6F-7C27-4DE6-AD42-16DE75E5A448}"/>
+                <a16:creationId xmlns:a16="http://schemas.microsoft.com/office/drawing/2014/main" id="{107A55FA-24F1-4845-B6D5-F0BCB7B5CE63}"/>
               </a:ext>
             </a:extLst>
           </p:cNvPr>
@@ -2174,7 +2174,7 @@
           <p:cNvPr id="3" name="">
             <a:extLst xmlns:a="http://schemas.openxmlformats.org/drawingml/2006/main">
               <a:ext uri="{FF2B5EF4-FFF2-40B4-BE49-F238E27FC236}">
-                <a16:creationId xmlns:a16="http://schemas.microsoft.com/office/drawing/2014/main" id="{E2153699-B6D9-45DC-90DA-2B8C93F9448D}"/>
+                <a16:creationId xmlns:a16="http://schemas.microsoft.com/office/drawing/2014/main" id="{9EC2D4EE-EC2E-46A5-9F02-CEAAAF6BFD13}"/>
               </a:ext>
             </a:extLst>
           </p:cNvPr>
@@ -2185,8 +2185,8 @@
         </p:nvSpPr>
         <p:spPr>
           <a:xfrm xmlns:a="http://schemas.openxmlformats.org/drawingml/2006/main">
-            <a:off x="6858000" y="1666875"/>
-            <a:ext cx="4857750" cy="1428750"/>
+            <a:off x="6858000" y="1571625"/>
+            <a:ext cx="4857750" cy="1524000"/>
           </a:xfrm>
           <a:prstGeom xmlns:a="http://schemas.openxmlformats.org/drawingml/2006/main" prst="rect">
             <a:avLst/>
@@ -2203,7 +2203,7 @@
           <a:lstStyle xmlns:a="http://schemas.openxmlformats.org/drawingml/2006/main"/>
           <a:p xmlns:a="http://schemas.openxmlformats.org/drawingml/2006/main">
             <a:pPr>
-              <a:defRPr sz="2100" b="0">
+              <a:defRPr sz="1950" b="0">
                 <a:solidFill>
                   <a:srgbClr val="152E38"/>
                 </a:solidFill>
@@ -2213,7 +2213,7 @@
               </a:defRPr>
             </a:pPr>
             <a:r>
-              <a:rPr sz="2100" b="0">
+              <a:rPr sz="1950" b="0">
                 <a:solidFill>
                   <a:srgbClr val="152E38"/>
                 </a:solidFill>
@@ -2221,12 +2221,12 @@
                 <a:ea typeface="Arial"/>
                 <a:cs typeface="Arial"/>
               </a:rPr>
-              <a:t>50,000 character TF-IDF features</a:t>
+              <a:t>TF-IDF: Term Frequency–</a:t>
             </a:r>
           </a:p>
           <a:p xmlns:a="http://schemas.openxmlformats.org/drawingml/2006/main">
             <a:pPr>
-              <a:defRPr sz="2100" b="0">
+              <a:defRPr sz="1950" b="0">
                 <a:solidFill>
                   <a:srgbClr val="152E38"/>
                 </a:solidFill>
@@ -2236,7 +2236,7 @@
               </a:defRPr>
             </a:pPr>
             <a:r>
-              <a:rPr sz="2100" b="0">
+              <a:rPr sz="1950" b="0">
                 <a:solidFill>
                   <a:srgbClr val="152E38"/>
                 </a:solidFill>
@@ -2244,12 +2244,12 @@
                 <a:ea typeface="Arial"/>
                 <a:cs typeface="Arial"/>
               </a:rPr>
-              <a:t>Three to five characters per pattern</a:t>
+              <a:t>Inverse Document Frequency</a:t>
             </a:r>
           </a:p>
           <a:p xmlns:a="http://schemas.openxmlformats.org/drawingml/2006/main">
             <a:pPr>
-              <a:defRPr sz="2100" b="0">
+              <a:defRPr sz="1950" b="0">
                 <a:solidFill>
                   <a:srgbClr val="152E38"/>
                 </a:solidFill>
@@ -2259,7 +2259,30 @@
               </a:defRPr>
             </a:pPr>
             <a:r>
-              <a:rPr sz="2100" b="0">
+              <a:rPr sz="1950" b="0">
+                <a:solidFill>
+                  <a:srgbClr val="152E38"/>
+                </a:solidFill>
+                <a:latin typeface="Arial"/>
+                <a:ea typeface="Arial"/>
+                <a:cs typeface="Arial"/>
+              </a:rPr>
+              <a:t>50,000 patterns of 3–5 characters</a:t>
+            </a:r>
+          </a:p>
+          <a:p xmlns:a="http://schemas.openxmlformats.org/drawingml/2006/main">
+            <a:pPr>
+              <a:defRPr sz="1950" b="0">
+                <a:solidFill>
+                  <a:srgbClr val="152E38"/>
+                </a:solidFill>
+                <a:latin typeface="Arial"/>
+                <a:ea typeface="Arial"/>
+                <a:cs typeface="Arial"/>
+              </a:defRPr>
+            </a:pPr>
+            <a:r>
+              <a:rPr sz="1950" b="0">
                 <a:solidFill>
                   <a:srgbClr val="152E38"/>
                 </a:solidFill>
@@ -2277,7 +2300,7 @@
           <p:cNvPr id="4" name="">
             <a:extLst xmlns:a="http://schemas.openxmlformats.org/drawingml/2006/main">
               <a:ext uri="{FF2B5EF4-FFF2-40B4-BE49-F238E27FC236}">
-                <a16:creationId xmlns:a16="http://schemas.microsoft.com/office/drawing/2014/main" id="{CB28F9F6-BE66-4C1A-8BAE-49EBCBBA8A71}"/>
+                <a16:creationId xmlns:a16="http://schemas.microsoft.com/office/drawing/2014/main" id="{40B6CCB9-0C49-439A-9A67-995E787FDD5D}"/>
               </a:ext>
             </a:extLst>
           </p:cNvPr>
@@ -2380,7 +2403,7 @@
           <p:cNvPr id="5" name="">
             <a:extLst xmlns:a="http://schemas.openxmlformats.org/drawingml/2006/main">
               <a:ext uri="{FF2B5EF4-FFF2-40B4-BE49-F238E27FC236}">
-                <a16:creationId xmlns:a16="http://schemas.microsoft.com/office/drawing/2014/main" id="{4082A76E-FD6A-4C21-ABA0-B45746873ADF}"/>
+                <a16:creationId xmlns:a16="http://schemas.microsoft.com/office/drawing/2014/main" id="{852B9607-2BC0-4B85-BD87-6D799385D698}"/>
               </a:ext>
             </a:extLst>
           </p:cNvPr>
@@ -2460,7 +2483,7 @@
           <p:cNvPr id="6" name="">
             <a:extLst xmlns:a="http://schemas.openxmlformats.org/drawingml/2006/main">
               <a:ext uri="{FF2B5EF4-FFF2-40B4-BE49-F238E27FC236}">
-                <a16:creationId xmlns:a16="http://schemas.microsoft.com/office/drawing/2014/main" id="{5581F71B-51D3-4047-B0E2-A7137D765F15}"/>
+                <a16:creationId xmlns:a16="http://schemas.microsoft.com/office/drawing/2014/main" id="{ECE58FAC-F286-45F4-9D30-438849A74BBE}"/>
               </a:ext>
             </a:extLst>
           </p:cNvPr>
@@ -2515,7 +2538,7 @@
     </p:spTree>
     <p:extLst>
       <p:ext uri="{BB962C8B-B14F-4D97-AF65-F5344CB8AC3E}">
-        <p14:creationId xmlns:p14="http://schemas.microsoft.com/office/powerpoint/2010/main" val="1427523030"/>
+        <p14:creationId xmlns:p14="http://schemas.microsoft.com/office/powerpoint/2010/main" val="1068471164"/>
       </p:ext>
     </p:extLst>
   </p:cSld>
@@ -2543,10 +2566,10 @@
       </p:grpSpPr>
       <p:sp>
         <p:nvSpPr>
-          <p:cNvPr id="13" name="">
+          <p:cNvPr id="9" name="">
             <a:extLst xmlns:a="http://schemas.openxmlformats.org/drawingml/2006/main">
               <a:ext uri="{FF2B5EF4-FFF2-40B4-BE49-F238E27FC236}">
-                <a16:creationId xmlns:a16="http://schemas.microsoft.com/office/drawing/2014/main" id="{FF616124-4688-498C-9AC9-B7AAC83B2E46}"/>
+                <a16:creationId xmlns:a16="http://schemas.microsoft.com/office/drawing/2014/main" id="{0617C12A-F730-4039-A653-063E2DEFA949}"/>
               </a:ext>
             </a:extLst>
           </p:cNvPr>
@@ -2593,7 +2616,7 @@
                 <a:ea typeface="Arial"/>
                 <a:cs typeface="Arial"/>
               </a:rPr>
-              <a:t>Experiment 1: original code</a:t>
+              <a:t>Experiment 1: how Linear SVM learns</a:t>
             </a:r>
           </a:p>
         </p:txBody>
@@ -2603,7 +2626,7 @@
           <p:cNvPr id="2" name="">
             <a:extLst xmlns:a="http://schemas.openxmlformats.org/drawingml/2006/main">
               <a:ext uri="{FF2B5EF4-FFF2-40B4-BE49-F238E27FC236}">
-                <a16:creationId xmlns:a16="http://schemas.microsoft.com/office/drawing/2014/main" id="{9EAF72D8-56E3-4DE4-B1DE-16BE5F6FAE0E}"/>
+                <a16:creationId xmlns:a16="http://schemas.microsoft.com/office/drawing/2014/main" id="{48FA743D-D208-4BFC-8DA7-AABE2039C6EB}"/>
               </a:ext>
             </a:extLst>
           </p:cNvPr>
@@ -2614,8 +2637,8 @@
         </p:nvSpPr>
         <p:spPr>
           <a:xfrm xmlns:a="http://schemas.openxmlformats.org/drawingml/2006/main">
-            <a:off x="571500" y="1428750"/>
-            <a:ext cx="11049000" cy="476250"/>
+            <a:off x="571500" y="1304925"/>
+            <a:ext cx="11049000" cy="762000"/>
           </a:xfrm>
           <a:prstGeom xmlns:a="http://schemas.openxmlformats.org/drawingml/2006/main" prst="rect">
             <a:avLst/>
@@ -2632,9 +2655,9 @@
           <a:lstStyle xmlns:a="http://schemas.openxmlformats.org/drawingml/2006/main"/>
           <a:p xmlns:a="http://schemas.openxmlformats.org/drawingml/2006/main">
             <a:pPr>
-              <a:defRPr sz="2250" b="1">
-                <a:solidFill>
-                  <a:srgbClr val="117C83"/>
+              <a:defRPr sz="1875" b="0">
+                <a:solidFill>
+                  <a:srgbClr val="152E38"/>
                 </a:solidFill>
                 <a:latin typeface="Arial"/>
                 <a:ea typeface="Arial"/>
@@ -2642,15 +2665,38 @@
               </a:defRPr>
             </a:pPr>
             <a:r>
-              <a:rPr sz="2250" b="1">
-                <a:solidFill>
-                  <a:srgbClr val="117C83"/>
+              <a:rPr sz="1875" b="0">
+                <a:solidFill>
+                  <a:srgbClr val="152E38"/>
                 </a:solidFill>
                 <a:latin typeface="Arial"/>
                 <a:ea typeface="Arial"/>
                 <a:cs typeface="Arial"/>
               </a:rPr>
-              <a:t>Four models use the same training, validation and test data</a:t>
+              <a:t>Naive Bayes: baseline    Logistic Regression: linear probability model</a:t>
+            </a:r>
+          </a:p>
+          <a:p xmlns:a="http://schemas.openxmlformats.org/drawingml/2006/main">
+            <a:pPr>
+              <a:defRPr sz="1875" b="0">
+                <a:solidFill>
+                  <a:srgbClr val="152E38"/>
+                </a:solidFill>
+                <a:latin typeface="Arial"/>
+                <a:ea typeface="Arial"/>
+                <a:cs typeface="Arial"/>
+              </a:defRPr>
+            </a:pPr>
+            <a:r>
+              <a:rPr sz="1875" b="0">
+                <a:solidFill>
+                  <a:srgbClr val="152E38"/>
+                </a:solidFill>
+                <a:latin typeface="Arial"/>
+                <a:ea typeface="Arial"/>
+                <a:cs typeface="Arial"/>
+              </a:rPr>
+              <a:t>Support Vector Machine: linear margin model    Random Forest: trees</a:t>
             </a:r>
           </a:p>
         </p:txBody>
@@ -2660,7 +2706,7 @@
           <p:cNvPr id="3" name="">
             <a:extLst xmlns:a="http://schemas.openxmlformats.org/drawingml/2006/main">
               <a:ext uri="{FF2B5EF4-FFF2-40B4-BE49-F238E27FC236}">
-                <a16:creationId xmlns:a16="http://schemas.microsoft.com/office/drawing/2014/main" id="{E73E074A-F0E1-493C-8B5E-6695927D410C}"/>
+                <a16:creationId xmlns:a16="http://schemas.microsoft.com/office/drawing/2014/main" id="{127D5340-7788-4C25-900F-48724F236622}"/>
               </a:ext>
             </a:extLst>
           </p:cNvPr>
@@ -2671,8 +2717,8 @@
         </p:nvSpPr>
         <p:spPr>
           <a:xfrm xmlns:a="http://schemas.openxmlformats.org/drawingml/2006/main">
-            <a:off x="571500" y="2114550"/>
-            <a:ext cx="4143375" cy="457200"/>
+            <a:off x="571500" y="2276475"/>
+            <a:ext cx="10953750" cy="457200"/>
           </a:xfrm>
           <a:prstGeom xmlns:a="http://schemas.openxmlformats.org/drawingml/2006/main" prst="rect">
             <a:avLst/>
@@ -2689,9 +2735,9 @@
           <a:lstStyle xmlns:a="http://schemas.openxmlformats.org/drawingml/2006/main"/>
           <a:p xmlns:a="http://schemas.openxmlformats.org/drawingml/2006/main">
             <a:pPr>
-              <a:defRPr sz="2250" b="1">
-                <a:solidFill>
-                  <a:srgbClr val="152E38"/>
+              <a:defRPr sz="2550" b="1">
+                <a:solidFill>
+                  <a:srgbClr val="117C83"/>
                 </a:solidFill>
                 <a:latin typeface="Arial"/>
                 <a:ea typeface="Arial"/>
@@ -2699,15 +2745,15 @@
               </a:defRPr>
             </a:pPr>
             <a:r>
-              <a:rPr sz="2250" b="1">
-                <a:solidFill>
-                  <a:srgbClr val="152E38"/>
+              <a:rPr sz="2550" b="1">
+                <a:solidFill>
+                  <a:srgbClr val="117C83"/>
                 </a:solidFill>
                 <a:latin typeface="Arial"/>
                 <a:ea typeface="Arial"/>
                 <a:cs typeface="Arial"/>
               </a:rPr>
-              <a:t>Naive Bayes</a:t>
+              <a:t>Score for class k:  fₖ(x) = wₖᵀx + bₖ</a:t>
             </a:r>
           </a:p>
         </p:txBody>
@@ -2717,7 +2763,7 @@
           <p:cNvPr id="4" name="">
             <a:extLst xmlns:a="http://schemas.openxmlformats.org/drawingml/2006/main">
               <a:ext uri="{FF2B5EF4-FFF2-40B4-BE49-F238E27FC236}">
-                <a16:creationId xmlns:a16="http://schemas.microsoft.com/office/drawing/2014/main" id="{8746A9B1-C976-408C-9E3B-CA4FC05E9479}"/>
+                <a16:creationId xmlns:a16="http://schemas.microsoft.com/office/drawing/2014/main" id="{5CA868F0-E7E7-4F56-B678-A58B6AEE3F77}"/>
               </a:ext>
             </a:extLst>
           </p:cNvPr>
@@ -2728,8 +2774,202 @@
         </p:nvSpPr>
         <p:spPr>
           <a:xfrm xmlns:a="http://schemas.openxmlformats.org/drawingml/2006/main">
-            <a:off x="5238750" y="2114550"/>
-            <a:ext cx="6096000" cy="457200"/>
+            <a:off x="571500" y="2800350"/>
+            <a:ext cx="11049000" cy="361950"/>
+          </a:xfrm>
+          <a:prstGeom xmlns:a="http://schemas.openxmlformats.org/drawingml/2006/main" prst="rect">
+            <a:avLst/>
+          </a:prstGeom>
+          <a:noFill xmlns:a="http://schemas.openxmlformats.org/drawingml/2006/main"/>
+          <a:ln xmlns:a="http://schemas.openxmlformats.org/drawingml/2006/main" w="0">
+            <a:noFill/>
+          </a:ln>
+        </p:spPr>
+        <p:txBody>
+          <a:bodyPr xmlns:a="http://schemas.openxmlformats.org/drawingml/2006/main" lIns="0" tIns="0" rIns="0" bIns="0">
+            <a:noAutofit/>
+          </a:bodyPr>
+          <a:lstStyle xmlns:a="http://schemas.openxmlformats.org/drawingml/2006/main"/>
+          <a:p xmlns:a="http://schemas.openxmlformats.org/drawingml/2006/main">
+            <a:pPr>
+              <a:defRPr sz="1875" b="0">
+                <a:solidFill>
+                  <a:srgbClr val="152E38"/>
+                </a:solidFill>
+                <a:latin typeface="Arial"/>
+                <a:ea typeface="Arial"/>
+                <a:cs typeface="Arial"/>
+              </a:defRPr>
+            </a:pPr>
+            <a:r>
+              <a:rPr sz="1875" b="0">
+                <a:solidFill>
+                  <a:srgbClr val="152E38"/>
+                </a:solidFill>
+                <a:latin typeface="Arial"/>
+                <a:ea typeface="Arial"/>
+                <a:cs typeface="Arial"/>
+              </a:rPr>
+              <a:t>Train five one-vs-rest classifiers. Predict the class with the largest score.</a:t>
+            </a:r>
+          </a:p>
+        </p:txBody>
+      </p:sp>
+      <p:sp>
+        <p:nvSpPr>
+          <p:cNvPr id="5" name="">
+            <a:extLst xmlns:a="http://schemas.openxmlformats.org/drawingml/2006/main">
+              <a:ext uri="{FF2B5EF4-FFF2-40B4-BE49-F238E27FC236}">
+                <a16:creationId xmlns:a16="http://schemas.microsoft.com/office/drawing/2014/main" id="{88225C70-D991-4FD5-B08C-7B4877B9B127}"/>
+              </a:ext>
+            </a:extLst>
+          </p:cNvPr>
+          <p:cNvSpPr>
+            <a:spLocks xmlns:a="http://schemas.openxmlformats.org/drawingml/2006/main" noGrp="1"/>
+          </p:cNvSpPr>
+          <p:nvPr/>
+        </p:nvSpPr>
+        <p:spPr>
+          <a:xfrm xmlns:a="http://schemas.openxmlformats.org/drawingml/2006/main">
+            <a:off x="571500" y="3429000"/>
+            <a:ext cx="11144250" cy="571500"/>
+          </a:xfrm>
+          <a:prstGeom xmlns:a="http://schemas.openxmlformats.org/drawingml/2006/main" prst="rect">
+            <a:avLst/>
+          </a:prstGeom>
+          <a:noFill xmlns:a="http://schemas.openxmlformats.org/drawingml/2006/main"/>
+          <a:ln xmlns:a="http://schemas.openxmlformats.org/drawingml/2006/main" w="0">
+            <a:noFill/>
+          </a:ln>
+        </p:spPr>
+        <p:txBody>
+          <a:bodyPr xmlns:a="http://schemas.openxmlformats.org/drawingml/2006/main" lIns="0" tIns="0" rIns="0" bIns="0">
+            <a:noAutofit/>
+          </a:bodyPr>
+          <a:lstStyle xmlns:a="http://schemas.openxmlformats.org/drawingml/2006/main"/>
+          <a:p xmlns:a="http://schemas.openxmlformats.org/drawingml/2006/main">
+            <a:pPr>
+              <a:defRPr sz="2400" b="1">
+                <a:solidFill>
+                  <a:srgbClr val="117C83"/>
+                </a:solidFill>
+                <a:latin typeface="Arial"/>
+                <a:ea typeface="Arial"/>
+                <a:cs typeface="Arial"/>
+              </a:defRPr>
+            </a:pPr>
+            <a:r>
+              <a:rPr sz="2400" b="1">
+                <a:solidFill>
+                  <a:srgbClr val="117C83"/>
+                </a:solidFill>
+                <a:latin typeface="Arial"/>
+                <a:ea typeface="Arial"/>
+                <a:cs typeface="Arial"/>
+              </a:rPr>
+              <a:t>Minimize J = ½(‖w‖² + b²) + C Σᵢ max(0, 1 − yᵢ f(xᵢ))²</a:t>
+            </a:r>
+          </a:p>
+        </p:txBody>
+      </p:sp>
+      <p:sp>
+        <p:nvSpPr>
+          <p:cNvPr id="6" name="">
+            <a:extLst xmlns:a="http://schemas.openxmlformats.org/drawingml/2006/main">
+              <a:ext uri="{FF2B5EF4-FFF2-40B4-BE49-F238E27FC236}">
+                <a16:creationId xmlns:a16="http://schemas.microsoft.com/office/drawing/2014/main" id="{1BC5E97D-4462-4C14-97F0-6286B37700D2}"/>
+              </a:ext>
+            </a:extLst>
+          </p:cNvPr>
+          <p:cNvSpPr>
+            <a:spLocks xmlns:a="http://schemas.openxmlformats.org/drawingml/2006/main" noGrp="1"/>
+          </p:cNvSpPr>
+          <p:nvPr/>
+        </p:nvSpPr>
+        <p:spPr>
+          <a:xfrm xmlns:a="http://schemas.openxmlformats.org/drawingml/2006/main">
+            <a:off x="571500" y="4171950"/>
+            <a:ext cx="11049000" cy="762000"/>
+          </a:xfrm>
+          <a:prstGeom xmlns:a="http://schemas.openxmlformats.org/drawingml/2006/main" prst="rect">
+            <a:avLst/>
+          </a:prstGeom>
+          <a:noFill xmlns:a="http://schemas.openxmlformats.org/drawingml/2006/main"/>
+          <a:ln xmlns:a="http://schemas.openxmlformats.org/drawingml/2006/main" w="0">
+            <a:noFill/>
+          </a:ln>
+        </p:spPr>
+        <p:txBody>
+          <a:bodyPr xmlns:a="http://schemas.openxmlformats.org/drawingml/2006/main" lIns="0" tIns="0" rIns="0" bIns="0">
+            <a:noAutofit/>
+          </a:bodyPr>
+          <a:lstStyle xmlns:a="http://schemas.openxmlformats.org/drawingml/2006/main"/>
+          <a:p xmlns:a="http://schemas.openxmlformats.org/drawingml/2006/main">
+            <a:pPr>
+              <a:defRPr sz="1950" b="0">
+                <a:solidFill>
+                  <a:srgbClr val="152E38"/>
+                </a:solidFill>
+                <a:latin typeface="Arial"/>
+                <a:ea typeface="Arial"/>
+                <a:cs typeface="Arial"/>
+              </a:defRPr>
+            </a:pPr>
+            <a:r>
+              <a:rPr sz="1950" b="0">
+                <a:solidFill>
+                  <a:srgbClr val="152E38"/>
+                </a:solidFill>
+                <a:latin typeface="Arial"/>
+                <a:ea typeface="Arial"/>
+                <a:cs typeface="Arial"/>
+              </a:rPr>
+              <a:t>x: TF-IDF weights     w: learned feature weights     b: learned offset</a:t>
+            </a:r>
+          </a:p>
+          <a:p xmlns:a="http://schemas.openxmlformats.org/drawingml/2006/main">
+            <a:pPr>
+              <a:defRPr sz="1950" b="0">
+                <a:solidFill>
+                  <a:srgbClr val="152E38"/>
+                </a:solidFill>
+                <a:latin typeface="Arial"/>
+                <a:ea typeface="Arial"/>
+                <a:cs typeface="Arial"/>
+              </a:defRPr>
+            </a:pPr>
+            <a:r>
+              <a:rPr sz="1950" b="0">
+                <a:solidFill>
+                  <a:srgbClr val="152E38"/>
+                </a:solidFill>
+                <a:latin typeface="Arial"/>
+                <a:ea typeface="Arial"/>
+                <a:cs typeface="Arial"/>
+              </a:rPr>
+              <a:t>yᵢ: +1 for this author, −1 for the others     C = 1 in our code</a:t>
+            </a:r>
+          </a:p>
+        </p:txBody>
+      </p:sp>
+      <p:sp>
+        <p:nvSpPr>
+          <p:cNvPr id="7" name="">
+            <a:extLst xmlns:a="http://schemas.openxmlformats.org/drawingml/2006/main">
+              <a:ext uri="{FF2B5EF4-FFF2-40B4-BE49-F238E27FC236}">
+                <a16:creationId xmlns:a16="http://schemas.microsoft.com/office/drawing/2014/main" id="{0CC44DE1-7080-48E1-A0C1-126E6238BFAD}"/>
+              </a:ext>
+            </a:extLst>
+          </p:cNvPr>
+          <p:cNvSpPr>
+            <a:spLocks xmlns:a="http://schemas.openxmlformats.org/drawingml/2006/main" noGrp="1"/>
+          </p:cNvSpPr>
+          <p:nvPr/>
+        </p:nvSpPr>
+        <p:spPr>
+          <a:xfrm xmlns:a="http://schemas.openxmlformats.org/drawingml/2006/main">
+            <a:off x="571500" y="5286375"/>
+            <a:ext cx="11049000" cy="800100"/>
           </a:xfrm>
           <a:prstGeom xmlns:a="http://schemas.openxmlformats.org/drawingml/2006/main" prst="rect">
             <a:avLst/>
@@ -2764,17 +3004,40 @@
                 <a:ea typeface="Arial"/>
                 <a:cs typeface="Arial"/>
               </a:rPr>
-              <a:t>Simple baseline</a:t>
+              <a:t>First term limits weight size. The sum penalizes margin violations.</a:t>
+            </a:r>
+          </a:p>
+          <a:p xmlns:a="http://schemas.openxmlformats.org/drawingml/2006/main">
+            <a:pPr>
+              <a:defRPr sz="2100" b="0">
+                <a:solidFill>
+                  <a:srgbClr val="152E38"/>
+                </a:solidFill>
+                <a:latin typeface="Arial"/>
+                <a:ea typeface="Arial"/>
+                <a:cs typeface="Arial"/>
+              </a:defRPr>
+            </a:pPr>
+            <a:r>
+              <a:rPr sz="2100" b="0">
+                <a:solidFill>
+                  <a:srgbClr val="152E38"/>
+                </a:solidFill>
+                <a:latin typeface="Arial"/>
+                <a:ea typeface="Arial"/>
+                <a:cs typeface="Arial"/>
+              </a:rPr>
+              <a:t>Toy example: yᵢ f(xᵢ) = 0.6 gives loss (1 − 0.6)² = 0.16.</a:t>
             </a:r>
           </a:p>
         </p:txBody>
       </p:sp>
       <p:sp>
         <p:nvSpPr>
-          <p:cNvPr id="5" name="">
+          <p:cNvPr id="8" name="">
             <a:extLst xmlns:a="http://schemas.openxmlformats.org/drawingml/2006/main">
               <a:ext uri="{FF2B5EF4-FFF2-40B4-BE49-F238E27FC236}">
-                <a16:creationId xmlns:a16="http://schemas.microsoft.com/office/drawing/2014/main" id="{49B8534D-1BF7-4013-B66A-04D0E41CE69C}"/>
+                <a16:creationId xmlns:a16="http://schemas.microsoft.com/office/drawing/2014/main" id="{A674E735-E345-4757-8812-71B3AA03D496}"/>
               </a:ext>
             </a:extLst>
           </p:cNvPr>
@@ -2785,8 +3048,8 @@
         </p:nvSpPr>
         <p:spPr>
           <a:xfrm xmlns:a="http://schemas.openxmlformats.org/drawingml/2006/main">
-            <a:off x="571500" y="2647950"/>
-            <a:ext cx="4143375" cy="457200"/>
+            <a:off x="571500" y="6276975"/>
+            <a:ext cx="11049000" cy="323850"/>
           </a:xfrm>
           <a:prstGeom xmlns:a="http://schemas.openxmlformats.org/drawingml/2006/main" prst="rect">
             <a:avLst/>
@@ -2803,9 +3066,9 @@
           <a:lstStyle xmlns:a="http://schemas.openxmlformats.org/drawingml/2006/main"/>
           <a:p xmlns:a="http://schemas.openxmlformats.org/drawingml/2006/main">
             <a:pPr>
-              <a:defRPr sz="2250" b="1">
-                <a:solidFill>
-                  <a:srgbClr val="152E38"/>
+              <a:defRPr sz="1650" b="0">
+                <a:solidFill>
+                  <a:srgbClr val="50636B"/>
                 </a:solidFill>
                 <a:latin typeface="Arial"/>
                 <a:ea typeface="Arial"/>
@@ -2813,437 +3076,15 @@
               </a:defRPr>
             </a:pPr>
             <a:r>
-              <a:rPr sz="2250" b="1">
-                <a:solidFill>
-                  <a:srgbClr val="152E38"/>
+              <a:rPr sz="1650" b="0">
+                <a:solidFill>
+                  <a:srgbClr val="50636B"/>
                 </a:solidFill>
                 <a:latin typeface="Arial"/>
                 <a:ea typeface="Arial"/>
                 <a:cs typeface="Arial"/>
               </a:rPr>
-              <a:t>Logistic Regression</a:t>
-            </a:r>
-          </a:p>
-        </p:txBody>
-      </p:sp>
-      <p:sp>
-        <p:nvSpPr>
-          <p:cNvPr id="6" name="">
-            <a:extLst xmlns:a="http://schemas.openxmlformats.org/drawingml/2006/main">
-              <a:ext uri="{FF2B5EF4-FFF2-40B4-BE49-F238E27FC236}">
-                <a16:creationId xmlns:a16="http://schemas.microsoft.com/office/drawing/2014/main" id="{1D3B7919-BF73-42C8-811D-421410BDBB80}"/>
-              </a:ext>
-            </a:extLst>
-          </p:cNvPr>
-          <p:cNvSpPr>
-            <a:spLocks xmlns:a="http://schemas.openxmlformats.org/drawingml/2006/main" noGrp="1"/>
-          </p:cNvSpPr>
-          <p:nvPr/>
-        </p:nvSpPr>
-        <p:spPr>
-          <a:xfrm xmlns:a="http://schemas.openxmlformats.org/drawingml/2006/main">
-            <a:off x="5238750" y="2647950"/>
-            <a:ext cx="6096000" cy="457200"/>
-          </a:xfrm>
-          <a:prstGeom xmlns:a="http://schemas.openxmlformats.org/drawingml/2006/main" prst="rect">
-            <a:avLst/>
-          </a:prstGeom>
-          <a:noFill xmlns:a="http://schemas.openxmlformats.org/drawingml/2006/main"/>
-          <a:ln xmlns:a="http://schemas.openxmlformats.org/drawingml/2006/main" w="0">
-            <a:noFill/>
-          </a:ln>
-        </p:spPr>
-        <p:txBody>
-          <a:bodyPr xmlns:a="http://schemas.openxmlformats.org/drawingml/2006/main" lIns="0" tIns="0" rIns="0" bIns="0">
-            <a:noAutofit/>
-          </a:bodyPr>
-          <a:lstStyle xmlns:a="http://schemas.openxmlformats.org/drawingml/2006/main"/>
-          <a:p xmlns:a="http://schemas.openxmlformats.org/drawingml/2006/main">
-            <a:pPr>
-              <a:defRPr sz="2100" b="0">
-                <a:solidFill>
-                  <a:srgbClr val="152E38"/>
-                </a:solidFill>
-                <a:latin typeface="Arial"/>
-                <a:ea typeface="Arial"/>
-                <a:cs typeface="Arial"/>
-              </a:defRPr>
-            </a:pPr>
-            <a:r>
-              <a:rPr sz="2100" b="0">
-                <a:solidFill>
-                  <a:srgbClr val="152E38"/>
-                </a:solidFill>
-                <a:latin typeface="Arial"/>
-                <a:ea typeface="Arial"/>
-                <a:cs typeface="Arial"/>
-              </a:rPr>
-              <a:t>Linear classifier</a:t>
-            </a:r>
-          </a:p>
-        </p:txBody>
-      </p:sp>
-      <p:sp>
-        <p:nvSpPr>
-          <p:cNvPr id="7" name="">
-            <a:extLst xmlns:a="http://schemas.openxmlformats.org/drawingml/2006/main">
-              <a:ext uri="{FF2B5EF4-FFF2-40B4-BE49-F238E27FC236}">
-                <a16:creationId xmlns:a16="http://schemas.microsoft.com/office/drawing/2014/main" id="{D148FDBB-540C-45F7-9AB4-443CC6AE94A3}"/>
-              </a:ext>
-            </a:extLst>
-          </p:cNvPr>
-          <p:cNvSpPr>
-            <a:spLocks xmlns:a="http://schemas.openxmlformats.org/drawingml/2006/main" noGrp="1"/>
-          </p:cNvSpPr>
-          <p:nvPr/>
-        </p:nvSpPr>
-        <p:spPr>
-          <a:xfrm xmlns:a="http://schemas.openxmlformats.org/drawingml/2006/main">
-            <a:off x="571500" y="3181350"/>
-            <a:ext cx="4143375" cy="457200"/>
-          </a:xfrm>
-          <a:prstGeom xmlns:a="http://schemas.openxmlformats.org/drawingml/2006/main" prst="rect">
-            <a:avLst/>
-          </a:prstGeom>
-          <a:noFill xmlns:a="http://schemas.openxmlformats.org/drawingml/2006/main"/>
-          <a:ln xmlns:a="http://schemas.openxmlformats.org/drawingml/2006/main" w="0">
-            <a:noFill/>
-          </a:ln>
-        </p:spPr>
-        <p:txBody>
-          <a:bodyPr xmlns:a="http://schemas.openxmlformats.org/drawingml/2006/main" lIns="0" tIns="0" rIns="0" bIns="0">
-            <a:noAutofit/>
-          </a:bodyPr>
-          <a:lstStyle xmlns:a="http://schemas.openxmlformats.org/drawingml/2006/main"/>
-          <a:p xmlns:a="http://schemas.openxmlformats.org/drawingml/2006/main">
-            <a:pPr>
-              <a:defRPr sz="2250" b="1">
-                <a:solidFill>
-                  <a:srgbClr val="152E38"/>
-                </a:solidFill>
-                <a:latin typeface="Arial"/>
-                <a:ea typeface="Arial"/>
-                <a:cs typeface="Arial"/>
-              </a:defRPr>
-            </a:pPr>
-            <a:r>
-              <a:rPr sz="2250" b="1">
-                <a:solidFill>
-                  <a:srgbClr val="152E38"/>
-                </a:solidFill>
-                <a:latin typeface="Arial"/>
-                <a:ea typeface="Arial"/>
-                <a:cs typeface="Arial"/>
-              </a:rPr>
-              <a:t>Linear SVM</a:t>
-            </a:r>
-          </a:p>
-        </p:txBody>
-      </p:sp>
-      <p:sp>
-        <p:nvSpPr>
-          <p:cNvPr id="8" name="">
-            <a:extLst xmlns:a="http://schemas.openxmlformats.org/drawingml/2006/main">
-              <a:ext uri="{FF2B5EF4-FFF2-40B4-BE49-F238E27FC236}">
-                <a16:creationId xmlns:a16="http://schemas.microsoft.com/office/drawing/2014/main" id="{3DFA98A6-C246-4649-9D9E-04654E80F4EA}"/>
-              </a:ext>
-            </a:extLst>
-          </p:cNvPr>
-          <p:cNvSpPr>
-            <a:spLocks xmlns:a="http://schemas.openxmlformats.org/drawingml/2006/main" noGrp="1"/>
-          </p:cNvSpPr>
-          <p:nvPr/>
-        </p:nvSpPr>
-        <p:spPr>
-          <a:xfrm xmlns:a="http://schemas.openxmlformats.org/drawingml/2006/main">
-            <a:off x="5238750" y="3181350"/>
-            <a:ext cx="6096000" cy="457200"/>
-          </a:xfrm>
-          <a:prstGeom xmlns:a="http://schemas.openxmlformats.org/drawingml/2006/main" prst="rect">
-            <a:avLst/>
-          </a:prstGeom>
-          <a:noFill xmlns:a="http://schemas.openxmlformats.org/drawingml/2006/main"/>
-          <a:ln xmlns:a="http://schemas.openxmlformats.org/drawingml/2006/main" w="0">
-            <a:noFill/>
-          </a:ln>
-        </p:spPr>
-        <p:txBody>
-          <a:bodyPr xmlns:a="http://schemas.openxmlformats.org/drawingml/2006/main" lIns="0" tIns="0" rIns="0" bIns="0">
-            <a:noAutofit/>
-          </a:bodyPr>
-          <a:lstStyle xmlns:a="http://schemas.openxmlformats.org/drawingml/2006/main"/>
-          <a:p xmlns:a="http://schemas.openxmlformats.org/drawingml/2006/main">
-            <a:pPr>
-              <a:defRPr sz="2100" b="0">
-                <a:solidFill>
-                  <a:srgbClr val="152E38"/>
-                </a:solidFill>
-                <a:latin typeface="Arial"/>
-                <a:ea typeface="Arial"/>
-                <a:cs typeface="Arial"/>
-              </a:defRPr>
-            </a:pPr>
-            <a:r>
-              <a:rPr sz="2100" b="0">
-                <a:solidFill>
-                  <a:srgbClr val="152E38"/>
-                </a:solidFill>
-                <a:latin typeface="Arial"/>
-                <a:ea typeface="Arial"/>
-                <a:cs typeface="Arial"/>
-              </a:rPr>
-              <a:t>Linear margin classifier</a:t>
-            </a:r>
-          </a:p>
-        </p:txBody>
-      </p:sp>
-      <p:sp>
-        <p:nvSpPr>
-          <p:cNvPr id="9" name="">
-            <a:extLst xmlns:a="http://schemas.openxmlformats.org/drawingml/2006/main">
-              <a:ext uri="{FF2B5EF4-FFF2-40B4-BE49-F238E27FC236}">
-                <a16:creationId xmlns:a16="http://schemas.microsoft.com/office/drawing/2014/main" id="{E82C7E5E-A0E6-4879-B422-29D651CCC07E}"/>
-              </a:ext>
-            </a:extLst>
-          </p:cNvPr>
-          <p:cNvSpPr>
-            <a:spLocks xmlns:a="http://schemas.openxmlformats.org/drawingml/2006/main" noGrp="1"/>
-          </p:cNvSpPr>
-          <p:nvPr/>
-        </p:nvSpPr>
-        <p:spPr>
-          <a:xfrm xmlns:a="http://schemas.openxmlformats.org/drawingml/2006/main">
-            <a:off x="571500" y="3714750"/>
-            <a:ext cx="4143375" cy="457200"/>
-          </a:xfrm>
-          <a:prstGeom xmlns:a="http://schemas.openxmlformats.org/drawingml/2006/main" prst="rect">
-            <a:avLst/>
-          </a:prstGeom>
-          <a:noFill xmlns:a="http://schemas.openxmlformats.org/drawingml/2006/main"/>
-          <a:ln xmlns:a="http://schemas.openxmlformats.org/drawingml/2006/main" w="0">
-            <a:noFill/>
-          </a:ln>
-        </p:spPr>
-        <p:txBody>
-          <a:bodyPr xmlns:a="http://schemas.openxmlformats.org/drawingml/2006/main" lIns="0" tIns="0" rIns="0" bIns="0">
-            <a:noAutofit/>
-          </a:bodyPr>
-          <a:lstStyle xmlns:a="http://schemas.openxmlformats.org/drawingml/2006/main"/>
-          <a:p xmlns:a="http://schemas.openxmlformats.org/drawingml/2006/main">
-            <a:pPr>
-              <a:defRPr sz="2250" b="1">
-                <a:solidFill>
-                  <a:srgbClr val="152E38"/>
-                </a:solidFill>
-                <a:latin typeface="Arial"/>
-                <a:ea typeface="Arial"/>
-                <a:cs typeface="Arial"/>
-              </a:defRPr>
-            </a:pPr>
-            <a:r>
-              <a:rPr sz="2250" b="1">
-                <a:solidFill>
-                  <a:srgbClr val="152E38"/>
-                </a:solidFill>
-                <a:latin typeface="Arial"/>
-                <a:ea typeface="Arial"/>
-                <a:cs typeface="Arial"/>
-              </a:rPr>
-              <a:t>Random Forest</a:t>
-            </a:r>
-          </a:p>
-        </p:txBody>
-      </p:sp>
-      <p:sp>
-        <p:nvSpPr>
-          <p:cNvPr id="10" name="">
-            <a:extLst xmlns:a="http://schemas.openxmlformats.org/drawingml/2006/main">
-              <a:ext uri="{FF2B5EF4-FFF2-40B4-BE49-F238E27FC236}">
-                <a16:creationId xmlns:a16="http://schemas.microsoft.com/office/drawing/2014/main" id="{2F73650F-7524-4FEE-9893-968C4109109D}"/>
-              </a:ext>
-            </a:extLst>
-          </p:cNvPr>
-          <p:cNvSpPr>
-            <a:spLocks xmlns:a="http://schemas.openxmlformats.org/drawingml/2006/main" noGrp="1"/>
-          </p:cNvSpPr>
-          <p:nvPr/>
-        </p:nvSpPr>
-        <p:spPr>
-          <a:xfrm xmlns:a="http://schemas.openxmlformats.org/drawingml/2006/main">
-            <a:off x="5238750" y="3714750"/>
-            <a:ext cx="6096000" cy="457200"/>
-          </a:xfrm>
-          <a:prstGeom xmlns:a="http://schemas.openxmlformats.org/drawingml/2006/main" prst="rect">
-            <a:avLst/>
-          </a:prstGeom>
-          <a:noFill xmlns:a="http://schemas.openxmlformats.org/drawingml/2006/main"/>
-          <a:ln xmlns:a="http://schemas.openxmlformats.org/drawingml/2006/main" w="0">
-            <a:noFill/>
-          </a:ln>
-        </p:spPr>
-        <p:txBody>
-          <a:bodyPr xmlns:a="http://schemas.openxmlformats.org/drawingml/2006/main" lIns="0" tIns="0" rIns="0" bIns="0">
-            <a:noAutofit/>
-          </a:bodyPr>
-          <a:lstStyle xmlns:a="http://schemas.openxmlformats.org/drawingml/2006/main"/>
-          <a:p xmlns:a="http://schemas.openxmlformats.org/drawingml/2006/main">
-            <a:pPr>
-              <a:defRPr sz="2100" b="0">
-                <a:solidFill>
-                  <a:srgbClr val="152E38"/>
-                </a:solidFill>
-                <a:latin typeface="Arial"/>
-                <a:ea typeface="Arial"/>
-                <a:cs typeface="Arial"/>
-              </a:defRPr>
-            </a:pPr>
-            <a:r>
-              <a:rPr sz="2100" b="0">
-                <a:solidFill>
-                  <a:srgbClr val="152E38"/>
-                </a:solidFill>
-                <a:latin typeface="Arial"/>
-                <a:ea typeface="Arial"/>
-                <a:cs typeface="Arial"/>
-              </a:rPr>
-              <a:t>Tree ensemble</a:t>
-            </a:r>
-          </a:p>
-        </p:txBody>
-      </p:sp>
-      <p:sp>
-        <p:nvSpPr>
-          <p:cNvPr id="11" name="">
-            <a:extLst xmlns:a="http://schemas.openxmlformats.org/drawingml/2006/main">
-              <a:ext uri="{FF2B5EF4-FFF2-40B4-BE49-F238E27FC236}">
-                <a16:creationId xmlns:a16="http://schemas.microsoft.com/office/drawing/2014/main" id="{3144B875-D7ED-464F-8B97-96A54E1284E3}"/>
-              </a:ext>
-            </a:extLst>
-          </p:cNvPr>
-          <p:cNvSpPr>
-            <a:spLocks xmlns:a="http://schemas.openxmlformats.org/drawingml/2006/main" noGrp="1"/>
-          </p:cNvSpPr>
-          <p:nvPr/>
-        </p:nvSpPr>
-        <p:spPr>
-          <a:xfrm xmlns:a="http://schemas.openxmlformats.org/drawingml/2006/main">
-            <a:off x="571500" y="4591050"/>
-            <a:ext cx="11049000" cy="895350"/>
-          </a:xfrm>
-          <a:prstGeom xmlns:a="http://schemas.openxmlformats.org/drawingml/2006/main" prst="rect">
-            <a:avLst/>
-          </a:prstGeom>
-          <a:noFill xmlns:a="http://schemas.openxmlformats.org/drawingml/2006/main"/>
-          <a:ln xmlns:a="http://schemas.openxmlformats.org/drawingml/2006/main" w="0">
-            <a:noFill/>
-          </a:ln>
-        </p:spPr>
-        <p:txBody>
-          <a:bodyPr xmlns:a="http://schemas.openxmlformats.org/drawingml/2006/main" lIns="0" tIns="0" rIns="0" bIns="0">
-            <a:noAutofit/>
-          </a:bodyPr>
-          <a:lstStyle xmlns:a="http://schemas.openxmlformats.org/drawingml/2006/main"/>
-          <a:p xmlns:a="http://schemas.openxmlformats.org/drawingml/2006/main">
-            <a:pPr>
-              <a:defRPr sz="2175" b="1">
-                <a:solidFill>
-                  <a:srgbClr val="117C83"/>
-                </a:solidFill>
-                <a:latin typeface="Arial"/>
-                <a:ea typeface="Arial"/>
-                <a:cs typeface="Arial"/>
-              </a:defRPr>
-            </a:pPr>
-            <a:r>
-              <a:rPr sz="2175" b="1">
-                <a:solidFill>
-                  <a:srgbClr val="117C83"/>
-                </a:solidFill>
-                <a:latin typeface="Arial"/>
-                <a:ea typeface="Arial"/>
-                <a:cs typeface="Arial"/>
-              </a:rPr>
-              <a:t>F1 = 2 × precision × recall / (precision + recall)</a:t>
-            </a:r>
-          </a:p>
-          <a:p xmlns:a="http://schemas.openxmlformats.org/drawingml/2006/main">
-            <a:pPr>
-              <a:defRPr sz="2175" b="1">
-                <a:solidFill>
-                  <a:srgbClr val="117C83"/>
-                </a:solidFill>
-                <a:latin typeface="Arial"/>
-                <a:ea typeface="Arial"/>
-                <a:cs typeface="Arial"/>
-              </a:defRPr>
-            </a:pPr>
-            <a:r>
-              <a:rPr sz="2175" b="1">
-                <a:solidFill>
-                  <a:srgbClr val="117C83"/>
-                </a:solidFill>
-                <a:latin typeface="Arial"/>
-                <a:ea typeface="Arial"/>
-                <a:cs typeface="Arial"/>
-              </a:rPr>
-              <a:t>Macro-F1 = average of the five class F1 scores</a:t>
-            </a:r>
-          </a:p>
-        </p:txBody>
-      </p:sp>
-      <p:sp>
-        <p:nvSpPr>
-          <p:cNvPr id="12" name="">
-            <a:extLst xmlns:a="http://schemas.openxmlformats.org/drawingml/2006/main">
-              <a:ext uri="{FF2B5EF4-FFF2-40B4-BE49-F238E27FC236}">
-                <a16:creationId xmlns:a16="http://schemas.microsoft.com/office/drawing/2014/main" id="{1BDD8B95-C3F1-4216-A438-1893F67CBE2A}"/>
-              </a:ext>
-            </a:extLst>
-          </p:cNvPr>
-          <p:cNvSpPr>
-            <a:spLocks xmlns:a="http://schemas.openxmlformats.org/drawingml/2006/main" noGrp="1"/>
-          </p:cNvSpPr>
-          <p:nvPr/>
-        </p:nvSpPr>
-        <p:spPr>
-          <a:xfrm xmlns:a="http://schemas.openxmlformats.org/drawingml/2006/main">
-            <a:off x="571500" y="5876925"/>
-            <a:ext cx="11049000" cy="409575"/>
-          </a:xfrm>
-          <a:prstGeom xmlns:a="http://schemas.openxmlformats.org/drawingml/2006/main" prst="rect">
-            <a:avLst/>
-          </a:prstGeom>
-          <a:noFill xmlns:a="http://schemas.openxmlformats.org/drawingml/2006/main"/>
-          <a:ln xmlns:a="http://schemas.openxmlformats.org/drawingml/2006/main" w="0">
-            <a:noFill/>
-          </a:ln>
-        </p:spPr>
-        <p:txBody>
-          <a:bodyPr xmlns:a="http://schemas.openxmlformats.org/drawingml/2006/main" lIns="0" tIns="0" rIns="0" bIns="0">
-            <a:noAutofit/>
-          </a:bodyPr>
-          <a:lstStyle xmlns:a="http://schemas.openxmlformats.org/drawingml/2006/main"/>
-          <a:p xmlns:a="http://schemas.openxmlformats.org/drawingml/2006/main">
-            <a:pPr>
-              <a:defRPr sz="1950" b="0">
-                <a:solidFill>
-                  <a:srgbClr val="152E38"/>
-                </a:solidFill>
-                <a:latin typeface="Arial"/>
-                <a:ea typeface="Arial"/>
-                <a:cs typeface="Arial"/>
-              </a:defRPr>
-            </a:pPr>
-            <a:r>
-              <a:rPr sz="1950" b="0">
-                <a:solidFill>
-                  <a:srgbClr val="152E38"/>
-                </a:solidFill>
-                <a:latin typeface="Arial"/>
-                <a:ea typeface="Arial"/>
-                <a:cs typeface="Arial"/>
-              </a:rPr>
-              <a:t>Select using validation Macro-F1. Each LLM class has equal weight.</a:t>
+              <a:t>LinearSVC uses squared-hinge loss and regularizes the intercept (scale = 1).</a:t>
             </a:r>
           </a:p>
         </p:txBody>
@@ -3251,7 +3092,7 @@
     </p:spTree>
     <p:extLst>
       <p:ext uri="{BB962C8B-B14F-4D97-AF65-F5344CB8AC3E}">
-        <p14:creationId xmlns:p14="http://schemas.microsoft.com/office/powerpoint/2010/main" val="1952846311"/>
+        <p14:creationId xmlns:p14="http://schemas.microsoft.com/office/powerpoint/2010/main" val="174756043"/>
       </p:ext>
     </p:extLst>
   </p:cSld>
@@ -3279,10 +3120,10 @@
       </p:grpSpPr>
       <p:sp>
         <p:nvSpPr>
-          <p:cNvPr id="6" name="">
+          <p:cNvPr id="7" name="">
             <a:extLst xmlns:a="http://schemas.openxmlformats.org/drawingml/2006/main">
               <a:ext uri="{FF2B5EF4-FFF2-40B4-BE49-F238E27FC236}">
-                <a16:creationId xmlns:a16="http://schemas.microsoft.com/office/drawing/2014/main" id="{0E07F51B-90B7-4763-8523-BDF78EEE1AF9}"/>
+                <a16:creationId xmlns:a16="http://schemas.microsoft.com/office/drawing/2014/main" id="{1423F091-2413-4DF6-941E-8108DFCA8852}"/>
               </a:ext>
             </a:extLst>
           </p:cNvPr>
@@ -3336,7 +3177,7 @@
       </p:sp>
       <p:graphicFrame>
         <p:nvGraphicFramePr>
-          <p:cNvPr id="7" name=""/>
+          <p:cNvPr id="8" name=""/>
           <p:cNvGraphicFramePr/>
           <p:nvPr/>
         </p:nvGraphicFramePr>
@@ -4046,14 +3887,14 @@
       </p:graphicFrame>
       <p:pic>
         <p:nvPicPr>
-          <p:cNvPr id="8" name=""/>
+          <p:cNvPr id="9" name=""/>
           <p:cNvPicPr>
             <a:picLocks xmlns:a="http://schemas.openxmlformats.org/drawingml/2006/main" noChangeAspect="1"/>
           </p:cNvPicPr>
           <p:nvPr/>
         </p:nvPicPr>
         <p:blipFill>
-          <a:blip xmlns:r="http://schemas.openxmlformats.org/officeDocument/2006/relationships" xmlns:a="http://schemas.openxmlformats.org/drawingml/2006/main" r:embed="R3c4ecda0ac844eb6"/>
+          <a:blip xmlns:r="http://schemas.openxmlformats.org/officeDocument/2006/relationships" xmlns:a="http://schemas.openxmlformats.org/drawingml/2006/main" r:embed="Rce88165ae4f4441e"/>
           <a:stretch xmlns:a="http://schemas.openxmlformats.org/drawingml/2006/main"/>
         </p:blipFill>
         <p:spPr>
@@ -4071,7 +3912,7 @@
           <p:cNvPr id="4" name="">
             <a:extLst xmlns:a="http://schemas.openxmlformats.org/drawingml/2006/main">
               <a:ext uri="{FF2B5EF4-FFF2-40B4-BE49-F238E27FC236}">
-                <a16:creationId xmlns:a16="http://schemas.microsoft.com/office/drawing/2014/main" id="{AA49DD9B-055A-415C-961C-21548E98591D}"/>
+                <a16:creationId xmlns:a16="http://schemas.microsoft.com/office/drawing/2014/main" id="{B0F132B3-303F-4730-88FF-4FDC1A85ADFE}"/>
               </a:ext>
             </a:extLst>
           </p:cNvPr>
@@ -4082,8 +3923,8 @@
         </p:nvSpPr>
         <p:spPr>
           <a:xfrm xmlns:a="http://schemas.openxmlformats.org/drawingml/2006/main">
-            <a:off x="571500" y="5095875"/>
-            <a:ext cx="6667500" cy="876300"/>
+            <a:off x="571500" y="4905375"/>
+            <a:ext cx="6667500" cy="762000"/>
           </a:xfrm>
           <a:prstGeom xmlns:a="http://schemas.openxmlformats.org/drawingml/2006/main" prst="rect">
             <a:avLst/>
@@ -4100,7 +3941,7 @@
           <a:lstStyle xmlns:a="http://schemas.openxmlformats.org/drawingml/2006/main"/>
           <a:p xmlns:a="http://schemas.openxmlformats.org/drawingml/2006/main">
             <a:pPr>
-              <a:defRPr sz="2025" b="1">
+              <a:defRPr sz="2100" b="1">
                 <a:solidFill>
                   <a:srgbClr val="117C83"/>
                 </a:solidFill>
@@ -4110,7 +3951,7 @@
               </a:defRPr>
             </a:pPr>
             <a:r>
-              <a:rPr sz="2025" b="1">
+              <a:rPr sz="2100" b="1">
                 <a:solidFill>
                   <a:srgbClr val="117C83"/>
                 </a:solidFill>
@@ -4118,12 +3959,12 @@
                 <a:ea typeface="Arial"/>
                 <a:cs typeface="Arial"/>
               </a:rPr>
-              <a:t>SVM test accuracy: 79.75%</a:t>
+              <a:t>F1 = 2PR / (P + R)</a:t>
             </a:r>
           </a:p>
           <a:p xmlns:a="http://schemas.openxmlformats.org/drawingml/2006/main">
             <a:pPr>
-              <a:defRPr sz="2025" b="1">
+              <a:defRPr sz="2100" b="1">
                 <a:solidFill>
                   <a:srgbClr val="117C83"/>
                 </a:solidFill>
@@ -4133,7 +3974,7 @@
               </a:defRPr>
             </a:pPr>
             <a:r>
-              <a:rPr sz="2025" b="1">
+              <a:rPr sz="2100" b="1">
                 <a:solidFill>
                   <a:srgbClr val="117C83"/>
                 </a:solidFill>
@@ -4141,7 +3982,7 @@
                 <a:ea typeface="Arial"/>
                 <a:cs typeface="Arial"/>
               </a:rPr>
-              <a:t>Correct predictions lie on the matrix diagonal.</a:t>
+              <a:t>Macro-F1 = (F1₁ + … + F1₅) / 5</a:t>
             </a:r>
           </a:p>
         </p:txBody>
@@ -4151,7 +3992,7 @@
           <p:cNvPr id="5" name="">
             <a:extLst xmlns:a="http://schemas.openxmlformats.org/drawingml/2006/main">
               <a:ext uri="{FF2B5EF4-FFF2-40B4-BE49-F238E27FC236}">
-                <a16:creationId xmlns:a16="http://schemas.microsoft.com/office/drawing/2014/main" id="{8ECC7E48-2CF4-40BF-9753-907875B43ED4}"/>
+                <a16:creationId xmlns:a16="http://schemas.microsoft.com/office/drawing/2014/main" id="{A9A5EECD-86FA-4FA2-AB09-E2ACF58D1459}"/>
               </a:ext>
             </a:extLst>
           </p:cNvPr>
@@ -4162,8 +4003,8 @@
         </p:nvSpPr>
         <p:spPr>
           <a:xfrm xmlns:a="http://schemas.openxmlformats.org/drawingml/2006/main">
-            <a:off x="571500" y="6257925"/>
-            <a:ext cx="11049000" cy="323850"/>
+            <a:off x="571500" y="5772150"/>
+            <a:ext cx="6667500" cy="542925"/>
           </a:xfrm>
           <a:prstGeom xmlns:a="http://schemas.openxmlformats.org/drawingml/2006/main" prst="rect">
             <a:avLst/>
@@ -4180,9 +4021,9 @@
           <a:lstStyle xmlns:a="http://schemas.openxmlformats.org/drawingml/2006/main"/>
           <a:p xmlns:a="http://schemas.openxmlformats.org/drawingml/2006/main">
             <a:pPr>
-              <a:defRPr sz="1725" b="0">
-                <a:solidFill>
-                  <a:srgbClr val="50636B"/>
+              <a:defRPr sz="1650" b="0">
+                <a:solidFill>
+                  <a:srgbClr val="152E38"/>
                 </a:solidFill>
                 <a:latin typeface="Arial"/>
                 <a:ea typeface="Arial"/>
@@ -4190,15 +4031,95 @@
               </a:defRPr>
             </a:pPr>
             <a:r>
-              <a:rPr sz="1725" b="0">
+              <a:rPr sz="1650" b="0">
+                <a:solidFill>
+                  <a:srgbClr val="152E38"/>
+                </a:solidFill>
+                <a:latin typeface="Arial"/>
+                <a:ea typeface="Arial"/>
+                <a:cs typeface="Arial"/>
+              </a:rPr>
+              <a:t>P: precision    R: recall</a:t>
+            </a:r>
+          </a:p>
+          <a:p xmlns:a="http://schemas.openxmlformats.org/drawingml/2006/main">
+            <a:pPr>
+              <a:defRPr sz="1650" b="0">
+                <a:solidFill>
+                  <a:srgbClr val="152E38"/>
+                </a:solidFill>
+                <a:latin typeface="Arial"/>
+                <a:ea typeface="Arial"/>
+                <a:cs typeface="Arial"/>
+              </a:defRPr>
+            </a:pPr>
+            <a:r>
+              <a:rPr sz="1650" b="0">
+                <a:solidFill>
+                  <a:srgbClr val="152E38"/>
+                </a:solidFill>
+                <a:latin typeface="Arial"/>
+                <a:ea typeface="Arial"/>
+                <a:cs typeface="Arial"/>
+              </a:rPr>
+              <a:t>SVM validation Macro-F1: 0.8062 (selection)</a:t>
+            </a:r>
+          </a:p>
+        </p:txBody>
+      </p:sp>
+      <p:sp>
+        <p:nvSpPr>
+          <p:cNvPr id="6" name="">
+            <a:extLst xmlns:a="http://schemas.openxmlformats.org/drawingml/2006/main">
+              <a:ext uri="{FF2B5EF4-FFF2-40B4-BE49-F238E27FC236}">
+                <a16:creationId xmlns:a16="http://schemas.microsoft.com/office/drawing/2014/main" id="{2BBB11DB-4A99-41AD-BF02-E3B05F1210E0}"/>
+              </a:ext>
+            </a:extLst>
+          </p:cNvPr>
+          <p:cNvSpPr>
+            <a:spLocks xmlns:a="http://schemas.openxmlformats.org/drawingml/2006/main" noGrp="1"/>
+          </p:cNvSpPr>
+          <p:nvPr/>
+        </p:nvSpPr>
+        <p:spPr>
+          <a:xfrm xmlns:a="http://schemas.openxmlformats.org/drawingml/2006/main">
+            <a:off x="571500" y="6486525"/>
+            <a:ext cx="11049000" cy="247650"/>
+          </a:xfrm>
+          <a:prstGeom xmlns:a="http://schemas.openxmlformats.org/drawingml/2006/main" prst="rect">
+            <a:avLst/>
+          </a:prstGeom>
+          <a:noFill xmlns:a="http://schemas.openxmlformats.org/drawingml/2006/main"/>
+          <a:ln xmlns:a="http://schemas.openxmlformats.org/drawingml/2006/main" w="0">
+            <a:noFill/>
+          </a:ln>
+        </p:spPr>
+        <p:txBody>
+          <a:bodyPr xmlns:a="http://schemas.openxmlformats.org/drawingml/2006/main" lIns="0" tIns="0" rIns="0" bIns="0">
+            <a:noAutofit/>
+          </a:bodyPr>
+          <a:lstStyle xmlns:a="http://schemas.openxmlformats.org/drawingml/2006/main"/>
+          <a:p xmlns:a="http://schemas.openxmlformats.org/drawingml/2006/main">
+            <a:pPr>
+              <a:defRPr sz="1500" b="0">
                 <a:solidFill>
                   <a:srgbClr val="50636B"/>
                 </a:solidFill>
                 <a:latin typeface="Arial"/>
                 <a:ea typeface="Arial"/>
                 <a:cs typeface="Arial"/>
+              </a:defRPr>
+            </a:pPr>
+            <a:r>
+              <a:rPr sz="1500" b="0">
+                <a:solidFill>
+                  <a:srgbClr val="50636B"/>
+                </a:solidFill>
+                <a:latin typeface="Arial"/>
+                <a:ea typeface="Arial"/>
+                <a:cs typeface="Arial"/>
               </a:rPr>
-              <a:t>Fit time excludes TF-IDF. MB measures the compressed classifier.</a:t>
+              <a:t>Test: 3,872 programs. Fit time and model size exclude TF-IDF.</a:t>
             </a:r>
           </a:p>
         </p:txBody>
@@ -4206,7 +4127,7 @@
     </p:spTree>
     <p:extLst>
       <p:ext uri="{BB962C8B-B14F-4D97-AF65-F5344CB8AC3E}">
-        <p14:creationId xmlns:p14="http://schemas.microsoft.com/office/powerpoint/2010/main" val="1863823771"/>
+        <p14:creationId xmlns:p14="http://schemas.microsoft.com/office/powerpoint/2010/main" val="869065995"/>
       </p:ext>
     </p:extLst>
   </p:cSld>
@@ -4237,7 +4158,7 @@
           <p:cNvPr id="5" name="">
             <a:extLst xmlns:a="http://schemas.openxmlformats.org/drawingml/2006/main">
               <a:ext uri="{FF2B5EF4-FFF2-40B4-BE49-F238E27FC236}">
-                <a16:creationId xmlns:a16="http://schemas.microsoft.com/office/drawing/2014/main" id="{53890294-D55C-47C7-A498-6BB4BE0A19A0}"/>
+                <a16:creationId xmlns:a16="http://schemas.microsoft.com/office/drawing/2014/main" id="{00F5A025-5950-4BD6-8F99-FD58F497E0BD}"/>
               </a:ext>
             </a:extLst>
           </p:cNvPr>
@@ -4298,7 +4219,7 @@
           <p:nvPr/>
         </p:nvPicPr>
         <p:blipFill>
-          <a:blip xmlns:r="http://schemas.openxmlformats.org/officeDocument/2006/relationships" xmlns:a="http://schemas.openxmlformats.org/drawingml/2006/main" r:embed="R28b6fe4ff8a646d5"/>
+          <a:blip xmlns:r="http://schemas.openxmlformats.org/officeDocument/2006/relationships" xmlns:a="http://schemas.openxmlformats.org/drawingml/2006/main" r:embed="R8a2680c66c9b4023"/>
           <a:stretch xmlns:a="http://schemas.openxmlformats.org/drawingml/2006/main"/>
         </p:blipFill>
         <p:spPr>
@@ -4316,7 +4237,7 @@
           <p:cNvPr id="3" name="">
             <a:extLst xmlns:a="http://schemas.openxmlformats.org/drawingml/2006/main">
               <a:ext uri="{FF2B5EF4-FFF2-40B4-BE49-F238E27FC236}">
-                <a16:creationId xmlns:a16="http://schemas.microsoft.com/office/drawing/2014/main" id="{B52D6927-C7B6-48B7-A846-68F39FCFDCEA}"/>
+                <a16:creationId xmlns:a16="http://schemas.microsoft.com/office/drawing/2014/main" id="{AB944FEB-AD25-4227-87DE-55188A5EB925}"/>
               </a:ext>
             </a:extLst>
           </p:cNvPr>
@@ -4396,7 +4317,7 @@
           <p:cNvPr id="4" name="">
             <a:extLst xmlns:a="http://schemas.openxmlformats.org/drawingml/2006/main">
               <a:ext uri="{FF2B5EF4-FFF2-40B4-BE49-F238E27FC236}">
-                <a16:creationId xmlns:a16="http://schemas.microsoft.com/office/drawing/2014/main" id="{557A80C0-68C2-49EB-920B-23EB0C756E51}"/>
+                <a16:creationId xmlns:a16="http://schemas.microsoft.com/office/drawing/2014/main" id="{8EBF3C80-E355-4397-8B16-C55BE55FA71F}"/>
               </a:ext>
             </a:extLst>
           </p:cNvPr>
@@ -4474,7 +4395,7 @@
     </p:spTree>
     <p:extLst>
       <p:ext uri="{BB962C8B-B14F-4D97-AF65-F5344CB8AC3E}">
-        <p14:creationId xmlns:p14="http://schemas.microsoft.com/office/powerpoint/2010/main" val="56885040"/>
+        <p14:creationId xmlns:p14="http://schemas.microsoft.com/office/powerpoint/2010/main" val="950581761"/>
       </p:ext>
     </p:extLst>
   </p:cSld>

</xml_diff>

<commit_message>
Typeset slide equations with research-style mathematical notation
</commit_message>
<xml_diff>
--- a/submission/Assignment.pptx
+++ b/submission/Assignment.pptx
@@ -2,17 +2,17 @@
 <file path=ppt/presentation.xml><?xml version="1.0" encoding="utf-8"?>
 <p:presentation xmlns:p="http://schemas.openxmlformats.org/presentationml/2006/main">
   <p:sldMasterIdLst>
-    <p:sldMasterId xmlns:r="http://schemas.openxmlformats.org/officeDocument/2006/relationships" id="2147483648" r:id="R034efcd4b1414613"/>
+    <p:sldMasterId xmlns:r="http://schemas.openxmlformats.org/officeDocument/2006/relationships" id="2147483648" r:id="R308a56acc3df4430"/>
   </p:sldMasterIdLst>
   <p:notesMasterIdLst>
-    <p:notesMasterId xmlns:r="http://schemas.openxmlformats.org/officeDocument/2006/relationships" r:id="R231da35ed40348b2"/>
+    <p:notesMasterId xmlns:r="http://schemas.openxmlformats.org/officeDocument/2006/relationships" r:id="R5d78586f7c4549e6"/>
   </p:notesMasterIdLst>
   <p:sldIdLst>
-    <p:sldId xmlns:r="http://schemas.openxmlformats.org/officeDocument/2006/relationships" id="256" r:id="R2edb8b2c9b7f4fb9"/>
-    <p:sldId xmlns:r="http://schemas.openxmlformats.org/officeDocument/2006/relationships" id="257" r:id="Rcb5dbcb3feaf4f1f"/>
-    <p:sldId xmlns:r="http://schemas.openxmlformats.org/officeDocument/2006/relationships" id="258" r:id="R5cec3d1956794dbf"/>
-    <p:sldId xmlns:r="http://schemas.openxmlformats.org/officeDocument/2006/relationships" id="259" r:id="R20c34acd1cbc41a6"/>
-    <p:sldId xmlns:r="http://schemas.openxmlformats.org/officeDocument/2006/relationships" id="260" r:id="R831267d18b184c01"/>
+    <p:sldId xmlns:r="http://schemas.openxmlformats.org/officeDocument/2006/relationships" id="256" r:id="R28d829945efb4f9c"/>
+    <p:sldId xmlns:r="http://schemas.openxmlformats.org/officeDocument/2006/relationships" id="257" r:id="R33ed2ee9fe7b41e5"/>
+    <p:sldId xmlns:r="http://schemas.openxmlformats.org/officeDocument/2006/relationships" id="258" r:id="R1122b233210c4238"/>
+    <p:sldId xmlns:r="http://schemas.openxmlformats.org/officeDocument/2006/relationships" id="259" r:id="Rf2d6543178524467"/>
+    <p:sldId xmlns:r="http://schemas.openxmlformats.org/officeDocument/2006/relationships" id="260" r:id="Rc006f61dcced4b85"/>
   </p:sldIdLst>
   <p:sldSz cx="12192000" cy="6858000"/>
   <p:notesSz cx="6858000" cy="9144000"/>
@@ -794,7 +794,7 @@
   </p:cSld>
   <p:clrMap bg1="lt1" tx1="dk1" bg2="lt2" tx2="dk2" accent1="accent1" accent2="accent2" accent3="accent3" accent4="accent4" accent5="accent5" accent6="accent6" hlink="hlink" folHlink="folHlink"/>
   <p:sldLayoutIdLst>
-    <p:sldLayoutId xmlns:r="http://schemas.openxmlformats.org/officeDocument/2006/relationships" id="2147483649" r:id="R3a140da35ba548f7"/>
+    <p:sldLayoutId xmlns:r="http://schemas.openxmlformats.org/officeDocument/2006/relationships" id="2147483649" r:id="R569feaa1e24c4cc5"/>
   </p:sldLayoutIdLst>
   <p:txStyles>
     <p:titleStyle>
@@ -1345,7 +1345,7 @@
           <p:cNvPr id="7" name="">
             <a:extLst xmlns:a="http://schemas.openxmlformats.org/drawingml/2006/main">
               <a:ext uri="{FF2B5EF4-FFF2-40B4-BE49-F238E27FC236}">
-                <a16:creationId xmlns:a16="http://schemas.microsoft.com/office/drawing/2014/main" id="{56AC8825-FCAD-442E-8CBD-A18A46741BBF}"/>
+                <a16:creationId xmlns:a16="http://schemas.microsoft.com/office/drawing/2014/main" id="{B1E3D35C-FB37-4EB8-B467-85C5032971CD}"/>
               </a:ext>
             </a:extLst>
           </p:cNvPr>
@@ -1402,7 +1402,7 @@
           <p:cNvPr id="2" name="">
             <a:extLst xmlns:a="http://schemas.openxmlformats.org/drawingml/2006/main">
               <a:ext uri="{FF2B5EF4-FFF2-40B4-BE49-F238E27FC236}">
-                <a16:creationId xmlns:a16="http://schemas.microsoft.com/office/drawing/2014/main" id="{A2FE5CA1-4B04-4F65-A91C-005CBBDB25E9}"/>
+                <a16:creationId xmlns:a16="http://schemas.microsoft.com/office/drawing/2014/main" id="{93FC002E-7B12-46A7-A235-2A04372AF7D4}"/>
               </a:ext>
             </a:extLst>
           </p:cNvPr>
@@ -1459,7 +1459,7 @@
           <p:cNvPr id="3" name="">
             <a:extLst xmlns:a="http://schemas.openxmlformats.org/drawingml/2006/main">
               <a:ext uri="{FF2B5EF4-FFF2-40B4-BE49-F238E27FC236}">
-                <a16:creationId xmlns:a16="http://schemas.microsoft.com/office/drawing/2014/main" id="{607AFCD3-D4B3-4324-95CB-B8C6C131BE73}"/>
+                <a16:creationId xmlns:a16="http://schemas.microsoft.com/office/drawing/2014/main" id="{17334C1B-D253-49F0-8995-6509CC9D5C24}"/>
               </a:ext>
             </a:extLst>
           </p:cNvPr>
@@ -1539,7 +1539,7 @@
           <p:cNvPr id="4" name="">
             <a:extLst xmlns:a="http://schemas.openxmlformats.org/drawingml/2006/main">
               <a:ext uri="{FF2B5EF4-FFF2-40B4-BE49-F238E27FC236}">
-                <a16:creationId xmlns:a16="http://schemas.microsoft.com/office/drawing/2014/main" id="{AE8BCC15-88B6-48F7-9C33-F475B6AB0BE7}"/>
+                <a16:creationId xmlns:a16="http://schemas.microsoft.com/office/drawing/2014/main" id="{746F9FBF-B5CE-4B47-ABE5-BE0B6BE88484}"/>
               </a:ext>
             </a:extLst>
           </p:cNvPr>
@@ -1619,7 +1619,7 @@
           <p:cNvPr id="5" name="">
             <a:extLst xmlns:a="http://schemas.openxmlformats.org/drawingml/2006/main">
               <a:ext uri="{FF2B5EF4-FFF2-40B4-BE49-F238E27FC236}">
-                <a16:creationId xmlns:a16="http://schemas.microsoft.com/office/drawing/2014/main" id="{8170F0D1-366C-488F-8971-A099B188867E}"/>
+                <a16:creationId xmlns:a16="http://schemas.microsoft.com/office/drawing/2014/main" id="{B3C8D6E4-6F63-4725-A8C1-017A1C0FD456}"/>
               </a:ext>
             </a:extLst>
           </p:cNvPr>
@@ -1676,7 +1676,7 @@
           <p:cNvPr id="6" name="">
             <a:extLst xmlns:a="http://schemas.openxmlformats.org/drawingml/2006/main">
               <a:ext uri="{FF2B5EF4-FFF2-40B4-BE49-F238E27FC236}">
-                <a16:creationId xmlns:a16="http://schemas.microsoft.com/office/drawing/2014/main" id="{D9E259FF-2AC6-4300-9E9F-2DA5870D6934}"/>
+                <a16:creationId xmlns:a16="http://schemas.microsoft.com/office/drawing/2014/main" id="{C29F1FE6-4CC8-42F3-AD28-82BA2500899E}"/>
               </a:ext>
             </a:extLst>
           </p:cNvPr>
@@ -1731,7 +1731,7 @@
     </p:spTree>
     <p:extLst>
       <p:ext uri="{BB962C8B-B14F-4D97-AF65-F5344CB8AC3E}">
-        <p14:creationId xmlns:p14="http://schemas.microsoft.com/office/powerpoint/2010/main" val="1348411800"/>
+        <p14:creationId xmlns:p14="http://schemas.microsoft.com/office/powerpoint/2010/main" val="405089188"/>
       </p:ext>
     </p:extLst>
   </p:cSld>
@@ -1762,7 +1762,7 @@
           <p:cNvPr id="7" name="">
             <a:extLst xmlns:a="http://schemas.openxmlformats.org/drawingml/2006/main">
               <a:ext uri="{FF2B5EF4-FFF2-40B4-BE49-F238E27FC236}">
-                <a16:creationId xmlns:a16="http://schemas.microsoft.com/office/drawing/2014/main" id="{107A55FA-24F1-4845-B6D5-F0BCB7B5CE63}"/>
+                <a16:creationId xmlns:a16="http://schemas.microsoft.com/office/drawing/2014/main" id="{47DABF14-80BA-4C5B-943C-212B1962BCBF}"/>
               </a:ext>
             </a:extLst>
           </p:cNvPr>
@@ -2174,7 +2174,7 @@
           <p:cNvPr id="3" name="">
             <a:extLst xmlns:a="http://schemas.openxmlformats.org/drawingml/2006/main">
               <a:ext uri="{FF2B5EF4-FFF2-40B4-BE49-F238E27FC236}">
-                <a16:creationId xmlns:a16="http://schemas.microsoft.com/office/drawing/2014/main" id="{9EC2D4EE-EC2E-46A5-9F02-CEAAAF6BFD13}"/>
+                <a16:creationId xmlns:a16="http://schemas.microsoft.com/office/drawing/2014/main" id="{38D05D51-B2AD-43DD-801B-9550482D1F0B}"/>
               </a:ext>
             </a:extLst>
           </p:cNvPr>
@@ -2300,7 +2300,7 @@
           <p:cNvPr id="4" name="">
             <a:extLst xmlns:a="http://schemas.openxmlformats.org/drawingml/2006/main">
               <a:ext uri="{FF2B5EF4-FFF2-40B4-BE49-F238E27FC236}">
-                <a16:creationId xmlns:a16="http://schemas.microsoft.com/office/drawing/2014/main" id="{40B6CCB9-0C49-439A-9A67-995E787FDD5D}"/>
+                <a16:creationId xmlns:a16="http://schemas.microsoft.com/office/drawing/2014/main" id="{D59C5223-7AF8-48CD-B443-F3ED09209035}"/>
               </a:ext>
             </a:extLst>
           </p:cNvPr>
@@ -2403,7 +2403,7 @@
           <p:cNvPr id="5" name="">
             <a:extLst xmlns:a="http://schemas.openxmlformats.org/drawingml/2006/main">
               <a:ext uri="{FF2B5EF4-FFF2-40B4-BE49-F238E27FC236}">
-                <a16:creationId xmlns:a16="http://schemas.microsoft.com/office/drawing/2014/main" id="{852B9607-2BC0-4B85-BD87-6D799385D698}"/>
+                <a16:creationId xmlns:a16="http://schemas.microsoft.com/office/drawing/2014/main" id="{4E633893-C05A-4A8D-B6B9-411D890077BD}"/>
               </a:ext>
             </a:extLst>
           </p:cNvPr>
@@ -2483,7 +2483,7 @@
           <p:cNvPr id="6" name="">
             <a:extLst xmlns:a="http://schemas.openxmlformats.org/drawingml/2006/main">
               <a:ext uri="{FF2B5EF4-FFF2-40B4-BE49-F238E27FC236}">
-                <a16:creationId xmlns:a16="http://schemas.microsoft.com/office/drawing/2014/main" id="{ECE58FAC-F286-45F4-9D30-438849A74BBE}"/>
+                <a16:creationId xmlns:a16="http://schemas.microsoft.com/office/drawing/2014/main" id="{C09E1ACB-0975-456B-A215-AD2CE4B04B90}"/>
               </a:ext>
             </a:extLst>
           </p:cNvPr>
@@ -2538,7 +2538,7 @@
     </p:spTree>
     <p:extLst>
       <p:ext uri="{BB962C8B-B14F-4D97-AF65-F5344CB8AC3E}">
-        <p14:creationId xmlns:p14="http://schemas.microsoft.com/office/powerpoint/2010/main" val="1068471164"/>
+        <p14:creationId xmlns:p14="http://schemas.microsoft.com/office/powerpoint/2010/main" val="561566841"/>
       </p:ext>
     </p:extLst>
   </p:cSld>
@@ -2569,7 +2569,7 @@
           <p:cNvPr id="9" name="">
             <a:extLst xmlns:a="http://schemas.openxmlformats.org/drawingml/2006/main">
               <a:ext uri="{FF2B5EF4-FFF2-40B4-BE49-F238E27FC236}">
-                <a16:creationId xmlns:a16="http://schemas.microsoft.com/office/drawing/2014/main" id="{0617C12A-F730-4039-A653-063E2DEFA949}"/>
+                <a16:creationId xmlns:a16="http://schemas.microsoft.com/office/drawing/2014/main" id="{A961A5B7-C093-4FD2-8077-50F929BC30FB}"/>
               </a:ext>
             </a:extLst>
           </p:cNvPr>
@@ -2626,7 +2626,7 @@
           <p:cNvPr id="2" name="">
             <a:extLst xmlns:a="http://schemas.openxmlformats.org/drawingml/2006/main">
               <a:ext uri="{FF2B5EF4-FFF2-40B4-BE49-F238E27FC236}">
-                <a16:creationId xmlns:a16="http://schemas.microsoft.com/office/drawing/2014/main" id="{48FA743D-D208-4BFC-8DA7-AABE2039C6EB}"/>
+                <a16:creationId xmlns:a16="http://schemas.microsoft.com/office/drawing/2014/main" id="{D729AD58-9D7A-4B43-8FCF-3448563F7E77}"/>
               </a:ext>
             </a:extLst>
           </p:cNvPr>
@@ -2701,69 +2701,34 @@
           </a:p>
         </p:txBody>
       </p:sp>
-      <p:sp>
-        <p:nvSpPr>
-          <p:cNvPr id="3" name="">
-            <a:extLst xmlns:a="http://schemas.openxmlformats.org/drawingml/2006/main">
-              <a:ext uri="{FF2B5EF4-FFF2-40B4-BE49-F238E27FC236}">
-                <a16:creationId xmlns:a16="http://schemas.microsoft.com/office/drawing/2014/main" id="{127D5340-7788-4C25-900F-48724F236622}"/>
-              </a:ext>
-            </a:extLst>
-          </p:cNvPr>
-          <p:cNvSpPr>
-            <a:spLocks xmlns:a="http://schemas.openxmlformats.org/drawingml/2006/main" noGrp="1"/>
-          </p:cNvSpPr>
+      <p:pic>
+        <p:nvPicPr>
+          <p:cNvPr id="11" name=""/>
+          <p:cNvPicPr>
+            <a:picLocks xmlns:a="http://schemas.openxmlformats.org/drawingml/2006/main" noChangeAspect="1"/>
+          </p:cNvPicPr>
           <p:nvPr/>
-        </p:nvSpPr>
+        </p:nvPicPr>
+        <p:blipFill>
+          <a:blip xmlns:r="http://schemas.openxmlformats.org/officeDocument/2006/relationships" xmlns:a="http://schemas.openxmlformats.org/drawingml/2006/main" r:embed="Rec3f6a9e90a94006"/>
+          <a:stretch xmlns:a="http://schemas.openxmlformats.org/drawingml/2006/main"/>
+        </p:blipFill>
         <p:spPr>
           <a:xfrm xmlns:a="http://schemas.openxmlformats.org/drawingml/2006/main">
-            <a:off x="571500" y="2276475"/>
-            <a:ext cx="10953750" cy="457200"/>
+            <a:off x="2941926" y="2019300"/>
+            <a:ext cx="6308148" cy="857250"/>
           </a:xfrm>
           <a:prstGeom xmlns:a="http://schemas.openxmlformats.org/drawingml/2006/main" prst="rect">
             <a:avLst/>
           </a:prstGeom>
-          <a:noFill xmlns:a="http://schemas.openxmlformats.org/drawingml/2006/main"/>
-          <a:ln xmlns:a="http://schemas.openxmlformats.org/drawingml/2006/main" w="0">
-            <a:noFill/>
-          </a:ln>
         </p:spPr>
-        <p:txBody>
-          <a:bodyPr xmlns:a="http://schemas.openxmlformats.org/drawingml/2006/main" lIns="0" tIns="0" rIns="0" bIns="0">
-            <a:noAutofit/>
-          </a:bodyPr>
-          <a:lstStyle xmlns:a="http://schemas.openxmlformats.org/drawingml/2006/main"/>
-          <a:p xmlns:a="http://schemas.openxmlformats.org/drawingml/2006/main">
-            <a:pPr>
-              <a:defRPr sz="2550" b="1">
-                <a:solidFill>
-                  <a:srgbClr val="117C83"/>
-                </a:solidFill>
-                <a:latin typeface="Arial"/>
-                <a:ea typeface="Arial"/>
-                <a:cs typeface="Arial"/>
-              </a:defRPr>
-            </a:pPr>
-            <a:r>
-              <a:rPr sz="2550" b="1">
-                <a:solidFill>
-                  <a:srgbClr val="117C83"/>
-                </a:solidFill>
-                <a:latin typeface="Arial"/>
-                <a:ea typeface="Arial"/>
-                <a:cs typeface="Arial"/>
-              </a:rPr>
-              <a:t>Score for class k:  fₖ(x) = wₖᵀx + bₖ</a:t>
-            </a:r>
-          </a:p>
-        </p:txBody>
-      </p:sp>
+      </p:pic>
       <p:sp>
         <p:nvSpPr>
           <p:cNvPr id="4" name="">
             <a:extLst xmlns:a="http://schemas.openxmlformats.org/drawingml/2006/main">
               <a:ext uri="{FF2B5EF4-FFF2-40B4-BE49-F238E27FC236}">
-                <a16:creationId xmlns:a16="http://schemas.microsoft.com/office/drawing/2014/main" id="{5CA868F0-E7E7-4F56-B678-A58B6AEE3F77}"/>
+                <a16:creationId xmlns:a16="http://schemas.microsoft.com/office/drawing/2014/main" id="{917BBA9F-7FF2-4D0E-B9DF-B2CEE192DA20}"/>
               </a:ext>
             </a:extLst>
           </p:cNvPr>
@@ -2815,69 +2780,34 @@
           </a:p>
         </p:txBody>
       </p:sp>
-      <p:sp>
-        <p:nvSpPr>
-          <p:cNvPr id="5" name="">
-            <a:extLst xmlns:a="http://schemas.openxmlformats.org/drawingml/2006/main">
-              <a:ext uri="{FF2B5EF4-FFF2-40B4-BE49-F238E27FC236}">
-                <a16:creationId xmlns:a16="http://schemas.microsoft.com/office/drawing/2014/main" id="{88225C70-D991-4FD5-B08C-7B4877B9B127}"/>
-              </a:ext>
-            </a:extLst>
-          </p:cNvPr>
-          <p:cNvSpPr>
-            <a:spLocks xmlns:a="http://schemas.openxmlformats.org/drawingml/2006/main" noGrp="1"/>
-          </p:cNvSpPr>
+      <p:pic>
+        <p:nvPicPr>
+          <p:cNvPr id="13" name=""/>
+          <p:cNvPicPr>
+            <a:picLocks xmlns:a="http://schemas.openxmlformats.org/drawingml/2006/main" noChangeAspect="1"/>
+          </p:cNvPicPr>
           <p:nvPr/>
-        </p:nvSpPr>
+        </p:nvPicPr>
+        <p:blipFill>
+          <a:blip xmlns:r="http://schemas.openxmlformats.org/officeDocument/2006/relationships" xmlns:a="http://schemas.openxmlformats.org/drawingml/2006/main" r:embed="Rccfd2ec01c65474b"/>
+          <a:stretch xmlns:a="http://schemas.openxmlformats.org/drawingml/2006/main"/>
+        </p:blipFill>
         <p:spPr>
           <a:xfrm xmlns:a="http://schemas.openxmlformats.org/drawingml/2006/main">
-            <a:off x="571500" y="3429000"/>
-            <a:ext cx="11144250" cy="571500"/>
+            <a:off x="1865344" y="3200400"/>
+            <a:ext cx="8461312" cy="1047750"/>
           </a:xfrm>
           <a:prstGeom xmlns:a="http://schemas.openxmlformats.org/drawingml/2006/main" prst="rect">
             <a:avLst/>
           </a:prstGeom>
-          <a:noFill xmlns:a="http://schemas.openxmlformats.org/drawingml/2006/main"/>
-          <a:ln xmlns:a="http://schemas.openxmlformats.org/drawingml/2006/main" w="0">
-            <a:noFill/>
-          </a:ln>
         </p:spPr>
-        <p:txBody>
-          <a:bodyPr xmlns:a="http://schemas.openxmlformats.org/drawingml/2006/main" lIns="0" tIns="0" rIns="0" bIns="0">
-            <a:noAutofit/>
-          </a:bodyPr>
-          <a:lstStyle xmlns:a="http://schemas.openxmlformats.org/drawingml/2006/main"/>
-          <a:p xmlns:a="http://schemas.openxmlformats.org/drawingml/2006/main">
-            <a:pPr>
-              <a:defRPr sz="2400" b="1">
-                <a:solidFill>
-                  <a:srgbClr val="117C83"/>
-                </a:solidFill>
-                <a:latin typeface="Arial"/>
-                <a:ea typeface="Arial"/>
-                <a:cs typeface="Arial"/>
-              </a:defRPr>
-            </a:pPr>
-            <a:r>
-              <a:rPr sz="2400" b="1">
-                <a:solidFill>
-                  <a:srgbClr val="117C83"/>
-                </a:solidFill>
-                <a:latin typeface="Arial"/>
-                <a:ea typeface="Arial"/>
-                <a:cs typeface="Arial"/>
-              </a:rPr>
-              <a:t>Minimize J = ½(‖w‖² + b²) + C Σᵢ max(0, 1 − yᵢ f(xᵢ))²</a:t>
-            </a:r>
-          </a:p>
-        </p:txBody>
-      </p:sp>
+      </p:pic>
       <p:sp>
         <p:nvSpPr>
           <p:cNvPr id="6" name="">
             <a:extLst xmlns:a="http://schemas.openxmlformats.org/drawingml/2006/main">
               <a:ext uri="{FF2B5EF4-FFF2-40B4-BE49-F238E27FC236}">
-                <a16:creationId xmlns:a16="http://schemas.microsoft.com/office/drawing/2014/main" id="{1BC5E97D-4462-4C14-97F0-6286B37700D2}"/>
+                <a16:creationId xmlns:a16="http://schemas.microsoft.com/office/drawing/2014/main" id="{0542703A-9361-48DF-A31A-EB9184DB8323}"/>
               </a:ext>
             </a:extLst>
           </p:cNvPr>
@@ -2957,7 +2887,7 @@
           <p:cNvPr id="7" name="">
             <a:extLst xmlns:a="http://schemas.openxmlformats.org/drawingml/2006/main">
               <a:ext uri="{FF2B5EF4-FFF2-40B4-BE49-F238E27FC236}">
-                <a16:creationId xmlns:a16="http://schemas.microsoft.com/office/drawing/2014/main" id="{0CC44DE1-7080-48E1-A0C1-126E6238BFAD}"/>
+                <a16:creationId xmlns:a16="http://schemas.microsoft.com/office/drawing/2014/main" id="{C4380A16-2263-4D1A-A8C9-1B554DCCBD58}"/>
               </a:ext>
             </a:extLst>
           </p:cNvPr>
@@ -3037,7 +2967,7 @@
           <p:cNvPr id="8" name="">
             <a:extLst xmlns:a="http://schemas.openxmlformats.org/drawingml/2006/main">
               <a:ext uri="{FF2B5EF4-FFF2-40B4-BE49-F238E27FC236}">
-                <a16:creationId xmlns:a16="http://schemas.microsoft.com/office/drawing/2014/main" id="{A674E735-E345-4757-8812-71B3AA03D496}"/>
+                <a16:creationId xmlns:a16="http://schemas.microsoft.com/office/drawing/2014/main" id="{E1DA0977-79FA-428C-A8DD-09357B65D598}"/>
               </a:ext>
             </a:extLst>
           </p:cNvPr>
@@ -3092,7 +3022,7 @@
     </p:spTree>
     <p:extLst>
       <p:ext uri="{BB962C8B-B14F-4D97-AF65-F5344CB8AC3E}">
-        <p14:creationId xmlns:p14="http://schemas.microsoft.com/office/powerpoint/2010/main" val="174756043"/>
+        <p14:creationId xmlns:p14="http://schemas.microsoft.com/office/powerpoint/2010/main" val="795001900"/>
       </p:ext>
     </p:extLst>
   </p:cSld>
@@ -3123,7 +3053,7 @@
           <p:cNvPr id="7" name="">
             <a:extLst xmlns:a="http://schemas.openxmlformats.org/drawingml/2006/main">
               <a:ext uri="{FF2B5EF4-FFF2-40B4-BE49-F238E27FC236}">
-                <a16:creationId xmlns:a16="http://schemas.microsoft.com/office/drawing/2014/main" id="{1423F091-2413-4DF6-941E-8108DFCA8852}"/>
+                <a16:creationId xmlns:a16="http://schemas.microsoft.com/office/drawing/2014/main" id="{0E76CBAA-43C8-4C9F-BD8F-90A7F0D8750C}"/>
               </a:ext>
             </a:extLst>
           </p:cNvPr>
@@ -3894,7 +3824,7 @@
           <p:nvPr/>
         </p:nvPicPr>
         <p:blipFill>
-          <a:blip xmlns:r="http://schemas.openxmlformats.org/officeDocument/2006/relationships" xmlns:a="http://schemas.openxmlformats.org/drawingml/2006/main" r:embed="Rce88165ae4f4441e"/>
+          <a:blip xmlns:r="http://schemas.openxmlformats.org/officeDocument/2006/relationships" xmlns:a="http://schemas.openxmlformats.org/drawingml/2006/main" r:embed="R40bae9e9ef0e4636"/>
           <a:stretch xmlns:a="http://schemas.openxmlformats.org/drawingml/2006/main"/>
         </p:blipFill>
         <p:spPr>
@@ -3907,92 +3837,34 @@
           </a:prstGeom>
         </p:spPr>
       </p:pic>
-      <p:sp>
-        <p:nvSpPr>
-          <p:cNvPr id="4" name="">
-            <a:extLst xmlns:a="http://schemas.openxmlformats.org/drawingml/2006/main">
-              <a:ext uri="{FF2B5EF4-FFF2-40B4-BE49-F238E27FC236}">
-                <a16:creationId xmlns:a16="http://schemas.microsoft.com/office/drawing/2014/main" id="{B0F132B3-303F-4730-88FF-4FDC1A85ADFE}"/>
-              </a:ext>
-            </a:extLst>
-          </p:cNvPr>
-          <p:cNvSpPr>
-            <a:spLocks xmlns:a="http://schemas.openxmlformats.org/drawingml/2006/main" noGrp="1"/>
-          </p:cNvSpPr>
+      <p:pic>
+        <p:nvPicPr>
+          <p:cNvPr id="10" name=""/>
+          <p:cNvPicPr>
+            <a:picLocks xmlns:a="http://schemas.openxmlformats.org/drawingml/2006/main" noChangeAspect="1"/>
+          </p:cNvPicPr>
           <p:nvPr/>
-        </p:nvSpPr>
+        </p:nvPicPr>
+        <p:blipFill>
+          <a:blip xmlns:r="http://schemas.openxmlformats.org/officeDocument/2006/relationships" xmlns:a="http://schemas.openxmlformats.org/drawingml/2006/main" r:embed="R0c30f0713d8c4127"/>
+          <a:stretch xmlns:a="http://schemas.openxmlformats.org/drawingml/2006/main"/>
+        </p:blipFill>
         <p:spPr>
           <a:xfrm xmlns:a="http://schemas.openxmlformats.org/drawingml/2006/main">
-            <a:off x="571500" y="4905375"/>
-            <a:ext cx="6667500" cy="762000"/>
+            <a:off x="795451" y="4762500"/>
+            <a:ext cx="6124348" cy="1047750"/>
           </a:xfrm>
           <a:prstGeom xmlns:a="http://schemas.openxmlformats.org/drawingml/2006/main" prst="rect">
             <a:avLst/>
           </a:prstGeom>
-          <a:noFill xmlns:a="http://schemas.openxmlformats.org/drawingml/2006/main"/>
-          <a:ln xmlns:a="http://schemas.openxmlformats.org/drawingml/2006/main" w="0">
-            <a:noFill/>
-          </a:ln>
         </p:spPr>
-        <p:txBody>
-          <a:bodyPr xmlns:a="http://schemas.openxmlformats.org/drawingml/2006/main" lIns="0" tIns="0" rIns="0" bIns="0">
-            <a:noAutofit/>
-          </a:bodyPr>
-          <a:lstStyle xmlns:a="http://schemas.openxmlformats.org/drawingml/2006/main"/>
-          <a:p xmlns:a="http://schemas.openxmlformats.org/drawingml/2006/main">
-            <a:pPr>
-              <a:defRPr sz="2100" b="1">
-                <a:solidFill>
-                  <a:srgbClr val="117C83"/>
-                </a:solidFill>
-                <a:latin typeface="Arial"/>
-                <a:ea typeface="Arial"/>
-                <a:cs typeface="Arial"/>
-              </a:defRPr>
-            </a:pPr>
-            <a:r>
-              <a:rPr sz="2100" b="1">
-                <a:solidFill>
-                  <a:srgbClr val="117C83"/>
-                </a:solidFill>
-                <a:latin typeface="Arial"/>
-                <a:ea typeface="Arial"/>
-                <a:cs typeface="Arial"/>
-              </a:rPr>
-              <a:t>F1 = 2PR / (P + R)</a:t>
-            </a:r>
-          </a:p>
-          <a:p xmlns:a="http://schemas.openxmlformats.org/drawingml/2006/main">
-            <a:pPr>
-              <a:defRPr sz="2100" b="1">
-                <a:solidFill>
-                  <a:srgbClr val="117C83"/>
-                </a:solidFill>
-                <a:latin typeface="Arial"/>
-                <a:ea typeface="Arial"/>
-                <a:cs typeface="Arial"/>
-              </a:defRPr>
-            </a:pPr>
-            <a:r>
-              <a:rPr sz="2100" b="1">
-                <a:solidFill>
-                  <a:srgbClr val="117C83"/>
-                </a:solidFill>
-                <a:latin typeface="Arial"/>
-                <a:ea typeface="Arial"/>
-                <a:cs typeface="Arial"/>
-              </a:rPr>
-              <a:t>Macro-F1 = (F1₁ + … + F1₅) / 5</a:t>
-            </a:r>
-          </a:p>
-        </p:txBody>
-      </p:sp>
+      </p:pic>
       <p:sp>
         <p:nvSpPr>
           <p:cNvPr id="5" name="">
             <a:extLst xmlns:a="http://schemas.openxmlformats.org/drawingml/2006/main">
               <a:ext uri="{FF2B5EF4-FFF2-40B4-BE49-F238E27FC236}">
-                <a16:creationId xmlns:a16="http://schemas.microsoft.com/office/drawing/2014/main" id="{A9A5EECD-86FA-4FA2-AB09-E2ACF58D1459}"/>
+                <a16:creationId xmlns:a16="http://schemas.microsoft.com/office/drawing/2014/main" id="{3B617228-A482-4895-94EC-321CB2A66962}"/>
               </a:ext>
             </a:extLst>
           </p:cNvPr>
@@ -4072,7 +3944,7 @@
           <p:cNvPr id="6" name="">
             <a:extLst xmlns:a="http://schemas.openxmlformats.org/drawingml/2006/main">
               <a:ext uri="{FF2B5EF4-FFF2-40B4-BE49-F238E27FC236}">
-                <a16:creationId xmlns:a16="http://schemas.microsoft.com/office/drawing/2014/main" id="{2BBB11DB-4A99-41AD-BF02-E3B05F1210E0}"/>
+                <a16:creationId xmlns:a16="http://schemas.microsoft.com/office/drawing/2014/main" id="{49ECBD16-42C6-4210-92F8-76E51FA62DFC}"/>
               </a:ext>
             </a:extLst>
           </p:cNvPr>
@@ -4127,7 +3999,7 @@
     </p:spTree>
     <p:extLst>
       <p:ext uri="{BB962C8B-B14F-4D97-AF65-F5344CB8AC3E}">
-        <p14:creationId xmlns:p14="http://schemas.microsoft.com/office/powerpoint/2010/main" val="869065995"/>
+        <p14:creationId xmlns:p14="http://schemas.microsoft.com/office/powerpoint/2010/main" val="1614871259"/>
       </p:ext>
     </p:extLst>
   </p:cSld>
@@ -4158,7 +4030,7 @@
           <p:cNvPr id="5" name="">
             <a:extLst xmlns:a="http://schemas.openxmlformats.org/drawingml/2006/main">
               <a:ext uri="{FF2B5EF4-FFF2-40B4-BE49-F238E27FC236}">
-                <a16:creationId xmlns:a16="http://schemas.microsoft.com/office/drawing/2014/main" id="{00F5A025-5950-4BD6-8F99-FD58F497E0BD}"/>
+                <a16:creationId xmlns:a16="http://schemas.microsoft.com/office/drawing/2014/main" id="{5D751A48-5F25-4527-9938-59A66620B651}"/>
               </a:ext>
             </a:extLst>
           </p:cNvPr>
@@ -4219,7 +4091,7 @@
           <p:nvPr/>
         </p:nvPicPr>
         <p:blipFill>
-          <a:blip xmlns:r="http://schemas.openxmlformats.org/officeDocument/2006/relationships" xmlns:a="http://schemas.openxmlformats.org/drawingml/2006/main" r:embed="R8a2680c66c9b4023"/>
+          <a:blip xmlns:r="http://schemas.openxmlformats.org/officeDocument/2006/relationships" xmlns:a="http://schemas.openxmlformats.org/drawingml/2006/main" r:embed="R8434c4425bba440c"/>
           <a:stretch xmlns:a="http://schemas.openxmlformats.org/drawingml/2006/main"/>
         </p:blipFill>
         <p:spPr>
@@ -4237,7 +4109,7 @@
           <p:cNvPr id="3" name="">
             <a:extLst xmlns:a="http://schemas.openxmlformats.org/drawingml/2006/main">
               <a:ext uri="{FF2B5EF4-FFF2-40B4-BE49-F238E27FC236}">
-                <a16:creationId xmlns:a16="http://schemas.microsoft.com/office/drawing/2014/main" id="{AB944FEB-AD25-4227-87DE-55188A5EB925}"/>
+                <a16:creationId xmlns:a16="http://schemas.microsoft.com/office/drawing/2014/main" id="{1398FCFD-9387-49EA-846C-CFE76EB09DEA}"/>
               </a:ext>
             </a:extLst>
           </p:cNvPr>
@@ -4317,7 +4189,7 @@
           <p:cNvPr id="4" name="">
             <a:extLst xmlns:a="http://schemas.openxmlformats.org/drawingml/2006/main">
               <a:ext uri="{FF2B5EF4-FFF2-40B4-BE49-F238E27FC236}">
-                <a16:creationId xmlns:a16="http://schemas.microsoft.com/office/drawing/2014/main" id="{8EBF3C80-E355-4397-8B16-C55BE55FA71F}"/>
+                <a16:creationId xmlns:a16="http://schemas.microsoft.com/office/drawing/2014/main" id="{2E18622C-6CA1-46D2-9A13-BEE3BEB3BDF9}"/>
               </a:ext>
             </a:extLst>
           </p:cNvPr>
@@ -4395,7 +4267,7 @@
     </p:spTree>
     <p:extLst>
       <p:ext uri="{BB962C8B-B14F-4D97-AF65-F5344CB8AC3E}">
-        <p14:creationId xmlns:p14="http://schemas.microsoft.com/office/powerpoint/2010/main" val="950581761"/>
+        <p14:creationId xmlns:p14="http://schemas.microsoft.com/office/powerpoint/2010/main" val="147755663"/>
       </p:ext>
     </p:extLst>
   </p:cSld>

</xml_diff>

<commit_message>
Publish five-model slides with group names and simplify README
</commit_message>
<xml_diff>
--- a/submission/Assignment.pptx
+++ b/submission/Assignment.pptx
@@ -2,17 +2,17 @@
 <file path=ppt/presentation.xml><?xml version="1.0" encoding="utf-8"?>
 <p:presentation xmlns:p="http://schemas.openxmlformats.org/presentationml/2006/main">
   <p:sldMasterIdLst>
-    <p:sldMasterId xmlns:r="http://schemas.openxmlformats.org/officeDocument/2006/relationships" id="2147483648" r:id="R308a56acc3df4430"/>
+    <p:sldMasterId xmlns:r="http://schemas.openxmlformats.org/officeDocument/2006/relationships" id="2147483648" r:id="Re6557b04c9e64e72"/>
   </p:sldMasterIdLst>
   <p:notesMasterIdLst>
-    <p:notesMasterId xmlns:r="http://schemas.openxmlformats.org/officeDocument/2006/relationships" r:id="R5d78586f7c4549e6"/>
+    <p:notesMasterId xmlns:r="http://schemas.openxmlformats.org/officeDocument/2006/relationships" r:id="Rfd40f8e0e0914d8d"/>
   </p:notesMasterIdLst>
   <p:sldIdLst>
-    <p:sldId xmlns:r="http://schemas.openxmlformats.org/officeDocument/2006/relationships" id="256" r:id="R28d829945efb4f9c"/>
-    <p:sldId xmlns:r="http://schemas.openxmlformats.org/officeDocument/2006/relationships" id="257" r:id="R33ed2ee9fe7b41e5"/>
-    <p:sldId xmlns:r="http://schemas.openxmlformats.org/officeDocument/2006/relationships" id="258" r:id="R1122b233210c4238"/>
-    <p:sldId xmlns:r="http://schemas.openxmlformats.org/officeDocument/2006/relationships" id="259" r:id="Rf2d6543178524467"/>
-    <p:sldId xmlns:r="http://schemas.openxmlformats.org/officeDocument/2006/relationships" id="260" r:id="Rc006f61dcced4b85"/>
+    <p:sldId xmlns:r="http://schemas.openxmlformats.org/officeDocument/2006/relationships" id="256" r:id="R5407add3af574b81"/>
+    <p:sldId xmlns:r="http://schemas.openxmlformats.org/officeDocument/2006/relationships" id="257" r:id="R5350ba14e1324fbd"/>
+    <p:sldId xmlns:r="http://schemas.openxmlformats.org/officeDocument/2006/relationships" id="258" r:id="R92651891c0f542b6"/>
+    <p:sldId xmlns:r="http://schemas.openxmlformats.org/officeDocument/2006/relationships" id="259" r:id="R24cf62cbc2fa4991"/>
+    <p:sldId xmlns:r="http://schemas.openxmlformats.org/officeDocument/2006/relationships" id="260" r:id="Rb4eead5d2a204908"/>
   </p:sldIdLst>
   <p:sldSz cx="12192000" cy="6858000"/>
   <p:notesSz cx="6858000" cy="9144000"/>
@@ -446,7 +446,7 @@
           <a:lstStyle xmlns:a="http://schemas.openxmlformats.org/drawingml/2006/main"/>
           <a:p xmlns:a="http://schemas.openxmlformats.org/drawingml/2006/main">
             <a:r>
-              <a:t>Source: https://github.com/LLMauthorbench/LLMauthorbench ; paper https://arxiv.org/abs/2506.17323 . The authors describe code generation from 300 parameterized C-programming templates, followed by deduplication and compilation filtering. We treat code as text. The five labels are gpt-4.1, deepseek-chat, claude-3.5-haiku, gemini-2.5-flash-preview-05-20 and llama-3.3-70b-instruct. AI assistance was used for code and writing. Research-use licence, dataset claim and member contributions still require group confirmation.</a:t>
+              <a:t>Source: https://github.com/LLMauthorbench/LLMauthorbench ; paper https://arxiv.org/abs/2506.17323 . The authors describe code generation from 300 parameterized C-programming templates, followed by deduplication and compilation filtering. We treat code as text. The five labels are gpt-4.1, deepseek-chat, claude-3.5-haiku, gemini-2.5-flash-preview-05-20 and llama-3.3-70b-instruct. AI assistance was used for code and writing. The instructor approved the dataset choice by email. Dataset reuse licence remains unverified; individual contributions remain to be documented.</a:t>
             </a:r>
           </a:p>
         </p:txBody>
@@ -656,7 +656,7 @@
           <a:lstStyle xmlns:a="http://schemas.openxmlformats.org/drawingml/2006/main"/>
           <a:p xmlns:a="http://schemas.openxmlformats.org/drawingml/2006/main">
             <a:r>
-              <a:t>Sources: results/metrics.csv and results/experiment_1_original/Linear SVM_test_confusion.csv. Matrix shows raw counts for 3,872 test programs. Labels abbreviated: Claude is claude-3.5-haiku, DeepSeek is deepseek-chat, Gemini is gemini-2.5-flash-preview-05-20, GPT-4.1 is gpt-4.1 and Llama is llama-3.3-70b-instruct. Rows are actual labels, columns predictions. SVM selected using validation Macro-F1 0.8062. Timings and compressed classifier sizes exclude shared TF-IDF. Single split, no significance claim.</a:t>
+              <a:t>Sources: results/metrics.csv and results/experiment_1_original/Linear SVM_test_confusion.csv. Matrix shows raw counts for 3,872 test programs. Labels abbreviated: Claude is claude-3.5-haiku, DeepSeek is deepseek-chat, Gemini is gemini-2.5-flash-preview-05-20, GPT-4.1 is gpt-4.1 and Llama is llama-3.3-70b-instruct. Rows are actual labels, columns predictions. SVM selected using validation Macro-F1 0.8062. Timings and compressed classifier sizes exclude shared TF-IDF. Single split, no significance claim. CodeT5 source: user-supplied codet5_results (1).zip, verified against all 3,872 saved test row IDs and true labels. Architecture: Salesforce/codet5-base encoder, masked mean pooling, dropout 0.1 and five-class linear head. 256-token limit, batch 16, AdamW learning rate 2e-5, weight decay 0.01, seed 42, five epochs, best validation epoch 3 at 0.7997564. Test accuracy 0.7696281, Macro-F1 0.7725136. Training wall time 291.706s on A100 40GB includes validation/saving and is not directly comparable with CPU fit timings. Downloaded best_model (1).pt is 438,494,134 bytes, or 438.494 MB. This is an uncompressed PyTorch state dictionary containing encoder and head weights; classical sizes use joblib compression. Serialization differs, so these are stored file sizes rather than a controlled memory comparison. Same split, different representation and truncation; not a paper reproduction. P is precision and R is recall. CodeT5 narrowly exceeds LR but trails SVM by 2.45 F1 percentage points.</a:t>
             </a:r>
           </a:p>
         </p:txBody>
@@ -726,7 +726,7 @@
           <a:lstStyle xmlns:a="http://schemas.openxmlformats.org/drawingml/2006/main"/>
           <a:p xmlns:a="http://schemas.openxmlformats.org/drawingml/2006/main">
             <a:r>
-              <a:t>Sources: PLAN.md, results/feature_comparison.csv and results/feature_interpretation.md. Hypothesis: distributed character patterns partly explain the SVM advantage. One limit of 500 was chosen and committed before execution in 5cdab0d, with no sweep. Original code and comments retained. Validation SVM-LR gap falls from 1.48692356 to 1.38818655 percentage points: a change of only 0.09873701 points. All validation and test ranks remain SVM, LR, RF, NB. Test SVM F1 falls from 0.7970261 to 0.7169088. This exploratory single-split result is weak directional support, not a ranking reversal or a statistically established causal explanation. Restricting vocabulary also changes normalization and the forest sqrt candidate-feature count. The prior comment-removal prediction failed: validation gap widened from 1.49 to 3.03 points. Both outcomes are retained and reported.</a:t>
+              <a:t>Sources: results/feature_comparison.csv and results/feature_interpretation.md. Hypothesis: distributed character patterns partly explain the SVM advantage. One limit of 500 was chosen and committed before execution in the original development history, with no sweep. Original code and comments retained. Validation SVM-LR gap falls from 1.48692356 to 1.38818655 percentage points: a change of only 0.09873701 points. All validation and test ranks remain SVM, LR, RF, NB. Test SVM F1 falls from 0.7970261 to 0.7169088. This exploratory single-split result is weak directional support, not a ranking reversal or a statistically established causal explanation. Restricting vocabulary also changes normalization and the forest sqrt candidate-feature count. The prior comment-removal prediction failed: validation gap widened from 1.49 to 3.03 points. Both outcomes are retained and reported.</a:t>
             </a:r>
           </a:p>
         </p:txBody>
@@ -794,7 +794,7 @@
   </p:cSld>
   <p:clrMap bg1="lt1" tx1="dk1" bg2="lt2" tx2="dk2" accent1="accent1" accent2="accent2" accent3="accent3" accent4="accent4" accent5="accent5" accent6="accent6" hlink="hlink" folHlink="folHlink"/>
   <p:sldLayoutIdLst>
-    <p:sldLayoutId xmlns:r="http://schemas.openxmlformats.org/officeDocument/2006/relationships" id="2147483649" r:id="R569feaa1e24c4cc5"/>
+    <p:sldLayoutId xmlns:r="http://schemas.openxmlformats.org/officeDocument/2006/relationships" id="2147483649" r:id="Rf9699fd47dad4ca6"/>
   </p:sldLayoutIdLst>
   <p:txStyles>
     <p:titleStyle>
@@ -1342,10 +1342,10 @@
       </p:grpSpPr>
       <p:sp>
         <p:nvSpPr>
-          <p:cNvPr id="7" name="">
+          <p:cNvPr id="8" name="">
             <a:extLst xmlns:a="http://schemas.openxmlformats.org/drawingml/2006/main">
               <a:ext uri="{FF2B5EF4-FFF2-40B4-BE49-F238E27FC236}">
-                <a16:creationId xmlns:a16="http://schemas.microsoft.com/office/drawing/2014/main" id="{B1E3D35C-FB37-4EB8-B467-85C5032971CD}"/>
+                <a16:creationId xmlns:a16="http://schemas.microsoft.com/office/drawing/2014/main" id="{46584576-CFE3-4750-8BFA-76749E34173E}"/>
               </a:ext>
             </a:extLst>
           </p:cNvPr>
@@ -1402,7 +1402,7 @@
           <p:cNvPr id="2" name="">
             <a:extLst xmlns:a="http://schemas.openxmlformats.org/drawingml/2006/main">
               <a:ext uri="{FF2B5EF4-FFF2-40B4-BE49-F238E27FC236}">
-                <a16:creationId xmlns:a16="http://schemas.microsoft.com/office/drawing/2014/main" id="{93FC002E-7B12-46A7-A235-2A04372AF7D4}"/>
+                <a16:creationId xmlns:a16="http://schemas.microsoft.com/office/drawing/2014/main" id="{3271D388-C5CD-4409-8DFF-CC7E9447062D}"/>
               </a:ext>
             </a:extLst>
           </p:cNvPr>
@@ -1459,7 +1459,7 @@
           <p:cNvPr id="3" name="">
             <a:extLst xmlns:a="http://schemas.openxmlformats.org/drawingml/2006/main">
               <a:ext uri="{FF2B5EF4-FFF2-40B4-BE49-F238E27FC236}">
-                <a16:creationId xmlns:a16="http://schemas.microsoft.com/office/drawing/2014/main" id="{17334C1B-D253-49F0-8995-6509CC9D5C24}"/>
+                <a16:creationId xmlns:a16="http://schemas.microsoft.com/office/drawing/2014/main" id="{A8148E40-F4B2-4B00-B0F0-89FAB57B0F0F}"/>
               </a:ext>
             </a:extLst>
           </p:cNvPr>
@@ -1539,7 +1539,7 @@
           <p:cNvPr id="4" name="">
             <a:extLst xmlns:a="http://schemas.openxmlformats.org/drawingml/2006/main">
               <a:ext uri="{FF2B5EF4-FFF2-40B4-BE49-F238E27FC236}">
-                <a16:creationId xmlns:a16="http://schemas.microsoft.com/office/drawing/2014/main" id="{746F9FBF-B5CE-4B47-ABE5-BE0B6BE88484}"/>
+                <a16:creationId xmlns:a16="http://schemas.microsoft.com/office/drawing/2014/main" id="{8DAED0CA-94BE-47AC-8572-DB1C06C133DB}"/>
               </a:ext>
             </a:extLst>
           </p:cNvPr>
@@ -1609,7 +1609,7 @@
                 <a:ea typeface="Arial"/>
                 <a:cs typeface="Arial"/>
               </a:rPr>
-              <a:t>We compare four standard classifiers using source text.</a:t>
+              <a:t>Four classical classifiers plus a CodeT5 encoder classifier.</a:t>
             </a:r>
           </a:p>
         </p:txBody>
@@ -1619,7 +1619,7 @@
           <p:cNvPr id="5" name="">
             <a:extLst xmlns:a="http://schemas.openxmlformats.org/drawingml/2006/main">
               <a:ext uri="{FF2B5EF4-FFF2-40B4-BE49-F238E27FC236}">
-                <a16:creationId xmlns:a16="http://schemas.microsoft.com/office/drawing/2014/main" id="{B3C8D6E4-6F63-4725-A8C1-017A1C0FD456}"/>
+                <a16:creationId xmlns:a16="http://schemas.microsoft.com/office/drawing/2014/main" id="{ECE56D39-1587-4C63-B6B8-AB95FC3BD137}"/>
               </a:ext>
             </a:extLst>
           </p:cNvPr>
@@ -1630,8 +1630,8 @@
         </p:nvSpPr>
         <p:spPr>
           <a:xfrm xmlns:a="http://schemas.openxmlformats.org/drawingml/2006/main">
-            <a:off x="571500" y="5286375"/>
-            <a:ext cx="11144250" cy="381000"/>
+            <a:off x="571500" y="4905375"/>
+            <a:ext cx="11049000" cy="619125"/>
           </a:xfrm>
           <a:prstGeom xmlns:a="http://schemas.openxmlformats.org/drawingml/2006/main" prst="rect">
             <a:avLst/>
@@ -1648,9 +1648,9 @@
           <a:lstStyle xmlns:a="http://schemas.openxmlformats.org/drawingml/2006/main"/>
           <a:p xmlns:a="http://schemas.openxmlformats.org/drawingml/2006/main">
             <a:pPr>
-              <a:defRPr sz="1800" b="0">
-                <a:solidFill>
-                  <a:srgbClr val="117C83"/>
+              <a:defRPr sz="1875" b="0">
+                <a:solidFill>
+                  <a:srgbClr val="152E38"/>
                 </a:solidFill>
                 <a:latin typeface="Arial"/>
                 <a:ea typeface="Arial"/>
@@ -1658,15 +1658,38 @@
               </a:defRPr>
             </a:pPr>
             <a:r>
-              <a:rPr sz="1800" b="0">
-                <a:solidFill>
-                  <a:srgbClr val="117C83"/>
+              <a:rPr sz="1875" b="0">
+                <a:solidFill>
+                  <a:srgbClr val="152E38"/>
                 </a:solidFill>
                 <a:latin typeface="Arial"/>
                 <a:ea typeface="Arial"/>
                 <a:cs typeface="Arial"/>
               </a:rPr>
-              <a:t>https://github.com/S3eeDTR/LLM-AuthorBench-Assignment</a:t>
+              <a:t>Saeed Alshehhi, Khalifa Alblooshi, Maitha Alblooshi</a:t>
+            </a:r>
+          </a:p>
+          <a:p xmlns:a="http://schemas.openxmlformats.org/drawingml/2006/main">
+            <a:pPr>
+              <a:defRPr sz="1875" b="0">
+                <a:solidFill>
+                  <a:srgbClr val="152E38"/>
+                </a:solidFill>
+                <a:latin typeface="Arial"/>
+                <a:ea typeface="Arial"/>
+                <a:cs typeface="Arial"/>
+              </a:defRPr>
+            </a:pPr>
+            <a:r>
+              <a:rPr sz="1875" b="0">
+                <a:solidFill>
+                  <a:srgbClr val="152E38"/>
+                </a:solidFill>
+                <a:latin typeface="Arial"/>
+                <a:ea typeface="Arial"/>
+                <a:cs typeface="Arial"/>
+              </a:rPr>
+              <a:t>Fatima Alnuaimi, Fatima Alsadi</a:t>
             </a:r>
           </a:p>
         </p:txBody>
@@ -1676,7 +1699,7 @@
           <p:cNvPr id="6" name="">
             <a:extLst xmlns:a="http://schemas.openxmlformats.org/drawingml/2006/main">
               <a:ext uri="{FF2B5EF4-FFF2-40B4-BE49-F238E27FC236}">
-                <a16:creationId xmlns:a16="http://schemas.microsoft.com/office/drawing/2014/main" id="{C29F1FE6-4CC8-42F3-AD28-82BA2500899E}"/>
+                <a16:creationId xmlns:a16="http://schemas.microsoft.com/office/drawing/2014/main" id="{5F997DC9-60D9-4E4D-B91F-AFB2C41804B9}"/>
               </a:ext>
             </a:extLst>
           </p:cNvPr>
@@ -1687,8 +1710,8 @@
         </p:nvSpPr>
         <p:spPr>
           <a:xfrm xmlns:a="http://schemas.openxmlformats.org/drawingml/2006/main">
-            <a:off x="571500" y="5819775"/>
-            <a:ext cx="11049000" cy="333375"/>
+            <a:off x="571500" y="5753100"/>
+            <a:ext cx="11144250" cy="333375"/>
           </a:xfrm>
           <a:prstGeom xmlns:a="http://schemas.openxmlformats.org/drawingml/2006/main" prst="rect">
             <a:avLst/>
@@ -1705,9 +1728,9 @@
           <a:lstStyle xmlns:a="http://schemas.openxmlformats.org/drawingml/2006/main"/>
           <a:p xmlns:a="http://schemas.openxmlformats.org/drawingml/2006/main">
             <a:pPr>
-              <a:defRPr sz="1800" b="0">
-                <a:solidFill>
-                  <a:srgbClr val="152E38"/>
+              <a:defRPr sz="1725" b="0">
+                <a:solidFill>
+                  <a:srgbClr val="117C83"/>
                 </a:solidFill>
                 <a:latin typeface="Arial"/>
                 <a:ea typeface="Arial"/>
@@ -1715,7 +1738,64 @@
               </a:defRPr>
             </a:pPr>
             <a:r>
-              <a:rPr sz="1800" b="0">
+              <a:rPr sz="1725" b="0">
+                <a:solidFill>
+                  <a:srgbClr val="117C83"/>
+                </a:solidFill>
+                <a:latin typeface="Arial"/>
+                <a:ea typeface="Arial"/>
+                <a:cs typeface="Arial"/>
+              </a:rPr>
+              <a:t>https://github.com/S3eeDTR/LLM-AuthorBench-Assignment</a:t>
+            </a:r>
+          </a:p>
+        </p:txBody>
+      </p:sp>
+      <p:sp>
+        <p:nvSpPr>
+          <p:cNvPr id="7" name="">
+            <a:extLst xmlns:a="http://schemas.openxmlformats.org/drawingml/2006/main">
+              <a:ext uri="{FF2B5EF4-FFF2-40B4-BE49-F238E27FC236}">
+                <a16:creationId xmlns:a16="http://schemas.microsoft.com/office/drawing/2014/main" id="{F23A8BB2-D0A4-4B9D-95BB-DCE76C046CE2}"/>
+              </a:ext>
+            </a:extLst>
+          </p:cNvPr>
+          <p:cNvSpPr>
+            <a:spLocks xmlns:a="http://schemas.openxmlformats.org/drawingml/2006/main" noGrp="1"/>
+          </p:cNvSpPr>
+          <p:nvPr/>
+        </p:nvSpPr>
+        <p:spPr>
+          <a:xfrm xmlns:a="http://schemas.openxmlformats.org/drawingml/2006/main">
+            <a:off x="571500" y="6257925"/>
+            <a:ext cx="11049000" cy="285750"/>
+          </a:xfrm>
+          <a:prstGeom xmlns:a="http://schemas.openxmlformats.org/drawingml/2006/main" prst="rect">
+            <a:avLst/>
+          </a:prstGeom>
+          <a:noFill xmlns:a="http://schemas.openxmlformats.org/drawingml/2006/main"/>
+          <a:ln xmlns:a="http://schemas.openxmlformats.org/drawingml/2006/main" w="0">
+            <a:noFill/>
+          </a:ln>
+        </p:spPr>
+        <p:txBody>
+          <a:bodyPr xmlns:a="http://schemas.openxmlformats.org/drawingml/2006/main" lIns="0" tIns="0" rIns="0" bIns="0">
+            <a:noAutofit/>
+          </a:bodyPr>
+          <a:lstStyle xmlns:a="http://schemas.openxmlformats.org/drawingml/2006/main"/>
+          <a:p xmlns:a="http://schemas.openxmlformats.org/drawingml/2006/main">
+            <a:pPr>
+              <a:defRPr sz="1575" b="0">
+                <a:solidFill>
+                  <a:srgbClr val="152E38"/>
+                </a:solidFill>
+                <a:latin typeface="Arial"/>
+                <a:ea typeface="Arial"/>
+                <a:cs typeface="Arial"/>
+              </a:defRPr>
+            </a:pPr>
+            <a:r>
+              <a:rPr sz="1575" b="0">
                 <a:solidFill>
                   <a:srgbClr val="152E38"/>
                 </a:solidFill>
@@ -1731,7 +1811,7 @@
     </p:spTree>
     <p:extLst>
       <p:ext uri="{BB962C8B-B14F-4D97-AF65-F5344CB8AC3E}">
-        <p14:creationId xmlns:p14="http://schemas.microsoft.com/office/powerpoint/2010/main" val="405089188"/>
+        <p14:creationId xmlns:p14="http://schemas.microsoft.com/office/powerpoint/2010/main" val="560717705"/>
       </p:ext>
     </p:extLst>
   </p:cSld>
@@ -1762,7 +1842,7 @@
           <p:cNvPr id="7" name="">
             <a:extLst xmlns:a="http://schemas.openxmlformats.org/drawingml/2006/main">
               <a:ext uri="{FF2B5EF4-FFF2-40B4-BE49-F238E27FC236}">
-                <a16:creationId xmlns:a16="http://schemas.microsoft.com/office/drawing/2014/main" id="{47DABF14-80BA-4C5B-943C-212B1962BCBF}"/>
+                <a16:creationId xmlns:a16="http://schemas.microsoft.com/office/drawing/2014/main" id="{EF282CD8-7419-4693-A8B5-A8C10B93131B}"/>
               </a:ext>
             </a:extLst>
           </p:cNvPr>
@@ -2174,7 +2254,7 @@
           <p:cNvPr id="3" name="">
             <a:extLst xmlns:a="http://schemas.openxmlformats.org/drawingml/2006/main">
               <a:ext uri="{FF2B5EF4-FFF2-40B4-BE49-F238E27FC236}">
-                <a16:creationId xmlns:a16="http://schemas.microsoft.com/office/drawing/2014/main" id="{38D05D51-B2AD-43DD-801B-9550482D1F0B}"/>
+                <a16:creationId xmlns:a16="http://schemas.microsoft.com/office/drawing/2014/main" id="{782F8707-BC68-48DC-9778-B028E5F34E2E}"/>
               </a:ext>
             </a:extLst>
           </p:cNvPr>
@@ -2300,7 +2380,7 @@
           <p:cNvPr id="4" name="">
             <a:extLst xmlns:a="http://schemas.openxmlformats.org/drawingml/2006/main">
               <a:ext uri="{FF2B5EF4-FFF2-40B4-BE49-F238E27FC236}">
-                <a16:creationId xmlns:a16="http://schemas.microsoft.com/office/drawing/2014/main" id="{D59C5223-7AF8-48CD-B443-F3ED09209035}"/>
+                <a16:creationId xmlns:a16="http://schemas.microsoft.com/office/drawing/2014/main" id="{AE582A62-1AEE-4FC0-9CFB-BF71E8906630}"/>
               </a:ext>
             </a:extLst>
           </p:cNvPr>
@@ -2403,7 +2483,7 @@
           <p:cNvPr id="5" name="">
             <a:extLst xmlns:a="http://schemas.openxmlformats.org/drawingml/2006/main">
               <a:ext uri="{FF2B5EF4-FFF2-40B4-BE49-F238E27FC236}">
-                <a16:creationId xmlns:a16="http://schemas.microsoft.com/office/drawing/2014/main" id="{4E633893-C05A-4A8D-B6B9-411D890077BD}"/>
+                <a16:creationId xmlns:a16="http://schemas.microsoft.com/office/drawing/2014/main" id="{0318A40D-BC49-4B36-BD86-C448713A06B0}"/>
               </a:ext>
             </a:extLst>
           </p:cNvPr>
@@ -2483,7 +2563,7 @@
           <p:cNvPr id="6" name="">
             <a:extLst xmlns:a="http://schemas.openxmlformats.org/drawingml/2006/main">
               <a:ext uri="{FF2B5EF4-FFF2-40B4-BE49-F238E27FC236}">
-                <a16:creationId xmlns:a16="http://schemas.microsoft.com/office/drawing/2014/main" id="{C09E1ACB-0975-456B-A215-AD2CE4B04B90}"/>
+                <a16:creationId xmlns:a16="http://schemas.microsoft.com/office/drawing/2014/main" id="{884624D7-EAF3-4717-8401-5E449868CF8C}"/>
               </a:ext>
             </a:extLst>
           </p:cNvPr>
@@ -2538,7 +2618,7 @@
     </p:spTree>
     <p:extLst>
       <p:ext uri="{BB962C8B-B14F-4D97-AF65-F5344CB8AC3E}">
-        <p14:creationId xmlns:p14="http://schemas.microsoft.com/office/powerpoint/2010/main" val="561566841"/>
+        <p14:creationId xmlns:p14="http://schemas.microsoft.com/office/powerpoint/2010/main" val="541353998"/>
       </p:ext>
     </p:extLst>
   </p:cSld>
@@ -2569,7 +2649,7 @@
           <p:cNvPr id="9" name="">
             <a:extLst xmlns:a="http://schemas.openxmlformats.org/drawingml/2006/main">
               <a:ext uri="{FF2B5EF4-FFF2-40B4-BE49-F238E27FC236}">
-                <a16:creationId xmlns:a16="http://schemas.microsoft.com/office/drawing/2014/main" id="{A961A5B7-C093-4FD2-8077-50F929BC30FB}"/>
+                <a16:creationId xmlns:a16="http://schemas.microsoft.com/office/drawing/2014/main" id="{0BDA73A7-37E6-4DC5-A42F-55D6A2DDC910}"/>
               </a:ext>
             </a:extLst>
           </p:cNvPr>
@@ -2626,7 +2706,7 @@
           <p:cNvPr id="2" name="">
             <a:extLst xmlns:a="http://schemas.openxmlformats.org/drawingml/2006/main">
               <a:ext uri="{FF2B5EF4-FFF2-40B4-BE49-F238E27FC236}">
-                <a16:creationId xmlns:a16="http://schemas.microsoft.com/office/drawing/2014/main" id="{D729AD58-9D7A-4B43-8FCF-3448563F7E77}"/>
+                <a16:creationId xmlns:a16="http://schemas.microsoft.com/office/drawing/2014/main" id="{BFA92117-0B84-47A5-86B8-99E6FE6A64FB}"/>
               </a:ext>
             </a:extLst>
           </p:cNvPr>
@@ -2710,7 +2790,7 @@
           <p:nvPr/>
         </p:nvPicPr>
         <p:blipFill>
-          <a:blip xmlns:r="http://schemas.openxmlformats.org/officeDocument/2006/relationships" xmlns:a="http://schemas.openxmlformats.org/drawingml/2006/main" r:embed="Rec3f6a9e90a94006"/>
+          <a:blip xmlns:r="http://schemas.openxmlformats.org/officeDocument/2006/relationships" xmlns:a="http://schemas.openxmlformats.org/drawingml/2006/main" r:embed="R235c806c50594b70"/>
           <a:stretch xmlns:a="http://schemas.openxmlformats.org/drawingml/2006/main"/>
         </p:blipFill>
         <p:spPr>
@@ -2728,7 +2808,7 @@
           <p:cNvPr id="4" name="">
             <a:extLst xmlns:a="http://schemas.openxmlformats.org/drawingml/2006/main">
               <a:ext uri="{FF2B5EF4-FFF2-40B4-BE49-F238E27FC236}">
-                <a16:creationId xmlns:a16="http://schemas.microsoft.com/office/drawing/2014/main" id="{917BBA9F-7FF2-4D0E-B9DF-B2CEE192DA20}"/>
+                <a16:creationId xmlns:a16="http://schemas.microsoft.com/office/drawing/2014/main" id="{BBBCF113-E955-4745-BCCF-33C9EF729177}"/>
               </a:ext>
             </a:extLst>
           </p:cNvPr>
@@ -2789,7 +2869,7 @@
           <p:nvPr/>
         </p:nvPicPr>
         <p:blipFill>
-          <a:blip xmlns:r="http://schemas.openxmlformats.org/officeDocument/2006/relationships" xmlns:a="http://schemas.openxmlformats.org/drawingml/2006/main" r:embed="Rccfd2ec01c65474b"/>
+          <a:blip xmlns:r="http://schemas.openxmlformats.org/officeDocument/2006/relationships" xmlns:a="http://schemas.openxmlformats.org/drawingml/2006/main" r:embed="Rbdaafcfd9c8e4af1"/>
           <a:stretch xmlns:a="http://schemas.openxmlformats.org/drawingml/2006/main"/>
         </p:blipFill>
         <p:spPr>
@@ -2807,7 +2887,7 @@
           <p:cNvPr id="6" name="">
             <a:extLst xmlns:a="http://schemas.openxmlformats.org/drawingml/2006/main">
               <a:ext uri="{FF2B5EF4-FFF2-40B4-BE49-F238E27FC236}">
-                <a16:creationId xmlns:a16="http://schemas.microsoft.com/office/drawing/2014/main" id="{0542703A-9361-48DF-A31A-EB9184DB8323}"/>
+                <a16:creationId xmlns:a16="http://schemas.microsoft.com/office/drawing/2014/main" id="{5D18A90E-DE6C-4C17-9ADC-D0FB828069C8}"/>
               </a:ext>
             </a:extLst>
           </p:cNvPr>
@@ -2887,7 +2967,7 @@
           <p:cNvPr id="7" name="">
             <a:extLst xmlns:a="http://schemas.openxmlformats.org/drawingml/2006/main">
               <a:ext uri="{FF2B5EF4-FFF2-40B4-BE49-F238E27FC236}">
-                <a16:creationId xmlns:a16="http://schemas.microsoft.com/office/drawing/2014/main" id="{C4380A16-2263-4D1A-A8C9-1B554DCCBD58}"/>
+                <a16:creationId xmlns:a16="http://schemas.microsoft.com/office/drawing/2014/main" id="{DFD7195C-005B-43B3-8A73-0F2E33FB4267}"/>
               </a:ext>
             </a:extLst>
           </p:cNvPr>
@@ -2967,7 +3047,7 @@
           <p:cNvPr id="8" name="">
             <a:extLst xmlns:a="http://schemas.openxmlformats.org/drawingml/2006/main">
               <a:ext uri="{FF2B5EF4-FFF2-40B4-BE49-F238E27FC236}">
-                <a16:creationId xmlns:a16="http://schemas.microsoft.com/office/drawing/2014/main" id="{E1DA0977-79FA-428C-A8DD-09357B65D598}"/>
+                <a16:creationId xmlns:a16="http://schemas.microsoft.com/office/drawing/2014/main" id="{FFAB221B-8B1B-462D-9DCE-D1120A296D47}"/>
               </a:ext>
             </a:extLst>
           </p:cNvPr>
@@ -3022,7 +3102,7 @@
     </p:spTree>
     <p:extLst>
       <p:ext uri="{BB962C8B-B14F-4D97-AF65-F5344CB8AC3E}">
-        <p14:creationId xmlns:p14="http://schemas.microsoft.com/office/powerpoint/2010/main" val="795001900"/>
+        <p14:creationId xmlns:p14="http://schemas.microsoft.com/office/powerpoint/2010/main" val="504161854"/>
       </p:ext>
     </p:extLst>
   </p:cSld>
@@ -3053,7 +3133,7 @@
           <p:cNvPr id="7" name="">
             <a:extLst xmlns:a="http://schemas.openxmlformats.org/drawingml/2006/main">
               <a:ext uri="{FF2B5EF4-FFF2-40B4-BE49-F238E27FC236}">
-                <a16:creationId xmlns:a16="http://schemas.microsoft.com/office/drawing/2014/main" id="{0E76CBAA-43C8-4C9F-BD8F-90A7F0D8750C}"/>
+                <a16:creationId xmlns:a16="http://schemas.microsoft.com/office/drawing/2014/main" id="{BBAD6A95-BBD3-4D26-94E6-73FAC832B900}"/>
               </a:ext>
             </a:extLst>
           </p:cNvPr>
@@ -3100,7 +3180,7 @@
                 <a:ea typeface="Arial"/>
                 <a:cs typeface="Arial"/>
               </a:rPr>
-              <a:t>Results and SVM classification errors</a:t>
+              <a:t>Five-model results: SVM remains best</a:t>
             </a:r>
           </a:p>
         </p:txBody>
@@ -3112,8 +3192,8 @@
           <p:nvPr/>
         </p:nvGraphicFramePr>
         <p:xfrm>
-          <a:off xmlns:a="http://schemas.openxmlformats.org/drawingml/2006/main" x="476250" y="1657350"/>
-          <a:ext xmlns:a="http://schemas.openxmlformats.org/drawingml/2006/main" cx="6762750" cy="2905125"/>
+          <a:off xmlns:a="http://schemas.openxmlformats.org/drawingml/2006/main" x="476250" y="1466850"/>
+          <a:ext xmlns:a="http://schemas.openxmlformats.org/drawingml/2006/main" cx="6762750" cy="3143250"/>
         </p:xfrm>
         <a:graphic xmlns:a="http://schemas.openxmlformats.org/drawingml/2006/main">
           <a:graphicData uri="http://schemas.openxmlformats.org/drawingml/2006/table">
@@ -3126,7 +3206,7 @@
                 <a:gridCol w="952500"/>
                 <a:gridCol w="952500"/>
               </a:tblGrid>
-              <a:tr h="581025">
+              <a:tr h="523875">
                 <a:tc>
                   <a:txBody>
                     <a:bodyPr>
@@ -3225,7 +3305,7 @@
                           <a:ea typeface="Arial"/>
                           <a:cs typeface="Arial"/>
                         </a:rPr>
-                        <a:t>Fit (s)</a:t>
+                        <a:t>Time (s)</a:t>
                       </a:r>
                     </a:p>
                   </a:txBody>
@@ -3252,7 +3332,7 @@
                           <a:ea typeface="Arial"/>
                           <a:cs typeface="Arial"/>
                         </a:rPr>
-                        <a:t>MB</a:t>
+                        <a:t>Size (MB)</a:t>
                       </a:r>
                     </a:p>
                   </a:txBody>
@@ -3263,7 +3343,7 @@
                   </a:tcPr>
                 </a:tc>
               </a:tr>
-              <a:tr h="581025">
+              <a:tr h="523875">
                 <a:tc>
                   <a:txBody>
                     <a:bodyPr>
@@ -3400,7 +3480,7 @@
                   </a:tcPr>
                 </a:tc>
               </a:tr>
-              <a:tr h="581025">
+              <a:tr h="523875">
                 <a:tc>
                   <a:txBody>
                     <a:bodyPr>
@@ -3537,7 +3617,7 @@
                   </a:tcPr>
                 </a:tc>
               </a:tr>
-              <a:tr h="581025">
+              <a:tr h="523875">
                 <a:tc>
                   <a:txBody>
                     <a:bodyPr>
@@ -3674,7 +3754,7 @@
                   </a:tcPr>
                 </a:tc>
               </a:tr>
-              <a:tr h="581025">
+              <a:tr h="523875">
                 <a:tc>
                   <a:txBody>
                     <a:bodyPr>
@@ -3811,6 +3891,143 @@
                   </a:tcPr>
                 </a:tc>
               </a:tr>
+              <a:tr h="523875">
+                <a:tc>
+                  <a:txBody>
+                    <a:bodyPr>
+                      <a:noAutofit/>
+                    </a:bodyPr>
+                    <a:lstStyle/>
+                    <a:p>
+                      <a:pPr algn="l"/>
+                      <a:r>
+                        <a:rPr sz="1725" b="0">
+                          <a:solidFill>
+                            <a:srgbClr val="152E38"/>
+                          </a:solidFill>
+                          <a:latin typeface="Arial"/>
+                          <a:ea typeface="Arial"/>
+                          <a:cs typeface="Arial"/>
+                        </a:rPr>
+                        <a:t>CodeT5 encoder</a:t>
+                      </a:r>
+                    </a:p>
+                  </a:txBody>
+                  <a:tcPr marL="91440" marR="91440" marT="45720" marB="45720">
+                    <a:solidFill>
+                      <a:srgbClr val="FFFFFF"/>
+                    </a:solidFill>
+                  </a:tcPr>
+                </a:tc>
+                <a:tc>
+                  <a:txBody>
+                    <a:bodyPr>
+                      <a:noAutofit/>
+                    </a:bodyPr>
+                    <a:lstStyle/>
+                    <a:p>
+                      <a:pPr algn="ctr"/>
+                      <a:r>
+                        <a:rPr sz="1725" b="0">
+                          <a:solidFill>
+                            <a:srgbClr val="152E38"/>
+                          </a:solidFill>
+                          <a:latin typeface="Arial"/>
+                          <a:ea typeface="Arial"/>
+                          <a:cs typeface="Arial"/>
+                        </a:rPr>
+                        <a:t>76.96%</a:t>
+                      </a:r>
+                    </a:p>
+                  </a:txBody>
+                  <a:tcPr marL="91440" marR="91440" marT="45720" marB="45720">
+                    <a:solidFill>
+                      <a:srgbClr val="FFFFFF"/>
+                    </a:solidFill>
+                  </a:tcPr>
+                </a:tc>
+                <a:tc>
+                  <a:txBody>
+                    <a:bodyPr>
+                      <a:noAutofit/>
+                    </a:bodyPr>
+                    <a:lstStyle/>
+                    <a:p>
+                      <a:pPr algn="ctr"/>
+                      <a:r>
+                        <a:rPr sz="1725" b="0">
+                          <a:solidFill>
+                            <a:srgbClr val="152E38"/>
+                          </a:solidFill>
+                          <a:latin typeface="Arial"/>
+                          <a:ea typeface="Arial"/>
+                          <a:cs typeface="Arial"/>
+                        </a:rPr>
+                        <a:t>0.7725</a:t>
+                      </a:r>
+                    </a:p>
+                  </a:txBody>
+                  <a:tcPr marL="91440" marR="91440" marT="45720" marB="45720">
+                    <a:solidFill>
+                      <a:srgbClr val="FFFFFF"/>
+                    </a:solidFill>
+                  </a:tcPr>
+                </a:tc>
+                <a:tc>
+                  <a:txBody>
+                    <a:bodyPr>
+                      <a:noAutofit/>
+                    </a:bodyPr>
+                    <a:lstStyle/>
+                    <a:p>
+                      <a:pPr algn="ctr"/>
+                      <a:r>
+                        <a:rPr sz="1725" b="0">
+                          <a:solidFill>
+                            <a:srgbClr val="152E38"/>
+                          </a:solidFill>
+                          <a:latin typeface="Arial"/>
+                          <a:ea typeface="Arial"/>
+                          <a:cs typeface="Arial"/>
+                        </a:rPr>
+                        <a:t>292*</a:t>
+                      </a:r>
+                    </a:p>
+                  </a:txBody>
+                  <a:tcPr marL="91440" marR="91440" marT="45720" marB="45720">
+                    <a:solidFill>
+                      <a:srgbClr val="FFFFFF"/>
+                    </a:solidFill>
+                  </a:tcPr>
+                </a:tc>
+                <a:tc>
+                  <a:txBody>
+                    <a:bodyPr>
+                      <a:noAutofit/>
+                    </a:bodyPr>
+                    <a:lstStyle/>
+                    <a:p>
+                      <a:pPr algn="ctr"/>
+                      <a:r>
+                        <a:rPr sz="1725" b="0">
+                          <a:solidFill>
+                            <a:srgbClr val="152E38"/>
+                          </a:solidFill>
+                          <a:latin typeface="Arial"/>
+                          <a:ea typeface="Arial"/>
+                          <a:cs typeface="Arial"/>
+                        </a:rPr>
+                        <a:t>438.5</a:t>
+                      </a:r>
+                    </a:p>
+                  </a:txBody>
+                  <a:tcPr marL="91440" marR="91440" marT="45720" marB="45720">
+                    <a:solidFill>
+                      <a:srgbClr val="FFFFFF"/>
+                    </a:solidFill>
+                  </a:tcPr>
+                </a:tc>
+              </a:tr>
             </a:tbl>
           </a:graphicData>
         </a:graphic>
@@ -3824,7 +4041,7 @@
           <p:nvPr/>
         </p:nvPicPr>
         <p:blipFill>
-          <a:blip xmlns:r="http://schemas.openxmlformats.org/officeDocument/2006/relationships" xmlns:a="http://schemas.openxmlformats.org/drawingml/2006/main" r:embed="R40bae9e9ef0e4636"/>
+          <a:blip xmlns:r="http://schemas.openxmlformats.org/officeDocument/2006/relationships" xmlns:a="http://schemas.openxmlformats.org/drawingml/2006/main" r:embed="R5efc2898260e40a4"/>
           <a:stretch xmlns:a="http://schemas.openxmlformats.org/drawingml/2006/main"/>
         </p:blipFill>
         <p:spPr>
@@ -3846,7 +4063,7 @@
           <p:nvPr/>
         </p:nvPicPr>
         <p:blipFill>
-          <a:blip xmlns:r="http://schemas.openxmlformats.org/officeDocument/2006/relationships" xmlns:a="http://schemas.openxmlformats.org/drawingml/2006/main" r:embed="R0c30f0713d8c4127"/>
+          <a:blip xmlns:r="http://schemas.openxmlformats.org/officeDocument/2006/relationships" xmlns:a="http://schemas.openxmlformats.org/drawingml/2006/main" r:embed="Rfef01b680e9f42ad"/>
           <a:stretch xmlns:a="http://schemas.openxmlformats.org/drawingml/2006/main"/>
         </p:blipFill>
         <p:spPr>
@@ -3864,7 +4081,7 @@
           <p:cNvPr id="5" name="">
             <a:extLst xmlns:a="http://schemas.openxmlformats.org/drawingml/2006/main">
               <a:ext uri="{FF2B5EF4-FFF2-40B4-BE49-F238E27FC236}">
-                <a16:creationId xmlns:a16="http://schemas.microsoft.com/office/drawing/2014/main" id="{3B617228-A482-4895-94EC-321CB2A66962}"/>
+                <a16:creationId xmlns:a16="http://schemas.microsoft.com/office/drawing/2014/main" id="{CA54B52E-495C-43F0-B61E-3FCE3B4A7F80}"/>
               </a:ext>
             </a:extLst>
           </p:cNvPr>
@@ -3875,8 +4092,8 @@
         </p:nvSpPr>
         <p:spPr>
           <a:xfrm xmlns:a="http://schemas.openxmlformats.org/drawingml/2006/main">
-            <a:off x="571500" y="5772150"/>
-            <a:ext cx="6667500" cy="542925"/>
+            <a:off x="571500" y="5800725"/>
+            <a:ext cx="6762750" cy="552450"/>
           </a:xfrm>
           <a:prstGeom xmlns:a="http://schemas.openxmlformats.org/drawingml/2006/main" prst="rect">
             <a:avLst/>
@@ -3911,7 +4128,7 @@
                 <a:ea typeface="Arial"/>
                 <a:cs typeface="Arial"/>
               </a:rPr>
-              <a:t>P: precision    R: recall</a:t>
+              <a:t>CodeT5: best epoch 3 of 5, validation F1 0.7998</a:t>
             </a:r>
           </a:p>
           <a:p xmlns:a="http://schemas.openxmlformats.org/drawingml/2006/main">
@@ -3934,7 +4151,7 @@
                 <a:ea typeface="Arial"/>
                 <a:cs typeface="Arial"/>
               </a:rPr>
-              <a:t>SVM validation Macro-F1: 0.8062 (selection)</a:t>
+              <a:t>Encoder + mean pooling; first 256 tokens</a:t>
             </a:r>
           </a:p>
         </p:txBody>
@@ -3944,7 +4161,7 @@
           <p:cNvPr id="6" name="">
             <a:extLst xmlns:a="http://schemas.openxmlformats.org/drawingml/2006/main">
               <a:ext uri="{FF2B5EF4-FFF2-40B4-BE49-F238E27FC236}">
-                <a16:creationId xmlns:a16="http://schemas.microsoft.com/office/drawing/2014/main" id="{49ECBD16-42C6-4210-92F8-76E51FA62DFC}"/>
+                <a16:creationId xmlns:a16="http://schemas.microsoft.com/office/drawing/2014/main" id="{8D03C232-1C85-4749-9C31-E00B8031F7C8}"/>
               </a:ext>
             </a:extLst>
           </p:cNvPr>
@@ -3991,7 +4208,7 @@
                 <a:ea typeface="Arial"/>
                 <a:cs typeface="Arial"/>
               </a:rPr>
-              <a:t>Test: 3,872 programs. Fit time and model size exclude TF-IDF.</a:t>
+              <a:t>*CodeT5: GPU wall time, raw checkpoint. Others: CPU fit time, compressed classifiers.</a:t>
             </a:r>
           </a:p>
         </p:txBody>
@@ -3999,7 +4216,7 @@
     </p:spTree>
     <p:extLst>
       <p:ext uri="{BB962C8B-B14F-4D97-AF65-F5344CB8AC3E}">
-        <p14:creationId xmlns:p14="http://schemas.microsoft.com/office/powerpoint/2010/main" val="1614871259"/>
+        <p14:creationId xmlns:p14="http://schemas.microsoft.com/office/powerpoint/2010/main" val="2067327625"/>
       </p:ext>
     </p:extLst>
   </p:cSld>
@@ -4030,7 +4247,7 @@
           <p:cNvPr id="5" name="">
             <a:extLst xmlns:a="http://schemas.openxmlformats.org/drawingml/2006/main">
               <a:ext uri="{FF2B5EF4-FFF2-40B4-BE49-F238E27FC236}">
-                <a16:creationId xmlns:a16="http://schemas.microsoft.com/office/drawing/2014/main" id="{5D751A48-5F25-4527-9938-59A66620B651}"/>
+                <a16:creationId xmlns:a16="http://schemas.microsoft.com/office/drawing/2014/main" id="{CD0D4E84-D662-4BAA-9F92-F4F34E563A83}"/>
               </a:ext>
             </a:extLst>
           </p:cNvPr>
@@ -4091,7 +4308,7 @@
           <p:nvPr/>
         </p:nvPicPr>
         <p:blipFill>
-          <a:blip xmlns:r="http://schemas.openxmlformats.org/officeDocument/2006/relationships" xmlns:a="http://schemas.openxmlformats.org/drawingml/2006/main" r:embed="R8434c4425bba440c"/>
+          <a:blip xmlns:r="http://schemas.openxmlformats.org/officeDocument/2006/relationships" xmlns:a="http://schemas.openxmlformats.org/drawingml/2006/main" r:embed="R13fb236e25dd41f5"/>
           <a:stretch xmlns:a="http://schemas.openxmlformats.org/drawingml/2006/main"/>
         </p:blipFill>
         <p:spPr>
@@ -4109,7 +4326,7 @@
           <p:cNvPr id="3" name="">
             <a:extLst xmlns:a="http://schemas.openxmlformats.org/drawingml/2006/main">
               <a:ext uri="{FF2B5EF4-FFF2-40B4-BE49-F238E27FC236}">
-                <a16:creationId xmlns:a16="http://schemas.microsoft.com/office/drawing/2014/main" id="{1398FCFD-9387-49EA-846C-CFE76EB09DEA}"/>
+                <a16:creationId xmlns:a16="http://schemas.microsoft.com/office/drawing/2014/main" id="{B92F5F9D-33DD-4648-9BAB-2E7D41868881}"/>
               </a:ext>
             </a:extLst>
           </p:cNvPr>
@@ -4189,7 +4406,7 @@
           <p:cNvPr id="4" name="">
             <a:extLst xmlns:a="http://schemas.openxmlformats.org/drawingml/2006/main">
               <a:ext uri="{FF2B5EF4-FFF2-40B4-BE49-F238E27FC236}">
-                <a16:creationId xmlns:a16="http://schemas.microsoft.com/office/drawing/2014/main" id="{2E18622C-6CA1-46D2-9A13-BEE3BEB3BDF9}"/>
+                <a16:creationId xmlns:a16="http://schemas.microsoft.com/office/drawing/2014/main" id="{7E6D8A84-137D-4D95-BADF-B3133F02140C}"/>
               </a:ext>
             </a:extLst>
           </p:cNvPr>
@@ -4267,7 +4484,7 @@
     </p:spTree>
     <p:extLst>
       <p:ext uri="{BB962C8B-B14F-4D97-AF65-F5344CB8AC3E}">
-        <p14:creationId xmlns:p14="http://schemas.microsoft.com/office/powerpoint/2010/main" val="147755663"/>
+        <p14:creationId xmlns:p14="http://schemas.microsoft.com/office/powerpoint/2010/main" val="82404803"/>
       </p:ext>
     </p:extLst>
   </p:cSld>

</xml_diff>

<commit_message>
Improve five-slide narrative and add detailed speaker notes
</commit_message>
<xml_diff>
--- a/submission/Assignment.pptx
+++ b/submission/Assignment.pptx
@@ -2,17 +2,17 @@
 <file path=ppt/presentation.xml><?xml version="1.0" encoding="utf-8"?>
 <p:presentation xmlns:p="http://schemas.openxmlformats.org/presentationml/2006/main">
   <p:sldMasterIdLst>
-    <p:sldMasterId xmlns:r="http://schemas.openxmlformats.org/officeDocument/2006/relationships" id="2147483648" r:id="Re6557b04c9e64e72"/>
+    <p:sldMasterId xmlns:r="http://schemas.openxmlformats.org/officeDocument/2006/relationships" id="2147483648" r:id="Rbc66f40befbd4fad"/>
   </p:sldMasterIdLst>
   <p:notesMasterIdLst>
-    <p:notesMasterId xmlns:r="http://schemas.openxmlformats.org/officeDocument/2006/relationships" r:id="Rfd40f8e0e0914d8d"/>
+    <p:notesMasterId xmlns:r="http://schemas.openxmlformats.org/officeDocument/2006/relationships" r:id="Re70e167b53c24727"/>
   </p:notesMasterIdLst>
   <p:sldIdLst>
-    <p:sldId xmlns:r="http://schemas.openxmlformats.org/officeDocument/2006/relationships" id="256" r:id="R5407add3af574b81"/>
-    <p:sldId xmlns:r="http://schemas.openxmlformats.org/officeDocument/2006/relationships" id="257" r:id="R5350ba14e1324fbd"/>
-    <p:sldId xmlns:r="http://schemas.openxmlformats.org/officeDocument/2006/relationships" id="258" r:id="R92651891c0f542b6"/>
-    <p:sldId xmlns:r="http://schemas.openxmlformats.org/officeDocument/2006/relationships" id="259" r:id="R24cf62cbc2fa4991"/>
-    <p:sldId xmlns:r="http://schemas.openxmlformats.org/officeDocument/2006/relationships" id="260" r:id="Rb4eead5d2a204908"/>
+    <p:sldId xmlns:r="http://schemas.openxmlformats.org/officeDocument/2006/relationships" id="256" r:id="Rc9d39d7d4e734f37"/>
+    <p:sldId xmlns:r="http://schemas.openxmlformats.org/officeDocument/2006/relationships" id="257" r:id="R0d1d2750949b434f"/>
+    <p:sldId xmlns:r="http://schemas.openxmlformats.org/officeDocument/2006/relationships" id="258" r:id="Rf436d112541e4258"/>
+    <p:sldId xmlns:r="http://schemas.openxmlformats.org/officeDocument/2006/relationships" id="259" r:id="R2ba91847b08f45b6"/>
+    <p:sldId xmlns:r="http://schemas.openxmlformats.org/officeDocument/2006/relationships" id="260" r:id="Rf81b878f91e04298"/>
   </p:sldIdLst>
   <p:sldSz cx="12192000" cy="6858000"/>
   <p:notesSz cx="6858000" cy="9144000"/>
@@ -446,7 +446,7 @@
           <a:lstStyle xmlns:a="http://schemas.openxmlformats.org/drawingml/2006/main"/>
           <a:p xmlns:a="http://schemas.openxmlformats.org/drawingml/2006/main">
             <a:r>
-              <a:t>Source: https://github.com/LLMauthorbench/LLMauthorbench ; paper https://arxiv.org/abs/2506.17323 . The authors describe code generation from 300 parameterized C-programming templates, followed by deduplication and compilation filtering. We treat code as text. The five labels are gpt-4.1, deepseek-chat, claude-3.5-haiku, gemini-2.5-flash-preview-05-20 and llama-3.3-70b-instruct. AI assistance was used for code and writing. The instructor approved the dataset choice by email. Dataset reuse licence remains unverified; individual contributions remain to be documented.</a:t>
+              <a:t>Opening explanation: We study attribution, meaning identifying the generating model from its C source code. The inputs are code strings and the targets are known LLM labels. We do not execute the programs or classify human authorship. LLM means Large Language Model. The full dataset has 32,000 examples and eight authors; we use the five labels from the paper's main setting. Balanced classes provide a 20% uniform-chance reference, while Naive Bayes is our trained baseline. The dataset is useful because it directly matches the question, fixes the programming language and provides comments and character patterns to investigate. Model versions, prompts and task content still limit generalization. Instructor approval was confirmed by email. Sources: https://github.com/LLMauthorbench/LLMauthorbench and https://arxiv.org/abs/2506.17323 . The original authors describe 300 parameterized C-programming templates followed by deduplication and compilation filtering. Our grouped split differs from the paper; this is not reproduction of its scores. AI assisted with implementation, figures and explanations. Transition: next explain how we keep the comparison fair.</a:t>
             </a:r>
           </a:p>
         </p:txBody>
@@ -516,7 +516,7 @@
           <a:lstStyle xmlns:a="http://schemas.openxmlformats.org/drawingml/2006/main"/>
           <a:p xmlns:a="http://schemas.openxmlformats.org/drawingml/2006/main">
             <a:r>
-              <a:t>Sources: data/splits.csv, results/split_counts.csv and class_counts.csv. We filter the prior seed-42 split to five labels. Grouping originally normalized prompt parameters, used audited task aliases and merged similar descriptions. Provenance: Git commit 33b42098d3bfdeddd8d94c77326a22fb8847be0a, src/prepare_data.py. There are no official task IDs. Groups can overmerge and unrecognized paraphrases may overlap. Full dataset has eight labels; the selected subset has 20,000 complete, unique source programs. Case retained; sklearn character analysis collapses repeated whitespace.</a:t>
+              <a:t>Explain the three roles: training learns parameters, validation chooses the original winner and CodeT5 checkpoint, test estimates held-out performance. Counts are 13,150/2,978/3,872; task-family counts are 181/38/40. Families differ in size, so a roughly 70/15/15 group assignment does not produce the same sample proportions. The saved split is reused by all models. Related prompt variants such as sorting 10 or 12 values can produce similar code; inferred grouping tries to prevent task memorization across splits, but cannot eliminate every semantic overlap. Exact source hashes and prompts are checked. TF-IDF expands to Term Frequency–Inverse Document Frequency. A term is a character pattern, a document is one program. TF uses 1+ln(count) for present patterns; IDF uses 1+ln((1+N)/(1+df)); weights are multiplied then normalized to Euclidean length 1. N is the training count and df the number of training programs containing the pattern. Training-only fitting prevents vocabulary/IDF leakage. Case is preserved, while the character analyzer collapses repeated whitespace. 500 features means fewer columns, not fewer examples. CodeT5 instead uses its pretrained tokenizer and first 256 tokens; its representation is different, but the split is identical. Sources: assignment.py, data/splits.csv, results/class_counts.csv, results/split_counts.csv.</a:t>
             </a:r>
           </a:p>
         </p:txBody>
@@ -586,7 +586,7 @@
           <a:lstStyle xmlns:a="http://schemas.openxmlformats.org/drawingml/2006/main"/>
           <a:p xmlns:a="http://schemas.openxmlformats.org/drawingml/2006/main">
             <a:r>
-              <a:t>Sources: assignment.py and https://scikit-learn.org/stable/modules/generated/sklearn.svm.LinearSVC.html . Explain aloud: each code sample becomes a vector x of TF-IDF weights. For a chosen author, multiply each feature by its learned weight, add the contributions, then add b. The superscript T means transpose and w-transpose-x is a dot product. k indexes authors; i indexes training programs. For each author y is +1 for that author and -1 for the other four. The training algorithm minimizes J over w and b. Norm squared means sum of squared weights; sigma means sum over training examples. Our defaults use L2 penalty, squared-hinge loss, one-vs-rest, fit_intercept=True and intercept_scaling=1, so b squared is part of the regularization term. C=1 controls the relative cost of margin violations. If signed score y*f is at least 1, loss is zero. At 0.6 loss is 0.16; at -0.5 loss is 2.25. These are invented teaching examples, not measured model outputs. Five class scores are compared by argmax; scores are not calibrated probabilities. NB alpha=1; LR C=1 max_iter=3000; RF 150 trees max_depth=40 min_samples_leaf=2 max_features=sqrt. Shared splits and feature matrix keep the comparison fair. The equation explains the mechanism, not proof of why SVM wins on this dataset.</a:t>
+              <a:t>Model rationale: Naive Bayes combines class-specific feature evidence under conditional independence; overlapping character patterns violate this assumption, but it is a useful fast baseline. Logistic Regression learns linear class scores with a probability loss. SVM is also linear but uses a margin objective, testing whether the training criterion matters. Random Forest combines 150 trees and can learn nonlinear interactions. Fixed settings: NB alpha=1; LR C=1, lbfgs, max_iter=3000; SVM C=1, dual=auto, max_iter=10000; RF max_depth=40, min_samples_leaf=2, sqrt feature sampling. Shared classical features and seed 42, with no grid search. Read the displayed equation: w transpose x means multiply each feature by its weight and sum. Add intercept b to obtain a score for class k. Argmax chooses the largest score. Scores are not probabilities. Toy example: x=[0.6,0.8], w=[2,-1], b=0.1 gives 0.5. Training minimizes one half of (sum of squared weights plus b squared) plus C times the sum of squared max(0, 1-y_i(w transpose x_i+b)). Label y is +1 for one author, -1 for the rest. C=1 balances regularization and margin violations; intercept is regularized because intercept_scaling=1. A signed score of 0.6 gives loss 0.16; at least 1 gives zero loss. CodeT5 uses Salesforce/codet5-base encoder, masked mean of token vectors, dropout 0.1 and linear head, with cross-entropy loss. AdamW learning rate 2e-5, weight decay 0.01, batch 16. All five epochs completed, best validation F1 0.799756 at epoch 3; loss kept falling while validation declined afterwards. This is our adaptation, not the paper implementation. Sources: assignment.py, supplied CodeT5 settings/history, https://scikit-learn.org/stable/modules/generated/sklearn.svm.LinearSVC.html and https://huggingface.co/Salesforce/codet5-base .</a:t>
             </a:r>
           </a:p>
         </p:txBody>
@@ -656,7 +656,7 @@
           <a:lstStyle xmlns:a="http://schemas.openxmlformats.org/drawingml/2006/main"/>
           <a:p xmlns:a="http://schemas.openxmlformats.org/drawingml/2006/main">
             <a:r>
-              <a:t>Sources: results/metrics.csv and results/experiment_1_original/Linear SVM_test_confusion.csv. Matrix shows raw counts for 3,872 test programs. Labels abbreviated: Claude is claude-3.5-haiku, DeepSeek is deepseek-chat, Gemini is gemini-2.5-flash-preview-05-20, GPT-4.1 is gpt-4.1 and Llama is llama-3.3-70b-instruct. Rows are actual labels, columns predictions. SVM selected using validation Macro-F1 0.8062. Timings and compressed classifier sizes exclude shared TF-IDF. Single split, no significance claim. CodeT5 source: user-supplied codet5_results (1).zip, verified against all 3,872 saved test row IDs and true labels. Architecture: Salesforce/codet5-base encoder, masked mean pooling, dropout 0.1 and five-class linear head. 256-token limit, batch 16, AdamW learning rate 2e-5, weight decay 0.01, seed 42, five epochs, best validation epoch 3 at 0.7997564. Test accuracy 0.7696281, Macro-F1 0.7725136. Training wall time 291.706s on A100 40GB includes validation/saving and is not directly comparable with CPU fit timings. Downloaded best_model (1).pt is 438,494,134 bytes, or 438.494 MB. This is an uncompressed PyTorch state dictionary containing encoder and head weights; classical sizes use joblib compression. Serialization differs, so these are stored file sizes rather than a controlled memory comparison. Same split, different representation and truncation; not a paper reproduction. P is precision and R is recall. CodeT5 narrowly exceeds LR but trails SVM by 2.45 F1 percentage points.</a:t>
+              <a:t>Read accuracy and F1 separately: accuracy counts all correct predictions, while Macro-F1 averages class F1 values equally. Precision is TP/(TP+FP), recall is TP/(TP+FN), F1 is 2PR/(P+R). SVM has 3,088 correct of 3,872. For DeepSeek, TP=462, predicted DeepSeek total=692 and actual DeepSeek total=771, so precision=0.6676, recall=0.5992 and F1=0.6316. Gemini is easier for this model, with F1=0.9524. The 199 DeepSeek-to-Llama errors indicate recurring confusion, not its cause. SVM was selected by validation Macro-F1 0.8062. CodeT5 best validation score is 0.7998 and test score 0.7725; do not confuse validation with test. The test F1 gap is 100*(0.7970261-0.7725136)=2.45125 percentage points. CodeT5 is slightly above LR, but no statistical significance is established. Its pretrained representation, truncation and optimization differ, so its ranking does not prove SVM universally superior. Classical fit seconds exclude TF-IDF and saving; CodeT5 291.706 seconds includes validation/saving on A100 40GB. CodeT5 raw state dictionary is 438,494,134 bytes; classical files use compression and exclude the vectorizer. These sizes/times are not controlled efficiency comparisons. Sources: results/metrics.csv, saved SVM confusion matrix, user-supplied codet5_results (1).zip and best_model (1).pt. All CodeT5 test IDs, labels, counts and metrics were verified.</a:t>
             </a:r>
           </a:p>
         </p:txBody>
@@ -726,7 +726,7 @@
           <a:lstStyle xmlns:a="http://schemas.openxmlformats.org/drawingml/2006/main"/>
           <a:p xmlns:a="http://schemas.openxmlformats.org/drawingml/2006/main">
             <a:r>
-              <a:t>Sources: results/feature_comparison.csv and results/feature_interpretation.md. Hypothesis: distributed character patterns partly explain the SVM advantage. One limit of 500 was chosen and committed before execution in the original development history, with no sweep. Original code and comments retained. Validation SVM-LR gap falls from 1.48692356 to 1.38818655 percentage points: a change of only 0.09873701 points. All validation and test ranks remain SVM, LR, RF, NB. Test SVM F1 falls from 0.7970261 to 0.7169088. This exploratory single-split result is weak directional support, not a ranking reversal or a statistically established causal explanation. Restricting vocabulary also changes normalization and the forest sqrt candidate-feature count. The prior comment-removal prediction failed: validation gap widened from 1.49 to 3.03 points. Both outcomes are retained and reported.</a:t>
+              <a:t>State the explanation before discussing the result: we hypothesized that comment patterns and many distributed character patterns particularly supported SVM relative to Logistic Regression. Removing comments refits TF-IDF on comment-free training code, with the same samples and model settings. Scores fell, but the validation gap grew from 1.4869 to 3.0270 percentage points, contradicting the predicted narrowing. Feature restriction keeps original code and comments, choosing the 500 most frequent patterns from training data rather than using labels to pick them. The gap fell to 1.3882 points, a narrowing of only 0.0987 points. That is weak directional evidence; all validation and test ranks stayed unchanged. We used one preset feature limit, not a sweep for a favorable result. These are exploratory follow-ups because prior outcomes were known. Restricting features also changes normalization and the forest sqrt candidate-feature count, so it is not a clean isolation of one mechanism. Adding CodeT5 expands the comparison but does not repair a failed ablation prediction. The honest conclusion is that SVM works best in our measured setup, and a richer representation helps all models, while the unique cause of SVM advantage remains unresolved. No confidence intervals or significance tests were established. Limit generalization to these authors, C code, prompt conditions and inferred groups. Sources: results/comment_comparison.csv, results/feature_comparison.csv and results/feature_interpretation.md.</a:t>
             </a:r>
           </a:p>
         </p:txBody>
@@ -794,7 +794,7 @@
   </p:cSld>
   <p:clrMap bg1="lt1" tx1="dk1" bg2="lt2" tx2="dk2" accent1="accent1" accent2="accent2" accent3="accent3" accent4="accent4" accent5="accent5" accent6="accent6" hlink="hlink" folHlink="folHlink"/>
   <p:sldLayoutIdLst>
-    <p:sldLayoutId xmlns:r="http://schemas.openxmlformats.org/officeDocument/2006/relationships" id="2147483649" r:id="Rf9699fd47dad4ca6"/>
+    <p:sldLayoutId xmlns:r="http://schemas.openxmlformats.org/officeDocument/2006/relationships" id="2147483649" r:id="R3649678b26104d4d"/>
   </p:sldLayoutIdLst>
   <p:txStyles>
     <p:titleStyle>
@@ -1342,10 +1342,10 @@
       </p:grpSpPr>
       <p:sp>
         <p:nvSpPr>
-          <p:cNvPr id="8" name="">
+          <p:cNvPr id="11" name="">
             <a:extLst xmlns:a="http://schemas.openxmlformats.org/drawingml/2006/main">
               <a:ext uri="{FF2B5EF4-FFF2-40B4-BE49-F238E27FC236}">
-                <a16:creationId xmlns:a16="http://schemas.microsoft.com/office/drawing/2014/main" id="{46584576-CFE3-4750-8BFA-76749E34173E}"/>
+                <a16:creationId xmlns:a16="http://schemas.microsoft.com/office/drawing/2014/main" id="{3AF16CA3-A499-478D-9725-81ABB9B5D03A}"/>
               </a:ext>
             </a:extLst>
           </p:cNvPr>
@@ -1392,7 +1392,7 @@
                 <a:ea typeface="Arial"/>
                 <a:cs typeface="Arial"/>
               </a:rPr>
-              <a:t>LLM code authorship: five classes</a:t>
+              <a:t>Which LLM wrote this C program?</a:t>
             </a:r>
           </a:p>
         </p:txBody>
@@ -1402,7 +1402,7 @@
           <p:cNvPr id="2" name="">
             <a:extLst xmlns:a="http://schemas.openxmlformats.org/drawingml/2006/main">
               <a:ext uri="{FF2B5EF4-FFF2-40B4-BE49-F238E27FC236}">
-                <a16:creationId xmlns:a16="http://schemas.microsoft.com/office/drawing/2014/main" id="{3271D388-C5CD-4409-8DFF-CC7E9447062D}"/>
+                <a16:creationId xmlns:a16="http://schemas.microsoft.com/office/drawing/2014/main" id="{385A8358-B894-45CE-8D52-29D864E1C4F4}"/>
               </a:ext>
             </a:extLst>
           </p:cNvPr>
@@ -1413,8 +1413,8 @@
         </p:nvSpPr>
         <p:spPr>
           <a:xfrm xmlns:a="http://schemas.openxmlformats.org/drawingml/2006/main">
-            <a:off x="571500" y="1476375"/>
-            <a:ext cx="11049000" cy="666750"/>
+            <a:off x="571500" y="1257300"/>
+            <a:ext cx="11049000" cy="409575"/>
           </a:xfrm>
           <a:prstGeom xmlns:a="http://schemas.openxmlformats.org/drawingml/2006/main" prst="rect">
             <a:avLst/>
@@ -1431,7 +1431,7 @@
           <a:lstStyle xmlns:a="http://schemas.openxmlformats.org/drawingml/2006/main"/>
           <a:p xmlns:a="http://schemas.openxmlformats.org/drawingml/2006/main">
             <a:pPr>
-              <a:defRPr sz="3000" b="1">
+              <a:defRPr sz="2250" b="1">
                 <a:solidFill>
                   <a:srgbClr val="117C83"/>
                 </a:solidFill>
@@ -1441,7 +1441,7 @@
               </a:defRPr>
             </a:pPr>
             <a:r>
-              <a:rPr sz="3000" b="1">
+              <a:rPr sz="2250" b="1">
                 <a:solidFill>
                   <a:srgbClr val="117C83"/>
                 </a:solidFill>
@@ -1449,7 +1449,7 @@
                 <a:ea typeface="Arial"/>
                 <a:cs typeface="Arial"/>
               </a:rPr>
-              <a:t>Which LLM wrote this C program?</a:t>
+              <a:t>A five-class authorship experiment using LLM-AuthorBench</a:t>
             </a:r>
           </a:p>
         </p:txBody>
@@ -1459,7 +1459,7 @@
           <p:cNvPr id="3" name="">
             <a:extLst xmlns:a="http://schemas.openxmlformats.org/drawingml/2006/main">
               <a:ext uri="{FF2B5EF4-FFF2-40B4-BE49-F238E27FC236}">
-                <a16:creationId xmlns:a16="http://schemas.microsoft.com/office/drawing/2014/main" id="{A8148E40-F4B2-4B00-B0F0-89FAB57B0F0F}"/>
+                <a16:creationId xmlns:a16="http://schemas.microsoft.com/office/drawing/2014/main" id="{B3AD9E12-7B30-4D18-AB86-8B01F4188983}"/>
               </a:ext>
             </a:extLst>
           </p:cNvPr>
@@ -1470,8 +1470,8 @@
         </p:nvSpPr>
         <p:spPr>
           <a:xfrm xmlns:a="http://schemas.openxmlformats.org/drawingml/2006/main">
-            <a:off x="571500" y="2543175"/>
-            <a:ext cx="10858500" cy="952500"/>
+            <a:off x="571500" y="2009775"/>
+            <a:ext cx="5095875" cy="952500"/>
           </a:xfrm>
           <a:prstGeom xmlns:a="http://schemas.openxmlformats.org/drawingml/2006/main" prst="rect">
             <a:avLst/>
@@ -1488,7 +1488,7 @@
           <a:lstStyle xmlns:a="http://schemas.openxmlformats.org/drawingml/2006/main"/>
           <a:p xmlns:a="http://schemas.openxmlformats.org/drawingml/2006/main">
             <a:pPr>
-              <a:defRPr sz="2400" b="0">
+              <a:defRPr sz="2850" b="1">
                 <a:solidFill>
                   <a:srgbClr val="152E38"/>
                 </a:solidFill>
@@ -1498,7 +1498,7 @@
               </a:defRPr>
             </a:pPr>
             <a:r>
-              <a:rPr sz="2400" b="0">
+              <a:rPr sz="2850" b="1">
                 <a:solidFill>
                   <a:srgbClr val="152E38"/>
                 </a:solidFill>
@@ -1506,12 +1506,12 @@
                 <a:ea typeface="Arial"/>
                 <a:cs typeface="Arial"/>
               </a:rPr>
-              <a:t>20,000 programs from LLM-AuthorBench</a:t>
+              <a:t>20,000 C programs</a:t>
             </a:r>
           </a:p>
           <a:p xmlns:a="http://schemas.openxmlformats.org/drawingml/2006/main">
             <a:pPr>
-              <a:defRPr sz="2400" b="0">
+              <a:defRPr sz="2850" b="1">
                 <a:solidFill>
                   <a:srgbClr val="152E38"/>
                 </a:solidFill>
@@ -1521,7 +1521,7 @@
               </a:defRPr>
             </a:pPr>
             <a:r>
-              <a:rPr sz="2400" b="0">
+              <a:rPr sz="2850" b="1">
                 <a:solidFill>
                   <a:srgbClr val="152E38"/>
                 </a:solidFill>
@@ -1529,7 +1529,7 @@
                 <a:ea typeface="Arial"/>
                 <a:cs typeface="Arial"/>
               </a:rPr>
-              <a:t>Five classes with 4,000 programs each</a:t>
+              <a:t>4,000 examples per author</a:t>
             </a:r>
           </a:p>
         </p:txBody>
@@ -1539,7 +1539,7 @@
           <p:cNvPr id="4" name="">
             <a:extLst xmlns:a="http://schemas.openxmlformats.org/drawingml/2006/main">
               <a:ext uri="{FF2B5EF4-FFF2-40B4-BE49-F238E27FC236}">
-                <a16:creationId xmlns:a16="http://schemas.microsoft.com/office/drawing/2014/main" id="{8DAED0CA-94BE-47AC-8572-DB1C06C133DB}"/>
+                <a16:creationId xmlns:a16="http://schemas.microsoft.com/office/drawing/2014/main" id="{8DB9F20D-3F17-4C12-80A2-9504C9FEC20F}"/>
               </a:ext>
             </a:extLst>
           </p:cNvPr>
@@ -1550,8 +1550,8 @@
         </p:nvSpPr>
         <p:spPr>
           <a:xfrm xmlns:a="http://schemas.openxmlformats.org/drawingml/2006/main">
-            <a:off x="571500" y="3838575"/>
-            <a:ext cx="10763250" cy="952500"/>
+            <a:off x="571500" y="3190875"/>
+            <a:ext cx="5238750" cy="1066800"/>
           </a:xfrm>
           <a:prstGeom xmlns:a="http://schemas.openxmlformats.org/drawingml/2006/main" prst="rect">
             <a:avLst/>
@@ -1568,7 +1568,7 @@
           <a:lstStyle xmlns:a="http://schemas.openxmlformats.org/drawingml/2006/main"/>
           <a:p xmlns:a="http://schemas.openxmlformats.org/drawingml/2006/main">
             <a:pPr>
-              <a:defRPr sz="2250" b="0">
+              <a:defRPr sz="1950" b="0">
                 <a:solidFill>
                   <a:srgbClr val="152E38"/>
                 </a:solidFill>
@@ -1578,7 +1578,7 @@
               </a:defRPr>
             </a:pPr>
             <a:r>
-              <a:rPr sz="2250" b="0">
+              <a:rPr sz="1950" b="0">
                 <a:solidFill>
                   <a:srgbClr val="152E38"/>
                 </a:solidFill>
@@ -1586,12 +1586,12 @@
                 <a:ea typeface="Arial"/>
                 <a:cs typeface="Arial"/>
               </a:rPr>
-              <a:t>Our topic: attributing LLM-generated code.</a:t>
+              <a:t>Claude 3.5 Haiku, DeepSeek Chat,</a:t>
             </a:r>
           </a:p>
           <a:p xmlns:a="http://schemas.openxmlformats.org/drawingml/2006/main">
             <a:pPr>
-              <a:defRPr sz="2250" b="0">
+              <a:defRPr sz="1950" b="0">
                 <a:solidFill>
                   <a:srgbClr val="152E38"/>
                 </a:solidFill>
@@ -1601,7 +1601,7 @@
               </a:defRPr>
             </a:pPr>
             <a:r>
-              <a:rPr sz="2250" b="0">
+              <a:rPr sz="1950" b="0">
                 <a:solidFill>
                   <a:srgbClr val="152E38"/>
                 </a:solidFill>
@@ -1609,7 +1609,30 @@
                 <a:ea typeface="Arial"/>
                 <a:cs typeface="Arial"/>
               </a:rPr>
-              <a:t>Four classical classifiers plus a CodeT5 encoder classifier.</a:t>
+              <a:t>Gemini 2.5 Flash Preview, GPT-4.1,</a:t>
+            </a:r>
+          </a:p>
+          <a:p xmlns:a="http://schemas.openxmlformats.org/drawingml/2006/main">
+            <a:pPr>
+              <a:defRPr sz="1950" b="0">
+                <a:solidFill>
+                  <a:srgbClr val="152E38"/>
+                </a:solidFill>
+                <a:latin typeface="Arial"/>
+                <a:ea typeface="Arial"/>
+                <a:cs typeface="Arial"/>
+              </a:defRPr>
+            </a:pPr>
+            <a:r>
+              <a:rPr sz="1950" b="0">
+                <a:solidFill>
+                  <a:srgbClr val="152E38"/>
+                </a:solidFill>
+                <a:latin typeface="Arial"/>
+                <a:ea typeface="Arial"/>
+                <a:cs typeface="Arial"/>
+              </a:rPr>
+              <a:t>Llama 3.3 70B Instruct</a:t>
             </a:r>
           </a:p>
         </p:txBody>
@@ -1619,7 +1642,7 @@
           <p:cNvPr id="5" name="">
             <a:extLst xmlns:a="http://schemas.openxmlformats.org/drawingml/2006/main">
               <a:ext uri="{FF2B5EF4-FFF2-40B4-BE49-F238E27FC236}">
-                <a16:creationId xmlns:a16="http://schemas.microsoft.com/office/drawing/2014/main" id="{ECE56D39-1587-4C63-B6B8-AB95FC3BD137}"/>
+                <a16:creationId xmlns:a16="http://schemas.microsoft.com/office/drawing/2014/main" id="{854C1886-7BB9-466D-B9EA-1BCC93707F5C}"/>
               </a:ext>
             </a:extLst>
           </p:cNvPr>
@@ -1630,8 +1653,8 @@
         </p:nvSpPr>
         <p:spPr>
           <a:xfrm xmlns:a="http://schemas.openxmlformats.org/drawingml/2006/main">
-            <a:off x="571500" y="4905375"/>
-            <a:ext cx="11049000" cy="619125"/>
+            <a:off x="6572250" y="2009775"/>
+            <a:ext cx="4953000" cy="381000"/>
           </a:xfrm>
           <a:prstGeom xmlns:a="http://schemas.openxmlformats.org/drawingml/2006/main" prst="rect">
             <a:avLst/>
@@ -1648,9 +1671,9 @@
           <a:lstStyle xmlns:a="http://schemas.openxmlformats.org/drawingml/2006/main"/>
           <a:p xmlns:a="http://schemas.openxmlformats.org/drawingml/2006/main">
             <a:pPr>
-              <a:defRPr sz="1875" b="0">
-                <a:solidFill>
-                  <a:srgbClr val="152E38"/>
+              <a:defRPr sz="2250" b="1">
+                <a:solidFill>
+                  <a:srgbClr val="117C83"/>
                 </a:solidFill>
                 <a:latin typeface="Arial"/>
                 <a:ea typeface="Arial"/>
@@ -1658,38 +1681,15 @@
               </a:defRPr>
             </a:pPr>
             <a:r>
-              <a:rPr sz="1875" b="0">
-                <a:solidFill>
-                  <a:srgbClr val="152E38"/>
+              <a:rPr sz="2250" b="1">
+                <a:solidFill>
+                  <a:srgbClr val="117C83"/>
                 </a:solidFill>
                 <a:latin typeface="Arial"/>
                 <a:ea typeface="Arial"/>
                 <a:cs typeface="Arial"/>
               </a:rPr>
-              <a:t>Saeed Alshehhi, Khalifa Alblooshi, Maitha Alblooshi</a:t>
-            </a:r>
-          </a:p>
-          <a:p xmlns:a="http://schemas.openxmlformats.org/drawingml/2006/main">
-            <a:pPr>
-              <a:defRPr sz="1875" b="0">
-                <a:solidFill>
-                  <a:srgbClr val="152E38"/>
-                </a:solidFill>
-                <a:latin typeface="Arial"/>
-                <a:ea typeface="Arial"/>
-                <a:cs typeface="Arial"/>
-              </a:defRPr>
-            </a:pPr>
-            <a:r>
-              <a:rPr sz="1875" b="0">
-                <a:solidFill>
-                  <a:srgbClr val="152E38"/>
-                </a:solidFill>
-                <a:latin typeface="Arial"/>
-                <a:ea typeface="Arial"/>
-                <a:cs typeface="Arial"/>
-              </a:rPr>
-              <a:t>Fatima Alnuaimi, Fatima Alsadi</a:t>
+              <a:t>Why this dataset?</a:t>
             </a:r>
           </a:p>
         </p:txBody>
@@ -1699,7 +1699,7 @@
           <p:cNvPr id="6" name="">
             <a:extLst xmlns:a="http://schemas.openxmlformats.org/drawingml/2006/main">
               <a:ext uri="{FF2B5EF4-FFF2-40B4-BE49-F238E27FC236}">
-                <a16:creationId xmlns:a16="http://schemas.microsoft.com/office/drawing/2014/main" id="{5F997DC9-60D9-4E4D-B91F-AFB2C41804B9}"/>
+                <a16:creationId xmlns:a16="http://schemas.microsoft.com/office/drawing/2014/main" id="{DFFDA5F9-6F4D-4055-ACA1-565CE42CAAB9}"/>
               </a:ext>
             </a:extLst>
           </p:cNvPr>
@@ -1710,8 +1710,214 @@
         </p:nvSpPr>
         <p:spPr>
           <a:xfrm xmlns:a="http://schemas.openxmlformats.org/drawingml/2006/main">
-            <a:off x="571500" y="5753100"/>
-            <a:ext cx="11144250" cy="333375"/>
+            <a:off x="6572250" y="2600325"/>
+            <a:ext cx="4953000" cy="1952625"/>
+          </a:xfrm>
+          <a:prstGeom xmlns:a="http://schemas.openxmlformats.org/drawingml/2006/main" prst="rect">
+            <a:avLst/>
+          </a:prstGeom>
+          <a:noFill xmlns:a="http://schemas.openxmlformats.org/drawingml/2006/main"/>
+          <a:ln xmlns:a="http://schemas.openxmlformats.org/drawingml/2006/main" w="0">
+            <a:noFill/>
+          </a:ln>
+        </p:spPr>
+        <p:txBody>
+          <a:bodyPr xmlns:a="http://schemas.openxmlformats.org/drawingml/2006/main" lIns="0" tIns="0" rIns="0" bIns="0">
+            <a:noAutofit/>
+          </a:bodyPr>
+          <a:lstStyle xmlns:a="http://schemas.openxmlformats.org/drawingml/2006/main"/>
+          <a:p xmlns:a="http://schemas.openxmlformats.org/drawingml/2006/main">
+            <a:pPr>
+              <a:defRPr sz="1950" b="0">
+                <a:solidFill>
+                  <a:srgbClr val="152E38"/>
+                </a:solidFill>
+                <a:latin typeface="Arial"/>
+                <a:ea typeface="Arial"/>
+                <a:cs typeface="Arial"/>
+              </a:defRPr>
+            </a:pPr>
+            <a:r>
+              <a:rPr sz="1950" b="0">
+                <a:solidFill>
+                  <a:srgbClr val="152E38"/>
+                </a:solidFill>
+                <a:latin typeface="Arial"/>
+                <a:ea typeface="Arial"/>
+                <a:cs typeface="Arial"/>
+              </a:rPr>
+              <a:t>Known labels for supervised learning</a:t>
+            </a:r>
+          </a:p>
+          <a:p xmlns:a="http://schemas.openxmlformats.org/drawingml/2006/main">
+            <a:pPr>
+              <a:defRPr sz="1950" b="0">
+                <a:solidFill>
+                  <a:srgbClr val="152E38"/>
+                </a:solidFill>
+                <a:latin typeface="Arial"/>
+                <a:ea typeface="Arial"/>
+                <a:cs typeface="Arial"/>
+              </a:defRPr>
+            </a:pPr>
+            <a:r>
+              <a:rPr sz="1950" b="0">
+                <a:solidFill>
+                  <a:srgbClr val="152E38"/>
+                </a:solidFill>
+                <a:latin typeface="Arial"/>
+                <a:ea typeface="Arial"/>
+                <a:cs typeface="Arial"/>
+              </a:rPr>
+              <a:t>Balanced examples across five authors</a:t>
+            </a:r>
+          </a:p>
+          <a:p xmlns:a="http://schemas.openxmlformats.org/drawingml/2006/main">
+            <a:pPr>
+              <a:defRPr sz="1950" b="0">
+                <a:solidFill>
+                  <a:srgbClr val="152E38"/>
+                </a:solidFill>
+                <a:latin typeface="Arial"/>
+                <a:ea typeface="Arial"/>
+                <a:cs typeface="Arial"/>
+              </a:defRPr>
+            </a:pPr>
+            <a:r>
+              <a:rPr sz="1950" b="0">
+                <a:solidFill>
+                  <a:srgbClr val="152E38"/>
+                </a:solidFill>
+                <a:latin typeface="Arial"/>
+                <a:ea typeface="Arial"/>
+                <a:cs typeface="Arial"/>
+              </a:rPr>
+              <a:t>C code keeps the language consistent</a:t>
+            </a:r>
+          </a:p>
+          <a:p xmlns:a="http://schemas.openxmlformats.org/drawingml/2006/main">
+            <a:pPr>
+              <a:defRPr sz="1950" b="0">
+                <a:solidFill>
+                  <a:srgbClr val="152E38"/>
+                </a:solidFill>
+                <a:latin typeface="Arial"/>
+                <a:ea typeface="Arial"/>
+                <a:cs typeface="Arial"/>
+              </a:defRPr>
+            </a:pPr>
+            <a:r>
+              <a:rPr sz="1950" b="0">
+                <a:solidFill>
+                  <a:srgbClr val="152E38"/>
+                </a:solidFill>
+                <a:latin typeface="Arial"/>
+                <a:ea typeface="Arial"/>
+                <a:cs typeface="Arial"/>
+              </a:rPr>
+              <a:t>Comments and patterns we can test</a:t>
+            </a:r>
+          </a:p>
+        </p:txBody>
+      </p:sp>
+      <p:sp>
+        <p:nvSpPr>
+          <p:cNvPr id="7" name="">
+            <a:extLst xmlns:a="http://schemas.openxmlformats.org/drawingml/2006/main">
+              <a:ext uri="{FF2B5EF4-FFF2-40B4-BE49-F238E27FC236}">
+                <a16:creationId xmlns:a16="http://schemas.microsoft.com/office/drawing/2014/main" id="{AC470FB2-169B-42D2-843E-F7649AC813DD}"/>
+              </a:ext>
+            </a:extLst>
+          </p:cNvPr>
+          <p:cNvSpPr>
+            <a:spLocks xmlns:a="http://schemas.openxmlformats.org/drawingml/2006/main" noGrp="1"/>
+          </p:cNvSpPr>
+          <p:nvPr/>
+        </p:nvSpPr>
+        <p:spPr>
+          <a:xfrm xmlns:a="http://schemas.openxmlformats.org/drawingml/2006/main">
+            <a:off x="571500" y="4562475"/>
+            <a:ext cx="11049000" cy="723900"/>
+          </a:xfrm>
+          <a:prstGeom xmlns:a="http://schemas.openxmlformats.org/drawingml/2006/main" prst="rect">
+            <a:avLst/>
+          </a:prstGeom>
+          <a:noFill xmlns:a="http://schemas.openxmlformats.org/drawingml/2006/main"/>
+          <a:ln xmlns:a="http://schemas.openxmlformats.org/drawingml/2006/main" w="0">
+            <a:noFill/>
+          </a:ln>
+        </p:spPr>
+        <p:txBody>
+          <a:bodyPr xmlns:a="http://schemas.openxmlformats.org/drawingml/2006/main" lIns="0" tIns="0" rIns="0" bIns="0">
+            <a:noAutofit/>
+          </a:bodyPr>
+          <a:lstStyle xmlns:a="http://schemas.openxmlformats.org/drawingml/2006/main"/>
+          <a:p xmlns:a="http://schemas.openxmlformats.org/drawingml/2006/main">
+            <a:pPr>
+              <a:defRPr sz="2025" b="0">
+                <a:solidFill>
+                  <a:srgbClr val="152E38"/>
+                </a:solidFill>
+                <a:latin typeface="Arial"/>
+                <a:ea typeface="Arial"/>
+                <a:cs typeface="Arial"/>
+              </a:defRPr>
+            </a:pPr>
+            <a:r>
+              <a:rPr sz="2025" b="0">
+                <a:solidFill>
+                  <a:srgbClr val="152E38"/>
+                </a:solidFill>
+                <a:latin typeface="Arial"/>
+                <a:ea typeface="Arial"/>
+                <a:cs typeface="Arial"/>
+              </a:rPr>
+              <a:t>We compare four classical models and a pretrained CodeT5 encoder.</a:t>
+            </a:r>
+          </a:p>
+          <a:p xmlns:a="http://schemas.openxmlformats.org/drawingml/2006/main">
+            <a:pPr>
+              <a:defRPr sz="2025" b="0">
+                <a:solidFill>
+                  <a:srgbClr val="152E38"/>
+                </a:solidFill>
+                <a:latin typeface="Arial"/>
+                <a:ea typeface="Arial"/>
+                <a:cs typeface="Arial"/>
+              </a:defRPr>
+            </a:pPr>
+            <a:r>
+              <a:rPr sz="2025" b="0">
+                <a:solidFill>
+                  <a:srgbClr val="152E38"/>
+                </a:solidFill>
+                <a:latin typeface="Arial"/>
+                <a:ea typeface="Arial"/>
+                <a:cs typeface="Arial"/>
+              </a:rPr>
+              <a:t>The goal is a fair comparison and an evidence-based explanation.</a:t>
+            </a:r>
+          </a:p>
+        </p:txBody>
+      </p:sp>
+      <p:sp>
+        <p:nvSpPr>
+          <p:cNvPr id="8" name="">
+            <a:extLst xmlns:a="http://schemas.openxmlformats.org/drawingml/2006/main">
+              <a:ext uri="{FF2B5EF4-FFF2-40B4-BE49-F238E27FC236}">
+                <a16:creationId xmlns:a16="http://schemas.microsoft.com/office/drawing/2014/main" id="{26E0854D-045C-4097-98F1-E8D31385BFFC}"/>
+              </a:ext>
+            </a:extLst>
+          </p:cNvPr>
+          <p:cNvSpPr>
+            <a:spLocks xmlns:a="http://schemas.openxmlformats.org/drawingml/2006/main" noGrp="1"/>
+          </p:cNvSpPr>
+          <p:nvPr/>
+        </p:nvSpPr>
+        <p:spPr>
+          <a:xfrm xmlns:a="http://schemas.openxmlformats.org/drawingml/2006/main">
+            <a:off x="571500" y="5429250"/>
+            <a:ext cx="11049000" cy="590550"/>
           </a:xfrm>
           <a:prstGeom xmlns:a="http://schemas.openxmlformats.org/drawingml/2006/main" prst="rect">
             <a:avLst/>
@@ -1730,7 +1936,7 @@
             <a:pPr>
               <a:defRPr sz="1725" b="0">
                 <a:solidFill>
-                  <a:srgbClr val="117C83"/>
+                  <a:srgbClr val="152E38"/>
                 </a:solidFill>
                 <a:latin typeface="Arial"/>
                 <a:ea typeface="Arial"/>
@@ -1740,23 +1946,46 @@
             <a:r>
               <a:rPr sz="1725" b="0">
                 <a:solidFill>
-                  <a:srgbClr val="117C83"/>
+                  <a:srgbClr val="152E38"/>
                 </a:solidFill>
                 <a:latin typeface="Arial"/>
                 <a:ea typeface="Arial"/>
                 <a:cs typeface="Arial"/>
               </a:rPr>
-              <a:t>https://github.com/S3eeDTR/LLM-AuthorBench-Assignment</a:t>
+              <a:t>Saeed Alshehhi, Khalifa Alblooshi, Maitha Alblooshi</a:t>
+            </a:r>
+          </a:p>
+          <a:p xmlns:a="http://schemas.openxmlformats.org/drawingml/2006/main">
+            <a:pPr>
+              <a:defRPr sz="1725" b="0">
+                <a:solidFill>
+                  <a:srgbClr val="152E38"/>
+                </a:solidFill>
+                <a:latin typeface="Arial"/>
+                <a:ea typeface="Arial"/>
+                <a:cs typeface="Arial"/>
+              </a:defRPr>
+            </a:pPr>
+            <a:r>
+              <a:rPr sz="1725" b="0">
+                <a:solidFill>
+                  <a:srgbClr val="152E38"/>
+                </a:solidFill>
+                <a:latin typeface="Arial"/>
+                <a:ea typeface="Arial"/>
+                <a:cs typeface="Arial"/>
+              </a:rPr>
+              <a:t>Fatima Alnuaimi, Fatima Alsadi</a:t>
             </a:r>
           </a:p>
         </p:txBody>
       </p:sp>
       <p:sp>
         <p:nvSpPr>
-          <p:cNvPr id="7" name="">
+          <p:cNvPr id="9" name="">
             <a:extLst xmlns:a="http://schemas.openxmlformats.org/drawingml/2006/main">
               <a:ext uri="{FF2B5EF4-FFF2-40B4-BE49-F238E27FC236}">
-                <a16:creationId xmlns:a16="http://schemas.microsoft.com/office/drawing/2014/main" id="{F23A8BB2-D0A4-4B9D-95BB-DCE76C046CE2}"/>
+                <a16:creationId xmlns:a16="http://schemas.microsoft.com/office/drawing/2014/main" id="{FB1E2BD7-EAE6-487A-921B-C195FB8663FE}"/>
               </a:ext>
             </a:extLst>
           </p:cNvPr>
@@ -1767,7 +1996,7 @@
         </p:nvSpPr>
         <p:spPr>
           <a:xfrm xmlns:a="http://schemas.openxmlformats.org/drawingml/2006/main">
-            <a:off x="571500" y="6257925"/>
+            <a:off x="571500" y="6115050"/>
             <a:ext cx="11049000" cy="285750"/>
           </a:xfrm>
           <a:prstGeom xmlns:a="http://schemas.openxmlformats.org/drawingml/2006/main" prst="rect">
@@ -1785,9 +2014,9 @@
           <a:lstStyle xmlns:a="http://schemas.openxmlformats.org/drawingml/2006/main"/>
           <a:p xmlns:a="http://schemas.openxmlformats.org/drawingml/2006/main">
             <a:pPr>
-              <a:defRPr sz="1575" b="0">
-                <a:solidFill>
-                  <a:srgbClr val="152E38"/>
+              <a:defRPr sz="1650" b="0">
+                <a:solidFill>
+                  <a:srgbClr val="117C83"/>
                 </a:solidFill>
                 <a:latin typeface="Arial"/>
                 <a:ea typeface="Arial"/>
@@ -1795,15 +2024,72 @@
               </a:defRPr>
             </a:pPr>
             <a:r>
-              <a:rPr sz="1575" b="0">
-                <a:solidFill>
-                  <a:srgbClr val="152E38"/>
+              <a:rPr sz="1650" b="0">
+                <a:solidFill>
+                  <a:srgbClr val="117C83"/>
                 </a:solidFill>
                 <a:latin typeface="Arial"/>
                 <a:ea typeface="Arial"/>
                 <a:cs typeface="Arial"/>
               </a:rPr>
-              <a:t>Source: github.com/LLMauthorbench/LLMauthorbench</a:t>
+              <a:t>https://github.com/S3eeDTR/LLM-AuthorBench-Assignment</a:t>
+            </a:r>
+          </a:p>
+        </p:txBody>
+      </p:sp>
+      <p:sp>
+        <p:nvSpPr>
+          <p:cNvPr id="10" name="">
+            <a:extLst xmlns:a="http://schemas.openxmlformats.org/drawingml/2006/main">
+              <a:ext uri="{FF2B5EF4-FFF2-40B4-BE49-F238E27FC236}">
+                <a16:creationId xmlns:a16="http://schemas.microsoft.com/office/drawing/2014/main" id="{F585C7A8-ACE2-4DC8-8643-27112F2F1B7B}"/>
+              </a:ext>
+            </a:extLst>
+          </p:cNvPr>
+          <p:cNvSpPr>
+            <a:spLocks xmlns:a="http://schemas.openxmlformats.org/drawingml/2006/main" noGrp="1"/>
+          </p:cNvSpPr>
+          <p:nvPr/>
+        </p:nvSpPr>
+        <p:spPr>
+          <a:xfrm xmlns:a="http://schemas.openxmlformats.org/drawingml/2006/main">
+            <a:off x="571500" y="6477000"/>
+            <a:ext cx="11049000" cy="238125"/>
+          </a:xfrm>
+          <a:prstGeom xmlns:a="http://schemas.openxmlformats.org/drawingml/2006/main" prst="rect">
+            <a:avLst/>
+          </a:prstGeom>
+          <a:noFill xmlns:a="http://schemas.openxmlformats.org/drawingml/2006/main"/>
+          <a:ln xmlns:a="http://schemas.openxmlformats.org/drawingml/2006/main" w="0">
+            <a:noFill/>
+          </a:ln>
+        </p:spPr>
+        <p:txBody>
+          <a:bodyPr xmlns:a="http://schemas.openxmlformats.org/drawingml/2006/main" lIns="0" tIns="0" rIns="0" bIns="0">
+            <a:noAutofit/>
+          </a:bodyPr>
+          <a:lstStyle xmlns:a="http://schemas.openxmlformats.org/drawingml/2006/main"/>
+          <a:p xmlns:a="http://schemas.openxmlformats.org/drawingml/2006/main">
+            <a:pPr>
+              <a:defRPr sz="1350" b="0">
+                <a:solidFill>
+                  <a:srgbClr val="50636B"/>
+                </a:solidFill>
+                <a:latin typeface="Arial"/>
+                <a:ea typeface="Arial"/>
+                <a:cs typeface="Arial"/>
+              </a:defRPr>
+            </a:pPr>
+            <a:r>
+              <a:rPr sz="1350" b="0">
+                <a:solidFill>
+                  <a:srgbClr val="50636B"/>
+                </a:solidFill>
+                <a:latin typeface="Arial"/>
+                <a:ea typeface="Arial"/>
+                <a:cs typeface="Arial"/>
+              </a:rPr>
+              <a:t>Data: github.com/LLMauthorbench/LLMauthorbench</a:t>
             </a:r>
           </a:p>
         </p:txBody>
@@ -1811,7 +2097,7 @@
     </p:spTree>
     <p:extLst>
       <p:ext uri="{BB962C8B-B14F-4D97-AF65-F5344CB8AC3E}">
-        <p14:creationId xmlns:p14="http://schemas.microsoft.com/office/powerpoint/2010/main" val="560717705"/>
+        <p14:creationId xmlns:p14="http://schemas.microsoft.com/office/powerpoint/2010/main" val="1277318705"/>
       </p:ext>
     </p:extLst>
   </p:cSld>
@@ -1842,7 +2128,7 @@
           <p:cNvPr id="7" name="">
             <a:extLst xmlns:a="http://schemas.openxmlformats.org/drawingml/2006/main">
               <a:ext uri="{FF2B5EF4-FFF2-40B4-BE49-F238E27FC236}">
-                <a16:creationId xmlns:a16="http://schemas.microsoft.com/office/drawing/2014/main" id="{EF282CD8-7419-4693-A8B5-A8C10B93131B}"/>
+                <a16:creationId xmlns:a16="http://schemas.microsoft.com/office/drawing/2014/main" id="{3604FCEB-A6B8-45EB-9CA7-91A0A3692EED}"/>
               </a:ext>
             </a:extLst>
           </p:cNvPr>
@@ -1889,7 +2175,7 @@
                 <a:ea typeface="Arial"/>
                 <a:cs typeface="Arial"/>
               </a:rPr>
-              <a:t>Data preparation</a:t>
+              <a:t>Data preparation: learn patterns without leakage</a:t>
             </a:r>
           </a:p>
         </p:txBody>
@@ -1901,19 +2187,19 @@
           <p:nvPr/>
         </p:nvGraphicFramePr>
         <p:xfrm>
-          <a:off xmlns:a="http://schemas.openxmlformats.org/drawingml/2006/main" x="571500" y="1495425"/>
-          <a:ext xmlns:a="http://schemas.openxmlformats.org/drawingml/2006/main" cx="5810250" cy="2714625"/>
+          <a:off xmlns:a="http://schemas.openxmlformats.org/drawingml/2006/main" x="571500" y="1381125"/>
+          <a:ext xmlns:a="http://schemas.openxmlformats.org/drawingml/2006/main" cx="11049000" cy="1952625"/>
         </p:xfrm>
         <a:graphic xmlns:a="http://schemas.openxmlformats.org/drawingml/2006/main">
           <a:graphicData uri="http://schemas.openxmlformats.org/drawingml/2006/table">
             <a:tbl>
               <a:tblPr/>
               <a:tblGrid>
-                <a:gridCol w="2476500"/>
-                <a:gridCol w="1714500"/>
+                <a:gridCol w="2095500"/>
                 <a:gridCol w="1619250"/>
+                <a:gridCol w="7334250"/>
               </a:tblGrid>
-              <a:tr h="678656">
+              <a:tr h="488156">
                 <a:tc>
                   <a:txBody>
                     <a:bodyPr>
@@ -1923,7 +2209,7 @@
                     <a:p>
                       <a:pPr algn="l"/>
                       <a:r>
-                        <a:rPr sz="1875" b="1">
+                        <a:rPr sz="1800" b="1">
                           <a:solidFill>
                             <a:srgbClr val="FFFFFF"/>
                           </a:solidFill>
@@ -1931,7 +2217,7 @@
                           <a:ea typeface="Arial"/>
                           <a:cs typeface="Arial"/>
                         </a:rPr>
-                        <a:t>Split</a:t>
+                        <a:t>Partition</a:t>
                       </a:r>
                     </a:p>
                   </a:txBody>
@@ -1950,7 +2236,7 @@
                     <a:p>
                       <a:pPr algn="ctr"/>
                       <a:r>
-                        <a:rPr sz="1875" b="1">
+                        <a:rPr sz="1800" b="1">
                           <a:solidFill>
                             <a:srgbClr val="FFFFFF"/>
                           </a:solidFill>
@@ -1977,7 +2263,7 @@
                     <a:p>
                       <a:pPr algn="ctr"/>
                       <a:r>
-                        <a:rPr sz="1875" b="1">
+                        <a:rPr sz="1800" b="1">
                           <a:solidFill>
                             <a:srgbClr val="FFFFFF"/>
                           </a:solidFill>
@@ -1985,7 +2271,7 @@
                           <a:ea typeface="Arial"/>
                           <a:cs typeface="Arial"/>
                         </a:rPr>
-                        <a:t>Task groups</a:t>
+                        <a:t>Purpose</a:t>
                       </a:r>
                     </a:p>
                   </a:txBody>
@@ -1996,7 +2282,7 @@
                   </a:tcPr>
                 </a:tc>
               </a:tr>
-              <a:tr h="678656">
+              <a:tr h="488156">
                 <a:tc>
                   <a:txBody>
                     <a:bodyPr>
@@ -2006,7 +2292,7 @@
                     <a:p>
                       <a:pPr algn="l"/>
                       <a:r>
-                        <a:rPr sz="1950" b="0">
+                        <a:rPr sz="1875" b="0">
                           <a:solidFill>
                             <a:srgbClr val="152E38"/>
                           </a:solidFill>
@@ -2033,7 +2319,7 @@
                     <a:p>
                       <a:pPr algn="ctr"/>
                       <a:r>
-                        <a:rPr sz="1950" b="0">
+                        <a:rPr sz="1875" b="0">
                           <a:solidFill>
                             <a:srgbClr val="152E38"/>
                           </a:solidFill>
@@ -2060,7 +2346,7 @@
                     <a:p>
                       <a:pPr algn="ctr"/>
                       <a:r>
-                        <a:rPr sz="1950" b="0">
+                        <a:rPr sz="1875" b="0">
                           <a:solidFill>
                             <a:srgbClr val="152E38"/>
                           </a:solidFill>
@@ -2068,7 +2354,7 @@
                           <a:ea typeface="Arial"/>
                           <a:cs typeface="Arial"/>
                         </a:rPr>
-                        <a:t>181</a:t>
+                        <a:t>Learn features and models</a:t>
                       </a:r>
                     </a:p>
                   </a:txBody>
@@ -2079,7 +2365,7 @@
                   </a:tcPr>
                 </a:tc>
               </a:tr>
-              <a:tr h="678656">
+              <a:tr h="488156">
                 <a:tc>
                   <a:txBody>
                     <a:bodyPr>
@@ -2089,7 +2375,7 @@
                     <a:p>
                       <a:pPr algn="l"/>
                       <a:r>
-                        <a:rPr sz="1950" b="0">
+                        <a:rPr sz="1875" b="0">
                           <a:solidFill>
                             <a:srgbClr val="152E38"/>
                           </a:solidFill>
@@ -2116,7 +2402,7 @@
                     <a:p>
                       <a:pPr algn="ctr"/>
                       <a:r>
-                        <a:rPr sz="1950" b="0">
+                        <a:rPr sz="1875" b="0">
                           <a:solidFill>
                             <a:srgbClr val="152E38"/>
                           </a:solidFill>
@@ -2143,7 +2429,7 @@
                     <a:p>
                       <a:pPr algn="ctr"/>
                       <a:r>
-                        <a:rPr sz="1950" b="0">
+                        <a:rPr sz="1875" b="0">
                           <a:solidFill>
                             <a:srgbClr val="152E38"/>
                           </a:solidFill>
@@ -2151,7 +2437,7 @@
                           <a:ea typeface="Arial"/>
                           <a:cs typeface="Arial"/>
                         </a:rPr>
-                        <a:t>38</a:t>
+                        <a:t>Choose models / checkpoints</a:t>
                       </a:r>
                     </a:p>
                   </a:txBody>
@@ -2162,7 +2448,7 @@
                   </a:tcPr>
                 </a:tc>
               </a:tr>
-              <a:tr h="678656">
+              <a:tr h="488156">
                 <a:tc>
                   <a:txBody>
                     <a:bodyPr>
@@ -2172,7 +2458,7 @@
                     <a:p>
                       <a:pPr algn="l"/>
                       <a:r>
-                        <a:rPr sz="1950" b="0">
+                        <a:rPr sz="1875" b="0">
                           <a:solidFill>
                             <a:srgbClr val="152E38"/>
                           </a:solidFill>
@@ -2199,7 +2485,7 @@
                     <a:p>
                       <a:pPr algn="ctr"/>
                       <a:r>
-                        <a:rPr sz="1950" b="0">
+                        <a:rPr sz="1875" b="0">
                           <a:solidFill>
                             <a:srgbClr val="152E38"/>
                           </a:solidFill>
@@ -2226,7 +2512,7 @@
                     <a:p>
                       <a:pPr algn="ctr"/>
                       <a:r>
-                        <a:rPr sz="1950" b="0">
+                        <a:rPr sz="1875" b="0">
                           <a:solidFill>
                             <a:srgbClr val="152E38"/>
                           </a:solidFill>
@@ -2234,7 +2520,7 @@
                           <a:ea typeface="Arial"/>
                           <a:cs typeface="Arial"/>
                         </a:rPr>
-                        <a:t>40</a:t>
+                        <a:t>Final held-out evaluation</a:t>
                       </a:r>
                     </a:p>
                   </a:txBody>
@@ -2254,7 +2540,7 @@
           <p:cNvPr id="3" name="">
             <a:extLst xmlns:a="http://schemas.openxmlformats.org/drawingml/2006/main">
               <a:ext uri="{FF2B5EF4-FFF2-40B4-BE49-F238E27FC236}">
-                <a16:creationId xmlns:a16="http://schemas.microsoft.com/office/drawing/2014/main" id="{782F8707-BC68-48DC-9778-B028E5F34E2E}"/>
+                <a16:creationId xmlns:a16="http://schemas.microsoft.com/office/drawing/2014/main" id="{F8AB9379-05E1-4A92-A463-2FE3653C230E}"/>
               </a:ext>
             </a:extLst>
           </p:cNvPr>
@@ -2265,8 +2551,145 @@
         </p:nvSpPr>
         <p:spPr>
           <a:xfrm xmlns:a="http://schemas.openxmlformats.org/drawingml/2006/main">
-            <a:off x="6858000" y="1571625"/>
-            <a:ext cx="4857750" cy="1524000"/>
+            <a:off x="571500" y="3629025"/>
+            <a:ext cx="11049000" cy="381000"/>
+          </a:xfrm>
+          <a:prstGeom xmlns:a="http://schemas.openxmlformats.org/drawingml/2006/main" prst="rect">
+            <a:avLst/>
+          </a:prstGeom>
+          <a:noFill xmlns:a="http://schemas.openxmlformats.org/drawingml/2006/main"/>
+          <a:ln xmlns:a="http://schemas.openxmlformats.org/drawingml/2006/main" w="0">
+            <a:noFill/>
+          </a:ln>
+        </p:spPr>
+        <p:txBody>
+          <a:bodyPr xmlns:a="http://schemas.openxmlformats.org/drawingml/2006/main" lIns="0" tIns="0" rIns="0" bIns="0">
+            <a:noAutofit/>
+          </a:bodyPr>
+          <a:lstStyle xmlns:a="http://schemas.openxmlformats.org/drawingml/2006/main"/>
+          <a:p xmlns:a="http://schemas.openxmlformats.org/drawingml/2006/main">
+            <a:pPr>
+              <a:defRPr sz="2175" b="1">
+                <a:solidFill>
+                  <a:srgbClr val="117C83"/>
+                </a:solidFill>
+                <a:latin typeface="Arial"/>
+                <a:ea typeface="Arial"/>
+                <a:cs typeface="Arial"/>
+              </a:defRPr>
+            </a:pPr>
+            <a:r>
+              <a:rPr sz="2175" b="1">
+                <a:solidFill>
+                  <a:srgbClr val="117C83"/>
+                </a:solidFill>
+                <a:latin typeface="Arial"/>
+                <a:ea typeface="Arial"/>
+                <a:cs typeface="Arial"/>
+              </a:rPr>
+              <a:t>TF-IDF: Term Frequency–Inverse Document Frequency</a:t>
+            </a:r>
+          </a:p>
+        </p:txBody>
+      </p:sp>
+      <p:sp>
+        <p:nvSpPr>
+          <p:cNvPr id="4" name="">
+            <a:extLst xmlns:a="http://schemas.openxmlformats.org/drawingml/2006/main">
+              <a:ext uri="{FF2B5EF4-FFF2-40B4-BE49-F238E27FC236}">
+                <a16:creationId xmlns:a16="http://schemas.microsoft.com/office/drawing/2014/main" id="{846D7E14-301D-451B-A776-2A9DB53E0871}"/>
+              </a:ext>
+            </a:extLst>
+          </p:cNvPr>
+          <p:cNvSpPr>
+            <a:spLocks xmlns:a="http://schemas.openxmlformats.org/drawingml/2006/main" noGrp="1"/>
+          </p:cNvSpPr>
+          <p:nvPr/>
+        </p:nvSpPr>
+        <p:spPr>
+          <a:xfrm xmlns:a="http://schemas.openxmlformats.org/drawingml/2006/main">
+            <a:off x="571500" y="4105275"/>
+            <a:ext cx="10953750" cy="723900"/>
+          </a:xfrm>
+          <a:prstGeom xmlns:a="http://schemas.openxmlformats.org/drawingml/2006/main" prst="rect">
+            <a:avLst/>
+          </a:prstGeom>
+          <a:noFill xmlns:a="http://schemas.openxmlformats.org/drawingml/2006/main"/>
+          <a:ln xmlns:a="http://schemas.openxmlformats.org/drawingml/2006/main" w="0">
+            <a:noFill/>
+          </a:ln>
+        </p:spPr>
+        <p:txBody>
+          <a:bodyPr xmlns:a="http://schemas.openxmlformats.org/drawingml/2006/main" lIns="0" tIns="0" rIns="0" bIns="0">
+            <a:noAutofit/>
+          </a:bodyPr>
+          <a:lstStyle xmlns:a="http://schemas.openxmlformats.org/drawingml/2006/main"/>
+          <a:p xmlns:a="http://schemas.openxmlformats.org/drawingml/2006/main">
+            <a:pPr>
+              <a:defRPr sz="2025" b="0">
+                <a:solidFill>
+                  <a:srgbClr val="152E38"/>
+                </a:solidFill>
+                <a:latin typeface="Arial"/>
+                <a:ea typeface="Arial"/>
+                <a:cs typeface="Arial"/>
+              </a:defRPr>
+            </a:pPr>
+            <a:r>
+              <a:rPr sz="2025" b="0">
+                <a:solidFill>
+                  <a:srgbClr val="152E38"/>
+                </a:solidFill>
+                <a:latin typeface="Arial"/>
+                <a:ea typeface="Arial"/>
+                <a:cs typeface="Arial"/>
+              </a:rPr>
+              <a:t>“int x;” contains patterns such as “int”, “nt ” and “t x”.</a:t>
+            </a:r>
+          </a:p>
+          <a:p xmlns:a="http://schemas.openxmlformats.org/drawingml/2006/main">
+            <a:pPr>
+              <a:defRPr sz="2025" b="0">
+                <a:solidFill>
+                  <a:srgbClr val="152E38"/>
+                </a:solidFill>
+                <a:latin typeface="Arial"/>
+                <a:ea typeface="Arial"/>
+                <a:cs typeface="Arial"/>
+              </a:defRPr>
+            </a:pPr>
+            <a:r>
+              <a:rPr sz="2025" b="0">
+                <a:solidFill>
+                  <a:srgbClr val="152E38"/>
+                </a:solidFill>
+                <a:latin typeface="Arial"/>
+                <a:ea typeface="Arial"/>
+                <a:cs typeface="Arial"/>
+              </a:rPr>
+              <a:t>Use 3–5-character patterns, up to 50,000 columns per program.</a:t>
+            </a:r>
+          </a:p>
+        </p:txBody>
+      </p:sp>
+      <p:sp>
+        <p:nvSpPr>
+          <p:cNvPr id="5" name="">
+            <a:extLst xmlns:a="http://schemas.openxmlformats.org/drawingml/2006/main">
+              <a:ext uri="{FF2B5EF4-FFF2-40B4-BE49-F238E27FC236}">
+                <a16:creationId xmlns:a16="http://schemas.microsoft.com/office/drawing/2014/main" id="{8828E0D5-0F7B-4A3B-8EBD-AE87143F7E13}"/>
+              </a:ext>
+            </a:extLst>
+          </p:cNvPr>
+          <p:cNvSpPr>
+            <a:spLocks xmlns:a="http://schemas.openxmlformats.org/drawingml/2006/main" noGrp="1"/>
+          </p:cNvSpPr>
+          <p:nvPr/>
+        </p:nvSpPr>
+        <p:spPr>
+          <a:xfrm xmlns:a="http://schemas.openxmlformats.org/drawingml/2006/main">
+            <a:off x="571500" y="4962525"/>
+            <a:ext cx="10953750" cy="742950"/>
           </a:xfrm>
           <a:prstGeom xmlns:a="http://schemas.openxmlformats.org/drawingml/2006/main" prst="rect">
             <a:avLst/>
@@ -2301,7 +2724,7 @@
                 <a:ea typeface="Arial"/>
                 <a:cs typeface="Arial"/>
               </a:rPr>
-              <a:t>TF-IDF: Term Frequency–</a:t>
+              <a:t>TF: repetition within a program. IDF: less weight for widespread patterns.</a:t>
             </a:r>
           </a:p>
           <a:p xmlns:a="http://schemas.openxmlformats.org/drawingml/2006/main">
@@ -2324,63 +2747,17 @@
                 <a:ea typeface="Arial"/>
                 <a:cs typeface="Arial"/>
               </a:rPr>
-              <a:t>Inverse Document Frequency</a:t>
-            </a:r>
-          </a:p>
-          <a:p xmlns:a="http://schemas.openxmlformats.org/drawingml/2006/main">
-            <a:pPr>
-              <a:defRPr sz="1950" b="0">
-                <a:solidFill>
-                  <a:srgbClr val="152E38"/>
-                </a:solidFill>
-                <a:latin typeface="Arial"/>
-                <a:ea typeface="Arial"/>
-                <a:cs typeface="Arial"/>
-              </a:defRPr>
-            </a:pPr>
-            <a:r>
-              <a:rPr sz="1950" b="0">
-                <a:solidFill>
-                  <a:srgbClr val="152E38"/>
-                </a:solidFill>
-                <a:latin typeface="Arial"/>
-                <a:ea typeface="Arial"/>
-                <a:cs typeface="Arial"/>
-              </a:rPr>
-              <a:t>50,000 patterns of 3–5 characters</a:t>
-            </a:r>
-          </a:p>
-          <a:p xmlns:a="http://schemas.openxmlformats.org/drawingml/2006/main">
-            <a:pPr>
-              <a:defRPr sz="1950" b="0">
-                <a:solidFill>
-                  <a:srgbClr val="152E38"/>
-                </a:solidFill>
-                <a:latin typeface="Arial"/>
-                <a:ea typeface="Arial"/>
-                <a:cs typeface="Arial"/>
-              </a:defRPr>
-            </a:pPr>
-            <a:r>
-              <a:rPr sz="1950" b="0">
-                <a:solidFill>
-                  <a:srgbClr val="152E38"/>
-                </a:solidFill>
-                <a:latin typeface="Arial"/>
-                <a:ea typeface="Arial"/>
-                <a:cs typeface="Arial"/>
-              </a:rPr>
-              <a:t>Fit using training code only</a:t>
+              <a:t>Fit vocabulary and IDF on training only; transform validation and test.</a:t>
             </a:r>
           </a:p>
         </p:txBody>
       </p:sp>
       <p:sp>
         <p:nvSpPr>
-          <p:cNvPr id="4" name="">
+          <p:cNvPr id="6" name="">
             <a:extLst xmlns:a="http://schemas.openxmlformats.org/drawingml/2006/main">
               <a:ext uri="{FF2B5EF4-FFF2-40B4-BE49-F238E27FC236}">
-                <a16:creationId xmlns:a16="http://schemas.microsoft.com/office/drawing/2014/main" id="{AE582A62-1AEE-4FC0-9CFB-BF71E8906630}"/>
+                <a16:creationId xmlns:a16="http://schemas.microsoft.com/office/drawing/2014/main" id="{36F9D14E-75A9-4EA5-B806-7DE16B2E0057}"/>
               </a:ext>
             </a:extLst>
           </p:cNvPr>
@@ -2391,8 +2768,8 @@
         </p:nvSpPr>
         <p:spPr>
           <a:xfrm xmlns:a="http://schemas.openxmlformats.org/drawingml/2006/main">
-            <a:off x="6858000" y="3333750"/>
-            <a:ext cx="4762500" cy="1190625"/>
+            <a:off x="571500" y="5905500"/>
+            <a:ext cx="11049000" cy="666750"/>
           </a:xfrm>
           <a:prstGeom xmlns:a="http://schemas.openxmlformats.org/drawingml/2006/main" prst="rect">
             <a:avLst/>
@@ -2409,9 +2786,9 @@
           <a:lstStyle xmlns:a="http://schemas.openxmlformats.org/drawingml/2006/main"/>
           <a:p xmlns:a="http://schemas.openxmlformats.org/drawingml/2006/main">
             <a:pPr>
-              <a:defRPr sz="2100" b="0">
-                <a:solidFill>
-                  <a:srgbClr val="152E38"/>
+              <a:defRPr sz="1800" b="0">
+                <a:solidFill>
+                  <a:srgbClr val="50636B"/>
                 </a:solidFill>
                 <a:latin typeface="Arial"/>
                 <a:ea typeface="Arial"/>
@@ -2419,22 +2796,22 @@
               </a:defRPr>
             </a:pPr>
             <a:r>
-              <a:rPr sz="2100" b="0">
-                <a:solidFill>
-                  <a:srgbClr val="152E38"/>
+              <a:rPr sz="1800" b="0">
+                <a:solidFill>
+                  <a:srgbClr val="50636B"/>
                 </a:solidFill>
                 <a:latin typeface="Arial"/>
                 <a:ea typeface="Arial"/>
                 <a:cs typeface="Arial"/>
               </a:rPr>
-              <a:t>0 empty programs</a:t>
+              <a:t>259 inferred task groups stay together. No exact code/prompt overlap.</a:t>
             </a:r>
           </a:p>
           <a:p xmlns:a="http://schemas.openxmlformats.org/drawingml/2006/main">
             <a:pPr>
-              <a:defRPr sz="2100" b="0">
-                <a:solidFill>
-                  <a:srgbClr val="152E38"/>
+              <a:defRPr sz="1800" b="0">
+                <a:solidFill>
+                  <a:srgbClr val="50636B"/>
                 </a:solidFill>
                 <a:latin typeface="Arial"/>
                 <a:ea typeface="Arial"/>
@@ -2442,175 +2819,15 @@
               </a:defRPr>
             </a:pPr>
             <a:r>
-              <a:rPr sz="2100" b="0">
-                <a:solidFill>
-                  <a:srgbClr val="152E38"/>
+              <a:rPr sz="1800" b="0">
+                <a:solidFill>
+                  <a:srgbClr val="50636B"/>
                 </a:solidFill>
                 <a:latin typeface="Arial"/>
                 <a:ea typeface="Arial"/>
                 <a:cs typeface="Arial"/>
               </a:rPr>
-              <a:t>0 exact source duplicates</a:t>
-            </a:r>
-          </a:p>
-          <a:p xmlns:a="http://schemas.openxmlformats.org/drawingml/2006/main">
-            <a:pPr>
-              <a:defRPr sz="2100" b="0">
-                <a:solidFill>
-                  <a:srgbClr val="152E38"/>
-                </a:solidFill>
-                <a:latin typeface="Arial"/>
-                <a:ea typeface="Arial"/>
-                <a:cs typeface="Arial"/>
-              </a:defRPr>
-            </a:pPr>
-            <a:r>
-              <a:rPr sz="2100" b="0">
-                <a:solidFill>
-                  <a:srgbClr val="152E38"/>
-                </a:solidFill>
-                <a:latin typeface="Arial"/>
-                <a:ea typeface="Arial"/>
-                <a:cs typeface="Arial"/>
-              </a:rPr>
-              <a:t>Five labels in every split</a:t>
-            </a:r>
-          </a:p>
-        </p:txBody>
-      </p:sp>
-      <p:sp>
-        <p:nvSpPr>
-          <p:cNvPr id="5" name="">
-            <a:extLst xmlns:a="http://schemas.openxmlformats.org/drawingml/2006/main">
-              <a:ext uri="{FF2B5EF4-FFF2-40B4-BE49-F238E27FC236}">
-                <a16:creationId xmlns:a16="http://schemas.microsoft.com/office/drawing/2014/main" id="{0318A40D-BC49-4B36-BD86-C448713A06B0}"/>
-              </a:ext>
-            </a:extLst>
-          </p:cNvPr>
-          <p:cNvSpPr>
-            <a:spLocks xmlns:a="http://schemas.openxmlformats.org/drawingml/2006/main" noGrp="1"/>
-          </p:cNvSpPr>
-          <p:nvPr/>
-        </p:nvSpPr>
-        <p:spPr>
-          <a:xfrm xmlns:a="http://schemas.openxmlformats.org/drawingml/2006/main">
-            <a:off x="571500" y="4762500"/>
-            <a:ext cx="10953750" cy="885825"/>
-          </a:xfrm>
-          <a:prstGeom xmlns:a="http://schemas.openxmlformats.org/drawingml/2006/main" prst="rect">
-            <a:avLst/>
-          </a:prstGeom>
-          <a:noFill xmlns:a="http://schemas.openxmlformats.org/drawingml/2006/main"/>
-          <a:ln xmlns:a="http://schemas.openxmlformats.org/drawingml/2006/main" w="0">
-            <a:noFill/>
-          </a:ln>
-        </p:spPr>
-        <p:txBody>
-          <a:bodyPr xmlns:a="http://schemas.openxmlformats.org/drawingml/2006/main" lIns="0" tIns="0" rIns="0" bIns="0">
-            <a:noAutofit/>
-          </a:bodyPr>
-          <a:lstStyle xmlns:a="http://schemas.openxmlformats.org/drawingml/2006/main"/>
-          <a:p xmlns:a="http://schemas.openxmlformats.org/drawingml/2006/main">
-            <a:pPr>
-              <a:defRPr sz="2100" b="0">
-                <a:solidFill>
-                  <a:srgbClr val="152E38"/>
-                </a:solidFill>
-                <a:latin typeface="Arial"/>
-                <a:ea typeface="Arial"/>
-                <a:cs typeface="Arial"/>
-              </a:defRPr>
-            </a:pPr>
-            <a:r>
-              <a:rPr sz="2100" b="0">
-                <a:solidFill>
-                  <a:srgbClr val="152E38"/>
-                </a:solidFill>
-                <a:latin typeface="Arial"/>
-                <a:ea typeface="Arial"/>
-                <a:cs typeface="Arial"/>
-              </a:rPr>
-              <a:t>Saved groups keep related prompt variants together.</a:t>
-            </a:r>
-          </a:p>
-          <a:p xmlns:a="http://schemas.openxmlformats.org/drawingml/2006/main">
-            <a:pPr>
-              <a:defRPr sz="2100" b="0">
-                <a:solidFill>
-                  <a:srgbClr val="152E38"/>
-                </a:solidFill>
-                <a:latin typeface="Arial"/>
-                <a:ea typeface="Arial"/>
-                <a:cs typeface="Arial"/>
-              </a:defRPr>
-            </a:pPr>
-            <a:r>
-              <a:rPr sz="2100" b="0">
-                <a:solidFill>
-                  <a:srgbClr val="152E38"/>
-                </a:solidFill>
-                <a:latin typeface="Arial"/>
-                <a:ea typeface="Arial"/>
-                <a:cs typeface="Arial"/>
-              </a:rPr>
-              <a:t>No shared group, exact prompt or source hash across splits.</a:t>
-            </a:r>
-          </a:p>
-        </p:txBody>
-      </p:sp>
-      <p:sp>
-        <p:nvSpPr>
-          <p:cNvPr id="6" name="">
-            <a:extLst xmlns:a="http://schemas.openxmlformats.org/drawingml/2006/main">
-              <a:ext uri="{FF2B5EF4-FFF2-40B4-BE49-F238E27FC236}">
-                <a16:creationId xmlns:a16="http://schemas.microsoft.com/office/drawing/2014/main" id="{884624D7-EAF3-4717-8401-5E449868CF8C}"/>
-              </a:ext>
-            </a:extLst>
-          </p:cNvPr>
-          <p:cNvSpPr>
-            <a:spLocks xmlns:a="http://schemas.openxmlformats.org/drawingml/2006/main" noGrp="1"/>
-          </p:cNvSpPr>
-          <p:nvPr/>
-        </p:nvSpPr>
-        <p:spPr>
-          <a:xfrm xmlns:a="http://schemas.openxmlformats.org/drawingml/2006/main">
-            <a:off x="571500" y="5972175"/>
-            <a:ext cx="10953750" cy="342900"/>
-          </a:xfrm>
-          <a:prstGeom xmlns:a="http://schemas.openxmlformats.org/drawingml/2006/main" prst="rect">
-            <a:avLst/>
-          </a:prstGeom>
-          <a:noFill xmlns:a="http://schemas.openxmlformats.org/drawingml/2006/main"/>
-          <a:ln xmlns:a="http://schemas.openxmlformats.org/drawingml/2006/main" w="0">
-            <a:noFill/>
-          </a:ln>
-        </p:spPr>
-        <p:txBody>
-          <a:bodyPr xmlns:a="http://schemas.openxmlformats.org/drawingml/2006/main" lIns="0" tIns="0" rIns="0" bIns="0">
-            <a:noAutofit/>
-          </a:bodyPr>
-          <a:lstStyle xmlns:a="http://schemas.openxmlformats.org/drawingml/2006/main"/>
-          <a:p xmlns:a="http://schemas.openxmlformats.org/drawingml/2006/main">
-            <a:pPr>
-              <a:defRPr sz="1875" b="0">
-                <a:solidFill>
-                  <a:srgbClr val="50636B"/>
-                </a:solidFill>
-                <a:latin typeface="Arial"/>
-                <a:ea typeface="Arial"/>
-                <a:cs typeface="Arial"/>
-              </a:defRPr>
-            </a:pPr>
-            <a:r>
-              <a:rPr sz="1875" b="0">
-                <a:solidFill>
-                  <a:srgbClr val="50636B"/>
-                </a:solidFill>
-                <a:latin typeface="Arial"/>
-                <a:ea typeface="Arial"/>
-                <a:cs typeface="Arial"/>
-              </a:rPr>
-              <a:t>Groups are inferred. Some semantic overlap may remain.</a:t>
+              <a:t>No empty programs or exact duplicates. Semantic overlap may remain.</a:t>
             </a:r>
           </a:p>
         </p:txBody>
@@ -2618,7 +2835,7 @@
     </p:spTree>
     <p:extLst>
       <p:ext uri="{BB962C8B-B14F-4D97-AF65-F5344CB8AC3E}">
-        <p14:creationId xmlns:p14="http://schemas.microsoft.com/office/powerpoint/2010/main" val="541353998"/>
+        <p14:creationId xmlns:p14="http://schemas.microsoft.com/office/powerpoint/2010/main" val="371595411"/>
       </p:ext>
     </p:extLst>
   </p:cSld>
@@ -2646,10 +2863,10 @@
       </p:grpSpPr>
       <p:sp>
         <p:nvSpPr>
-          <p:cNvPr id="9" name="">
+          <p:cNvPr id="6" name="">
             <a:extLst xmlns:a="http://schemas.openxmlformats.org/drawingml/2006/main">
               <a:ext uri="{FF2B5EF4-FFF2-40B4-BE49-F238E27FC236}">
-                <a16:creationId xmlns:a16="http://schemas.microsoft.com/office/drawing/2014/main" id="{0BDA73A7-37E6-4DC5-A42F-55D6A2DDC910}"/>
+                <a16:creationId xmlns:a16="http://schemas.microsoft.com/office/drawing/2014/main" id="{EC79DB08-0376-4161-A63C-9EF54AC634BE}"/>
               </a:ext>
             </a:extLst>
           </p:cNvPr>
@@ -2696,17 +2913,397 @@
                 <a:ea typeface="Arial"/>
                 <a:cs typeface="Arial"/>
               </a:rPr>
-              <a:t>Experiment 1: how Linear SVM learns</a:t>
+              <a:t>Model choices: baseline, linear, trees and transfer</a:t>
             </a:r>
           </a:p>
         </p:txBody>
       </p:sp>
+      <p:graphicFrame>
+        <p:nvGraphicFramePr>
+          <p:cNvPr id="7" name=""/>
+          <p:cNvGraphicFramePr/>
+          <p:nvPr/>
+        </p:nvGraphicFramePr>
+        <p:xfrm>
+          <a:off xmlns:a="http://schemas.openxmlformats.org/drawingml/2006/main" x="571500" y="1314450"/>
+          <a:ext xmlns:a="http://schemas.openxmlformats.org/drawingml/2006/main" cx="11049000" cy="2809875"/>
+        </p:xfrm>
+        <a:graphic xmlns:a="http://schemas.openxmlformats.org/drawingml/2006/main">
+          <a:graphicData uri="http://schemas.openxmlformats.org/drawingml/2006/table">
+            <a:tbl>
+              <a:tblPr/>
+              <a:tblGrid>
+                <a:gridCol w="3048000"/>
+                <a:gridCol w="8001000"/>
+              </a:tblGrid>
+              <a:tr h="468313">
+                <a:tc>
+                  <a:txBody>
+                    <a:bodyPr>
+                      <a:noAutofit/>
+                    </a:bodyPr>
+                    <a:lstStyle/>
+                    <a:p>
+                      <a:pPr algn="l"/>
+                      <a:r>
+                        <a:rPr sz="1800" b="1">
+                          <a:solidFill>
+                            <a:srgbClr val="FFFFFF"/>
+                          </a:solidFill>
+                          <a:latin typeface="Arial"/>
+                          <a:ea typeface="Arial"/>
+                          <a:cs typeface="Arial"/>
+                        </a:rPr>
+                        <a:t>Model</a:t>
+                      </a:r>
+                    </a:p>
+                  </a:txBody>
+                  <a:tcPr marL="91440" marR="91440" marT="45720" marB="45720">
+                    <a:solidFill>
+                      <a:srgbClr val="152E38"/>
+                    </a:solidFill>
+                  </a:tcPr>
+                </a:tc>
+                <a:tc>
+                  <a:txBody>
+                    <a:bodyPr>
+                      <a:noAutofit/>
+                    </a:bodyPr>
+                    <a:lstStyle/>
+                    <a:p>
+                      <a:pPr algn="ctr"/>
+                      <a:r>
+                        <a:rPr sz="1800" b="1">
+                          <a:solidFill>
+                            <a:srgbClr val="FFFFFF"/>
+                          </a:solidFill>
+                          <a:latin typeface="Arial"/>
+                          <a:ea typeface="Arial"/>
+                          <a:cs typeface="Arial"/>
+                        </a:rPr>
+                        <a:t>Why include it?</a:t>
+                      </a:r>
+                    </a:p>
+                  </a:txBody>
+                  <a:tcPr marL="91440" marR="91440" marT="45720" marB="45720">
+                    <a:solidFill>
+                      <a:srgbClr val="152E38"/>
+                    </a:solidFill>
+                  </a:tcPr>
+                </a:tc>
+              </a:tr>
+              <a:tr h="468313">
+                <a:tc>
+                  <a:txBody>
+                    <a:bodyPr>
+                      <a:noAutofit/>
+                    </a:bodyPr>
+                    <a:lstStyle/>
+                    <a:p>
+                      <a:pPr algn="l"/>
+                      <a:r>
+                        <a:rPr sz="1875" b="0">
+                          <a:solidFill>
+                            <a:srgbClr val="152E38"/>
+                          </a:solidFill>
+                          <a:latin typeface="Arial"/>
+                          <a:ea typeface="Arial"/>
+                          <a:cs typeface="Arial"/>
+                        </a:rPr>
+                        <a:t>Naive Bayes</a:t>
+                      </a:r>
+                    </a:p>
+                  </a:txBody>
+                  <a:tcPr marL="91440" marR="91440" marT="45720" marB="45720">
+                    <a:solidFill>
+                      <a:srgbClr val="FFFFFF"/>
+                    </a:solidFill>
+                  </a:tcPr>
+                </a:tc>
+                <a:tc>
+                  <a:txBody>
+                    <a:bodyPr>
+                      <a:noAutofit/>
+                    </a:bodyPr>
+                    <a:lstStyle/>
+                    <a:p>
+                      <a:pPr algn="ctr"/>
+                      <a:r>
+                        <a:rPr sz="1875" b="0">
+                          <a:solidFill>
+                            <a:srgbClr val="152E38"/>
+                          </a:solidFill>
+                          <a:latin typeface="Arial"/>
+                          <a:ea typeface="Arial"/>
+                          <a:cs typeface="Arial"/>
+                        </a:rPr>
+                        <a:t>Simple probabilistic baseline</a:t>
+                      </a:r>
+                    </a:p>
+                  </a:txBody>
+                  <a:tcPr marL="91440" marR="91440" marT="45720" marB="45720">
+                    <a:solidFill>
+                      <a:srgbClr val="FFFFFF"/>
+                    </a:solidFill>
+                  </a:tcPr>
+                </a:tc>
+              </a:tr>
+              <a:tr h="468313">
+                <a:tc>
+                  <a:txBody>
+                    <a:bodyPr>
+                      <a:noAutofit/>
+                    </a:bodyPr>
+                    <a:lstStyle/>
+                    <a:p>
+                      <a:pPr algn="l"/>
+                      <a:r>
+                        <a:rPr sz="1875" b="0">
+                          <a:solidFill>
+                            <a:srgbClr val="152E38"/>
+                          </a:solidFill>
+                          <a:latin typeface="Arial"/>
+                          <a:ea typeface="Arial"/>
+                          <a:cs typeface="Arial"/>
+                        </a:rPr>
+                        <a:t>Logistic Regression</a:t>
+                      </a:r>
+                    </a:p>
+                  </a:txBody>
+                  <a:tcPr marL="91440" marR="91440" marT="45720" marB="45720">
+                    <a:solidFill>
+                      <a:srgbClr val="FFFFFF"/>
+                    </a:solidFill>
+                  </a:tcPr>
+                </a:tc>
+                <a:tc>
+                  <a:txBody>
+                    <a:bodyPr>
+                      <a:noAutofit/>
+                    </a:bodyPr>
+                    <a:lstStyle/>
+                    <a:p>
+                      <a:pPr algn="ctr"/>
+                      <a:r>
+                        <a:rPr sz="1875" b="0">
+                          <a:solidFill>
+                            <a:srgbClr val="152E38"/>
+                          </a:solidFill>
+                          <a:latin typeface="Arial"/>
+                          <a:ea typeface="Arial"/>
+                          <a:cs typeface="Arial"/>
+                        </a:rPr>
+                        <a:t>Linear probability model</a:t>
+                      </a:r>
+                    </a:p>
+                  </a:txBody>
+                  <a:tcPr marL="91440" marR="91440" marT="45720" marB="45720">
+                    <a:solidFill>
+                      <a:srgbClr val="FFFFFF"/>
+                    </a:solidFill>
+                  </a:tcPr>
+                </a:tc>
+              </a:tr>
+              <a:tr h="468313">
+                <a:tc>
+                  <a:txBody>
+                    <a:bodyPr>
+                      <a:noAutofit/>
+                    </a:bodyPr>
+                    <a:lstStyle/>
+                    <a:p>
+                      <a:pPr algn="l"/>
+                      <a:r>
+                        <a:rPr sz="1875" b="0">
+                          <a:solidFill>
+                            <a:srgbClr val="152E38"/>
+                          </a:solidFill>
+                          <a:latin typeface="Arial"/>
+                          <a:ea typeface="Arial"/>
+                          <a:cs typeface="Arial"/>
+                        </a:rPr>
+                        <a:t>Linear SVM</a:t>
+                      </a:r>
+                    </a:p>
+                  </a:txBody>
+                  <a:tcPr marL="91440" marR="91440" marT="45720" marB="45720">
+                    <a:solidFill>
+                      <a:srgbClr val="FFFFFF"/>
+                    </a:solidFill>
+                  </a:tcPr>
+                </a:tc>
+                <a:tc>
+                  <a:txBody>
+                    <a:bodyPr>
+                      <a:noAutofit/>
+                    </a:bodyPr>
+                    <a:lstStyle/>
+                    <a:p>
+                      <a:pPr algn="ctr"/>
+                      <a:r>
+                        <a:rPr sz="1875" b="0">
+                          <a:solidFill>
+                            <a:srgbClr val="152E38"/>
+                          </a:solidFill>
+                          <a:latin typeface="Arial"/>
+                          <a:ea typeface="Arial"/>
+                          <a:cs typeface="Arial"/>
+                        </a:rPr>
+                        <a:t>Linear margin model; different training objective</a:t>
+                      </a:r>
+                    </a:p>
+                  </a:txBody>
+                  <a:tcPr marL="91440" marR="91440" marT="45720" marB="45720">
+                    <a:solidFill>
+                      <a:srgbClr val="FFFFFF"/>
+                    </a:solidFill>
+                  </a:tcPr>
+                </a:tc>
+              </a:tr>
+              <a:tr h="468313">
+                <a:tc>
+                  <a:txBody>
+                    <a:bodyPr>
+                      <a:noAutofit/>
+                    </a:bodyPr>
+                    <a:lstStyle/>
+                    <a:p>
+                      <a:pPr algn="l"/>
+                      <a:r>
+                        <a:rPr sz="1875" b="0">
+                          <a:solidFill>
+                            <a:srgbClr val="152E38"/>
+                          </a:solidFill>
+                          <a:latin typeface="Arial"/>
+                          <a:ea typeface="Arial"/>
+                          <a:cs typeface="Arial"/>
+                        </a:rPr>
+                        <a:t>Random Forest</a:t>
+                      </a:r>
+                    </a:p>
+                  </a:txBody>
+                  <a:tcPr marL="91440" marR="91440" marT="45720" marB="45720">
+                    <a:solidFill>
+                      <a:srgbClr val="FFFFFF"/>
+                    </a:solidFill>
+                  </a:tcPr>
+                </a:tc>
+                <a:tc>
+                  <a:txBody>
+                    <a:bodyPr>
+                      <a:noAutofit/>
+                    </a:bodyPr>
+                    <a:lstStyle/>
+                    <a:p>
+                      <a:pPr algn="ctr"/>
+                      <a:r>
+                        <a:rPr sz="1875" b="0">
+                          <a:solidFill>
+                            <a:srgbClr val="152E38"/>
+                          </a:solidFill>
+                          <a:latin typeface="Arial"/>
+                          <a:ea typeface="Arial"/>
+                          <a:cs typeface="Arial"/>
+                        </a:rPr>
+                        <a:t>Nonlinear ensemble of 150 decision trees</a:t>
+                      </a:r>
+                    </a:p>
+                  </a:txBody>
+                  <a:tcPr marL="91440" marR="91440" marT="45720" marB="45720">
+                    <a:solidFill>
+                      <a:srgbClr val="FFFFFF"/>
+                    </a:solidFill>
+                  </a:tcPr>
+                </a:tc>
+              </a:tr>
+              <a:tr h="468313">
+                <a:tc>
+                  <a:txBody>
+                    <a:bodyPr>
+                      <a:noAutofit/>
+                    </a:bodyPr>
+                    <a:lstStyle/>
+                    <a:p>
+                      <a:pPr algn="l"/>
+                      <a:r>
+                        <a:rPr sz="1875" b="0">
+                          <a:solidFill>
+                            <a:srgbClr val="152E38"/>
+                          </a:solidFill>
+                          <a:latin typeface="Arial"/>
+                          <a:ea typeface="Arial"/>
+                          <a:cs typeface="Arial"/>
+                        </a:rPr>
+                        <a:t>CodeT5 encoder</a:t>
+                      </a:r>
+                    </a:p>
+                  </a:txBody>
+                  <a:tcPr marL="91440" marR="91440" marT="45720" marB="45720">
+                    <a:solidFill>
+                      <a:srgbClr val="FFFFFF"/>
+                    </a:solidFill>
+                  </a:tcPr>
+                </a:tc>
+                <a:tc>
+                  <a:txBody>
+                    <a:bodyPr>
+                      <a:noAutofit/>
+                    </a:bodyPr>
+                    <a:lstStyle/>
+                    <a:p>
+                      <a:pPr algn="ctr"/>
+                      <a:r>
+                        <a:rPr sz="1875" b="0">
+                          <a:solidFill>
+                            <a:srgbClr val="152E38"/>
+                          </a:solidFill>
+                          <a:latin typeface="Arial"/>
+                          <a:ea typeface="Arial"/>
+                          <a:cs typeface="Arial"/>
+                        </a:rPr>
+                        <a:t>Pretrained code representation with a learned class head</a:t>
+                      </a:r>
+                    </a:p>
+                  </a:txBody>
+                  <a:tcPr marL="91440" marR="91440" marT="45720" marB="45720">
+                    <a:solidFill>
+                      <a:srgbClr val="FFFFFF"/>
+                    </a:solidFill>
+                  </a:tcPr>
+                </a:tc>
+              </a:tr>
+            </a:tbl>
+          </a:graphicData>
+        </a:graphic>
+      </p:graphicFrame>
+      <p:pic>
+        <p:nvPicPr>
+          <p:cNvPr id="8" name=""/>
+          <p:cNvPicPr>
+            <a:picLocks xmlns:a="http://schemas.openxmlformats.org/drawingml/2006/main" noChangeAspect="1"/>
+          </p:cNvPicPr>
+          <p:nvPr/>
+        </p:nvPicPr>
+        <p:blipFill>
+          <a:blip xmlns:r="http://schemas.openxmlformats.org/officeDocument/2006/relationships" xmlns:a="http://schemas.openxmlformats.org/drawingml/2006/main" r:embed="R73baf8e432f14494"/>
+          <a:stretch xmlns:a="http://schemas.openxmlformats.org/drawingml/2006/main"/>
+        </p:blipFill>
+        <p:spPr>
+          <a:xfrm xmlns:a="http://schemas.openxmlformats.org/drawingml/2006/main">
+            <a:off x="3117152" y="4314825"/>
+            <a:ext cx="5957695" cy="809625"/>
+          </a:xfrm>
+          <a:prstGeom xmlns:a="http://schemas.openxmlformats.org/drawingml/2006/main" prst="rect">
+            <a:avLst/>
+          </a:prstGeom>
+        </p:spPr>
+      </p:pic>
       <p:sp>
         <p:nvSpPr>
-          <p:cNvPr id="2" name="">
+          <p:cNvPr id="4" name="">
             <a:extLst xmlns:a="http://schemas.openxmlformats.org/drawingml/2006/main">
               <a:ext uri="{FF2B5EF4-FFF2-40B4-BE49-F238E27FC236}">
-                <a16:creationId xmlns:a16="http://schemas.microsoft.com/office/drawing/2014/main" id="{BFA92117-0B84-47A5-86B8-99E6FE6A64FB}"/>
+                <a16:creationId xmlns:a16="http://schemas.microsoft.com/office/drawing/2014/main" id="{16C926EA-3DF5-4AD1-B6E4-362BFB6A2DE8}"/>
               </a:ext>
             </a:extLst>
           </p:cNvPr>
@@ -2717,8 +3314,8 @@
         </p:nvSpPr>
         <p:spPr>
           <a:xfrm xmlns:a="http://schemas.openxmlformats.org/drawingml/2006/main">
-            <a:off x="571500" y="1304925"/>
-            <a:ext cx="11049000" cy="762000"/>
+            <a:off x="571500" y="5248275"/>
+            <a:ext cx="11049000" cy="723900"/>
           </a:xfrm>
           <a:prstGeom xmlns:a="http://schemas.openxmlformats.org/drawingml/2006/main" prst="rect">
             <a:avLst/>
@@ -2753,7 +3350,7 @@
                 <a:ea typeface="Arial"/>
                 <a:cs typeface="Arial"/>
               </a:rPr>
-              <a:t>Naive Bayes: baseline    Logistic Regression: linear probability model</a:t>
+              <a:t>SVM: x = TF-IDF features, w = learned weights, b = offset.</a:t>
             </a:r>
           </a:p>
           <a:p xmlns:a="http://schemas.openxmlformats.org/drawingml/2006/main">
@@ -2776,39 +3373,17 @@
                 <a:ea typeface="Arial"/>
                 <a:cs typeface="Arial"/>
               </a:rPr>
-              <a:t>Support Vector Machine: linear margin model    Random Forest: trees</a:t>
+              <a:t>Train one author against the rest; predict the largest of five scores.</a:t>
             </a:r>
           </a:p>
         </p:txBody>
       </p:sp>
-      <p:pic>
-        <p:nvPicPr>
-          <p:cNvPr id="11" name=""/>
-          <p:cNvPicPr>
-            <a:picLocks xmlns:a="http://schemas.openxmlformats.org/drawingml/2006/main" noChangeAspect="1"/>
-          </p:cNvPicPr>
-          <p:nvPr/>
-        </p:nvPicPr>
-        <p:blipFill>
-          <a:blip xmlns:r="http://schemas.openxmlformats.org/officeDocument/2006/relationships" xmlns:a="http://schemas.openxmlformats.org/drawingml/2006/main" r:embed="R235c806c50594b70"/>
-          <a:stretch xmlns:a="http://schemas.openxmlformats.org/drawingml/2006/main"/>
-        </p:blipFill>
-        <p:spPr>
-          <a:xfrm xmlns:a="http://schemas.openxmlformats.org/drawingml/2006/main">
-            <a:off x="2941926" y="2019300"/>
-            <a:ext cx="6308148" cy="857250"/>
-          </a:xfrm>
-          <a:prstGeom xmlns:a="http://schemas.openxmlformats.org/drawingml/2006/main" prst="rect">
-            <a:avLst/>
-          </a:prstGeom>
-        </p:spPr>
-      </p:pic>
       <p:sp>
         <p:nvSpPr>
-          <p:cNvPr id="4" name="">
+          <p:cNvPr id="5" name="">
             <a:extLst xmlns:a="http://schemas.openxmlformats.org/drawingml/2006/main">
               <a:ext uri="{FF2B5EF4-FFF2-40B4-BE49-F238E27FC236}">
-                <a16:creationId xmlns:a16="http://schemas.microsoft.com/office/drawing/2014/main" id="{BBBCF113-E955-4745-BCCF-33C9EF729177}"/>
+                <a16:creationId xmlns:a16="http://schemas.microsoft.com/office/drawing/2014/main" id="{D4AC67B0-8C2D-4F56-A0B0-C46FC63DE428}"/>
               </a:ext>
             </a:extLst>
           </p:cNvPr>
@@ -2819,8 +3394,8 @@
         </p:nvSpPr>
         <p:spPr>
           <a:xfrm xmlns:a="http://schemas.openxmlformats.org/drawingml/2006/main">
-            <a:off x="571500" y="2800350"/>
-            <a:ext cx="11049000" cy="361950"/>
+            <a:off x="571500" y="6038850"/>
+            <a:ext cx="11049000" cy="619125"/>
           </a:xfrm>
           <a:prstGeom xmlns:a="http://schemas.openxmlformats.org/drawingml/2006/main" prst="rect">
             <a:avLst/>
@@ -2837,9 +3412,9 @@
           <a:lstStyle xmlns:a="http://schemas.openxmlformats.org/drawingml/2006/main"/>
           <a:p xmlns:a="http://schemas.openxmlformats.org/drawingml/2006/main">
             <a:pPr>
-              <a:defRPr sz="1875" b="0">
-                <a:solidFill>
-                  <a:srgbClr val="152E38"/>
+              <a:defRPr sz="1725" b="0">
+                <a:solidFill>
+                  <a:srgbClr val="117C83"/>
                 </a:solidFill>
                 <a:latin typeface="Arial"/>
                 <a:ea typeface="Arial"/>
@@ -2847,101 +3422,22 @@
               </a:defRPr>
             </a:pPr>
             <a:r>
-              <a:rPr sz="1875" b="0">
-                <a:solidFill>
-                  <a:srgbClr val="152E38"/>
+              <a:rPr sz="1725" b="0">
+                <a:solidFill>
+                  <a:srgbClr val="117C83"/>
                 </a:solidFill>
                 <a:latin typeface="Arial"/>
                 <a:ea typeface="Arial"/>
                 <a:cs typeface="Arial"/>
               </a:rPr>
-              <a:t>Train five one-vs-rest classifiers. Predict the class with the largest score.</a:t>
-            </a:r>
-          </a:p>
-        </p:txBody>
-      </p:sp>
-      <p:pic>
-        <p:nvPicPr>
-          <p:cNvPr id="13" name=""/>
-          <p:cNvPicPr>
-            <a:picLocks xmlns:a="http://schemas.openxmlformats.org/drawingml/2006/main" noChangeAspect="1"/>
-          </p:cNvPicPr>
-          <p:nvPr/>
-        </p:nvPicPr>
-        <p:blipFill>
-          <a:blip xmlns:r="http://schemas.openxmlformats.org/officeDocument/2006/relationships" xmlns:a="http://schemas.openxmlformats.org/drawingml/2006/main" r:embed="Rbdaafcfd9c8e4af1"/>
-          <a:stretch xmlns:a="http://schemas.openxmlformats.org/drawingml/2006/main"/>
-        </p:blipFill>
-        <p:spPr>
-          <a:xfrm xmlns:a="http://schemas.openxmlformats.org/drawingml/2006/main">
-            <a:off x="1865344" y="3200400"/>
-            <a:ext cx="8461312" cy="1047750"/>
-          </a:xfrm>
-          <a:prstGeom xmlns:a="http://schemas.openxmlformats.org/drawingml/2006/main" prst="rect">
-            <a:avLst/>
-          </a:prstGeom>
-        </p:spPr>
-      </p:pic>
-      <p:sp>
-        <p:nvSpPr>
-          <p:cNvPr id="6" name="">
-            <a:extLst xmlns:a="http://schemas.openxmlformats.org/drawingml/2006/main">
-              <a:ext uri="{FF2B5EF4-FFF2-40B4-BE49-F238E27FC236}">
-                <a16:creationId xmlns:a16="http://schemas.microsoft.com/office/drawing/2014/main" id="{5D18A90E-DE6C-4C17-9ADC-D0FB828069C8}"/>
-              </a:ext>
-            </a:extLst>
-          </p:cNvPr>
-          <p:cNvSpPr>
-            <a:spLocks xmlns:a="http://schemas.openxmlformats.org/drawingml/2006/main" noGrp="1"/>
-          </p:cNvSpPr>
-          <p:nvPr/>
-        </p:nvSpPr>
-        <p:spPr>
-          <a:xfrm xmlns:a="http://schemas.openxmlformats.org/drawingml/2006/main">
-            <a:off x="571500" y="4171950"/>
-            <a:ext cx="11049000" cy="762000"/>
-          </a:xfrm>
-          <a:prstGeom xmlns:a="http://schemas.openxmlformats.org/drawingml/2006/main" prst="rect">
-            <a:avLst/>
-          </a:prstGeom>
-          <a:noFill xmlns:a="http://schemas.openxmlformats.org/drawingml/2006/main"/>
-          <a:ln xmlns:a="http://schemas.openxmlformats.org/drawingml/2006/main" w="0">
-            <a:noFill/>
-          </a:ln>
-        </p:spPr>
-        <p:txBody>
-          <a:bodyPr xmlns:a="http://schemas.openxmlformats.org/drawingml/2006/main" lIns="0" tIns="0" rIns="0" bIns="0">
-            <a:noAutofit/>
-          </a:bodyPr>
-          <a:lstStyle xmlns:a="http://schemas.openxmlformats.org/drawingml/2006/main"/>
-          <a:p xmlns:a="http://schemas.openxmlformats.org/drawingml/2006/main">
-            <a:pPr>
-              <a:defRPr sz="1950" b="0">
-                <a:solidFill>
-                  <a:srgbClr val="152E38"/>
-                </a:solidFill>
-                <a:latin typeface="Arial"/>
-                <a:ea typeface="Arial"/>
-                <a:cs typeface="Arial"/>
-              </a:defRPr>
-            </a:pPr>
-            <a:r>
-              <a:rPr sz="1950" b="0">
-                <a:solidFill>
-                  <a:srgbClr val="152E38"/>
-                </a:solidFill>
-                <a:latin typeface="Arial"/>
-                <a:ea typeface="Arial"/>
-                <a:cs typeface="Arial"/>
-              </a:rPr>
-              <a:t>x: TF-IDF weights     w: learned feature weights     b: learned offset</a:t>
+              <a:t>CodeT5: first 256 tokens, mean pooling, dropout and a five-class head.</a:t>
             </a:r>
           </a:p>
           <a:p xmlns:a="http://schemas.openxmlformats.org/drawingml/2006/main">
             <a:pPr>
-              <a:defRPr sz="1950" b="0">
-                <a:solidFill>
-                  <a:srgbClr val="152E38"/>
+              <a:defRPr sz="1725" b="0">
+                <a:solidFill>
+                  <a:srgbClr val="117C83"/>
                 </a:solidFill>
                 <a:latin typeface="Arial"/>
                 <a:ea typeface="Arial"/>
@@ -2949,152 +3445,15 @@
               </a:defRPr>
             </a:pPr>
             <a:r>
-              <a:rPr sz="1950" b="0">
-                <a:solidFill>
-                  <a:srgbClr val="152E38"/>
+              <a:rPr sz="1725" b="0">
+                <a:solidFill>
+                  <a:srgbClr val="117C83"/>
                 </a:solidFill>
                 <a:latin typeface="Arial"/>
                 <a:ea typeface="Arial"/>
                 <a:cs typeface="Arial"/>
               </a:rPr>
-              <a:t>yᵢ: +1 for this author, −1 for the others     C = 1 in our code</a:t>
-            </a:r>
-          </a:p>
-        </p:txBody>
-      </p:sp>
-      <p:sp>
-        <p:nvSpPr>
-          <p:cNvPr id="7" name="">
-            <a:extLst xmlns:a="http://schemas.openxmlformats.org/drawingml/2006/main">
-              <a:ext uri="{FF2B5EF4-FFF2-40B4-BE49-F238E27FC236}">
-                <a16:creationId xmlns:a16="http://schemas.microsoft.com/office/drawing/2014/main" id="{DFD7195C-005B-43B3-8A73-0F2E33FB4267}"/>
-              </a:ext>
-            </a:extLst>
-          </p:cNvPr>
-          <p:cNvSpPr>
-            <a:spLocks xmlns:a="http://schemas.openxmlformats.org/drawingml/2006/main" noGrp="1"/>
-          </p:cNvSpPr>
-          <p:nvPr/>
-        </p:nvSpPr>
-        <p:spPr>
-          <a:xfrm xmlns:a="http://schemas.openxmlformats.org/drawingml/2006/main">
-            <a:off x="571500" y="5286375"/>
-            <a:ext cx="11049000" cy="800100"/>
-          </a:xfrm>
-          <a:prstGeom xmlns:a="http://schemas.openxmlformats.org/drawingml/2006/main" prst="rect">
-            <a:avLst/>
-          </a:prstGeom>
-          <a:noFill xmlns:a="http://schemas.openxmlformats.org/drawingml/2006/main"/>
-          <a:ln xmlns:a="http://schemas.openxmlformats.org/drawingml/2006/main" w="0">
-            <a:noFill/>
-          </a:ln>
-        </p:spPr>
-        <p:txBody>
-          <a:bodyPr xmlns:a="http://schemas.openxmlformats.org/drawingml/2006/main" lIns="0" tIns="0" rIns="0" bIns="0">
-            <a:noAutofit/>
-          </a:bodyPr>
-          <a:lstStyle xmlns:a="http://schemas.openxmlformats.org/drawingml/2006/main"/>
-          <a:p xmlns:a="http://schemas.openxmlformats.org/drawingml/2006/main">
-            <a:pPr>
-              <a:defRPr sz="2100" b="0">
-                <a:solidFill>
-                  <a:srgbClr val="152E38"/>
-                </a:solidFill>
-                <a:latin typeface="Arial"/>
-                <a:ea typeface="Arial"/>
-                <a:cs typeface="Arial"/>
-              </a:defRPr>
-            </a:pPr>
-            <a:r>
-              <a:rPr sz="2100" b="0">
-                <a:solidFill>
-                  <a:srgbClr val="152E38"/>
-                </a:solidFill>
-                <a:latin typeface="Arial"/>
-                <a:ea typeface="Arial"/>
-                <a:cs typeface="Arial"/>
-              </a:rPr>
-              <a:t>First term limits weight size. The sum penalizes margin violations.</a:t>
-            </a:r>
-          </a:p>
-          <a:p xmlns:a="http://schemas.openxmlformats.org/drawingml/2006/main">
-            <a:pPr>
-              <a:defRPr sz="2100" b="0">
-                <a:solidFill>
-                  <a:srgbClr val="152E38"/>
-                </a:solidFill>
-                <a:latin typeface="Arial"/>
-                <a:ea typeface="Arial"/>
-                <a:cs typeface="Arial"/>
-              </a:defRPr>
-            </a:pPr>
-            <a:r>
-              <a:rPr sz="2100" b="0">
-                <a:solidFill>
-                  <a:srgbClr val="152E38"/>
-                </a:solidFill>
-                <a:latin typeface="Arial"/>
-                <a:ea typeface="Arial"/>
-                <a:cs typeface="Arial"/>
-              </a:rPr>
-              <a:t>Toy example: yᵢ f(xᵢ) = 0.6 gives loss (1 − 0.6)² = 0.16.</a:t>
-            </a:r>
-          </a:p>
-        </p:txBody>
-      </p:sp>
-      <p:sp>
-        <p:nvSpPr>
-          <p:cNvPr id="8" name="">
-            <a:extLst xmlns:a="http://schemas.openxmlformats.org/drawingml/2006/main">
-              <a:ext uri="{FF2B5EF4-FFF2-40B4-BE49-F238E27FC236}">
-                <a16:creationId xmlns:a16="http://schemas.microsoft.com/office/drawing/2014/main" id="{FFAB221B-8B1B-462D-9DCE-D1120A296D47}"/>
-              </a:ext>
-            </a:extLst>
-          </p:cNvPr>
-          <p:cNvSpPr>
-            <a:spLocks xmlns:a="http://schemas.openxmlformats.org/drawingml/2006/main" noGrp="1"/>
-          </p:cNvSpPr>
-          <p:nvPr/>
-        </p:nvSpPr>
-        <p:spPr>
-          <a:xfrm xmlns:a="http://schemas.openxmlformats.org/drawingml/2006/main">
-            <a:off x="571500" y="6276975"/>
-            <a:ext cx="11049000" cy="323850"/>
-          </a:xfrm>
-          <a:prstGeom xmlns:a="http://schemas.openxmlformats.org/drawingml/2006/main" prst="rect">
-            <a:avLst/>
-          </a:prstGeom>
-          <a:noFill xmlns:a="http://schemas.openxmlformats.org/drawingml/2006/main"/>
-          <a:ln xmlns:a="http://schemas.openxmlformats.org/drawingml/2006/main" w="0">
-            <a:noFill/>
-          </a:ln>
-        </p:spPr>
-        <p:txBody>
-          <a:bodyPr xmlns:a="http://schemas.openxmlformats.org/drawingml/2006/main" lIns="0" tIns="0" rIns="0" bIns="0">
-            <a:noAutofit/>
-          </a:bodyPr>
-          <a:lstStyle xmlns:a="http://schemas.openxmlformats.org/drawingml/2006/main"/>
-          <a:p xmlns:a="http://schemas.openxmlformats.org/drawingml/2006/main">
-            <a:pPr>
-              <a:defRPr sz="1650" b="0">
-                <a:solidFill>
-                  <a:srgbClr val="50636B"/>
-                </a:solidFill>
-                <a:latin typeface="Arial"/>
-                <a:ea typeface="Arial"/>
-                <a:cs typeface="Arial"/>
-              </a:defRPr>
-            </a:pPr>
-            <a:r>
-              <a:rPr sz="1650" b="0">
-                <a:solidFill>
-                  <a:srgbClr val="50636B"/>
-                </a:solidFill>
-                <a:latin typeface="Arial"/>
-                <a:ea typeface="Arial"/>
-                <a:cs typeface="Arial"/>
-              </a:rPr>
-              <a:t>LinearSVC uses squared-hinge loss and regularizes the intercept (scale = 1).</a:t>
+              <a:t>Five epochs on A100; validation selected epoch 3. Encoder and head fine-tuned.</a:t>
             </a:r>
           </a:p>
         </p:txBody>
@@ -3102,7 +3461,7 @@
     </p:spTree>
     <p:extLst>
       <p:ext uri="{BB962C8B-B14F-4D97-AF65-F5344CB8AC3E}">
-        <p14:creationId xmlns:p14="http://schemas.microsoft.com/office/powerpoint/2010/main" val="504161854"/>
+        <p14:creationId xmlns:p14="http://schemas.microsoft.com/office/powerpoint/2010/main" val="1116935472"/>
       </p:ext>
     </p:extLst>
   </p:cSld>
@@ -3133,7 +3492,7 @@
           <p:cNvPr id="7" name="">
             <a:extLst xmlns:a="http://schemas.openxmlformats.org/drawingml/2006/main">
               <a:ext uri="{FF2B5EF4-FFF2-40B4-BE49-F238E27FC236}">
-                <a16:creationId xmlns:a16="http://schemas.microsoft.com/office/drawing/2014/main" id="{BBAD6A95-BBD3-4D26-94E6-73FAC832B900}"/>
+                <a16:creationId xmlns:a16="http://schemas.microsoft.com/office/drawing/2014/main" id="{1EC03B84-EE9A-4B63-9250-0D38A6B55A5E}"/>
               </a:ext>
             </a:extLst>
           </p:cNvPr>
@@ -3180,7 +3539,7 @@
                 <a:ea typeface="Arial"/>
                 <a:cs typeface="Arial"/>
               </a:rPr>
-              <a:t>Five-model results: SVM remains best</a:t>
+              <a:t>SVM leads; CodeT5 places second</a:t>
             </a:r>
           </a:p>
         </p:txBody>
@@ -3192,8 +3551,8 @@
           <p:nvPr/>
         </p:nvGraphicFramePr>
         <p:xfrm>
-          <a:off xmlns:a="http://schemas.openxmlformats.org/drawingml/2006/main" x="476250" y="1466850"/>
-          <a:ext xmlns:a="http://schemas.openxmlformats.org/drawingml/2006/main" cx="6762750" cy="3143250"/>
+          <a:off xmlns:a="http://schemas.openxmlformats.org/drawingml/2006/main" x="476250" y="1362075"/>
+          <a:ext xmlns:a="http://schemas.openxmlformats.org/drawingml/2006/main" cx="6762750" cy="3095625"/>
         </p:xfrm>
         <a:graphic xmlns:a="http://schemas.openxmlformats.org/drawingml/2006/main">
           <a:graphicData uri="http://schemas.openxmlformats.org/drawingml/2006/table">
@@ -3206,7 +3565,7 @@
                 <a:gridCol w="952500"/>
                 <a:gridCol w="952500"/>
               </a:tblGrid>
-              <a:tr h="523875">
+              <a:tr h="515938">
                 <a:tc>
                   <a:txBody>
                     <a:bodyPr>
@@ -3332,7 +3691,7 @@
                           <a:ea typeface="Arial"/>
                           <a:cs typeface="Arial"/>
                         </a:rPr>
-                        <a:t>Size (MB)</a:t>
+                        <a:t>MB</a:t>
                       </a:r>
                     </a:p>
                   </a:txBody>
@@ -3343,7 +3702,7 @@
                   </a:tcPr>
                 </a:tc>
               </a:tr>
-              <a:tr h="523875">
+              <a:tr h="515938">
                 <a:tc>
                   <a:txBody>
                     <a:bodyPr>
@@ -3480,7 +3839,7 @@
                   </a:tcPr>
                 </a:tc>
               </a:tr>
-              <a:tr h="523875">
+              <a:tr h="515938">
                 <a:tc>
                   <a:txBody>
                     <a:bodyPr>
@@ -3617,7 +3976,7 @@
                   </a:tcPr>
                 </a:tc>
               </a:tr>
-              <a:tr h="523875">
+              <a:tr h="515938">
                 <a:tc>
                   <a:txBody>
                     <a:bodyPr>
@@ -3754,7 +4113,7 @@
                   </a:tcPr>
                 </a:tc>
               </a:tr>
-              <a:tr h="523875">
+              <a:tr h="515938">
                 <a:tc>
                   <a:txBody>
                     <a:bodyPr>
@@ -3891,7 +4250,7 @@
                   </a:tcPr>
                 </a:tc>
               </a:tr>
-              <a:tr h="523875">
+              <a:tr h="515938">
                 <a:tc>
                   <a:txBody>
                     <a:bodyPr>
@@ -4017,7 +4376,7 @@
                           <a:ea typeface="Arial"/>
                           <a:cs typeface="Arial"/>
                         </a:rPr>
-                        <a:t>438.5</a:t>
+                        <a:t>438.5*</a:t>
                       </a:r>
                     </a:p>
                   </a:txBody>
@@ -4041,35 +4400,13 @@
           <p:nvPr/>
         </p:nvPicPr>
         <p:blipFill>
-          <a:blip xmlns:r="http://schemas.openxmlformats.org/officeDocument/2006/relationships" xmlns:a="http://schemas.openxmlformats.org/drawingml/2006/main" r:embed="R5efc2898260e40a4"/>
+          <a:blip xmlns:r="http://schemas.openxmlformats.org/officeDocument/2006/relationships" xmlns:a="http://schemas.openxmlformats.org/drawingml/2006/main" r:embed="R86f8f581dd4940a4"/>
           <a:stretch xmlns:a="http://schemas.openxmlformats.org/drawingml/2006/main"/>
         </p:blipFill>
         <p:spPr>
           <a:xfrm xmlns:a="http://schemas.openxmlformats.org/drawingml/2006/main">
-            <a:off x="7410450" y="1333500"/>
+            <a:off x="7410450" y="1228725"/>
             <a:ext cx="4667250" cy="4667250"/>
-          </a:xfrm>
-          <a:prstGeom xmlns:a="http://schemas.openxmlformats.org/drawingml/2006/main" prst="rect">
-            <a:avLst/>
-          </a:prstGeom>
-        </p:spPr>
-      </p:pic>
-      <p:pic>
-        <p:nvPicPr>
-          <p:cNvPr id="10" name=""/>
-          <p:cNvPicPr>
-            <a:picLocks xmlns:a="http://schemas.openxmlformats.org/drawingml/2006/main" noChangeAspect="1"/>
-          </p:cNvPicPr>
-          <p:nvPr/>
-        </p:nvPicPr>
-        <p:blipFill>
-          <a:blip xmlns:r="http://schemas.openxmlformats.org/officeDocument/2006/relationships" xmlns:a="http://schemas.openxmlformats.org/drawingml/2006/main" r:embed="Rfef01b680e9f42ad"/>
-          <a:stretch xmlns:a="http://schemas.openxmlformats.org/drawingml/2006/main"/>
-        </p:blipFill>
-        <p:spPr>
-          <a:xfrm xmlns:a="http://schemas.openxmlformats.org/drawingml/2006/main">
-            <a:off x="795451" y="4762500"/>
-            <a:ext cx="6124348" cy="1047750"/>
           </a:xfrm>
           <a:prstGeom xmlns:a="http://schemas.openxmlformats.org/drawingml/2006/main" prst="rect">
             <a:avLst/>
@@ -4078,10 +4415,10 @@
       </p:pic>
       <p:sp>
         <p:nvSpPr>
-          <p:cNvPr id="5" name="">
+          <p:cNvPr id="4" name="">
             <a:extLst xmlns:a="http://schemas.openxmlformats.org/drawingml/2006/main">
               <a:ext uri="{FF2B5EF4-FFF2-40B4-BE49-F238E27FC236}">
-                <a16:creationId xmlns:a16="http://schemas.microsoft.com/office/drawing/2014/main" id="{CA54B52E-495C-43F0-B61E-3FCE3B4A7F80}"/>
+                <a16:creationId xmlns:a16="http://schemas.microsoft.com/office/drawing/2014/main" id="{782B65A2-452B-417E-8741-5F8A8018B924}"/>
               </a:ext>
             </a:extLst>
           </p:cNvPr>
@@ -4092,8 +4429,8 @@
         </p:nvSpPr>
         <p:spPr>
           <a:xfrm xmlns:a="http://schemas.openxmlformats.org/drawingml/2006/main">
-            <a:off x="571500" y="5800725"/>
-            <a:ext cx="6762750" cy="552450"/>
+            <a:off x="571500" y="4676775"/>
+            <a:ext cx="6667500" cy="742950"/>
           </a:xfrm>
           <a:prstGeom xmlns:a="http://schemas.openxmlformats.org/drawingml/2006/main" prst="rect">
             <a:avLst/>
@@ -4110,9 +4447,9 @@
           <a:lstStyle xmlns:a="http://schemas.openxmlformats.org/drawingml/2006/main"/>
           <a:p xmlns:a="http://schemas.openxmlformats.org/drawingml/2006/main">
             <a:pPr>
-              <a:defRPr sz="1650" b="0">
-                <a:solidFill>
-                  <a:srgbClr val="152E38"/>
+              <a:defRPr sz="1800" b="1">
+                <a:solidFill>
+                  <a:srgbClr val="117C83"/>
                 </a:solidFill>
                 <a:latin typeface="Arial"/>
                 <a:ea typeface="Arial"/>
@@ -4120,22 +4457,22 @@
               </a:defRPr>
             </a:pPr>
             <a:r>
-              <a:rPr sz="1650" b="0">
-                <a:solidFill>
-                  <a:srgbClr val="152E38"/>
+              <a:rPr sz="1800" b="1">
+                <a:solidFill>
+                  <a:srgbClr val="117C83"/>
                 </a:solidFill>
                 <a:latin typeface="Arial"/>
                 <a:ea typeface="Arial"/>
                 <a:cs typeface="Arial"/>
               </a:rPr>
-              <a:t>CodeT5: best epoch 3 of 5, validation F1 0.7998</a:t>
+              <a:t>Same 3,872 test programs. SVM validation F1: 0.8062.</a:t>
             </a:r>
           </a:p>
           <a:p xmlns:a="http://schemas.openxmlformats.org/drawingml/2006/main">
             <a:pPr>
-              <a:defRPr sz="1650" b="0">
-                <a:solidFill>
-                  <a:srgbClr val="152E38"/>
+              <a:defRPr sz="1800" b="1">
+                <a:solidFill>
+                  <a:srgbClr val="117C83"/>
                 </a:solidFill>
                 <a:latin typeface="Arial"/>
                 <a:ea typeface="Arial"/>
@@ -4143,25 +4480,25 @@
               </a:defRPr>
             </a:pPr>
             <a:r>
-              <a:rPr sz="1650" b="0">
-                <a:solidFill>
-                  <a:srgbClr val="152E38"/>
+              <a:rPr sz="1800" b="1">
+                <a:solidFill>
+                  <a:srgbClr val="117C83"/>
                 </a:solidFill>
                 <a:latin typeface="Arial"/>
                 <a:ea typeface="Arial"/>
                 <a:cs typeface="Arial"/>
               </a:rPr>
-              <a:t>Encoder + mean pooling; first 256 tokens</a:t>
+              <a:t>SVM exceeds CodeT5 test F1 by 2.45 percentage points.</a:t>
             </a:r>
           </a:p>
         </p:txBody>
       </p:sp>
       <p:sp>
         <p:nvSpPr>
-          <p:cNvPr id="6" name="">
+          <p:cNvPr id="5" name="">
             <a:extLst xmlns:a="http://schemas.openxmlformats.org/drawingml/2006/main">
               <a:ext uri="{FF2B5EF4-FFF2-40B4-BE49-F238E27FC236}">
-                <a16:creationId xmlns:a16="http://schemas.microsoft.com/office/drawing/2014/main" id="{8D03C232-1C85-4749-9C31-E00B8031F7C8}"/>
+                <a16:creationId xmlns:a16="http://schemas.microsoft.com/office/drawing/2014/main" id="{7BBCF69D-9E94-4231-A62D-C8156D058E9B}"/>
               </a:ext>
             </a:extLst>
           </p:cNvPr>
@@ -4172,8 +4509,8 @@
         </p:nvSpPr>
         <p:spPr>
           <a:xfrm xmlns:a="http://schemas.openxmlformats.org/drawingml/2006/main">
-            <a:off x="571500" y="6486525"/>
-            <a:ext cx="11049000" cy="247650"/>
+            <a:off x="571500" y="5524500"/>
+            <a:ext cx="11049000" cy="876300"/>
           </a:xfrm>
           <a:prstGeom xmlns:a="http://schemas.openxmlformats.org/drawingml/2006/main" prst="rect">
             <a:avLst/>
@@ -4190,9 +4527,9 @@
           <a:lstStyle xmlns:a="http://schemas.openxmlformats.org/drawingml/2006/main"/>
           <a:p xmlns:a="http://schemas.openxmlformats.org/drawingml/2006/main">
             <a:pPr>
-              <a:defRPr sz="1500" b="0">
-                <a:solidFill>
-                  <a:srgbClr val="50636B"/>
+              <a:defRPr sz="1800" b="0">
+                <a:solidFill>
+                  <a:srgbClr val="152E38"/>
                 </a:solidFill>
                 <a:latin typeface="Arial"/>
                 <a:ea typeface="Arial"/>
@@ -4200,15 +4537,118 @@
               </a:defRPr>
             </a:pPr>
             <a:r>
-              <a:rPr sz="1500" b="0">
+              <a:rPr sz="1800" b="0">
+                <a:solidFill>
+                  <a:srgbClr val="152E38"/>
+                </a:solidFill>
+                <a:latin typeface="Arial"/>
+                <a:ea typeface="Arial"/>
+                <a:cs typeface="Arial"/>
+              </a:rPr>
+              <a:t>Macro-F1 averages five class F1 scores equally.</a:t>
+            </a:r>
+          </a:p>
+          <a:p xmlns:a="http://schemas.openxmlformats.org/drawingml/2006/main">
+            <a:pPr>
+              <a:defRPr sz="1800" b="0">
+                <a:solidFill>
+                  <a:srgbClr val="152E38"/>
+                </a:solidFill>
+                <a:latin typeface="Arial"/>
+                <a:ea typeface="Arial"/>
+                <a:cs typeface="Arial"/>
+              </a:defRPr>
+            </a:pPr>
+            <a:r>
+              <a:rPr sz="1800" b="0">
+                <a:solidFill>
+                  <a:srgbClr val="152E38"/>
+                </a:solidFill>
+                <a:latin typeface="Arial"/>
+                <a:ea typeface="Arial"/>
+                <a:cs typeface="Arial"/>
+              </a:rPr>
+              <a:t>Matrix: rows = actual, columns = predicted.</a:t>
+            </a:r>
+          </a:p>
+          <a:p xmlns:a="http://schemas.openxmlformats.org/drawingml/2006/main">
+            <a:pPr>
+              <a:defRPr sz="1800" b="0">
+                <a:solidFill>
+                  <a:srgbClr val="152E38"/>
+                </a:solidFill>
+                <a:latin typeface="Arial"/>
+                <a:ea typeface="Arial"/>
+                <a:cs typeface="Arial"/>
+              </a:defRPr>
+            </a:pPr>
+            <a:r>
+              <a:rPr sz="1800" b="0">
+                <a:solidFill>
+                  <a:srgbClr val="152E38"/>
+                </a:solidFill>
+                <a:latin typeface="Arial"/>
+                <a:ea typeface="Arial"/>
+                <a:cs typeface="Arial"/>
+              </a:rPr>
+              <a:t>Largest error: 199 DeepSeek programs labelled Llama.</a:t>
+            </a:r>
+          </a:p>
+        </p:txBody>
+      </p:sp>
+      <p:sp>
+        <p:nvSpPr>
+          <p:cNvPr id="6" name="">
+            <a:extLst xmlns:a="http://schemas.openxmlformats.org/drawingml/2006/main">
+              <a:ext uri="{FF2B5EF4-FFF2-40B4-BE49-F238E27FC236}">
+                <a16:creationId xmlns:a16="http://schemas.microsoft.com/office/drawing/2014/main" id="{39B21E80-7984-4750-B228-0E3D0BC10BCB}"/>
+              </a:ext>
+            </a:extLst>
+          </p:cNvPr>
+          <p:cNvSpPr>
+            <a:spLocks xmlns:a="http://schemas.openxmlformats.org/drawingml/2006/main" noGrp="1"/>
+          </p:cNvSpPr>
+          <p:nvPr/>
+        </p:nvSpPr>
+        <p:spPr>
+          <a:xfrm xmlns:a="http://schemas.openxmlformats.org/drawingml/2006/main">
+            <a:off x="571500" y="6534150"/>
+            <a:ext cx="11049000" cy="238125"/>
+          </a:xfrm>
+          <a:prstGeom xmlns:a="http://schemas.openxmlformats.org/drawingml/2006/main" prst="rect">
+            <a:avLst/>
+          </a:prstGeom>
+          <a:noFill xmlns:a="http://schemas.openxmlformats.org/drawingml/2006/main"/>
+          <a:ln xmlns:a="http://schemas.openxmlformats.org/drawingml/2006/main" w="0">
+            <a:noFill/>
+          </a:ln>
+        </p:spPr>
+        <p:txBody>
+          <a:bodyPr xmlns:a="http://schemas.openxmlformats.org/drawingml/2006/main" lIns="0" tIns="0" rIns="0" bIns="0">
+            <a:noAutofit/>
+          </a:bodyPr>
+          <a:lstStyle xmlns:a="http://schemas.openxmlformats.org/drawingml/2006/main"/>
+          <a:p xmlns:a="http://schemas.openxmlformats.org/drawingml/2006/main">
+            <a:pPr>
+              <a:defRPr sz="1350" b="0">
                 <a:solidFill>
                   <a:srgbClr val="50636B"/>
                 </a:solidFill>
                 <a:latin typeface="Arial"/>
                 <a:ea typeface="Arial"/>
                 <a:cs typeface="Arial"/>
+              </a:defRPr>
+            </a:pPr>
+            <a:r>
+              <a:rPr sz="1350" b="0">
+                <a:solidFill>
+                  <a:srgbClr val="50636B"/>
+                </a:solidFill>
+                <a:latin typeface="Arial"/>
+                <a:ea typeface="Arial"/>
+                <a:cs typeface="Arial"/>
               </a:rPr>
-              <a:t>*CodeT5: GPU wall time, raw checkpoint. Others: CPU fit time, compressed classifiers.</a:t>
+              <a:t>*CodeT5: GPU wall time and raw weights. Others: CPU fit time and compressed classifiers.</a:t>
             </a:r>
           </a:p>
         </p:txBody>
@@ -4216,7 +4656,7 @@
     </p:spTree>
     <p:extLst>
       <p:ext uri="{BB962C8B-B14F-4D97-AF65-F5344CB8AC3E}">
-        <p14:creationId xmlns:p14="http://schemas.microsoft.com/office/powerpoint/2010/main" val="2067327625"/>
+        <p14:creationId xmlns:p14="http://schemas.microsoft.com/office/powerpoint/2010/main" val="76218528"/>
       </p:ext>
     </p:extLst>
   </p:cSld>
@@ -4244,10 +4684,10 @@
       </p:grpSpPr>
       <p:sp>
         <p:nvSpPr>
-          <p:cNvPr id="5" name="">
+          <p:cNvPr id="6" name="">
             <a:extLst xmlns:a="http://schemas.openxmlformats.org/drawingml/2006/main">
               <a:ext uri="{FF2B5EF4-FFF2-40B4-BE49-F238E27FC236}">
-                <a16:creationId xmlns:a16="http://schemas.microsoft.com/office/drawing/2014/main" id="{CD0D4E84-D662-4BAA-9F92-F4F34E563A83}"/>
+                <a16:creationId xmlns:a16="http://schemas.microsoft.com/office/drawing/2014/main" id="{70FDD76E-E9D1-4895-906A-EDB2EA94CF50}"/>
               </a:ext>
             </a:extLst>
           </p:cNvPr>
@@ -4294,39 +4734,311 @@
                 <a:ea typeface="Arial"/>
                 <a:cs typeface="Arial"/>
               </a:rPr>
-              <a:t>Ablation: restrict the code-pattern vocabulary</a:t>
+              <a:t>Ablations test the explanation, with mixed evidence</a:t>
             </a:r>
           </a:p>
         </p:txBody>
       </p:sp>
       <p:pic>
         <p:nvPicPr>
-          <p:cNvPr id="6" name=""/>
+          <p:cNvPr id="7" name=""/>
           <p:cNvPicPr>
             <a:picLocks xmlns:a="http://schemas.openxmlformats.org/drawingml/2006/main" noChangeAspect="1"/>
           </p:cNvPicPr>
           <p:nvPr/>
         </p:nvPicPr>
         <p:blipFill>
-          <a:blip xmlns:r="http://schemas.openxmlformats.org/officeDocument/2006/relationships" xmlns:a="http://schemas.openxmlformats.org/drawingml/2006/main" r:embed="R13fb236e25dd41f5"/>
+          <a:blip xmlns:r="http://schemas.openxmlformats.org/officeDocument/2006/relationships" xmlns:a="http://schemas.openxmlformats.org/drawingml/2006/main" r:embed="R9054cb99d4e74ea4"/>
           <a:stretch xmlns:a="http://schemas.openxmlformats.org/drawingml/2006/main"/>
         </p:blipFill>
         <p:spPr>
           <a:xfrm xmlns:a="http://schemas.openxmlformats.org/drawingml/2006/main">
-            <a:off x="633132" y="1333500"/>
-            <a:ext cx="10925735" cy="3095625"/>
+            <a:off x="1608044" y="1219200"/>
+            <a:ext cx="8975912" cy="2543175"/>
           </a:xfrm>
           <a:prstGeom xmlns:a="http://schemas.openxmlformats.org/drawingml/2006/main" prst="rect">
             <a:avLst/>
           </a:prstGeom>
         </p:spPr>
       </p:pic>
+      <p:graphicFrame>
+        <p:nvGraphicFramePr>
+          <p:cNvPr id="8" name=""/>
+          <p:cNvGraphicFramePr/>
+          <p:nvPr/>
+        </p:nvGraphicFramePr>
+        <p:xfrm>
+          <a:off xmlns:a="http://schemas.openxmlformats.org/drawingml/2006/main" x="571500" y="3962400"/>
+          <a:ext xmlns:a="http://schemas.openxmlformats.org/drawingml/2006/main" cx="11049000" cy="1428750"/>
+        </p:xfrm>
+        <a:graphic xmlns:a="http://schemas.openxmlformats.org/drawingml/2006/main">
+          <a:graphicData uri="http://schemas.openxmlformats.org/drawingml/2006/table">
+            <a:tbl>
+              <a:tblPr/>
+              <a:tblGrid>
+                <a:gridCol w="2857500"/>
+                <a:gridCol w="3143250"/>
+                <a:gridCol w="5048250"/>
+              </a:tblGrid>
+              <a:tr h="476250">
+                <a:tc>
+                  <a:txBody>
+                    <a:bodyPr>
+                      <a:noAutofit/>
+                    </a:bodyPr>
+                    <a:lstStyle/>
+                    <a:p>
+                      <a:pPr algn="l"/>
+                      <a:r>
+                        <a:rPr sz="1650" b="1">
+                          <a:solidFill>
+                            <a:srgbClr val="FFFFFF"/>
+                          </a:solidFill>
+                          <a:latin typeface="Arial"/>
+                          <a:ea typeface="Arial"/>
+                          <a:cs typeface="Arial"/>
+                        </a:rPr>
+                        <a:t>Change</a:t>
+                      </a:r>
+                    </a:p>
+                  </a:txBody>
+                  <a:tcPr marL="91440" marR="91440" marT="45720" marB="45720">
+                    <a:solidFill>
+                      <a:srgbClr val="152E38"/>
+                    </a:solidFill>
+                  </a:tcPr>
+                </a:tc>
+                <a:tc>
+                  <a:txBody>
+                    <a:bodyPr>
+                      <a:noAutofit/>
+                    </a:bodyPr>
+                    <a:lstStyle/>
+                    <a:p>
+                      <a:pPr algn="ctr"/>
+                      <a:r>
+                        <a:rPr sz="1650" b="1">
+                          <a:solidFill>
+                            <a:srgbClr val="FFFFFF"/>
+                          </a:solidFill>
+                          <a:latin typeface="Arial"/>
+                          <a:ea typeface="Arial"/>
+                          <a:cs typeface="Arial"/>
+                        </a:rPr>
+                        <a:t>Prediction</a:t>
+                      </a:r>
+                    </a:p>
+                  </a:txBody>
+                  <a:tcPr marL="91440" marR="91440" marT="45720" marB="45720">
+                    <a:solidFill>
+                      <a:srgbClr val="152E38"/>
+                    </a:solidFill>
+                  </a:tcPr>
+                </a:tc>
+                <a:tc>
+                  <a:txBody>
+                    <a:bodyPr>
+                      <a:noAutofit/>
+                    </a:bodyPr>
+                    <a:lstStyle/>
+                    <a:p>
+                      <a:pPr algn="ctr"/>
+                      <a:r>
+                        <a:rPr sz="1650" b="1">
+                          <a:solidFill>
+                            <a:srgbClr val="FFFFFF"/>
+                          </a:solidFill>
+                          <a:latin typeface="Arial"/>
+                          <a:ea typeface="Arial"/>
+                          <a:cs typeface="Arial"/>
+                        </a:rPr>
+                        <a:t>Observed SVM–LR validation gap</a:t>
+                      </a:r>
+                    </a:p>
+                  </a:txBody>
+                  <a:tcPr marL="91440" marR="91440" marT="45720" marB="45720">
+                    <a:solidFill>
+                      <a:srgbClr val="152E38"/>
+                    </a:solidFill>
+                  </a:tcPr>
+                </a:tc>
+              </a:tr>
+              <a:tr h="476250">
+                <a:tc>
+                  <a:txBody>
+                    <a:bodyPr>
+                      <a:noAutofit/>
+                    </a:bodyPr>
+                    <a:lstStyle/>
+                    <a:p>
+                      <a:pPr algn="l"/>
+                      <a:r>
+                        <a:rPr sz="1725" b="0">
+                          <a:solidFill>
+                            <a:srgbClr val="152E38"/>
+                          </a:solidFill>
+                          <a:latin typeface="Arial"/>
+                          <a:ea typeface="Arial"/>
+                          <a:cs typeface="Arial"/>
+                        </a:rPr>
+                        <a:t>Remove comments</a:t>
+                      </a:r>
+                    </a:p>
+                  </a:txBody>
+                  <a:tcPr marL="91440" marR="91440" marT="45720" marB="45720">
+                    <a:solidFill>
+                      <a:srgbClr val="FFFFFF"/>
+                    </a:solidFill>
+                  </a:tcPr>
+                </a:tc>
+                <a:tc>
+                  <a:txBody>
+                    <a:bodyPr>
+                      <a:noAutofit/>
+                    </a:bodyPr>
+                    <a:lstStyle/>
+                    <a:p>
+                      <a:pPr algn="ctr"/>
+                      <a:r>
+                        <a:rPr sz="1725" b="0">
+                          <a:solidFill>
+                            <a:srgbClr val="152E38"/>
+                          </a:solidFill>
+                          <a:latin typeface="Arial"/>
+                          <a:ea typeface="Arial"/>
+                          <a:cs typeface="Arial"/>
+                        </a:rPr>
+                        <a:t>SVM lead should shrink</a:t>
+                      </a:r>
+                    </a:p>
+                  </a:txBody>
+                  <a:tcPr marL="91440" marR="91440" marT="45720" marB="45720">
+                    <a:solidFill>
+                      <a:srgbClr val="FFFFFF"/>
+                    </a:solidFill>
+                  </a:tcPr>
+                </a:tc>
+                <a:tc>
+                  <a:txBody>
+                    <a:bodyPr>
+                      <a:noAutofit/>
+                    </a:bodyPr>
+                    <a:lstStyle/>
+                    <a:p>
+                      <a:pPr algn="ctr"/>
+                      <a:r>
+                        <a:rPr sz="1725" b="0">
+                          <a:solidFill>
+                            <a:srgbClr val="152E38"/>
+                          </a:solidFill>
+                          <a:latin typeface="Arial"/>
+                          <a:ea typeface="Arial"/>
+                          <a:cs typeface="Arial"/>
+                        </a:rPr>
+                        <a:t>1.49 to 3.03 points: prediction failed</a:t>
+                      </a:r>
+                    </a:p>
+                  </a:txBody>
+                  <a:tcPr marL="91440" marR="91440" marT="45720" marB="45720">
+                    <a:solidFill>
+                      <a:srgbClr val="FFFFFF"/>
+                    </a:solidFill>
+                  </a:tcPr>
+                </a:tc>
+              </a:tr>
+              <a:tr h="476250">
+                <a:tc>
+                  <a:txBody>
+                    <a:bodyPr>
+                      <a:noAutofit/>
+                    </a:bodyPr>
+                    <a:lstStyle/>
+                    <a:p>
+                      <a:pPr algn="l"/>
+                      <a:r>
+                        <a:rPr sz="1725" b="0">
+                          <a:solidFill>
+                            <a:srgbClr val="152E38"/>
+                          </a:solidFill>
+                          <a:latin typeface="Arial"/>
+                          <a:ea typeface="Arial"/>
+                          <a:cs typeface="Arial"/>
+                        </a:rPr>
+                        <a:t>50,000 to 500 features</a:t>
+                      </a:r>
+                    </a:p>
+                  </a:txBody>
+                  <a:tcPr marL="91440" marR="91440" marT="45720" marB="45720">
+                    <a:solidFill>
+                      <a:srgbClr val="FFFFFF"/>
+                    </a:solidFill>
+                  </a:tcPr>
+                </a:tc>
+                <a:tc>
+                  <a:txBody>
+                    <a:bodyPr>
+                      <a:noAutofit/>
+                    </a:bodyPr>
+                    <a:lstStyle/>
+                    <a:p>
+                      <a:pPr algn="ctr"/>
+                      <a:r>
+                        <a:rPr sz="1725" b="0">
+                          <a:solidFill>
+                            <a:srgbClr val="152E38"/>
+                          </a:solidFill>
+                          <a:latin typeface="Arial"/>
+                          <a:ea typeface="Arial"/>
+                          <a:cs typeface="Arial"/>
+                        </a:rPr>
+                        <a:t>SVM lead should shrink</a:t>
+                      </a:r>
+                    </a:p>
+                  </a:txBody>
+                  <a:tcPr marL="91440" marR="91440" marT="45720" marB="45720">
+                    <a:solidFill>
+                      <a:srgbClr val="FFFFFF"/>
+                    </a:solidFill>
+                  </a:tcPr>
+                </a:tc>
+                <a:tc>
+                  <a:txBody>
+                    <a:bodyPr>
+                      <a:noAutofit/>
+                    </a:bodyPr>
+                    <a:lstStyle/>
+                    <a:p>
+                      <a:pPr algn="ctr"/>
+                      <a:r>
+                        <a:rPr sz="1725" b="0">
+                          <a:solidFill>
+                            <a:srgbClr val="152E38"/>
+                          </a:solidFill>
+                          <a:latin typeface="Arial"/>
+                          <a:ea typeface="Arial"/>
+                          <a:cs typeface="Arial"/>
+                        </a:rPr>
+                        <a:t>1.49 to 1.39 points: slight narrowing</a:t>
+                      </a:r>
+                    </a:p>
+                  </a:txBody>
+                  <a:tcPr marL="91440" marR="91440" marT="45720" marB="45720">
+                    <a:solidFill>
+                      <a:srgbClr val="FFFFFF"/>
+                    </a:solidFill>
+                  </a:tcPr>
+                </a:tc>
+              </a:tr>
+            </a:tbl>
+          </a:graphicData>
+        </a:graphic>
+      </p:graphicFrame>
       <p:sp>
         <p:nvSpPr>
-          <p:cNvPr id="3" name="">
+          <p:cNvPr id="4" name="">
             <a:extLst xmlns:a="http://schemas.openxmlformats.org/drawingml/2006/main">
               <a:ext uri="{FF2B5EF4-FFF2-40B4-BE49-F238E27FC236}">
-                <a16:creationId xmlns:a16="http://schemas.microsoft.com/office/drawing/2014/main" id="{B92F5F9D-33DD-4648-9BAB-2E7D41868881}"/>
+                <a16:creationId xmlns:a16="http://schemas.microsoft.com/office/drawing/2014/main" id="{0FA3BFD0-EDD1-43B5-AD76-6E52BDFC8E63}"/>
               </a:ext>
             </a:extLst>
           </p:cNvPr>
@@ -4337,88 +5049,8 @@
         </p:nvSpPr>
         <p:spPr>
           <a:xfrm xmlns:a="http://schemas.openxmlformats.org/drawingml/2006/main">
-            <a:off x="571500" y="4524375"/>
-            <a:ext cx="11049000" cy="866775"/>
-          </a:xfrm>
-          <a:prstGeom xmlns:a="http://schemas.openxmlformats.org/drawingml/2006/main" prst="rect">
-            <a:avLst/>
-          </a:prstGeom>
-          <a:noFill xmlns:a="http://schemas.openxmlformats.org/drawingml/2006/main"/>
-          <a:ln xmlns:a="http://schemas.openxmlformats.org/drawingml/2006/main" w="0">
-            <a:noFill/>
-          </a:ln>
-        </p:spPr>
-        <p:txBody>
-          <a:bodyPr xmlns:a="http://schemas.openxmlformats.org/drawingml/2006/main" lIns="0" tIns="0" rIns="0" bIns="0">
-            <a:noAutofit/>
-          </a:bodyPr>
-          <a:lstStyle xmlns:a="http://schemas.openxmlformats.org/drawingml/2006/main"/>
-          <a:p xmlns:a="http://schemas.openxmlformats.org/drawingml/2006/main">
-            <a:pPr>
-              <a:defRPr sz="2100" b="0">
-                <a:solidFill>
-                  <a:srgbClr val="152E38"/>
-                </a:solidFill>
-                <a:latin typeface="Arial"/>
-                <a:ea typeface="Arial"/>
-                <a:cs typeface="Arial"/>
-              </a:defRPr>
-            </a:pPr>
-            <a:r>
-              <a:rPr sz="2100" b="0">
-                <a:solidFill>
-                  <a:srgbClr val="152E38"/>
-                </a:solidFill>
-                <a:latin typeface="Arial"/>
-                <a:ea typeface="Arial"/>
-                <a:cs typeface="Arial"/>
-              </a:rPr>
-              <a:t>Prediction: fewer patterns would narrow SVM’s lead over LR.</a:t>
-            </a:r>
-          </a:p>
-          <a:p xmlns:a="http://schemas.openxmlformats.org/drawingml/2006/main">
-            <a:pPr>
-              <a:defRPr sz="2100" b="0">
-                <a:solidFill>
-                  <a:srgbClr val="152E38"/>
-                </a:solidFill>
-                <a:latin typeface="Arial"/>
-                <a:ea typeface="Arial"/>
-                <a:cs typeface="Arial"/>
-              </a:defRPr>
-            </a:pPr>
-            <a:r>
-              <a:rPr sz="2100" b="0">
-                <a:solidFill>
-                  <a:srgbClr val="152E38"/>
-                </a:solidFill>
-                <a:latin typeface="Arial"/>
-                <a:ea typeface="Arial"/>
-                <a:cs typeface="Arial"/>
-              </a:rPr>
-              <a:t>Observed: 1.49 to 1.39 percentage points. Rankings did not change.</a:t>
-            </a:r>
-          </a:p>
-        </p:txBody>
-      </p:sp>
-      <p:sp>
-        <p:nvSpPr>
-          <p:cNvPr id="4" name="">
-            <a:extLst xmlns:a="http://schemas.openxmlformats.org/drawingml/2006/main">
-              <a:ext uri="{FF2B5EF4-FFF2-40B4-BE49-F238E27FC236}">
-                <a16:creationId xmlns:a16="http://schemas.microsoft.com/office/drawing/2014/main" id="{7E6D8A84-137D-4D95-BADF-B3133F02140C}"/>
-              </a:ext>
-            </a:extLst>
-          </p:cNvPr>
-          <p:cNvSpPr>
-            <a:spLocks xmlns:a="http://schemas.openxmlformats.org/drawingml/2006/main" noGrp="1"/>
-          </p:cNvSpPr>
-          <p:nvPr/>
-        </p:nvSpPr>
-        <p:spPr>
-          <a:xfrm xmlns:a="http://schemas.openxmlformats.org/drawingml/2006/main">
-            <a:off x="571500" y="5572125"/>
-            <a:ext cx="11049000" cy="838200"/>
+            <a:off x="571500" y="5610225"/>
+            <a:ext cx="11049000" cy="381000"/>
           </a:xfrm>
           <a:prstGeom xmlns:a="http://schemas.openxmlformats.org/drawingml/2006/main" prst="rect">
             <a:avLst/>
@@ -4453,14 +5085,71 @@
                 <a:ea typeface="Arial"/>
                 <a:cs typeface="Arial"/>
               </a:rPr>
-              <a:t>Weak support for the gap prediction, not a full explanation.</a:t>
+              <a:t>Both changes lowered all four scores; neither changed their ranking.</a:t>
+            </a:r>
+          </a:p>
+        </p:txBody>
+      </p:sp>
+      <p:sp>
+        <p:nvSpPr>
+          <p:cNvPr id="5" name="">
+            <a:extLst xmlns:a="http://schemas.openxmlformats.org/drawingml/2006/main">
+              <a:ext uri="{FF2B5EF4-FFF2-40B4-BE49-F238E27FC236}">
+                <a16:creationId xmlns:a16="http://schemas.microsoft.com/office/drawing/2014/main" id="{A637C79C-FDC1-4816-9F6F-6DE679E875FD}"/>
+              </a:ext>
+            </a:extLst>
+          </p:cNvPr>
+          <p:cNvSpPr>
+            <a:spLocks xmlns:a="http://schemas.openxmlformats.org/drawingml/2006/main" noGrp="1"/>
+          </p:cNvSpPr>
+          <p:nvPr/>
+        </p:nvSpPr>
+        <p:spPr>
+          <a:xfrm xmlns:a="http://schemas.openxmlformats.org/drawingml/2006/main">
+            <a:off x="571500" y="6086475"/>
+            <a:ext cx="11049000" cy="638175"/>
+          </a:xfrm>
+          <a:prstGeom xmlns:a="http://schemas.openxmlformats.org/drawingml/2006/main" prst="rect">
+            <a:avLst/>
+          </a:prstGeom>
+          <a:noFill xmlns:a="http://schemas.openxmlformats.org/drawingml/2006/main"/>
+          <a:ln xmlns:a="http://schemas.openxmlformats.org/drawingml/2006/main" w="0">
+            <a:noFill/>
+          </a:ln>
+        </p:spPr>
+        <p:txBody>
+          <a:bodyPr xmlns:a="http://schemas.openxmlformats.org/drawingml/2006/main" lIns="0" tIns="0" rIns="0" bIns="0">
+            <a:noAutofit/>
+          </a:bodyPr>
+          <a:lstStyle xmlns:a="http://schemas.openxmlformats.org/drawingml/2006/main"/>
+          <a:p xmlns:a="http://schemas.openxmlformats.org/drawingml/2006/main">
+            <a:pPr>
+              <a:defRPr sz="2025" b="0">
+                <a:solidFill>
+                  <a:srgbClr val="152E38"/>
+                </a:solidFill>
+                <a:latin typeface="Arial"/>
+                <a:ea typeface="Arial"/>
+                <a:cs typeface="Arial"/>
+              </a:defRPr>
+            </a:pPr>
+            <a:r>
+              <a:rPr sz="2025" b="0">
+                <a:solidFill>
+                  <a:srgbClr val="152E38"/>
+                </a:solidFill>
+                <a:latin typeface="Arial"/>
+                <a:ea typeface="Arial"/>
+                <a:cs typeface="Arial"/>
+              </a:rPr>
+              <a:t>Conclusion: SVM is best under our settings. Rich code patterns help,</a:t>
             </a:r>
           </a:p>
           <a:p xmlns:a="http://schemas.openxmlformats.org/drawingml/2006/main">
             <a:pPr>
-              <a:defRPr sz="2025" b="1">
-                <a:solidFill>
-                  <a:srgbClr val="117C83"/>
+              <a:defRPr sz="2025" b="0">
+                <a:solidFill>
+                  <a:srgbClr val="152E38"/>
                 </a:solidFill>
                 <a:latin typeface="Arial"/>
                 <a:ea typeface="Arial"/>
@@ -4468,15 +5157,15 @@
               </a:defRPr>
             </a:pPr>
             <a:r>
-              <a:rPr sz="2025" b="1">
-                <a:solidFill>
-                  <a:srgbClr val="117C83"/>
+              <a:rPr sz="2025" b="0">
+                <a:solidFill>
+                  <a:srgbClr val="152E38"/>
                 </a:solidFill>
                 <a:latin typeface="Arial"/>
                 <a:ea typeface="Arial"/>
                 <a:cs typeface="Arial"/>
               </a:rPr>
-              <a:t>Removing comments also hurt all models without changing ranks.</a:t>
+              <a:t>but these tests do not conclusively explain its advantage.</a:t>
             </a:r>
           </a:p>
         </p:txBody>
@@ -4484,7 +5173,7 @@
     </p:spTree>
     <p:extLst>
       <p:ext uri="{BB962C8B-B14F-4D97-AF65-F5344CB8AC3E}">
-        <p14:creationId xmlns:p14="http://schemas.microsoft.com/office/powerpoint/2010/main" val="82404803"/>
+        <p14:creationId xmlns:p14="http://schemas.microsoft.com/office/powerpoint/2010/main" val="1632542797"/>
       </p:ext>
     </p:extLst>
   </p:cSld>

</xml_diff>